<commit_message>
Sunuma platform ve indirme bilgileri eklendi (Windows + macOS, v1.0.0)
Kapanis slaytindaki yerel EXE yolu, GitHub Releases indirme satirlari ile
degistirildi: Windows 10/11 (x64) + macOS (Apple Silicon), v1.0.0, ozel repo
notu ve macOS notarizasyon dipnotu. Kapak slaytina macOS ibaresi eklendi;
PPTX ve PDF yeniden uretildi.

Co-Authored-By: Claude Fable 5 <noreply@anthropic.com>
</commit_message>
<xml_diff>
--- a/docs/presentation/English-Course-AI-Bilingual.pptx
+++ b/docs/presentation/English-Course-AI-Bilingual.pptx
@@ -2,18 +2,18 @@
 <file path=ppt/presentation.xml><?xml version="1.0" encoding="utf-8"?>
 <p:presentation xmlns:p="http://schemas.openxmlformats.org/presentationml/2006/main">
   <p:sldMasterIdLst>
-    <p:sldMasterId xmlns:r="http://schemas.openxmlformats.org/officeDocument/2006/relationships" id="2147483648" r:id="R985a69996986494b"/>
+    <p:sldMasterId xmlns:r="http://schemas.openxmlformats.org/officeDocument/2006/relationships" id="2147483648" r:id="Ra29485e8011a4b83"/>
   </p:sldMasterIdLst>
   <p:notesMasterIdLst>
-    <p:notesMasterId xmlns:r="http://schemas.openxmlformats.org/officeDocument/2006/relationships" r:id="R67d425ce6e9a4600"/>
+    <p:notesMasterId xmlns:r="http://schemas.openxmlformats.org/officeDocument/2006/relationships" r:id="R9ea13128d2f4429f"/>
   </p:notesMasterIdLst>
   <p:sldIdLst>
-    <p:sldId xmlns:r="http://schemas.openxmlformats.org/officeDocument/2006/relationships" id="256" r:id="R7ddbe9ae86234ec8"/>
-    <p:sldId xmlns:r="http://schemas.openxmlformats.org/officeDocument/2006/relationships" id="257" r:id="R805cac1591264f51"/>
-    <p:sldId xmlns:r="http://schemas.openxmlformats.org/officeDocument/2006/relationships" id="258" r:id="Rd2e3e8b570c8439b"/>
-    <p:sldId xmlns:r="http://schemas.openxmlformats.org/officeDocument/2006/relationships" id="259" r:id="R7fb453246fe64c9c"/>
-    <p:sldId xmlns:r="http://schemas.openxmlformats.org/officeDocument/2006/relationships" id="260" r:id="Rebab24ee04444959"/>
-    <p:sldId xmlns:r="http://schemas.openxmlformats.org/officeDocument/2006/relationships" id="261" r:id="R97e949d24f884484"/>
+    <p:sldId xmlns:r="http://schemas.openxmlformats.org/officeDocument/2006/relationships" id="256" r:id="R8e9aab4a95744bb1"/>
+    <p:sldId xmlns:r="http://schemas.openxmlformats.org/officeDocument/2006/relationships" id="257" r:id="R43fac0b1499445d0"/>
+    <p:sldId xmlns:r="http://schemas.openxmlformats.org/officeDocument/2006/relationships" id="258" r:id="R8884697262114368"/>
+    <p:sldId xmlns:r="http://schemas.openxmlformats.org/officeDocument/2006/relationships" id="259" r:id="R2180dfd678c54a47"/>
+    <p:sldId xmlns:r="http://schemas.openxmlformats.org/officeDocument/2006/relationships" id="260" r:id="Rb1f7e36787da4d82"/>
+    <p:sldId xmlns:r="http://schemas.openxmlformats.org/officeDocument/2006/relationships" id="261" r:id="R9102b31cf5c04c4e"/>
   </p:sldIdLst>
   <p:sldSz cx="12192000" cy="6858000"/>
   <p:notesSz cx="6858000" cy="9144000"/>
@@ -902,7 +902,7 @@
           <a:lstStyle xmlns:a="http://schemas.openxmlformats.org/drawingml/2006/main"/>
           <a:p xmlns:a="http://schemas.openxmlformats.org/drawingml/2006/main">
             <a:r>
-              <a:t>Kapanış: ilk kullanım için EXE, günlük tekrar ve isteğe bağlı yerel AI sırası.</a:t>
+              <a:t>Kapanış: ilk kullanım için uygulama, günlük tekrar ve isteğe bağlı yerel AI sırası.</a:t>
             </a:r>
           </a:p>
           <a:p xmlns:a="http://schemas.openxmlformats.org/drawingml/2006/main">
@@ -912,7 +912,7 @@
           </a:p>
           <a:p xmlns:a="http://schemas.openxmlformats.org/drawingml/2006/main">
             <a:r>
-              <a:t>- Local executable: D:/GE_FR/EnglishCourseAI/dist/EnglishCourseAI.exe</a:t>
+              <a:t>- GitHub release (private repo): https://github.com/Azizsekerdil/EnglishCourseAI/releases/tag/v1.0.0 (Windows zip + macOS zip)</a:t>
             </a:r>
           </a:p>
           <a:p xmlns:a="http://schemas.openxmlformats.org/drawingml/2006/main">
@@ -985,7 +985,7 @@
   </p:cSld>
   <p:clrMap bg1="lt1" tx1="dk1" bg2="lt2" tx2="dk2" accent1="accent1" accent2="accent2" accent3="accent3" accent4="accent4" accent5="accent5" accent6="accent6" hlink="hlink" folHlink="folHlink"/>
   <p:sldLayoutIdLst>
-    <p:sldLayoutId xmlns:r="http://schemas.openxmlformats.org/officeDocument/2006/relationships" id="2147483649" r:id="R40ab972e323440b6"/>
+    <p:sldLayoutId xmlns:r="http://schemas.openxmlformats.org/officeDocument/2006/relationships" id="2147483649" r:id="Ra5e8d747a5084010"/>
   </p:sldLayoutIdLst>
   <p:txStyles>
     <p:titleStyle>
@@ -1536,7 +1536,7 @@
           <p:cNvPr id="8" name="">
             <a:extLst xmlns:a="http://schemas.openxmlformats.org/drawingml/2006/main">
               <a:ext uri="{FF2B5EF4-FFF2-40B4-BE49-F238E27FC236}">
-                <a16:creationId xmlns:a16="http://schemas.microsoft.com/office/drawing/2014/main" id="{EB59204D-696F-42B1-BEDF-BFAA1A24AB81}"/>
+                <a16:creationId xmlns:a16="http://schemas.microsoft.com/office/drawing/2014/main" id="{DE6ABFF0-78D1-48EB-BB30-2228E9334712}"/>
               </a:ext>
             </a:extLst>
           </p:cNvPr>
@@ -1571,7 +1571,7 @@
           <p:nvPr/>
         </p:nvPicPr>
         <p:blipFill>
-          <a:blip xmlns:r="http://schemas.openxmlformats.org/officeDocument/2006/relationships" xmlns:a="http://schemas.openxmlformats.org/drawingml/2006/main" r:embed="R7fc2102289f14e98"/>
+          <a:blip xmlns:r="http://schemas.openxmlformats.org/officeDocument/2006/relationships" xmlns:a="http://schemas.openxmlformats.org/drawingml/2006/main" r:embed="Red959deee9dc4f3d"/>
           <a:stretch xmlns:a="http://schemas.openxmlformats.org/drawingml/2006/main"/>
         </p:blipFill>
         <p:spPr>
@@ -1589,7 +1589,7 @@
           <p:cNvPr id="3" name="">
             <a:extLst xmlns:a="http://schemas.openxmlformats.org/drawingml/2006/main">
               <a:ext uri="{FF2B5EF4-FFF2-40B4-BE49-F238E27FC236}">
-                <a16:creationId xmlns:a16="http://schemas.microsoft.com/office/drawing/2014/main" id="{AF25C6F6-C529-4535-8524-B378A8C9BE2E}"/>
+                <a16:creationId xmlns:a16="http://schemas.microsoft.com/office/drawing/2014/main" id="{4722D123-694F-4EB6-938F-CA72F6588C56}"/>
               </a:ext>
             </a:extLst>
           </p:cNvPr>
@@ -1635,7 +1635,7 @@
                 <a:ea typeface="Arial"/>
                 <a:cs typeface="Arial"/>
               </a:rPr>
-              <a:t>YEREL • BILINGUAL • WINDOWS</a:t>
+              <a:t>YEREL • BILINGUAL • WINDOWS + MACOS</a:t>
             </a:r>
           </a:p>
         </p:txBody>
@@ -1645,7 +1645,7 @@
           <p:cNvPr id="4" name="">
             <a:extLst xmlns:a="http://schemas.openxmlformats.org/drawingml/2006/main">
               <a:ext uri="{FF2B5EF4-FFF2-40B4-BE49-F238E27FC236}">
-                <a16:creationId xmlns:a16="http://schemas.microsoft.com/office/drawing/2014/main" id="{11CFA87D-CFB6-472C-98A3-BFAFC8B5AF27}"/>
+                <a16:creationId xmlns:a16="http://schemas.microsoft.com/office/drawing/2014/main" id="{A72EBCC1-585D-4C90-8455-82FBDBE2F2A0}"/>
               </a:ext>
             </a:extLst>
           </p:cNvPr>
@@ -1724,7 +1724,7 @@
           <p:cNvPr id="5" name="">
             <a:extLst xmlns:a="http://schemas.openxmlformats.org/drawingml/2006/main">
               <a:ext uri="{FF2B5EF4-FFF2-40B4-BE49-F238E27FC236}">
-                <a16:creationId xmlns:a16="http://schemas.microsoft.com/office/drawing/2014/main" id="{F73AC4ED-A572-4A7A-B3D7-1A297CABF776}"/>
+                <a16:creationId xmlns:a16="http://schemas.microsoft.com/office/drawing/2014/main" id="{46A5E9D3-77DD-4980-8E49-6B3C83B453EC}"/>
               </a:ext>
             </a:extLst>
           </p:cNvPr>
@@ -1755,7 +1755,7 @@
           <p:cNvPr id="6" name="">
             <a:extLst xmlns:a="http://schemas.openxmlformats.org/drawingml/2006/main">
               <a:ext uri="{FF2B5EF4-FFF2-40B4-BE49-F238E27FC236}">
-                <a16:creationId xmlns:a16="http://schemas.microsoft.com/office/drawing/2014/main" id="{8B5D1EFA-6117-477B-8D7A-3556F7B94A94}"/>
+                <a16:creationId xmlns:a16="http://schemas.microsoft.com/office/drawing/2014/main" id="{6B849B45-50E5-4239-82A6-B0E35AF6E6D6}"/>
               </a:ext>
             </a:extLst>
           </p:cNvPr>
@@ -1834,7 +1834,7 @@
           <p:cNvPr id="7" name="">
             <a:extLst xmlns:a="http://schemas.openxmlformats.org/drawingml/2006/main">
               <a:ext uri="{FF2B5EF4-FFF2-40B4-BE49-F238E27FC236}">
-                <a16:creationId xmlns:a16="http://schemas.microsoft.com/office/drawing/2014/main" id="{6CE213CD-E360-498B-887E-8B76FD7106F5}"/>
+                <a16:creationId xmlns:a16="http://schemas.microsoft.com/office/drawing/2014/main" id="{844F740C-7C2C-4B30-B46E-B0BE31B687A6}"/>
               </a:ext>
             </a:extLst>
           </p:cNvPr>
@@ -1888,7 +1888,7 @@
     </p:spTree>
     <p:extLst>
       <p:ext uri="{BB962C8B-B14F-4D97-AF65-F5344CB8AC3E}">
-        <p14:creationId xmlns:p14="http://schemas.microsoft.com/office/powerpoint/2010/main" val="1579025437"/>
+        <p14:creationId xmlns:p14="http://schemas.microsoft.com/office/powerpoint/2010/main" val="1963692219"/>
       </p:ext>
     </p:extLst>
   </p:cSld>
@@ -1919,7 +1919,7 @@
           <p:cNvPr id="21" name="">
             <a:extLst xmlns:a="http://schemas.openxmlformats.org/drawingml/2006/main">
               <a:ext uri="{FF2B5EF4-FFF2-40B4-BE49-F238E27FC236}">
-                <a16:creationId xmlns:a16="http://schemas.microsoft.com/office/drawing/2014/main" id="{C0FE978E-2344-4AD4-87F6-1532CE66A2E2}"/>
+                <a16:creationId xmlns:a16="http://schemas.microsoft.com/office/drawing/2014/main" id="{B81DACB6-B642-4DD1-944B-A7C77DA013C5}"/>
               </a:ext>
             </a:extLst>
           </p:cNvPr>
@@ -1975,7 +1975,7 @@
           <p:cNvPr id="2" name="">
             <a:extLst xmlns:a="http://schemas.openxmlformats.org/drawingml/2006/main">
               <a:ext uri="{FF2B5EF4-FFF2-40B4-BE49-F238E27FC236}">
-                <a16:creationId xmlns:a16="http://schemas.microsoft.com/office/drawing/2014/main" id="{8AAABABF-5E4B-4D3A-8AA3-89DCF0B7F746}"/>
+                <a16:creationId xmlns:a16="http://schemas.microsoft.com/office/drawing/2014/main" id="{4BBFDAB4-2CEE-4075-8934-6F78D0C28A0F}"/>
               </a:ext>
             </a:extLst>
           </p:cNvPr>
@@ -2031,7 +2031,7 @@
           <p:cNvPr id="3" name="">
             <a:extLst xmlns:a="http://schemas.openxmlformats.org/drawingml/2006/main">
               <a:ext uri="{FF2B5EF4-FFF2-40B4-BE49-F238E27FC236}">
-                <a16:creationId xmlns:a16="http://schemas.microsoft.com/office/drawing/2014/main" id="{5F50B792-C734-4D36-9EB0-787CF308593B}"/>
+                <a16:creationId xmlns:a16="http://schemas.microsoft.com/office/drawing/2014/main" id="{6025EAEB-E37D-48BF-BB1C-3435E71FCDA4}"/>
               </a:ext>
             </a:extLst>
           </p:cNvPr>
@@ -2087,7 +2087,7 @@
           <p:cNvPr id="4" name="">
             <a:extLst xmlns:a="http://schemas.openxmlformats.org/drawingml/2006/main">
               <a:ext uri="{FF2B5EF4-FFF2-40B4-BE49-F238E27FC236}">
-                <a16:creationId xmlns:a16="http://schemas.microsoft.com/office/drawing/2014/main" id="{8A194862-60B0-4A00-BED6-51B4A812C0F1}"/>
+                <a16:creationId xmlns:a16="http://schemas.microsoft.com/office/drawing/2014/main" id="{3D029ABA-78F5-4C01-B003-F5E24BCB3F57}"/>
               </a:ext>
             </a:extLst>
           </p:cNvPr>
@@ -2143,7 +2143,7 @@
           <p:cNvPr id="5" name="">
             <a:extLst xmlns:a="http://schemas.openxmlformats.org/drawingml/2006/main">
               <a:ext uri="{FF2B5EF4-FFF2-40B4-BE49-F238E27FC236}">
-                <a16:creationId xmlns:a16="http://schemas.microsoft.com/office/drawing/2014/main" id="{ACB4C0DB-C1AD-4B7F-8346-A1F8DE709DAB}"/>
+                <a16:creationId xmlns:a16="http://schemas.microsoft.com/office/drawing/2014/main" id="{7CBEB735-1046-4F2B-B1AB-55B593C7ECE9}"/>
               </a:ext>
             </a:extLst>
           </p:cNvPr>
@@ -2174,7 +2174,7 @@
           <p:cNvPr id="6" name="">
             <a:extLst xmlns:a="http://schemas.openxmlformats.org/drawingml/2006/main">
               <a:ext uri="{FF2B5EF4-FFF2-40B4-BE49-F238E27FC236}">
-                <a16:creationId xmlns:a16="http://schemas.microsoft.com/office/drawing/2014/main" id="{5D9F1F30-7501-4661-BA71-579C26A38744}"/>
+                <a16:creationId xmlns:a16="http://schemas.microsoft.com/office/drawing/2014/main" id="{E4730941-B91E-4B22-ACDB-5A84E90A7B37}"/>
               </a:ext>
             </a:extLst>
           </p:cNvPr>
@@ -2230,7 +2230,7 @@
           <p:cNvPr id="7" name="">
             <a:extLst xmlns:a="http://schemas.openxmlformats.org/drawingml/2006/main">
               <a:ext uri="{FF2B5EF4-FFF2-40B4-BE49-F238E27FC236}">
-                <a16:creationId xmlns:a16="http://schemas.microsoft.com/office/drawing/2014/main" id="{D9B998D1-0E1E-465B-86F5-649B18744656}"/>
+                <a16:creationId xmlns:a16="http://schemas.microsoft.com/office/drawing/2014/main" id="{E592A08E-D89F-4A6B-9238-0C2E21BE6025}"/>
               </a:ext>
             </a:extLst>
           </p:cNvPr>
@@ -2286,7 +2286,7 @@
           <p:cNvPr id="8" name="">
             <a:extLst xmlns:a="http://schemas.openxmlformats.org/drawingml/2006/main">
               <a:ext uri="{FF2B5EF4-FFF2-40B4-BE49-F238E27FC236}">
-                <a16:creationId xmlns:a16="http://schemas.microsoft.com/office/drawing/2014/main" id="{169AD400-AD08-46E3-B6FD-6D0A2A72398C}"/>
+                <a16:creationId xmlns:a16="http://schemas.microsoft.com/office/drawing/2014/main" id="{DA5C8306-F1C0-4583-9D5E-540F351D2591}"/>
               </a:ext>
             </a:extLst>
           </p:cNvPr>
@@ -2342,7 +2342,7 @@
           <p:cNvPr id="9" name="">
             <a:extLst xmlns:a="http://schemas.openxmlformats.org/drawingml/2006/main">
               <a:ext uri="{FF2B5EF4-FFF2-40B4-BE49-F238E27FC236}">
-                <a16:creationId xmlns:a16="http://schemas.microsoft.com/office/drawing/2014/main" id="{E72DBB4E-F7B1-408A-9FF6-E4B5D3FCECE9}"/>
+                <a16:creationId xmlns:a16="http://schemas.microsoft.com/office/drawing/2014/main" id="{B13C48C9-E3D1-4F45-B462-AE4D2D435729}"/>
               </a:ext>
             </a:extLst>
           </p:cNvPr>
@@ -2373,7 +2373,7 @@
           <p:cNvPr id="10" name="">
             <a:extLst xmlns:a="http://schemas.openxmlformats.org/drawingml/2006/main">
               <a:ext uri="{FF2B5EF4-FFF2-40B4-BE49-F238E27FC236}">
-                <a16:creationId xmlns:a16="http://schemas.microsoft.com/office/drawing/2014/main" id="{9B03CBDF-FD7C-4534-BA3D-3C14BA2BE130}"/>
+                <a16:creationId xmlns:a16="http://schemas.microsoft.com/office/drawing/2014/main" id="{6F9CB6E6-9FBA-4CA1-AF3E-2D6C19A7A8D3}"/>
               </a:ext>
             </a:extLst>
           </p:cNvPr>
@@ -2429,7 +2429,7 @@
           <p:cNvPr id="11" name="">
             <a:extLst xmlns:a="http://schemas.openxmlformats.org/drawingml/2006/main">
               <a:ext uri="{FF2B5EF4-FFF2-40B4-BE49-F238E27FC236}">
-                <a16:creationId xmlns:a16="http://schemas.microsoft.com/office/drawing/2014/main" id="{8D3035CE-EF3F-423F-95AD-9F8109EE7314}"/>
+                <a16:creationId xmlns:a16="http://schemas.microsoft.com/office/drawing/2014/main" id="{BC261F93-DAB4-4D3B-B2B7-9058099CD4B0}"/>
               </a:ext>
             </a:extLst>
           </p:cNvPr>
@@ -2485,7 +2485,7 @@
           <p:cNvPr id="12" name="">
             <a:extLst xmlns:a="http://schemas.openxmlformats.org/drawingml/2006/main">
               <a:ext uri="{FF2B5EF4-FFF2-40B4-BE49-F238E27FC236}">
-                <a16:creationId xmlns:a16="http://schemas.microsoft.com/office/drawing/2014/main" id="{26E14932-44B2-4467-979C-683C2C1969DE}"/>
+                <a16:creationId xmlns:a16="http://schemas.microsoft.com/office/drawing/2014/main" id="{89FE405C-A52A-49C3-8571-0A3DA745C7DA}"/>
               </a:ext>
             </a:extLst>
           </p:cNvPr>
@@ -2541,7 +2541,7 @@
           <p:cNvPr id="13" name="">
             <a:extLst xmlns:a="http://schemas.openxmlformats.org/drawingml/2006/main">
               <a:ext uri="{FF2B5EF4-FFF2-40B4-BE49-F238E27FC236}">
-                <a16:creationId xmlns:a16="http://schemas.microsoft.com/office/drawing/2014/main" id="{E859CE01-FD3A-4384-9C4F-9201492E1833}"/>
+                <a16:creationId xmlns:a16="http://schemas.microsoft.com/office/drawing/2014/main" id="{A1B95424-5C90-437A-B817-5FEA490AB48A}"/>
               </a:ext>
             </a:extLst>
           </p:cNvPr>
@@ -2572,7 +2572,7 @@
           <p:cNvPr id="14" name="">
             <a:extLst xmlns:a="http://schemas.openxmlformats.org/drawingml/2006/main">
               <a:ext uri="{FF2B5EF4-FFF2-40B4-BE49-F238E27FC236}">
-                <a16:creationId xmlns:a16="http://schemas.microsoft.com/office/drawing/2014/main" id="{6567810B-2C83-4893-86F9-F295D84E0CFA}"/>
+                <a16:creationId xmlns:a16="http://schemas.microsoft.com/office/drawing/2014/main" id="{C5AB9C6E-D63F-4A52-A9C9-5703AB3BA462}"/>
               </a:ext>
             </a:extLst>
           </p:cNvPr>
@@ -2628,7 +2628,7 @@
           <p:cNvPr id="15" name="">
             <a:extLst xmlns:a="http://schemas.openxmlformats.org/drawingml/2006/main">
               <a:ext uri="{FF2B5EF4-FFF2-40B4-BE49-F238E27FC236}">
-                <a16:creationId xmlns:a16="http://schemas.microsoft.com/office/drawing/2014/main" id="{A4DFDE7D-302B-482B-9494-A143CE9C137F}"/>
+                <a16:creationId xmlns:a16="http://schemas.microsoft.com/office/drawing/2014/main" id="{3F15DC03-9B53-44CF-BEF0-889FEC51946D}"/>
               </a:ext>
             </a:extLst>
           </p:cNvPr>
@@ -2684,7 +2684,7 @@
           <p:cNvPr id="16" name="">
             <a:extLst xmlns:a="http://schemas.openxmlformats.org/drawingml/2006/main">
               <a:ext uri="{FF2B5EF4-FFF2-40B4-BE49-F238E27FC236}">
-                <a16:creationId xmlns:a16="http://schemas.microsoft.com/office/drawing/2014/main" id="{5ECE5708-BFBC-4A19-9DEC-07005BC58F2D}"/>
+                <a16:creationId xmlns:a16="http://schemas.microsoft.com/office/drawing/2014/main" id="{7400C4E4-25E5-4CC5-A493-CF9F845CB51F}"/>
               </a:ext>
             </a:extLst>
           </p:cNvPr>
@@ -2740,7 +2740,7 @@
           <p:cNvPr id="17" name="">
             <a:extLst xmlns:a="http://schemas.openxmlformats.org/drawingml/2006/main">
               <a:ext uri="{FF2B5EF4-FFF2-40B4-BE49-F238E27FC236}">
-                <a16:creationId xmlns:a16="http://schemas.microsoft.com/office/drawing/2014/main" id="{68B56DAA-28BF-45AB-9A8E-85391D1AE134}"/>
+                <a16:creationId xmlns:a16="http://schemas.microsoft.com/office/drawing/2014/main" id="{AABFD430-CB2D-44B4-9EB1-094451FC275B}"/>
               </a:ext>
             </a:extLst>
           </p:cNvPr>
@@ -2771,7 +2771,7 @@
           <p:cNvPr id="18" name="">
             <a:extLst xmlns:a="http://schemas.openxmlformats.org/drawingml/2006/main">
               <a:ext uri="{FF2B5EF4-FFF2-40B4-BE49-F238E27FC236}">
-                <a16:creationId xmlns:a16="http://schemas.microsoft.com/office/drawing/2014/main" id="{6E7C84DB-EABA-4200-AA9C-3DB45BB1F266}"/>
+                <a16:creationId xmlns:a16="http://schemas.microsoft.com/office/drawing/2014/main" id="{A0DA2B0B-F68B-4988-AE91-18C812D1D1B3}"/>
               </a:ext>
             </a:extLst>
           </p:cNvPr>
@@ -2827,7 +2827,7 @@
           <p:cNvPr id="19" name="">
             <a:extLst xmlns:a="http://schemas.openxmlformats.org/drawingml/2006/main">
               <a:ext uri="{FF2B5EF4-FFF2-40B4-BE49-F238E27FC236}">
-                <a16:creationId xmlns:a16="http://schemas.microsoft.com/office/drawing/2014/main" id="{C801B364-4984-4B22-A0DA-5CF2D8A758B3}"/>
+                <a16:creationId xmlns:a16="http://schemas.microsoft.com/office/drawing/2014/main" id="{88725B02-F8A9-4E29-AF5C-64B5BAA7A638}"/>
               </a:ext>
             </a:extLst>
           </p:cNvPr>
@@ -2883,7 +2883,7 @@
           <p:cNvPr id="20" name="">
             <a:extLst xmlns:a="http://schemas.openxmlformats.org/drawingml/2006/main">
               <a:ext uri="{FF2B5EF4-FFF2-40B4-BE49-F238E27FC236}">
-                <a16:creationId xmlns:a16="http://schemas.microsoft.com/office/drawing/2014/main" id="{F9CB50DE-66F4-457B-8485-B9A4B7B46AC2}"/>
+                <a16:creationId xmlns:a16="http://schemas.microsoft.com/office/drawing/2014/main" id="{0DFFE737-874B-4296-B2A1-3704D578E48B}"/>
               </a:ext>
             </a:extLst>
           </p:cNvPr>
@@ -2937,7 +2937,7 @@
     </p:spTree>
     <p:extLst>
       <p:ext uri="{BB962C8B-B14F-4D97-AF65-F5344CB8AC3E}">
-        <p14:creationId xmlns:p14="http://schemas.microsoft.com/office/powerpoint/2010/main" val="995490604"/>
+        <p14:creationId xmlns:p14="http://schemas.microsoft.com/office/powerpoint/2010/main" val="1550593081"/>
       </p:ext>
     </p:extLst>
   </p:cSld>
@@ -2968,7 +2968,7 @@
           <p:cNvPr id="23" name="">
             <a:extLst xmlns:a="http://schemas.openxmlformats.org/drawingml/2006/main">
               <a:ext uri="{FF2B5EF4-FFF2-40B4-BE49-F238E27FC236}">
-                <a16:creationId xmlns:a16="http://schemas.microsoft.com/office/drawing/2014/main" id="{4B07FB9B-E5B5-4891-8B2A-E053FC9D1C07}"/>
+                <a16:creationId xmlns:a16="http://schemas.microsoft.com/office/drawing/2014/main" id="{3652A4B3-5704-4AB6-BBFA-9F7B5C63B5C4}"/>
               </a:ext>
             </a:extLst>
           </p:cNvPr>
@@ -3024,7 +3024,7 @@
           <p:cNvPr id="2" name="">
             <a:extLst xmlns:a="http://schemas.openxmlformats.org/drawingml/2006/main">
               <a:ext uri="{FF2B5EF4-FFF2-40B4-BE49-F238E27FC236}">
-                <a16:creationId xmlns:a16="http://schemas.microsoft.com/office/drawing/2014/main" id="{EF85E67A-8FD9-46B7-B303-EB580B4CDEB4}"/>
+                <a16:creationId xmlns:a16="http://schemas.microsoft.com/office/drawing/2014/main" id="{6362A262-6D48-4BE7-AB9C-20E1C323E1BA}"/>
               </a:ext>
             </a:extLst>
           </p:cNvPr>
@@ -3080,7 +3080,7 @@
           <p:cNvPr id="3" name="">
             <a:extLst xmlns:a="http://schemas.openxmlformats.org/drawingml/2006/main">
               <a:ext uri="{FF2B5EF4-FFF2-40B4-BE49-F238E27FC236}">
-                <a16:creationId xmlns:a16="http://schemas.microsoft.com/office/drawing/2014/main" id="{620501E1-2BB0-4858-93EA-99568333E50D}"/>
+                <a16:creationId xmlns:a16="http://schemas.microsoft.com/office/drawing/2014/main" id="{58878DC7-F3EA-4E93-A189-7032A0CAE6D0}"/>
               </a:ext>
             </a:extLst>
           </p:cNvPr>
@@ -3136,7 +3136,7 @@
           <p:cNvPr id="4" name="">
             <a:extLst xmlns:a="http://schemas.openxmlformats.org/drawingml/2006/main">
               <a:ext uri="{FF2B5EF4-FFF2-40B4-BE49-F238E27FC236}">
-                <a16:creationId xmlns:a16="http://schemas.microsoft.com/office/drawing/2014/main" id="{535D0505-82D3-4033-BECD-82EC356EF712}"/>
+                <a16:creationId xmlns:a16="http://schemas.microsoft.com/office/drawing/2014/main" id="{91D04CDF-8F41-496D-B710-149EA015290F}"/>
               </a:ext>
             </a:extLst>
           </p:cNvPr>
@@ -3192,7 +3192,7 @@
           <p:cNvPr id="5" name="">
             <a:extLst xmlns:a="http://schemas.openxmlformats.org/drawingml/2006/main">
               <a:ext uri="{FF2B5EF4-FFF2-40B4-BE49-F238E27FC236}">
-                <a16:creationId xmlns:a16="http://schemas.microsoft.com/office/drawing/2014/main" id="{6E71D076-CDBC-49DD-82B1-1A5CFB362B99}"/>
+                <a16:creationId xmlns:a16="http://schemas.microsoft.com/office/drawing/2014/main" id="{F425B2C1-64E5-4DB6-A472-E217E21E6D8B}"/>
               </a:ext>
             </a:extLst>
           </p:cNvPr>
@@ -3223,7 +3223,7 @@
           <p:cNvPr id="6" name="">
             <a:extLst xmlns:a="http://schemas.openxmlformats.org/drawingml/2006/main">
               <a:ext uri="{FF2B5EF4-FFF2-40B4-BE49-F238E27FC236}">
-                <a16:creationId xmlns:a16="http://schemas.microsoft.com/office/drawing/2014/main" id="{442BC164-44EC-4D4B-94C2-8D6B1CC85DE1}"/>
+                <a16:creationId xmlns:a16="http://schemas.microsoft.com/office/drawing/2014/main" id="{F0B23118-8D0C-432E-A1ED-8D39A43DB194}"/>
               </a:ext>
             </a:extLst>
           </p:cNvPr>
@@ -3279,7 +3279,7 @@
           <p:cNvPr id="7" name="">
             <a:extLst xmlns:a="http://schemas.openxmlformats.org/drawingml/2006/main">
               <a:ext uri="{FF2B5EF4-FFF2-40B4-BE49-F238E27FC236}">
-                <a16:creationId xmlns:a16="http://schemas.microsoft.com/office/drawing/2014/main" id="{9A976CAB-E297-4661-95EA-141434B1B4AF}"/>
+                <a16:creationId xmlns:a16="http://schemas.microsoft.com/office/drawing/2014/main" id="{6FC1EFC3-8F0C-4797-BD77-0E035D9B1FB9}"/>
               </a:ext>
             </a:extLst>
           </p:cNvPr>
@@ -3335,7 +3335,7 @@
           <p:cNvPr id="8" name="">
             <a:extLst xmlns:a="http://schemas.openxmlformats.org/drawingml/2006/main">
               <a:ext uri="{FF2B5EF4-FFF2-40B4-BE49-F238E27FC236}">
-                <a16:creationId xmlns:a16="http://schemas.microsoft.com/office/drawing/2014/main" id="{FFC8230E-E2AE-4B4E-B5B5-34B33FEF5F7F}"/>
+                <a16:creationId xmlns:a16="http://schemas.microsoft.com/office/drawing/2014/main" id="{B17A5875-2665-412E-A469-D492D41568ED}"/>
               </a:ext>
             </a:extLst>
           </p:cNvPr>
@@ -3391,7 +3391,7 @@
           <p:cNvPr id="9" name="">
             <a:extLst xmlns:a="http://schemas.openxmlformats.org/drawingml/2006/main">
               <a:ext uri="{FF2B5EF4-FFF2-40B4-BE49-F238E27FC236}">
-                <a16:creationId xmlns:a16="http://schemas.microsoft.com/office/drawing/2014/main" id="{BF5C0882-3D4F-4AAC-BC4D-1A4BA94F9572}"/>
+                <a16:creationId xmlns:a16="http://schemas.microsoft.com/office/drawing/2014/main" id="{C5CF2F4B-7367-47C4-8F64-EBAB8F72DE53}"/>
               </a:ext>
             </a:extLst>
           </p:cNvPr>
@@ -3422,7 +3422,7 @@
           <p:cNvPr id="10" name="">
             <a:extLst xmlns:a="http://schemas.openxmlformats.org/drawingml/2006/main">
               <a:ext uri="{FF2B5EF4-FFF2-40B4-BE49-F238E27FC236}">
-                <a16:creationId xmlns:a16="http://schemas.microsoft.com/office/drawing/2014/main" id="{742E071C-84EA-4805-9C78-A48DD55383A5}"/>
+                <a16:creationId xmlns:a16="http://schemas.microsoft.com/office/drawing/2014/main" id="{55690B3B-E524-4B50-9C7C-F2C997C64B1D}"/>
               </a:ext>
             </a:extLst>
           </p:cNvPr>
@@ -3478,7 +3478,7 @@
           <p:cNvPr id="11" name="">
             <a:extLst xmlns:a="http://schemas.openxmlformats.org/drawingml/2006/main">
               <a:ext uri="{FF2B5EF4-FFF2-40B4-BE49-F238E27FC236}">
-                <a16:creationId xmlns:a16="http://schemas.microsoft.com/office/drawing/2014/main" id="{788C3416-C480-4656-8312-75BD1C821AB7}"/>
+                <a16:creationId xmlns:a16="http://schemas.microsoft.com/office/drawing/2014/main" id="{E49443F6-CA52-490B-9922-8827EAF320A0}"/>
               </a:ext>
             </a:extLst>
           </p:cNvPr>
@@ -3534,7 +3534,7 @@
           <p:cNvPr id="12" name="">
             <a:extLst xmlns:a="http://schemas.openxmlformats.org/drawingml/2006/main">
               <a:ext uri="{FF2B5EF4-FFF2-40B4-BE49-F238E27FC236}">
-                <a16:creationId xmlns:a16="http://schemas.microsoft.com/office/drawing/2014/main" id="{8CB0FEE7-7678-4C2F-94A9-4AA180BAFAB4}"/>
+                <a16:creationId xmlns:a16="http://schemas.microsoft.com/office/drawing/2014/main" id="{F98C7A2D-1F53-4F99-A4F0-926E052EF0F0}"/>
               </a:ext>
             </a:extLst>
           </p:cNvPr>
@@ -3590,7 +3590,7 @@
           <p:cNvPr id="13" name="">
             <a:extLst xmlns:a="http://schemas.openxmlformats.org/drawingml/2006/main">
               <a:ext uri="{FF2B5EF4-FFF2-40B4-BE49-F238E27FC236}">
-                <a16:creationId xmlns:a16="http://schemas.microsoft.com/office/drawing/2014/main" id="{B09F02B5-16F3-4923-9320-029621353579}"/>
+                <a16:creationId xmlns:a16="http://schemas.microsoft.com/office/drawing/2014/main" id="{E5D6E362-6BA9-4225-854D-A0B63236F0C3}"/>
               </a:ext>
             </a:extLst>
           </p:cNvPr>
@@ -3621,7 +3621,7 @@
           <p:cNvPr id="14" name="">
             <a:extLst xmlns:a="http://schemas.openxmlformats.org/drawingml/2006/main">
               <a:ext uri="{FF2B5EF4-FFF2-40B4-BE49-F238E27FC236}">
-                <a16:creationId xmlns:a16="http://schemas.microsoft.com/office/drawing/2014/main" id="{26BF42B3-7998-4107-AE76-CB4A5A8AADE8}"/>
+                <a16:creationId xmlns:a16="http://schemas.microsoft.com/office/drawing/2014/main" id="{11BA7EDB-DA81-4B5E-AB2E-70F5982D235C}"/>
               </a:ext>
             </a:extLst>
           </p:cNvPr>
@@ -3677,7 +3677,7 @@
           <p:cNvPr id="15" name="">
             <a:extLst xmlns:a="http://schemas.openxmlformats.org/drawingml/2006/main">
               <a:ext uri="{FF2B5EF4-FFF2-40B4-BE49-F238E27FC236}">
-                <a16:creationId xmlns:a16="http://schemas.microsoft.com/office/drawing/2014/main" id="{E5BA9E12-EF20-41A8-AF25-4EE66C60255A}"/>
+                <a16:creationId xmlns:a16="http://schemas.microsoft.com/office/drawing/2014/main" id="{A13BD9A2-E3C0-4914-807E-20CD0435D64F}"/>
               </a:ext>
             </a:extLst>
           </p:cNvPr>
@@ -3733,7 +3733,7 @@
           <p:cNvPr id="16" name="">
             <a:extLst xmlns:a="http://schemas.openxmlformats.org/drawingml/2006/main">
               <a:ext uri="{FF2B5EF4-FFF2-40B4-BE49-F238E27FC236}">
-                <a16:creationId xmlns:a16="http://schemas.microsoft.com/office/drawing/2014/main" id="{1E66559D-2AED-4336-A92C-214CB2B34FDE}"/>
+                <a16:creationId xmlns:a16="http://schemas.microsoft.com/office/drawing/2014/main" id="{89C498B5-ABB5-482B-AB8C-2BB3F5EDD4D6}"/>
               </a:ext>
             </a:extLst>
           </p:cNvPr>
@@ -3789,7 +3789,7 @@
           <p:cNvPr id="17" name="">
             <a:extLst xmlns:a="http://schemas.openxmlformats.org/drawingml/2006/main">
               <a:ext uri="{FF2B5EF4-FFF2-40B4-BE49-F238E27FC236}">
-                <a16:creationId xmlns:a16="http://schemas.microsoft.com/office/drawing/2014/main" id="{F13F218A-1B75-40BA-A983-BB3FF4C6D2F4}"/>
+                <a16:creationId xmlns:a16="http://schemas.microsoft.com/office/drawing/2014/main" id="{C8D591D3-57AD-495B-8059-6E9A6202B0EA}"/>
               </a:ext>
             </a:extLst>
           </p:cNvPr>
@@ -3820,7 +3820,7 @@
           <p:cNvPr id="18" name="">
             <a:extLst xmlns:a="http://schemas.openxmlformats.org/drawingml/2006/main">
               <a:ext uri="{FF2B5EF4-FFF2-40B4-BE49-F238E27FC236}">
-                <a16:creationId xmlns:a16="http://schemas.microsoft.com/office/drawing/2014/main" id="{9AB0A591-83F0-4A13-B452-F4A17FCE8425}"/>
+                <a16:creationId xmlns:a16="http://schemas.microsoft.com/office/drawing/2014/main" id="{34D9BCBC-0206-4A8B-9140-5A8DFC0E514E}"/>
               </a:ext>
             </a:extLst>
           </p:cNvPr>
@@ -3876,7 +3876,7 @@
           <p:cNvPr id="19" name="">
             <a:extLst xmlns:a="http://schemas.openxmlformats.org/drawingml/2006/main">
               <a:ext uri="{FF2B5EF4-FFF2-40B4-BE49-F238E27FC236}">
-                <a16:creationId xmlns:a16="http://schemas.microsoft.com/office/drawing/2014/main" id="{99454FB2-DC84-4294-84F5-C2EDC3719AE2}"/>
+                <a16:creationId xmlns:a16="http://schemas.microsoft.com/office/drawing/2014/main" id="{AB1721F4-1898-4475-AE5D-7D4EFA2517EC}"/>
               </a:ext>
             </a:extLst>
           </p:cNvPr>
@@ -3932,7 +3932,7 @@
           <p:cNvPr id="20" name="">
             <a:extLst xmlns:a="http://schemas.openxmlformats.org/drawingml/2006/main">
               <a:ext uri="{FF2B5EF4-FFF2-40B4-BE49-F238E27FC236}">
-                <a16:creationId xmlns:a16="http://schemas.microsoft.com/office/drawing/2014/main" id="{2FB9DD5B-B96B-4137-B170-6DD53A8BF87E}"/>
+                <a16:creationId xmlns:a16="http://schemas.microsoft.com/office/drawing/2014/main" id="{397C1CBA-D313-4F17-879C-569014E92256}"/>
               </a:ext>
             </a:extLst>
           </p:cNvPr>
@@ -3988,7 +3988,7 @@
           <p:cNvPr id="21" name="">
             <a:extLst xmlns:a="http://schemas.openxmlformats.org/drawingml/2006/main">
               <a:ext uri="{FF2B5EF4-FFF2-40B4-BE49-F238E27FC236}">
-                <a16:creationId xmlns:a16="http://schemas.microsoft.com/office/drawing/2014/main" id="{21772A46-F545-4463-A523-EB748518FC42}"/>
+                <a16:creationId xmlns:a16="http://schemas.microsoft.com/office/drawing/2014/main" id="{48829EAC-470A-4744-AC77-D6D0778C2705}"/>
               </a:ext>
             </a:extLst>
           </p:cNvPr>
@@ -4019,7 +4019,7 @@
           <p:cNvPr id="22" name="">
             <a:extLst xmlns:a="http://schemas.openxmlformats.org/drawingml/2006/main">
               <a:ext uri="{FF2B5EF4-FFF2-40B4-BE49-F238E27FC236}">
-                <a16:creationId xmlns:a16="http://schemas.microsoft.com/office/drawing/2014/main" id="{76C61BB2-C4E3-4FE5-9C57-6B3BCD6D89BB}"/>
+                <a16:creationId xmlns:a16="http://schemas.microsoft.com/office/drawing/2014/main" id="{E36431C4-F264-4677-B778-AEB8AD1F0431}"/>
               </a:ext>
             </a:extLst>
           </p:cNvPr>
@@ -4073,7 +4073,7 @@
     </p:spTree>
     <p:extLst>
       <p:ext uri="{BB962C8B-B14F-4D97-AF65-F5344CB8AC3E}">
-        <p14:creationId xmlns:p14="http://schemas.microsoft.com/office/powerpoint/2010/main" val="801295764"/>
+        <p14:creationId xmlns:p14="http://schemas.microsoft.com/office/powerpoint/2010/main" val="1071479596"/>
       </p:ext>
     </p:extLst>
   </p:cSld>
@@ -4104,7 +4104,7 @@
           <p:cNvPr id="9" name="">
             <a:extLst xmlns:a="http://schemas.openxmlformats.org/drawingml/2006/main">
               <a:ext uri="{FF2B5EF4-FFF2-40B4-BE49-F238E27FC236}">
-                <a16:creationId xmlns:a16="http://schemas.microsoft.com/office/drawing/2014/main" id="{C5A5BC03-30CA-4BC8-A007-B9F8EBE8E182}"/>
+                <a16:creationId xmlns:a16="http://schemas.microsoft.com/office/drawing/2014/main" id="{30A98E8F-1D73-4FF0-92AA-8E9606BBD2BD}"/>
               </a:ext>
             </a:extLst>
           </p:cNvPr>
@@ -4160,7 +4160,7 @@
           <p:cNvPr id="2" name="">
             <a:extLst xmlns:a="http://schemas.openxmlformats.org/drawingml/2006/main">
               <a:ext uri="{FF2B5EF4-FFF2-40B4-BE49-F238E27FC236}">
-                <a16:creationId xmlns:a16="http://schemas.microsoft.com/office/drawing/2014/main" id="{8AF1FC15-2849-486E-A728-B2D6A01AF4ED}"/>
+                <a16:creationId xmlns:a16="http://schemas.microsoft.com/office/drawing/2014/main" id="{E903E680-5672-45D9-8C52-3DE93E24653E}"/>
               </a:ext>
             </a:extLst>
           </p:cNvPr>
@@ -4216,7 +4216,7 @@
           <p:cNvPr id="3" name="">
             <a:extLst xmlns:a="http://schemas.openxmlformats.org/drawingml/2006/main">
               <a:ext uri="{FF2B5EF4-FFF2-40B4-BE49-F238E27FC236}">
-                <a16:creationId xmlns:a16="http://schemas.microsoft.com/office/drawing/2014/main" id="{F92CF9F6-CB08-4EC4-BD97-78F671FA990E}"/>
+                <a16:creationId xmlns:a16="http://schemas.microsoft.com/office/drawing/2014/main" id="{DBD838F7-D9A2-40A6-B4B3-AE78AC929E4E}"/>
               </a:ext>
             </a:extLst>
           </p:cNvPr>
@@ -4272,7 +4272,7 @@
           <p:cNvPr id="4" name="">
             <a:extLst xmlns:a="http://schemas.openxmlformats.org/drawingml/2006/main">
               <a:ext uri="{FF2B5EF4-FFF2-40B4-BE49-F238E27FC236}">
-                <a16:creationId xmlns:a16="http://schemas.microsoft.com/office/drawing/2014/main" id="{4442EBD7-DC9B-4562-B325-5943803F3126}"/>
+                <a16:creationId xmlns:a16="http://schemas.microsoft.com/office/drawing/2014/main" id="{17CAFB13-9DC5-4B5E-BA5C-38DF492B601C}"/>
               </a:ext>
             </a:extLst>
           </p:cNvPr>
@@ -4328,7 +4328,7 @@
           <p:cNvPr id="5" name="">
             <a:extLst xmlns:a="http://schemas.openxmlformats.org/drawingml/2006/main">
               <a:ext uri="{FF2B5EF4-FFF2-40B4-BE49-F238E27FC236}">
-                <a16:creationId xmlns:a16="http://schemas.microsoft.com/office/drawing/2014/main" id="{E80CD671-872F-4024-B381-E0BA4790DA40}"/>
+                <a16:creationId xmlns:a16="http://schemas.microsoft.com/office/drawing/2014/main" id="{C03ECA59-7A87-49B3-A90B-BAB4D680D43C}"/>
               </a:ext>
             </a:extLst>
           </p:cNvPr>
@@ -4468,7 +4468,7 @@
           <p:cNvPr id="6" name="">
             <a:extLst xmlns:a="http://schemas.openxmlformats.org/drawingml/2006/main">
               <a:ext uri="{FF2B5EF4-FFF2-40B4-BE49-F238E27FC236}">
-                <a16:creationId xmlns:a16="http://schemas.microsoft.com/office/drawing/2014/main" id="{957F1ABE-5A86-4021-A053-F172023BAEBA}"/>
+                <a16:creationId xmlns:a16="http://schemas.microsoft.com/office/drawing/2014/main" id="{052A18D3-6A3F-4234-8826-4F63BEDAAA95}"/>
               </a:ext>
             </a:extLst>
           </p:cNvPr>
@@ -4505,7 +4505,7 @@
           <p:nvPr/>
         </p:nvPicPr>
         <p:blipFill>
-          <a:blip xmlns:r="http://schemas.openxmlformats.org/officeDocument/2006/relationships" xmlns:a="http://schemas.openxmlformats.org/drawingml/2006/main" r:embed="R7d74b581a6f945c9"/>
+          <a:blip xmlns:r="http://schemas.openxmlformats.org/officeDocument/2006/relationships" xmlns:a="http://schemas.openxmlformats.org/drawingml/2006/main" r:embed="R6e388cc41f42474e"/>
           <a:stretch xmlns:a="http://schemas.openxmlformats.org/drawingml/2006/main"/>
         </p:blipFill>
         <p:spPr>
@@ -4523,7 +4523,7 @@
           <p:cNvPr id="8" name="">
             <a:extLst xmlns:a="http://schemas.openxmlformats.org/drawingml/2006/main">
               <a:ext uri="{FF2B5EF4-FFF2-40B4-BE49-F238E27FC236}">
-                <a16:creationId xmlns:a16="http://schemas.microsoft.com/office/drawing/2014/main" id="{525681EA-3F2E-487A-9DD9-2FAAA15B676E}"/>
+                <a16:creationId xmlns:a16="http://schemas.microsoft.com/office/drawing/2014/main" id="{B0150D73-AC6E-4C58-8266-B0C71E999178}"/>
               </a:ext>
             </a:extLst>
           </p:cNvPr>
@@ -4577,7 +4577,7 @@
     </p:spTree>
     <p:extLst>
       <p:ext uri="{BB962C8B-B14F-4D97-AF65-F5344CB8AC3E}">
-        <p14:creationId xmlns:p14="http://schemas.microsoft.com/office/powerpoint/2010/main" val="2010907077"/>
+        <p14:creationId xmlns:p14="http://schemas.microsoft.com/office/powerpoint/2010/main" val="329357279"/>
       </p:ext>
     </p:extLst>
   </p:cSld>
@@ -4608,7 +4608,7 @@
           <p:cNvPr id="15" name="">
             <a:extLst xmlns:a="http://schemas.openxmlformats.org/drawingml/2006/main">
               <a:ext uri="{FF2B5EF4-FFF2-40B4-BE49-F238E27FC236}">
-                <a16:creationId xmlns:a16="http://schemas.microsoft.com/office/drawing/2014/main" id="{6A3263C4-5EB4-4DEE-84B6-8BB6AC28671B}"/>
+                <a16:creationId xmlns:a16="http://schemas.microsoft.com/office/drawing/2014/main" id="{A38AAC00-5887-4683-B94D-1520BA20DD10}"/>
               </a:ext>
             </a:extLst>
           </p:cNvPr>
@@ -4664,7 +4664,7 @@
           <p:cNvPr id="2" name="">
             <a:extLst xmlns:a="http://schemas.openxmlformats.org/drawingml/2006/main">
               <a:ext uri="{FF2B5EF4-FFF2-40B4-BE49-F238E27FC236}">
-                <a16:creationId xmlns:a16="http://schemas.microsoft.com/office/drawing/2014/main" id="{716395FB-AD3E-4A91-B84D-F57376596FD1}"/>
+                <a16:creationId xmlns:a16="http://schemas.microsoft.com/office/drawing/2014/main" id="{F06FEE02-4B2E-4075-AB76-4AA694A570C3}"/>
               </a:ext>
             </a:extLst>
           </p:cNvPr>
@@ -4720,7 +4720,7 @@
           <p:cNvPr id="3" name="">
             <a:extLst xmlns:a="http://schemas.openxmlformats.org/drawingml/2006/main">
               <a:ext uri="{FF2B5EF4-FFF2-40B4-BE49-F238E27FC236}">
-                <a16:creationId xmlns:a16="http://schemas.microsoft.com/office/drawing/2014/main" id="{5A4D6E09-828B-4226-BB57-F27E0FD92338}"/>
+                <a16:creationId xmlns:a16="http://schemas.microsoft.com/office/drawing/2014/main" id="{6E8B611E-354D-41C1-811B-E313666E9517}"/>
               </a:ext>
             </a:extLst>
           </p:cNvPr>
@@ -4776,7 +4776,7 @@
           <p:cNvPr id="4" name="">
             <a:extLst xmlns:a="http://schemas.openxmlformats.org/drawingml/2006/main">
               <a:ext uri="{FF2B5EF4-FFF2-40B4-BE49-F238E27FC236}">
-                <a16:creationId xmlns:a16="http://schemas.microsoft.com/office/drawing/2014/main" id="{19AB7AC5-58B6-4F04-BF9A-8F520EA1A9E0}"/>
+                <a16:creationId xmlns:a16="http://schemas.microsoft.com/office/drawing/2014/main" id="{CC01886C-3579-4A59-B2D9-941039623ED3}"/>
               </a:ext>
             </a:extLst>
           </p:cNvPr>
@@ -4832,7 +4832,7 @@
           <p:cNvPr id="5" name="">
             <a:extLst xmlns:a="http://schemas.openxmlformats.org/drawingml/2006/main">
               <a:ext uri="{FF2B5EF4-FFF2-40B4-BE49-F238E27FC236}">
-                <a16:creationId xmlns:a16="http://schemas.microsoft.com/office/drawing/2014/main" id="{C966B016-EB14-4325-A1CC-E3E3D5ACACE0}"/>
+                <a16:creationId xmlns:a16="http://schemas.microsoft.com/office/drawing/2014/main" id="{333240A9-501B-401F-A747-63846292AE18}"/>
               </a:ext>
             </a:extLst>
           </p:cNvPr>
@@ -4863,7 +4863,7 @@
           <p:cNvPr id="6" name="">
             <a:extLst xmlns:a="http://schemas.openxmlformats.org/drawingml/2006/main">
               <a:ext uri="{FF2B5EF4-FFF2-40B4-BE49-F238E27FC236}">
-                <a16:creationId xmlns:a16="http://schemas.microsoft.com/office/drawing/2014/main" id="{F8F661D2-3242-47E6-9424-92654FEB4C9D}"/>
+                <a16:creationId xmlns:a16="http://schemas.microsoft.com/office/drawing/2014/main" id="{49B7DD5B-FB11-48BC-8551-41A2272204F7}"/>
               </a:ext>
             </a:extLst>
           </p:cNvPr>
@@ -4894,7 +4894,7 @@
           <p:cNvPr id="7" name="">
             <a:extLst xmlns:a="http://schemas.openxmlformats.org/drawingml/2006/main">
               <a:ext uri="{FF2B5EF4-FFF2-40B4-BE49-F238E27FC236}">
-                <a16:creationId xmlns:a16="http://schemas.microsoft.com/office/drawing/2014/main" id="{8FBD9F79-F161-47BA-B61D-2F183EE2C50A}"/>
+                <a16:creationId xmlns:a16="http://schemas.microsoft.com/office/drawing/2014/main" id="{4265D518-5E54-4015-BFD9-9DE087EA0A3A}"/>
               </a:ext>
             </a:extLst>
           </p:cNvPr>
@@ -4950,7 +4950,7 @@
           <p:cNvPr id="8" name="">
             <a:extLst xmlns:a="http://schemas.openxmlformats.org/drawingml/2006/main">
               <a:ext uri="{FF2B5EF4-FFF2-40B4-BE49-F238E27FC236}">
-                <a16:creationId xmlns:a16="http://schemas.microsoft.com/office/drawing/2014/main" id="{4F1F7A4A-B266-4DB3-B4A1-3F5989A5AC48}"/>
+                <a16:creationId xmlns:a16="http://schemas.microsoft.com/office/drawing/2014/main" id="{CF77AC74-09E2-4558-BEEC-DBC874115E26}"/>
               </a:ext>
             </a:extLst>
           </p:cNvPr>
@@ -5006,7 +5006,7 @@
           <p:cNvPr id="9" name="">
             <a:extLst xmlns:a="http://schemas.openxmlformats.org/drawingml/2006/main">
               <a:ext uri="{FF2B5EF4-FFF2-40B4-BE49-F238E27FC236}">
-                <a16:creationId xmlns:a16="http://schemas.microsoft.com/office/drawing/2014/main" id="{E25EBD15-FCF1-49F5-B56F-DE797605D130}"/>
+                <a16:creationId xmlns:a16="http://schemas.microsoft.com/office/drawing/2014/main" id="{05DE8135-1D83-4C5F-BA15-BB48986582D7}"/>
               </a:ext>
             </a:extLst>
           </p:cNvPr>
@@ -5131,7 +5131,7 @@
           <p:cNvPr id="10" name="">
             <a:extLst xmlns:a="http://schemas.openxmlformats.org/drawingml/2006/main">
               <a:ext uri="{FF2B5EF4-FFF2-40B4-BE49-F238E27FC236}">
-                <a16:creationId xmlns:a16="http://schemas.microsoft.com/office/drawing/2014/main" id="{9ACA398C-AB1B-41C7-A666-088672D4CF54}"/>
+                <a16:creationId xmlns:a16="http://schemas.microsoft.com/office/drawing/2014/main" id="{BFACC530-1C7A-4581-B12A-07A91D666F9B}"/>
               </a:ext>
             </a:extLst>
           </p:cNvPr>
@@ -5187,7 +5187,7 @@
           <p:cNvPr id="11" name="">
             <a:extLst xmlns:a="http://schemas.openxmlformats.org/drawingml/2006/main">
               <a:ext uri="{FF2B5EF4-FFF2-40B4-BE49-F238E27FC236}">
-                <a16:creationId xmlns:a16="http://schemas.microsoft.com/office/drawing/2014/main" id="{92F3B696-8B0A-44E3-BF75-59A29DF26E51}"/>
+                <a16:creationId xmlns:a16="http://schemas.microsoft.com/office/drawing/2014/main" id="{10BFB2F4-50D7-4DC2-BEF8-6B0C08325D0E}"/>
               </a:ext>
             </a:extLst>
           </p:cNvPr>
@@ -5243,7 +5243,7 @@
           <p:cNvPr id="12" name="">
             <a:extLst xmlns:a="http://schemas.openxmlformats.org/drawingml/2006/main">
               <a:ext uri="{FF2B5EF4-FFF2-40B4-BE49-F238E27FC236}">
-                <a16:creationId xmlns:a16="http://schemas.microsoft.com/office/drawing/2014/main" id="{86436F9E-86F5-4090-A800-50538DE40238}"/>
+                <a16:creationId xmlns:a16="http://schemas.microsoft.com/office/drawing/2014/main" id="{64E0108A-2F94-4556-B6D6-8474BEF1E421}"/>
               </a:ext>
             </a:extLst>
           </p:cNvPr>
@@ -5299,7 +5299,7 @@
           <p:cNvPr id="13" name="">
             <a:extLst xmlns:a="http://schemas.openxmlformats.org/drawingml/2006/main">
               <a:ext uri="{FF2B5EF4-FFF2-40B4-BE49-F238E27FC236}">
-                <a16:creationId xmlns:a16="http://schemas.microsoft.com/office/drawing/2014/main" id="{8971DFCD-BE8F-4619-8890-EEAB1360FB5C}"/>
+                <a16:creationId xmlns:a16="http://schemas.microsoft.com/office/drawing/2014/main" id="{148FB7D5-F004-41E4-9507-BC1F97784461}"/>
               </a:ext>
             </a:extLst>
           </p:cNvPr>
@@ -5424,7 +5424,7 @@
           <p:cNvPr id="14" name="">
             <a:extLst xmlns:a="http://schemas.openxmlformats.org/drawingml/2006/main">
               <a:ext uri="{FF2B5EF4-FFF2-40B4-BE49-F238E27FC236}">
-                <a16:creationId xmlns:a16="http://schemas.microsoft.com/office/drawing/2014/main" id="{C4E9F38B-192F-49ED-93E8-3B7BD8725072}"/>
+                <a16:creationId xmlns:a16="http://schemas.microsoft.com/office/drawing/2014/main" id="{53BF57C0-729B-4B4E-BEAB-096691F6BFC5}"/>
               </a:ext>
             </a:extLst>
           </p:cNvPr>
@@ -5478,7 +5478,7 @@
     </p:spTree>
     <p:extLst>
       <p:ext uri="{BB962C8B-B14F-4D97-AF65-F5344CB8AC3E}">
-        <p14:creationId xmlns:p14="http://schemas.microsoft.com/office/powerpoint/2010/main" val="1563651337"/>
+        <p14:creationId xmlns:p14="http://schemas.microsoft.com/office/powerpoint/2010/main" val="1177139156"/>
       </p:ext>
     </p:extLst>
   </p:cSld>
@@ -5506,10 +5506,10 @@
       </p:grpSpPr>
       <p:sp>
         <p:nvSpPr>
-          <p:cNvPr id="18" name="">
-            <a:extLst xmlns:a="http://schemas.openxmlformats.org/drawingml/2006/main">
-              <a:ext uri="{FF2B5EF4-FFF2-40B4-BE49-F238E27FC236}">
-                <a16:creationId xmlns:a16="http://schemas.microsoft.com/office/drawing/2014/main" id="{88287748-8D18-4493-8F8C-D2D9B62C032E}"/>
+          <p:cNvPr id="20" name="">
+            <a:extLst xmlns:a="http://schemas.openxmlformats.org/drawingml/2006/main">
+              <a:ext uri="{FF2B5EF4-FFF2-40B4-BE49-F238E27FC236}">
+                <a16:creationId xmlns:a16="http://schemas.microsoft.com/office/drawing/2014/main" id="{E5EAF928-B54E-4470-BE44-7657B9834476}"/>
               </a:ext>
             </a:extLst>
           </p:cNvPr>
@@ -5565,7 +5565,7 @@
           <p:cNvPr id="2" name="">
             <a:extLst xmlns:a="http://schemas.openxmlformats.org/drawingml/2006/main">
               <a:ext uri="{FF2B5EF4-FFF2-40B4-BE49-F238E27FC236}">
-                <a16:creationId xmlns:a16="http://schemas.microsoft.com/office/drawing/2014/main" id="{097E66DD-1DCE-47FE-8925-4113C68AFB61}"/>
+                <a16:creationId xmlns:a16="http://schemas.microsoft.com/office/drawing/2014/main" id="{2DE3BB85-7793-4F18-9AAC-89A34F978A86}"/>
               </a:ext>
             </a:extLst>
           </p:cNvPr>
@@ -5644,7 +5644,7 @@
           <p:cNvPr id="3" name="">
             <a:extLst xmlns:a="http://schemas.openxmlformats.org/drawingml/2006/main">
               <a:ext uri="{FF2B5EF4-FFF2-40B4-BE49-F238E27FC236}">
-                <a16:creationId xmlns:a16="http://schemas.microsoft.com/office/drawing/2014/main" id="{C9AFD279-FBEB-4BAE-9E68-142AF47954D0}"/>
+                <a16:creationId xmlns:a16="http://schemas.microsoft.com/office/drawing/2014/main" id="{E0F102CA-EDD0-4906-B7F9-7A2D022811B7}"/>
               </a:ext>
             </a:extLst>
           </p:cNvPr>
@@ -5700,7 +5700,7 @@
           <p:cNvPr id="4" name="">
             <a:extLst xmlns:a="http://schemas.openxmlformats.org/drawingml/2006/main">
               <a:ext uri="{FF2B5EF4-FFF2-40B4-BE49-F238E27FC236}">
-                <a16:creationId xmlns:a16="http://schemas.microsoft.com/office/drawing/2014/main" id="{785922D7-EA3E-4B58-9F7A-2FB84B424E90}"/>
+                <a16:creationId xmlns:a16="http://schemas.microsoft.com/office/drawing/2014/main" id="{FF5D2D55-40A1-4057-85DF-0AB466296570}"/>
               </a:ext>
             </a:extLst>
           </p:cNvPr>
@@ -5731,7 +5731,7 @@
           <p:cNvPr id="5" name="">
             <a:extLst xmlns:a="http://schemas.openxmlformats.org/drawingml/2006/main">
               <a:ext uri="{FF2B5EF4-FFF2-40B4-BE49-F238E27FC236}">
-                <a16:creationId xmlns:a16="http://schemas.microsoft.com/office/drawing/2014/main" id="{B9C440A2-8B0C-4A1C-A6A5-F370E92B37D5}"/>
+                <a16:creationId xmlns:a16="http://schemas.microsoft.com/office/drawing/2014/main" id="{FECE4D70-334C-4FE9-8629-D4C7C7C4601F}"/>
               </a:ext>
             </a:extLst>
           </p:cNvPr>
@@ -5787,7 +5787,7 @@
           <p:cNvPr id="6" name="">
             <a:extLst xmlns:a="http://schemas.openxmlformats.org/drawingml/2006/main">
               <a:ext uri="{FF2B5EF4-FFF2-40B4-BE49-F238E27FC236}">
-                <a16:creationId xmlns:a16="http://schemas.microsoft.com/office/drawing/2014/main" id="{71405AED-8003-4278-BA4E-3FCFEB5B3F41}"/>
+                <a16:creationId xmlns:a16="http://schemas.microsoft.com/office/drawing/2014/main" id="{7FAC556B-7539-477D-B178-8BB78F72C2B9}"/>
               </a:ext>
             </a:extLst>
           </p:cNvPr>
@@ -5843,7 +5843,7 @@
           <p:cNvPr id="7" name="">
             <a:extLst xmlns:a="http://schemas.openxmlformats.org/drawingml/2006/main">
               <a:ext uri="{FF2B5EF4-FFF2-40B4-BE49-F238E27FC236}">
-                <a16:creationId xmlns:a16="http://schemas.microsoft.com/office/drawing/2014/main" id="{FD20F29F-E9BA-41F1-A9BE-5EF1F5C2956E}"/>
+                <a16:creationId xmlns:a16="http://schemas.microsoft.com/office/drawing/2014/main" id="{9893AE07-B6DC-4D9F-A766-6684C416208B}"/>
               </a:ext>
             </a:extLst>
           </p:cNvPr>
@@ -5899,7 +5899,7 @@
           <p:cNvPr id="8" name="">
             <a:extLst xmlns:a="http://schemas.openxmlformats.org/drawingml/2006/main">
               <a:ext uri="{FF2B5EF4-FFF2-40B4-BE49-F238E27FC236}">
-                <a16:creationId xmlns:a16="http://schemas.microsoft.com/office/drawing/2014/main" id="{ECCFB3E1-CA9E-4811-9597-9CDF18B72710}"/>
+                <a16:creationId xmlns:a16="http://schemas.microsoft.com/office/drawing/2014/main" id="{451D749D-7617-4882-B8FF-8263B505C303}"/>
               </a:ext>
             </a:extLst>
           </p:cNvPr>
@@ -5930,7 +5930,7 @@
           <p:cNvPr id="9" name="">
             <a:extLst xmlns:a="http://schemas.openxmlformats.org/drawingml/2006/main">
               <a:ext uri="{FF2B5EF4-FFF2-40B4-BE49-F238E27FC236}">
-                <a16:creationId xmlns:a16="http://schemas.microsoft.com/office/drawing/2014/main" id="{2B4D82D3-0DD6-4EDB-982F-ED1701C3BE3B}"/>
+                <a16:creationId xmlns:a16="http://schemas.microsoft.com/office/drawing/2014/main" id="{3498F643-36C8-496C-8DD0-FE4A46C24597}"/>
               </a:ext>
             </a:extLst>
           </p:cNvPr>
@@ -5986,7 +5986,7 @@
           <p:cNvPr id="10" name="">
             <a:extLst xmlns:a="http://schemas.openxmlformats.org/drawingml/2006/main">
               <a:ext uri="{FF2B5EF4-FFF2-40B4-BE49-F238E27FC236}">
-                <a16:creationId xmlns:a16="http://schemas.microsoft.com/office/drawing/2014/main" id="{44E9D78F-1249-4655-9287-DEB2CE0FD24B}"/>
+                <a16:creationId xmlns:a16="http://schemas.microsoft.com/office/drawing/2014/main" id="{7BE2AAC4-99BB-4C0E-AA45-AB2A33791191}"/>
               </a:ext>
             </a:extLst>
           </p:cNvPr>
@@ -6042,7 +6042,7 @@
           <p:cNvPr id="11" name="">
             <a:extLst xmlns:a="http://schemas.openxmlformats.org/drawingml/2006/main">
               <a:ext uri="{FF2B5EF4-FFF2-40B4-BE49-F238E27FC236}">
-                <a16:creationId xmlns:a16="http://schemas.microsoft.com/office/drawing/2014/main" id="{DA4A8F39-04B5-465E-898A-B87BA54049D3}"/>
+                <a16:creationId xmlns:a16="http://schemas.microsoft.com/office/drawing/2014/main" id="{44343F02-36A8-4E09-8809-3C09E4BEB6DC}"/>
               </a:ext>
             </a:extLst>
           </p:cNvPr>
@@ -6098,7 +6098,7 @@
           <p:cNvPr id="12" name="">
             <a:extLst xmlns:a="http://schemas.openxmlformats.org/drawingml/2006/main">
               <a:ext uri="{FF2B5EF4-FFF2-40B4-BE49-F238E27FC236}">
-                <a16:creationId xmlns:a16="http://schemas.microsoft.com/office/drawing/2014/main" id="{DD7266F9-B40F-41A3-804A-3B40BC083674}"/>
+                <a16:creationId xmlns:a16="http://schemas.microsoft.com/office/drawing/2014/main" id="{D05AC38C-9B29-4C26-B11A-1A6634718F68}"/>
               </a:ext>
             </a:extLst>
           </p:cNvPr>
@@ -6129,7 +6129,7 @@
           <p:cNvPr id="13" name="">
             <a:extLst xmlns:a="http://schemas.openxmlformats.org/drawingml/2006/main">
               <a:ext uri="{FF2B5EF4-FFF2-40B4-BE49-F238E27FC236}">
-                <a16:creationId xmlns:a16="http://schemas.microsoft.com/office/drawing/2014/main" id="{6ADCACB4-4586-4DB3-9850-C282807CD68A}"/>
+                <a16:creationId xmlns:a16="http://schemas.microsoft.com/office/drawing/2014/main" id="{30D0D97B-2025-4F16-8A36-969915E40CDF}"/>
               </a:ext>
             </a:extLst>
           </p:cNvPr>
@@ -6185,7 +6185,7 @@
           <p:cNvPr id="14" name="">
             <a:extLst xmlns:a="http://schemas.openxmlformats.org/drawingml/2006/main">
               <a:ext uri="{FF2B5EF4-FFF2-40B4-BE49-F238E27FC236}">
-                <a16:creationId xmlns:a16="http://schemas.microsoft.com/office/drawing/2014/main" id="{60D96327-10CF-4CB2-803E-A07796118F70}"/>
+                <a16:creationId xmlns:a16="http://schemas.microsoft.com/office/drawing/2014/main" id="{70C01F9B-6913-4452-B03F-D9711D31B7F7}"/>
               </a:ext>
             </a:extLst>
           </p:cNvPr>
@@ -6241,7 +6241,7 @@
           <p:cNvPr id="15" name="">
             <a:extLst xmlns:a="http://schemas.openxmlformats.org/drawingml/2006/main">
               <a:ext uri="{FF2B5EF4-FFF2-40B4-BE49-F238E27FC236}">
-                <a16:creationId xmlns:a16="http://schemas.microsoft.com/office/drawing/2014/main" id="{64038786-27D2-49DA-A8A3-BAD1B9CC5D65}"/>
+                <a16:creationId xmlns:a16="http://schemas.microsoft.com/office/drawing/2014/main" id="{72C38233-0D44-4E43-988D-E89FC3060030}"/>
               </a:ext>
             </a:extLst>
           </p:cNvPr>
@@ -6297,35 +6297,91 @@
           <p:cNvPr id="16" name="">
             <a:extLst xmlns:a="http://schemas.openxmlformats.org/drawingml/2006/main">
               <a:ext uri="{FF2B5EF4-FFF2-40B4-BE49-F238E27FC236}">
-                <a16:creationId xmlns:a16="http://schemas.microsoft.com/office/drawing/2014/main" id="{C880B965-8050-4C42-9344-79492576BA48}"/>
-              </a:ext>
-            </a:extLst>
-          </p:cNvPr>
-          <p:cNvSpPr>
-            <a:spLocks xmlns:a="http://schemas.openxmlformats.org/drawingml/2006/main" noGrp="1"/>
-          </p:cNvSpPr>
-          <p:nvPr/>
-        </p:nvSpPr>
-        <p:spPr>
-          <a:xfrm xmlns:a="http://schemas.openxmlformats.org/drawingml/2006/main">
-            <a:off x="666750" y="5924550"/>
-            <a:ext cx="8191500" cy="266700"/>
-          </a:xfrm>
-          <a:prstGeom xmlns:a="http://schemas.openxmlformats.org/drawingml/2006/main" prst="rect">
-            <a:avLst/>
-          </a:prstGeom>
-          <a:noFill xmlns:a="http://schemas.openxmlformats.org/drawingml/2006/main"/>
-          <a:ln xmlns:a="http://schemas.openxmlformats.org/drawingml/2006/main" w="0">
-            <a:noFill/>
-            <a:prstDash val="solid"/>
-          </a:ln>
-        </p:spPr>
-        <p:txBody>
-          <a:bodyPr xmlns:a="http://schemas.openxmlformats.org/drawingml/2006/main" anchor="ctr"/>
-          <a:lstStyle xmlns:a="http://schemas.openxmlformats.org/drawingml/2006/main"/>
-          <a:p xmlns:a="http://schemas.openxmlformats.org/drawingml/2006/main">
-            <a:pPr algn="l">
-              <a:defRPr sz="1200" b="0">
+                <a16:creationId xmlns:a16="http://schemas.microsoft.com/office/drawing/2014/main" id="{10D97E0A-D6AD-4D80-A663-DB0244F21A90}"/>
+              </a:ext>
+            </a:extLst>
+          </p:cNvPr>
+          <p:cNvSpPr>
+            <a:spLocks xmlns:a="http://schemas.openxmlformats.org/drawingml/2006/main" noGrp="1"/>
+          </p:cNvSpPr>
+          <p:nvPr/>
+        </p:nvSpPr>
+        <p:spPr>
+          <a:xfrm xmlns:a="http://schemas.openxmlformats.org/drawingml/2006/main">
+            <a:off x="666750" y="5600700"/>
+            <a:ext cx="9429750" cy="247650"/>
+          </a:xfrm>
+          <a:prstGeom xmlns:a="http://schemas.openxmlformats.org/drawingml/2006/main" prst="rect">
+            <a:avLst/>
+          </a:prstGeom>
+          <a:noFill xmlns:a="http://schemas.openxmlformats.org/drawingml/2006/main"/>
+          <a:ln xmlns:a="http://schemas.openxmlformats.org/drawingml/2006/main" w="0">
+            <a:noFill/>
+            <a:prstDash val="solid"/>
+          </a:ln>
+        </p:spPr>
+        <p:txBody>
+          <a:bodyPr xmlns:a="http://schemas.openxmlformats.org/drawingml/2006/main" anchor="ctr"/>
+          <a:lstStyle xmlns:a="http://schemas.openxmlformats.org/drawingml/2006/main"/>
+          <a:p xmlns:a="http://schemas.openxmlformats.org/drawingml/2006/main">
+            <a:pPr algn="l">
+              <a:defRPr sz="1125" b="1">
+                <a:solidFill>
+                  <a:srgbClr val="FFFFFF"/>
+                </a:solidFill>
+                <a:latin typeface="Arial"/>
+                <a:ea typeface="Arial"/>
+                <a:cs typeface="Arial"/>
+              </a:defRPr>
+            </a:pPr>
+            <a:r>
+              <a:rPr sz="1125" b="1">
+                <a:solidFill>
+                  <a:srgbClr val="FFFFFF"/>
+                </a:solidFill>
+                <a:latin typeface="Arial"/>
+                <a:ea typeface="Arial"/>
+                <a:cs typeface="Arial"/>
+              </a:rPr>
+              <a:t>Windows 10/11 (x64) + macOS (Apple Silicon) — İndirme: github.com/Azizsekerdil/EnglishCourseAI/releases (v1.0.0, özel repo)</a:t>
+            </a:r>
+          </a:p>
+        </p:txBody>
+      </p:sp>
+      <p:sp>
+        <p:nvSpPr>
+          <p:cNvPr id="17" name="">
+            <a:extLst xmlns:a="http://schemas.openxmlformats.org/drawingml/2006/main">
+              <a:ext uri="{FF2B5EF4-FFF2-40B4-BE49-F238E27FC236}">
+                <a16:creationId xmlns:a16="http://schemas.microsoft.com/office/drawing/2014/main" id="{7744AF83-5888-45B0-BC43-3E0416BC5C30}"/>
+              </a:ext>
+            </a:extLst>
+          </p:cNvPr>
+          <p:cNvSpPr>
+            <a:spLocks xmlns:a="http://schemas.openxmlformats.org/drawingml/2006/main" noGrp="1"/>
+          </p:cNvSpPr>
+          <p:nvPr/>
+        </p:nvSpPr>
+        <p:spPr>
+          <a:xfrm xmlns:a="http://schemas.openxmlformats.org/drawingml/2006/main">
+            <a:off x="666750" y="5886450"/>
+            <a:ext cx="9429750" cy="228600"/>
+          </a:xfrm>
+          <a:prstGeom xmlns:a="http://schemas.openxmlformats.org/drawingml/2006/main" prst="rect">
+            <a:avLst/>
+          </a:prstGeom>
+          <a:noFill xmlns:a="http://schemas.openxmlformats.org/drawingml/2006/main"/>
+          <a:ln xmlns:a="http://schemas.openxmlformats.org/drawingml/2006/main" w="0">
+            <a:noFill/>
+            <a:prstDash val="solid"/>
+          </a:ln>
+        </p:spPr>
+        <p:txBody>
+          <a:bodyPr xmlns:a="http://schemas.openxmlformats.org/drawingml/2006/main" anchor="ctr"/>
+          <a:lstStyle xmlns:a="http://schemas.openxmlformats.org/drawingml/2006/main"/>
+          <a:p xmlns:a="http://schemas.openxmlformats.org/drawingml/2006/main">
+            <a:pPr algn="l">
+              <a:defRPr sz="1050" b="0">
                 <a:solidFill>
                   <a:srgbClr val="B9C7DD"/>
                 </a:solidFill>
@@ -6335,7 +6391,7 @@
               </a:defRPr>
             </a:pPr>
             <a:r>
-              <a:rPr sz="1200" b="0">
+              <a:rPr sz="1050" b="0">
                 <a:solidFill>
                   <a:srgbClr val="B9C7DD"/>
                 </a:solidFill>
@@ -6343,21 +6399,77 @@
                 <a:ea typeface="Arial"/>
                 <a:cs typeface="Arial"/>
               </a:rPr>
-              <a:t>D:/GE_FR/EnglishCourseAI/dist/EnglishCourseAI.exe</a:t>
+              <a:t>Windows 10/11 (x64) &amp; macOS (Apple Silicon) — Download: GitHub Releases (v1.0.0)</a:t>
+            </a:r>
+          </a:p>
+        </p:txBody>
+      </p:sp>
+      <p:sp>
+        <p:nvSpPr>
+          <p:cNvPr id="18" name="">
+            <a:extLst xmlns:a="http://schemas.openxmlformats.org/drawingml/2006/main">
+              <a:ext uri="{FF2B5EF4-FFF2-40B4-BE49-F238E27FC236}">
+                <a16:creationId xmlns:a16="http://schemas.microsoft.com/office/drawing/2014/main" id="{DA48AD66-8854-47AE-987E-A7CCEB016B55}"/>
+              </a:ext>
+            </a:extLst>
+          </p:cNvPr>
+          <p:cNvSpPr>
+            <a:spLocks xmlns:a="http://schemas.openxmlformats.org/drawingml/2006/main" noGrp="1"/>
+          </p:cNvSpPr>
+          <p:nvPr/>
+        </p:nvSpPr>
+        <p:spPr>
+          <a:xfrm xmlns:a="http://schemas.openxmlformats.org/drawingml/2006/main">
+            <a:off x="666750" y="6153150"/>
+            <a:ext cx="9429750" cy="209550"/>
+          </a:xfrm>
+          <a:prstGeom xmlns:a="http://schemas.openxmlformats.org/drawingml/2006/main" prst="rect">
+            <a:avLst/>
+          </a:prstGeom>
+          <a:noFill xmlns:a="http://schemas.openxmlformats.org/drawingml/2006/main"/>
+          <a:ln xmlns:a="http://schemas.openxmlformats.org/drawingml/2006/main" w="0">
+            <a:noFill/>
+            <a:prstDash val="solid"/>
+          </a:ln>
+        </p:spPr>
+        <p:txBody>
+          <a:bodyPr xmlns:a="http://schemas.openxmlformats.org/drawingml/2006/main" anchor="ctr"/>
+          <a:lstStyle xmlns:a="http://schemas.openxmlformats.org/drawingml/2006/main"/>
+          <a:p xmlns:a="http://schemas.openxmlformats.org/drawingml/2006/main">
+            <a:pPr algn="l">
+              <a:defRPr sz="900" b="0">
+                <a:solidFill>
+                  <a:srgbClr val="B9C7DD"/>
+                </a:solidFill>
+                <a:latin typeface="Arial"/>
+                <a:ea typeface="Arial"/>
+                <a:cs typeface="Arial"/>
+              </a:defRPr>
+            </a:pPr>
+            <a:r>
+              <a:rPr sz="900" b="0">
+                <a:solidFill>
+                  <a:srgbClr val="B9C7DD"/>
+                </a:solidFill>
+                <a:latin typeface="Arial"/>
+                <a:ea typeface="Arial"/>
+                <a:cs typeface="Arial"/>
+              </a:rPr>
+              <a:t>macOS paketi notarize edilmemiştir; ilk açılışta sağ tık → Aç. / Not notarized; first launch: right-click → Open.</a:t>
             </a:r>
           </a:p>
         </p:txBody>
       </p:sp>
       <p:pic>
         <p:nvPicPr>
-          <p:cNvPr id="34" name=""/>
+          <p:cNvPr id="38" name=""/>
           <p:cNvPicPr>
             <a:picLocks xmlns:a="http://schemas.openxmlformats.org/drawingml/2006/main" noChangeAspect="1"/>
           </p:cNvPicPr>
           <p:nvPr/>
         </p:nvPicPr>
         <p:blipFill>
-          <a:blip xmlns:r="http://schemas.openxmlformats.org/officeDocument/2006/relationships" xmlns:a="http://schemas.openxmlformats.org/drawingml/2006/main" r:embed="R7effbbc3b2b94315"/>
+          <a:blip xmlns:r="http://schemas.openxmlformats.org/officeDocument/2006/relationships" xmlns:a="http://schemas.openxmlformats.org/drawingml/2006/main" r:embed="Rd4f3daaad9e14d66"/>
           <a:stretch xmlns:a="http://schemas.openxmlformats.org/drawingml/2006/main"/>
         </p:blipFill>
         <p:spPr>
@@ -6373,7 +6485,7 @@
     </p:spTree>
     <p:extLst>
       <p:ext uri="{BB962C8B-B14F-4D97-AF65-F5344CB8AC3E}">
-        <p14:creationId xmlns:p14="http://schemas.microsoft.com/office/powerpoint/2010/main" val="301608822"/>
+        <p14:creationId xmlns:p14="http://schemas.microsoft.com/office/powerpoint/2010/main" val="2033317976"/>
       </p:ext>
     </p:extLst>
   </p:cSld>

</xml_diff>

<commit_message>
Dictionary EN-TR: bidirectional English-Turkish learner's dictionary tab
- eca/dictionary.py: search engine merging built-in and user entries
  (automatic direction, exact > prefix > substring ranking, definition search)
- eca/dict_data.py: 1,210+ A1-B1 entries with Turkish meaning and plain-English definition
- eca/tabs/dictionary.py: TTS, ask AI, add to word bank, CSV/TSV import/export, history
- db: dict_entries table + DictRepo; i18n keys in TR/EN
- 8 new tests (37 total), README TR/EN and presentation (18 areas) updated

Co-Authored-By: Claude Fable 5.1 <noreply@anthropic.com>
</commit_message>
<xml_diff>
--- a/docs/presentation/English-Course-AI-Bilingual.pptx
+++ b/docs/presentation/English-Course-AI-Bilingual.pptx
@@ -2,18 +2,18 @@
 <file path=ppt/presentation.xml><?xml version="1.0" encoding="utf-8"?>
 <p:presentation xmlns:p="http://schemas.openxmlformats.org/presentationml/2006/main">
   <p:sldMasterIdLst>
-    <p:sldMasterId xmlns:r="http://schemas.openxmlformats.org/officeDocument/2006/relationships" id="2147483648" r:id="Ra29485e8011a4b83"/>
+    <p:sldMasterId xmlns:r="http://schemas.openxmlformats.org/officeDocument/2006/relationships" id="2147483648" r:id="R7edb7c08ecf94745"/>
   </p:sldMasterIdLst>
   <p:notesMasterIdLst>
-    <p:notesMasterId xmlns:r="http://schemas.openxmlformats.org/officeDocument/2006/relationships" r:id="R9ea13128d2f4429f"/>
+    <p:notesMasterId xmlns:r="http://schemas.openxmlformats.org/officeDocument/2006/relationships" r:id="Rc90896163ab64c5c"/>
   </p:notesMasterIdLst>
   <p:sldIdLst>
-    <p:sldId xmlns:r="http://schemas.openxmlformats.org/officeDocument/2006/relationships" id="256" r:id="R8e9aab4a95744bb1"/>
-    <p:sldId xmlns:r="http://schemas.openxmlformats.org/officeDocument/2006/relationships" id="257" r:id="R43fac0b1499445d0"/>
-    <p:sldId xmlns:r="http://schemas.openxmlformats.org/officeDocument/2006/relationships" id="258" r:id="R8884697262114368"/>
-    <p:sldId xmlns:r="http://schemas.openxmlformats.org/officeDocument/2006/relationships" id="259" r:id="R2180dfd678c54a47"/>
-    <p:sldId xmlns:r="http://schemas.openxmlformats.org/officeDocument/2006/relationships" id="260" r:id="Rb1f7e36787da4d82"/>
-    <p:sldId xmlns:r="http://schemas.openxmlformats.org/officeDocument/2006/relationships" id="261" r:id="R9102b31cf5c04c4e"/>
+    <p:sldId xmlns:r="http://schemas.openxmlformats.org/officeDocument/2006/relationships" id="256" r:id="R7bee2c70acd246eb"/>
+    <p:sldId xmlns:r="http://schemas.openxmlformats.org/officeDocument/2006/relationships" id="257" r:id="R5c7ae9bd1f264011"/>
+    <p:sldId xmlns:r="http://schemas.openxmlformats.org/officeDocument/2006/relationships" id="258" r:id="Rc50e2daa5fa84a9a"/>
+    <p:sldId xmlns:r="http://schemas.openxmlformats.org/officeDocument/2006/relationships" id="259" r:id="Rc7b79f9f08494001"/>
+    <p:sldId xmlns:r="http://schemas.openxmlformats.org/officeDocument/2006/relationships" id="260" r:id="R8586d0791d364ea0"/>
+    <p:sldId xmlns:r="http://schemas.openxmlformats.org/officeDocument/2006/relationships" id="261" r:id="Ra722d1ec4eb74f99"/>
   </p:sldIdLst>
   <p:sldSz cx="12192000" cy="6858000"/>
   <p:notesSz cx="6858000" cy="9144000"/>
@@ -632,6 +632,11 @@
           </a:p>
           <a:p xmlns:a="http://schemas.openxmlformats.org/drawingml/2006/main">
             <a:r>
+              <a:t>- Dictionary: D:/GE_FR/EnglishCourseAI/eca/dict_data.py (1,210+ EN-TR entries with definitions)</a:t>
+            </a:r>
+          </a:p>
+          <a:p xmlns:a="http://schemas.openxmlformats.org/drawingml/2006/main">
+            <a:r>
               <a:t>- Grammar/spelling/resources: D:/GE_FR/EnglishCourseAI/eca/content.py</a:t>
             </a:r>
           </a:p>
@@ -985,7 +990,7 @@
   </p:cSld>
   <p:clrMap bg1="lt1" tx1="dk1" bg2="lt2" tx2="dk2" accent1="accent1" accent2="accent2" accent3="accent3" accent4="accent4" accent5="accent5" accent6="accent6" hlink="hlink" folHlink="folHlink"/>
   <p:sldLayoutIdLst>
-    <p:sldLayoutId xmlns:r="http://schemas.openxmlformats.org/officeDocument/2006/relationships" id="2147483649" r:id="Ra5e8d747a5084010"/>
+    <p:sldLayoutId xmlns:r="http://schemas.openxmlformats.org/officeDocument/2006/relationships" id="2147483649" r:id="Ra9522b1a04184b50"/>
   </p:sldLayoutIdLst>
   <p:txStyles>
     <p:titleStyle>
@@ -1536,7 +1541,7 @@
           <p:cNvPr id="8" name="">
             <a:extLst xmlns:a="http://schemas.openxmlformats.org/drawingml/2006/main">
               <a:ext uri="{FF2B5EF4-FFF2-40B4-BE49-F238E27FC236}">
-                <a16:creationId xmlns:a16="http://schemas.microsoft.com/office/drawing/2014/main" id="{DE6ABFF0-78D1-48EB-BB30-2228E9334712}"/>
+                <a16:creationId xmlns:a16="http://schemas.microsoft.com/office/drawing/2014/main" id="{F0D6EE19-E3A3-487F-9185-1D16D2BECF55}"/>
               </a:ext>
             </a:extLst>
           </p:cNvPr>
@@ -1571,7 +1576,7 @@
           <p:nvPr/>
         </p:nvPicPr>
         <p:blipFill>
-          <a:blip xmlns:r="http://schemas.openxmlformats.org/officeDocument/2006/relationships" xmlns:a="http://schemas.openxmlformats.org/drawingml/2006/main" r:embed="Red959deee9dc4f3d"/>
+          <a:blip xmlns:r="http://schemas.openxmlformats.org/officeDocument/2006/relationships" xmlns:a="http://schemas.openxmlformats.org/drawingml/2006/main" r:embed="Re49337b706d14520"/>
           <a:stretch xmlns:a="http://schemas.openxmlformats.org/drawingml/2006/main"/>
         </p:blipFill>
         <p:spPr>
@@ -1589,7 +1594,7 @@
           <p:cNvPr id="3" name="">
             <a:extLst xmlns:a="http://schemas.openxmlformats.org/drawingml/2006/main">
               <a:ext uri="{FF2B5EF4-FFF2-40B4-BE49-F238E27FC236}">
-                <a16:creationId xmlns:a16="http://schemas.microsoft.com/office/drawing/2014/main" id="{4722D123-694F-4EB6-938F-CA72F6588C56}"/>
+                <a16:creationId xmlns:a16="http://schemas.microsoft.com/office/drawing/2014/main" id="{0FCF35E6-313C-405C-BB15-091C9670D361}"/>
               </a:ext>
             </a:extLst>
           </p:cNvPr>
@@ -1645,7 +1650,7 @@
           <p:cNvPr id="4" name="">
             <a:extLst xmlns:a="http://schemas.openxmlformats.org/drawingml/2006/main">
               <a:ext uri="{FF2B5EF4-FFF2-40B4-BE49-F238E27FC236}">
-                <a16:creationId xmlns:a16="http://schemas.microsoft.com/office/drawing/2014/main" id="{A72EBCC1-585D-4C90-8455-82FBDBE2F2A0}"/>
+                <a16:creationId xmlns:a16="http://schemas.microsoft.com/office/drawing/2014/main" id="{FCD61B4B-BD15-4901-BC06-436816126E9A}"/>
               </a:ext>
             </a:extLst>
           </p:cNvPr>
@@ -1724,7 +1729,7 @@
           <p:cNvPr id="5" name="">
             <a:extLst xmlns:a="http://schemas.openxmlformats.org/drawingml/2006/main">
               <a:ext uri="{FF2B5EF4-FFF2-40B4-BE49-F238E27FC236}">
-                <a16:creationId xmlns:a16="http://schemas.microsoft.com/office/drawing/2014/main" id="{46A5E9D3-77DD-4980-8E49-6B3C83B453EC}"/>
+                <a16:creationId xmlns:a16="http://schemas.microsoft.com/office/drawing/2014/main" id="{F57F9DF9-C29F-46E4-800C-E14BCB79643A}"/>
               </a:ext>
             </a:extLst>
           </p:cNvPr>
@@ -1755,7 +1760,7 @@
           <p:cNvPr id="6" name="">
             <a:extLst xmlns:a="http://schemas.openxmlformats.org/drawingml/2006/main">
               <a:ext uri="{FF2B5EF4-FFF2-40B4-BE49-F238E27FC236}">
-                <a16:creationId xmlns:a16="http://schemas.microsoft.com/office/drawing/2014/main" id="{6B849B45-50E5-4239-82A6-B0E35AF6E6D6}"/>
+                <a16:creationId xmlns:a16="http://schemas.microsoft.com/office/drawing/2014/main" id="{480A8198-B97B-4E17-999A-A881552F03F2}"/>
               </a:ext>
             </a:extLst>
           </p:cNvPr>
@@ -1834,7 +1839,7 @@
           <p:cNvPr id="7" name="">
             <a:extLst xmlns:a="http://schemas.openxmlformats.org/drawingml/2006/main">
               <a:ext uri="{FF2B5EF4-FFF2-40B4-BE49-F238E27FC236}">
-                <a16:creationId xmlns:a16="http://schemas.microsoft.com/office/drawing/2014/main" id="{844F740C-7C2C-4B30-B46E-B0BE31B687A6}"/>
+                <a16:creationId xmlns:a16="http://schemas.microsoft.com/office/drawing/2014/main" id="{3A4F3CC1-086E-4148-9B26-0D80B1DF0C0E}"/>
               </a:ext>
             </a:extLst>
           </p:cNvPr>
@@ -1888,7 +1893,7 @@
     </p:spTree>
     <p:extLst>
       <p:ext uri="{BB962C8B-B14F-4D97-AF65-F5344CB8AC3E}">
-        <p14:creationId xmlns:p14="http://schemas.microsoft.com/office/powerpoint/2010/main" val="1963692219"/>
+        <p14:creationId xmlns:p14="http://schemas.microsoft.com/office/powerpoint/2010/main" val="1067418838"/>
       </p:ext>
     </p:extLst>
   </p:cSld>
@@ -1919,7 +1924,7 @@
           <p:cNvPr id="21" name="">
             <a:extLst xmlns:a="http://schemas.openxmlformats.org/drawingml/2006/main">
               <a:ext uri="{FF2B5EF4-FFF2-40B4-BE49-F238E27FC236}">
-                <a16:creationId xmlns:a16="http://schemas.microsoft.com/office/drawing/2014/main" id="{B81DACB6-B642-4DD1-944B-A7C77DA013C5}"/>
+                <a16:creationId xmlns:a16="http://schemas.microsoft.com/office/drawing/2014/main" id="{6702CE05-D302-4F70-900C-4D8E276275E3}"/>
               </a:ext>
             </a:extLst>
           </p:cNvPr>
@@ -1975,7 +1980,7 @@
           <p:cNvPr id="2" name="">
             <a:extLst xmlns:a="http://schemas.openxmlformats.org/drawingml/2006/main">
               <a:ext uri="{FF2B5EF4-FFF2-40B4-BE49-F238E27FC236}">
-                <a16:creationId xmlns:a16="http://schemas.microsoft.com/office/drawing/2014/main" id="{4BBFDAB4-2CEE-4075-8934-6F78D0C28A0F}"/>
+                <a16:creationId xmlns:a16="http://schemas.microsoft.com/office/drawing/2014/main" id="{293ECE08-0098-427D-B217-3C032F5D7A78}"/>
               </a:ext>
             </a:extLst>
           </p:cNvPr>
@@ -2031,7 +2036,7 @@
           <p:cNvPr id="3" name="">
             <a:extLst xmlns:a="http://schemas.openxmlformats.org/drawingml/2006/main">
               <a:ext uri="{FF2B5EF4-FFF2-40B4-BE49-F238E27FC236}">
-                <a16:creationId xmlns:a16="http://schemas.microsoft.com/office/drawing/2014/main" id="{6025EAEB-E37D-48BF-BB1C-3435E71FCDA4}"/>
+                <a16:creationId xmlns:a16="http://schemas.microsoft.com/office/drawing/2014/main" id="{881D52C1-2A34-4B85-A99F-C2A614772FE5}"/>
               </a:ext>
             </a:extLst>
           </p:cNvPr>
@@ -2077,7 +2082,7 @@
                 <a:ea typeface="Arial"/>
                 <a:cs typeface="Arial"/>
               </a:rPr>
-              <a:t>17 çalışma alanı tek bir öğrenme döngüsü kuruyor</a:t>
+              <a:t>18 çalışma alanı tek bir öğrenme döngüsü kuruyor</a:t>
             </a:r>
           </a:p>
         </p:txBody>
@@ -2087,7 +2092,7 @@
           <p:cNvPr id="4" name="">
             <a:extLst xmlns:a="http://schemas.openxmlformats.org/drawingml/2006/main">
               <a:ext uri="{FF2B5EF4-FFF2-40B4-BE49-F238E27FC236}">
-                <a16:creationId xmlns:a16="http://schemas.microsoft.com/office/drawing/2014/main" id="{3D029ABA-78F5-4C01-B003-F5E24BCB3F57}"/>
+                <a16:creationId xmlns:a16="http://schemas.microsoft.com/office/drawing/2014/main" id="{4BB28EC2-4507-4D6E-B925-1200AF8E2579}"/>
               </a:ext>
             </a:extLst>
           </p:cNvPr>
@@ -2133,7 +2138,7 @@
                 <a:ea typeface="Arial"/>
                 <a:cs typeface="Arial"/>
               </a:rPr>
-              <a:t>Seventeen areas form one learning loop</a:t>
+              <a:t>Eighteen areas form one learning loop</a:t>
             </a:r>
           </a:p>
         </p:txBody>
@@ -2143,7 +2148,7 @@
           <p:cNvPr id="5" name="">
             <a:extLst xmlns:a="http://schemas.openxmlformats.org/drawingml/2006/main">
               <a:ext uri="{FF2B5EF4-FFF2-40B4-BE49-F238E27FC236}">
-                <a16:creationId xmlns:a16="http://schemas.microsoft.com/office/drawing/2014/main" id="{7CBEB735-1046-4F2B-B1AB-55B593C7ECE9}"/>
+                <a16:creationId xmlns:a16="http://schemas.microsoft.com/office/drawing/2014/main" id="{F6A38E5A-D788-4F14-A03F-6B3BF4466D31}"/>
               </a:ext>
             </a:extLst>
           </p:cNvPr>
@@ -2174,7 +2179,7 @@
           <p:cNvPr id="6" name="">
             <a:extLst xmlns:a="http://schemas.openxmlformats.org/drawingml/2006/main">
               <a:ext uri="{FF2B5EF4-FFF2-40B4-BE49-F238E27FC236}">
-                <a16:creationId xmlns:a16="http://schemas.microsoft.com/office/drawing/2014/main" id="{E4730941-B91E-4B22-ACDB-5A84E90A7B37}"/>
+                <a16:creationId xmlns:a16="http://schemas.microsoft.com/office/drawing/2014/main" id="{44D9E31D-F1B8-4611-ABC6-48C11C645A83}"/>
               </a:ext>
             </a:extLst>
           </p:cNvPr>
@@ -2230,7 +2235,7 @@
           <p:cNvPr id="7" name="">
             <a:extLst xmlns:a="http://schemas.openxmlformats.org/drawingml/2006/main">
               <a:ext uri="{FF2B5EF4-FFF2-40B4-BE49-F238E27FC236}">
-                <a16:creationId xmlns:a16="http://schemas.microsoft.com/office/drawing/2014/main" id="{E592A08E-D89F-4A6B-9238-0C2E21BE6025}"/>
+                <a16:creationId xmlns:a16="http://schemas.microsoft.com/office/drawing/2014/main" id="{E941B783-61FC-4614-BCA0-586F69A05376}"/>
               </a:ext>
             </a:extLst>
           </p:cNvPr>
@@ -2286,7 +2291,7 @@
           <p:cNvPr id="8" name="">
             <a:extLst xmlns:a="http://schemas.openxmlformats.org/drawingml/2006/main">
               <a:ext uri="{FF2B5EF4-FFF2-40B4-BE49-F238E27FC236}">
-                <a16:creationId xmlns:a16="http://schemas.microsoft.com/office/drawing/2014/main" id="{DA5C8306-F1C0-4583-9D5E-540F351D2591}"/>
+                <a16:creationId xmlns:a16="http://schemas.microsoft.com/office/drawing/2014/main" id="{BE8264BC-83EF-46B3-BFCD-CDBB35A0C322}"/>
               </a:ext>
             </a:extLst>
           </p:cNvPr>
@@ -2332,7 +2337,7 @@
                 <a:ea typeface="Arial"/>
                 <a:cs typeface="Arial"/>
               </a:rPr>
-              <a:t>Aralıklı tekrar, kelime bankası ve CEFR sınavları</a:t>
+              <a:t>Aralıklı tekrar, kelime bankası, EN-TR öğrenci sözlüğü ve CEFR sınavları</a:t>
             </a:r>
           </a:p>
         </p:txBody>
@@ -2342,7 +2347,7 @@
           <p:cNvPr id="9" name="">
             <a:extLst xmlns:a="http://schemas.openxmlformats.org/drawingml/2006/main">
               <a:ext uri="{FF2B5EF4-FFF2-40B4-BE49-F238E27FC236}">
-                <a16:creationId xmlns:a16="http://schemas.microsoft.com/office/drawing/2014/main" id="{B13C48C9-E3D1-4F45-B462-AE4D2D435729}"/>
+                <a16:creationId xmlns:a16="http://schemas.microsoft.com/office/drawing/2014/main" id="{D35A6FEE-EF34-416C-999C-17DEBC87D256}"/>
               </a:ext>
             </a:extLst>
           </p:cNvPr>
@@ -2373,7 +2378,7 @@
           <p:cNvPr id="10" name="">
             <a:extLst xmlns:a="http://schemas.openxmlformats.org/drawingml/2006/main">
               <a:ext uri="{FF2B5EF4-FFF2-40B4-BE49-F238E27FC236}">
-                <a16:creationId xmlns:a16="http://schemas.microsoft.com/office/drawing/2014/main" id="{6F9CB6E6-9FBA-4CA1-AF3E-2D6C19A7A8D3}"/>
+                <a16:creationId xmlns:a16="http://schemas.microsoft.com/office/drawing/2014/main" id="{86823042-0A3D-4EF3-AB27-6FEB3A7E42CD}"/>
               </a:ext>
             </a:extLst>
           </p:cNvPr>
@@ -2429,7 +2434,7 @@
           <p:cNvPr id="11" name="">
             <a:extLst xmlns:a="http://schemas.openxmlformats.org/drawingml/2006/main">
               <a:ext uri="{FF2B5EF4-FFF2-40B4-BE49-F238E27FC236}">
-                <a16:creationId xmlns:a16="http://schemas.microsoft.com/office/drawing/2014/main" id="{BC261F93-DAB4-4D3B-B2B7-9058099CD4B0}"/>
+                <a16:creationId xmlns:a16="http://schemas.microsoft.com/office/drawing/2014/main" id="{793FDA2A-09F4-42ED-9EC5-7BD86A6C6271}"/>
               </a:ext>
             </a:extLst>
           </p:cNvPr>
@@ -2485,7 +2490,7 @@
           <p:cNvPr id="12" name="">
             <a:extLst xmlns:a="http://schemas.openxmlformats.org/drawingml/2006/main">
               <a:ext uri="{FF2B5EF4-FFF2-40B4-BE49-F238E27FC236}">
-                <a16:creationId xmlns:a16="http://schemas.microsoft.com/office/drawing/2014/main" id="{89FE405C-A52A-49C3-8571-0A3DA745C7DA}"/>
+                <a16:creationId xmlns:a16="http://schemas.microsoft.com/office/drawing/2014/main" id="{4950F57F-88C0-4BE2-930D-EA07C9AB1DAA}"/>
               </a:ext>
             </a:extLst>
           </p:cNvPr>
@@ -2541,7 +2546,7 @@
           <p:cNvPr id="13" name="">
             <a:extLst xmlns:a="http://schemas.openxmlformats.org/drawingml/2006/main">
               <a:ext uri="{FF2B5EF4-FFF2-40B4-BE49-F238E27FC236}">
-                <a16:creationId xmlns:a16="http://schemas.microsoft.com/office/drawing/2014/main" id="{A1B95424-5C90-437A-B817-5FEA490AB48A}"/>
+                <a16:creationId xmlns:a16="http://schemas.microsoft.com/office/drawing/2014/main" id="{996B4D1D-67B6-496A-B507-74C9CD92535C}"/>
               </a:ext>
             </a:extLst>
           </p:cNvPr>
@@ -2572,7 +2577,7 @@
           <p:cNvPr id="14" name="">
             <a:extLst xmlns:a="http://schemas.openxmlformats.org/drawingml/2006/main">
               <a:ext uri="{FF2B5EF4-FFF2-40B4-BE49-F238E27FC236}">
-                <a16:creationId xmlns:a16="http://schemas.microsoft.com/office/drawing/2014/main" id="{C5AB9C6E-D63F-4A52-A9C9-5703AB3BA462}"/>
+                <a16:creationId xmlns:a16="http://schemas.microsoft.com/office/drawing/2014/main" id="{0B5F49D9-AEA3-48C0-907A-5C3B3B628F61}"/>
               </a:ext>
             </a:extLst>
           </p:cNvPr>
@@ -2628,7 +2633,7 @@
           <p:cNvPr id="15" name="">
             <a:extLst xmlns:a="http://schemas.openxmlformats.org/drawingml/2006/main">
               <a:ext uri="{FF2B5EF4-FFF2-40B4-BE49-F238E27FC236}">
-                <a16:creationId xmlns:a16="http://schemas.microsoft.com/office/drawing/2014/main" id="{3F15DC03-9B53-44CF-BEF0-889FEC51946D}"/>
+                <a16:creationId xmlns:a16="http://schemas.microsoft.com/office/drawing/2014/main" id="{B9BEFA16-71EB-4253-B94E-5F33016A0A39}"/>
               </a:ext>
             </a:extLst>
           </p:cNvPr>
@@ -2684,7 +2689,7 @@
           <p:cNvPr id="16" name="">
             <a:extLst xmlns:a="http://schemas.openxmlformats.org/drawingml/2006/main">
               <a:ext uri="{FF2B5EF4-FFF2-40B4-BE49-F238E27FC236}">
-                <a16:creationId xmlns:a16="http://schemas.microsoft.com/office/drawing/2014/main" id="{7400C4E4-25E5-4CC5-A493-CF9F845CB51F}"/>
+                <a16:creationId xmlns:a16="http://schemas.microsoft.com/office/drawing/2014/main" id="{B6D9EC47-12EB-46C4-AE24-22E49E180AC3}"/>
               </a:ext>
             </a:extLst>
           </p:cNvPr>
@@ -2740,7 +2745,7 @@
           <p:cNvPr id="17" name="">
             <a:extLst xmlns:a="http://schemas.openxmlformats.org/drawingml/2006/main">
               <a:ext uri="{FF2B5EF4-FFF2-40B4-BE49-F238E27FC236}">
-                <a16:creationId xmlns:a16="http://schemas.microsoft.com/office/drawing/2014/main" id="{AABFD430-CB2D-44B4-9EB1-094451FC275B}"/>
+                <a16:creationId xmlns:a16="http://schemas.microsoft.com/office/drawing/2014/main" id="{837C0B21-8FEB-404E-94D0-6AEC929A12D0}"/>
               </a:ext>
             </a:extLst>
           </p:cNvPr>
@@ -2771,7 +2776,7 @@
           <p:cNvPr id="18" name="">
             <a:extLst xmlns:a="http://schemas.openxmlformats.org/drawingml/2006/main">
               <a:ext uri="{FF2B5EF4-FFF2-40B4-BE49-F238E27FC236}">
-                <a16:creationId xmlns:a16="http://schemas.microsoft.com/office/drawing/2014/main" id="{A0DA2B0B-F68B-4988-AE91-18C812D1D1B3}"/>
+                <a16:creationId xmlns:a16="http://schemas.microsoft.com/office/drawing/2014/main" id="{59B1CC7D-FDBF-4620-95DD-9A57D0934517}"/>
               </a:ext>
             </a:extLst>
           </p:cNvPr>
@@ -2827,7 +2832,7 @@
           <p:cNvPr id="19" name="">
             <a:extLst xmlns:a="http://schemas.openxmlformats.org/drawingml/2006/main">
               <a:ext uri="{FF2B5EF4-FFF2-40B4-BE49-F238E27FC236}">
-                <a16:creationId xmlns:a16="http://schemas.microsoft.com/office/drawing/2014/main" id="{88725B02-F8A9-4E29-AF5C-64B5BAA7A638}"/>
+                <a16:creationId xmlns:a16="http://schemas.microsoft.com/office/drawing/2014/main" id="{34054248-C267-47FE-A7CE-3161FF24C02F}"/>
               </a:ext>
             </a:extLst>
           </p:cNvPr>
@@ -2883,7 +2888,7 @@
           <p:cNvPr id="20" name="">
             <a:extLst xmlns:a="http://schemas.openxmlformats.org/drawingml/2006/main">
               <a:ext uri="{FF2B5EF4-FFF2-40B4-BE49-F238E27FC236}">
-                <a16:creationId xmlns:a16="http://schemas.microsoft.com/office/drawing/2014/main" id="{0DFFE737-874B-4296-B2A1-3704D578E48B}"/>
+                <a16:creationId xmlns:a16="http://schemas.microsoft.com/office/drawing/2014/main" id="{3C107357-35F5-46CA-B373-383E7FE2E17A}"/>
               </a:ext>
             </a:extLst>
           </p:cNvPr>
@@ -2937,7 +2942,7 @@
     </p:spTree>
     <p:extLst>
       <p:ext uri="{BB962C8B-B14F-4D97-AF65-F5344CB8AC3E}">
-        <p14:creationId xmlns:p14="http://schemas.microsoft.com/office/powerpoint/2010/main" val="1550593081"/>
+        <p14:creationId xmlns:p14="http://schemas.microsoft.com/office/powerpoint/2010/main" val="1097892686"/>
       </p:ext>
     </p:extLst>
   </p:cSld>
@@ -2968,7 +2973,7 @@
           <p:cNvPr id="23" name="">
             <a:extLst xmlns:a="http://schemas.openxmlformats.org/drawingml/2006/main">
               <a:ext uri="{FF2B5EF4-FFF2-40B4-BE49-F238E27FC236}">
-                <a16:creationId xmlns:a16="http://schemas.microsoft.com/office/drawing/2014/main" id="{3652A4B3-5704-4AB6-BBFA-9F7B5C63B5C4}"/>
+                <a16:creationId xmlns:a16="http://schemas.microsoft.com/office/drawing/2014/main" id="{211645A7-0D33-4648-9107-2990485AE77E}"/>
               </a:ext>
             </a:extLst>
           </p:cNvPr>
@@ -3024,7 +3029,7 @@
           <p:cNvPr id="2" name="">
             <a:extLst xmlns:a="http://schemas.openxmlformats.org/drawingml/2006/main">
               <a:ext uri="{FF2B5EF4-FFF2-40B4-BE49-F238E27FC236}">
-                <a16:creationId xmlns:a16="http://schemas.microsoft.com/office/drawing/2014/main" id="{6362A262-6D48-4BE7-AB9C-20E1C323E1BA}"/>
+                <a16:creationId xmlns:a16="http://schemas.microsoft.com/office/drawing/2014/main" id="{35EE677A-F0F8-40C0-9D15-FFA617680BA5}"/>
               </a:ext>
             </a:extLst>
           </p:cNvPr>
@@ -3080,7 +3085,7 @@
           <p:cNvPr id="3" name="">
             <a:extLst xmlns:a="http://schemas.openxmlformats.org/drawingml/2006/main">
               <a:ext uri="{FF2B5EF4-FFF2-40B4-BE49-F238E27FC236}">
-                <a16:creationId xmlns:a16="http://schemas.microsoft.com/office/drawing/2014/main" id="{58878DC7-F3EA-4E93-A189-7032A0CAE6D0}"/>
+                <a16:creationId xmlns:a16="http://schemas.microsoft.com/office/drawing/2014/main" id="{755997F4-71DD-4497-A41E-140485CE39C3}"/>
               </a:ext>
             </a:extLst>
           </p:cNvPr>
@@ -3136,7 +3141,7 @@
           <p:cNvPr id="4" name="">
             <a:extLst xmlns:a="http://schemas.openxmlformats.org/drawingml/2006/main">
               <a:ext uri="{FF2B5EF4-FFF2-40B4-BE49-F238E27FC236}">
-                <a16:creationId xmlns:a16="http://schemas.microsoft.com/office/drawing/2014/main" id="{91D04CDF-8F41-496D-B710-149EA015290F}"/>
+                <a16:creationId xmlns:a16="http://schemas.microsoft.com/office/drawing/2014/main" id="{5841C2C9-B377-44FB-AAC7-A63628AF5D41}"/>
               </a:ext>
             </a:extLst>
           </p:cNvPr>
@@ -3192,7 +3197,7 @@
           <p:cNvPr id="5" name="">
             <a:extLst xmlns:a="http://schemas.openxmlformats.org/drawingml/2006/main">
               <a:ext uri="{FF2B5EF4-FFF2-40B4-BE49-F238E27FC236}">
-                <a16:creationId xmlns:a16="http://schemas.microsoft.com/office/drawing/2014/main" id="{F425B2C1-64E5-4DB6-A472-E217E21E6D8B}"/>
+                <a16:creationId xmlns:a16="http://schemas.microsoft.com/office/drawing/2014/main" id="{AF24F4B6-FFB4-4AE6-AE47-535F4F35943D}"/>
               </a:ext>
             </a:extLst>
           </p:cNvPr>
@@ -3223,7 +3228,7 @@
           <p:cNvPr id="6" name="">
             <a:extLst xmlns:a="http://schemas.openxmlformats.org/drawingml/2006/main">
               <a:ext uri="{FF2B5EF4-FFF2-40B4-BE49-F238E27FC236}">
-                <a16:creationId xmlns:a16="http://schemas.microsoft.com/office/drawing/2014/main" id="{F0B23118-8D0C-432E-A1ED-8D39A43DB194}"/>
+                <a16:creationId xmlns:a16="http://schemas.microsoft.com/office/drawing/2014/main" id="{540174A5-FDA7-404C-A3E3-A457A12A882C}"/>
               </a:ext>
             </a:extLst>
           </p:cNvPr>
@@ -3269,7 +3274,7 @@
                 <a:ea typeface="Arial"/>
                 <a:cs typeface="Arial"/>
               </a:rPr>
-              <a:t>162</a:t>
+              <a:t>1.370+</a:t>
             </a:r>
           </a:p>
         </p:txBody>
@@ -3279,7 +3284,7 @@
           <p:cNvPr id="7" name="">
             <a:extLst xmlns:a="http://schemas.openxmlformats.org/drawingml/2006/main">
               <a:ext uri="{FF2B5EF4-FFF2-40B4-BE49-F238E27FC236}">
-                <a16:creationId xmlns:a16="http://schemas.microsoft.com/office/drawing/2014/main" id="{6FC1EFC3-8F0C-4797-BD77-0E035D9B1FB9}"/>
+                <a16:creationId xmlns:a16="http://schemas.microsoft.com/office/drawing/2014/main" id="{8EC065D9-900D-44EF-929E-86AA84710C40}"/>
               </a:ext>
             </a:extLst>
           </p:cNvPr>
@@ -3325,7 +3330,7 @@
                 <a:ea typeface="Arial"/>
                 <a:cs typeface="Arial"/>
               </a:rPr>
-              <a:t>A1 words</a:t>
+              <a:t>vocabulary entries</a:t>
             </a:r>
           </a:p>
         </p:txBody>
@@ -3335,7 +3340,7 @@
           <p:cNvPr id="8" name="">
             <a:extLst xmlns:a="http://schemas.openxmlformats.org/drawingml/2006/main">
               <a:ext uri="{FF2B5EF4-FFF2-40B4-BE49-F238E27FC236}">
-                <a16:creationId xmlns:a16="http://schemas.microsoft.com/office/drawing/2014/main" id="{B17A5875-2665-412E-A469-D492D41568ED}"/>
+                <a16:creationId xmlns:a16="http://schemas.microsoft.com/office/drawing/2014/main" id="{380A609E-74C4-4665-AA80-8F1E63B9FA1D}"/>
               </a:ext>
             </a:extLst>
           </p:cNvPr>
@@ -3381,7 +3386,7 @@
                 <a:ea typeface="Arial"/>
                 <a:cs typeface="Arial"/>
               </a:rPr>
-              <a:t>Türkçe anlam ve doğal örnek</a:t>
+              <a:t>162 A1 kelime + 1.210 EN-TR sözlük maddesi</a:t>
             </a:r>
           </a:p>
         </p:txBody>
@@ -3391,7 +3396,7 @@
           <p:cNvPr id="9" name="">
             <a:extLst xmlns:a="http://schemas.openxmlformats.org/drawingml/2006/main">
               <a:ext uri="{FF2B5EF4-FFF2-40B4-BE49-F238E27FC236}">
-                <a16:creationId xmlns:a16="http://schemas.microsoft.com/office/drawing/2014/main" id="{C5CF2F4B-7367-47C4-8F64-EBAB8F72DE53}"/>
+                <a16:creationId xmlns:a16="http://schemas.microsoft.com/office/drawing/2014/main" id="{2457BD8D-693B-4710-92CB-55E0F34D52BF}"/>
               </a:ext>
             </a:extLst>
           </p:cNvPr>
@@ -3422,7 +3427,7 @@
           <p:cNvPr id="10" name="">
             <a:extLst xmlns:a="http://schemas.openxmlformats.org/drawingml/2006/main">
               <a:ext uri="{FF2B5EF4-FFF2-40B4-BE49-F238E27FC236}">
-                <a16:creationId xmlns:a16="http://schemas.microsoft.com/office/drawing/2014/main" id="{55690B3B-E524-4B50-9C7C-F2C997C64B1D}"/>
+                <a16:creationId xmlns:a16="http://schemas.microsoft.com/office/drawing/2014/main" id="{1E8960C4-7F66-4078-A652-4C1393B57AAB}"/>
               </a:ext>
             </a:extLst>
           </p:cNvPr>
@@ -3478,7 +3483,7 @@
           <p:cNvPr id="11" name="">
             <a:extLst xmlns:a="http://schemas.openxmlformats.org/drawingml/2006/main">
               <a:ext uri="{FF2B5EF4-FFF2-40B4-BE49-F238E27FC236}">
-                <a16:creationId xmlns:a16="http://schemas.microsoft.com/office/drawing/2014/main" id="{E49443F6-CA52-490B-9922-8827EAF320A0}"/>
+                <a16:creationId xmlns:a16="http://schemas.microsoft.com/office/drawing/2014/main" id="{7824B72F-90BC-4FFF-BECF-D467EDC86F25}"/>
               </a:ext>
             </a:extLst>
           </p:cNvPr>
@@ -3534,7 +3539,7 @@
           <p:cNvPr id="12" name="">
             <a:extLst xmlns:a="http://schemas.openxmlformats.org/drawingml/2006/main">
               <a:ext uri="{FF2B5EF4-FFF2-40B4-BE49-F238E27FC236}">
-                <a16:creationId xmlns:a16="http://schemas.microsoft.com/office/drawing/2014/main" id="{F98C7A2D-1F53-4F99-A4F0-926E052EF0F0}"/>
+                <a16:creationId xmlns:a16="http://schemas.microsoft.com/office/drawing/2014/main" id="{89527322-F6BD-46D9-933E-3E274475EEA7}"/>
               </a:ext>
             </a:extLst>
           </p:cNvPr>
@@ -3590,7 +3595,7 @@
           <p:cNvPr id="13" name="">
             <a:extLst xmlns:a="http://schemas.openxmlformats.org/drawingml/2006/main">
               <a:ext uri="{FF2B5EF4-FFF2-40B4-BE49-F238E27FC236}">
-                <a16:creationId xmlns:a16="http://schemas.microsoft.com/office/drawing/2014/main" id="{E5D6E362-6BA9-4225-854D-A0B63236F0C3}"/>
+                <a16:creationId xmlns:a16="http://schemas.microsoft.com/office/drawing/2014/main" id="{704373A8-3D4A-48C1-BE7C-A3B163F8A9CC}"/>
               </a:ext>
             </a:extLst>
           </p:cNvPr>
@@ -3621,7 +3626,7 @@
           <p:cNvPr id="14" name="">
             <a:extLst xmlns:a="http://schemas.openxmlformats.org/drawingml/2006/main">
               <a:ext uri="{FF2B5EF4-FFF2-40B4-BE49-F238E27FC236}">
-                <a16:creationId xmlns:a16="http://schemas.microsoft.com/office/drawing/2014/main" id="{11BA7EDB-DA81-4B5E-AB2E-70F5982D235C}"/>
+                <a16:creationId xmlns:a16="http://schemas.microsoft.com/office/drawing/2014/main" id="{10016126-5952-49D6-ABBE-D21DA067E73A}"/>
               </a:ext>
             </a:extLst>
           </p:cNvPr>
@@ -3677,7 +3682,7 @@
           <p:cNvPr id="15" name="">
             <a:extLst xmlns:a="http://schemas.openxmlformats.org/drawingml/2006/main">
               <a:ext uri="{FF2B5EF4-FFF2-40B4-BE49-F238E27FC236}">
-                <a16:creationId xmlns:a16="http://schemas.microsoft.com/office/drawing/2014/main" id="{A13BD9A2-E3C0-4914-807E-20CD0435D64F}"/>
+                <a16:creationId xmlns:a16="http://schemas.microsoft.com/office/drawing/2014/main" id="{3452C510-EFAC-4667-A1DD-BBBF8CDDB831}"/>
               </a:ext>
             </a:extLst>
           </p:cNvPr>
@@ -3733,7 +3738,7 @@
           <p:cNvPr id="16" name="">
             <a:extLst xmlns:a="http://schemas.openxmlformats.org/drawingml/2006/main">
               <a:ext uri="{FF2B5EF4-FFF2-40B4-BE49-F238E27FC236}">
-                <a16:creationId xmlns:a16="http://schemas.microsoft.com/office/drawing/2014/main" id="{89C498B5-ABB5-482B-AB8C-2BB3F5EDD4D6}"/>
+                <a16:creationId xmlns:a16="http://schemas.microsoft.com/office/drawing/2014/main" id="{0290DDBF-D131-4151-AC31-D7B1664FA935}"/>
               </a:ext>
             </a:extLst>
           </p:cNvPr>
@@ -3789,7 +3794,7 @@
           <p:cNvPr id="17" name="">
             <a:extLst xmlns:a="http://schemas.openxmlformats.org/drawingml/2006/main">
               <a:ext uri="{FF2B5EF4-FFF2-40B4-BE49-F238E27FC236}">
-                <a16:creationId xmlns:a16="http://schemas.microsoft.com/office/drawing/2014/main" id="{C8D591D3-57AD-495B-8059-6E9A6202B0EA}"/>
+                <a16:creationId xmlns:a16="http://schemas.microsoft.com/office/drawing/2014/main" id="{763DA481-9224-4B58-AEE6-1E95FBC11DB2}"/>
               </a:ext>
             </a:extLst>
           </p:cNvPr>
@@ -3820,7 +3825,7 @@
           <p:cNvPr id="18" name="">
             <a:extLst xmlns:a="http://schemas.openxmlformats.org/drawingml/2006/main">
               <a:ext uri="{FF2B5EF4-FFF2-40B4-BE49-F238E27FC236}">
-                <a16:creationId xmlns:a16="http://schemas.microsoft.com/office/drawing/2014/main" id="{34D9BCBC-0206-4A8B-9140-5A8DFC0E514E}"/>
+                <a16:creationId xmlns:a16="http://schemas.microsoft.com/office/drawing/2014/main" id="{E507FF94-6D00-405C-B3FC-1D849A5A02F8}"/>
               </a:ext>
             </a:extLst>
           </p:cNvPr>
@@ -3876,7 +3881,7 @@
           <p:cNvPr id="19" name="">
             <a:extLst xmlns:a="http://schemas.openxmlformats.org/drawingml/2006/main">
               <a:ext uri="{FF2B5EF4-FFF2-40B4-BE49-F238E27FC236}">
-                <a16:creationId xmlns:a16="http://schemas.microsoft.com/office/drawing/2014/main" id="{AB1721F4-1898-4475-AE5D-7D4EFA2517EC}"/>
+                <a16:creationId xmlns:a16="http://schemas.microsoft.com/office/drawing/2014/main" id="{E06E4BAC-D736-4796-99C6-427791F864B2}"/>
               </a:ext>
             </a:extLst>
           </p:cNvPr>
@@ -3932,7 +3937,7 @@
           <p:cNvPr id="20" name="">
             <a:extLst xmlns:a="http://schemas.openxmlformats.org/drawingml/2006/main">
               <a:ext uri="{FF2B5EF4-FFF2-40B4-BE49-F238E27FC236}">
-                <a16:creationId xmlns:a16="http://schemas.microsoft.com/office/drawing/2014/main" id="{397C1CBA-D313-4F17-879C-569014E92256}"/>
+                <a16:creationId xmlns:a16="http://schemas.microsoft.com/office/drawing/2014/main" id="{C8F51AB6-4BFE-4C03-9E48-B812D303F370}"/>
               </a:ext>
             </a:extLst>
           </p:cNvPr>
@@ -3988,7 +3993,7 @@
           <p:cNvPr id="21" name="">
             <a:extLst xmlns:a="http://schemas.openxmlformats.org/drawingml/2006/main">
               <a:ext uri="{FF2B5EF4-FFF2-40B4-BE49-F238E27FC236}">
-                <a16:creationId xmlns:a16="http://schemas.microsoft.com/office/drawing/2014/main" id="{48829EAC-470A-4744-AC77-D6D0778C2705}"/>
+                <a16:creationId xmlns:a16="http://schemas.microsoft.com/office/drawing/2014/main" id="{C3379F25-583C-44E1-B6BA-DCF4C38B9D12}"/>
               </a:ext>
             </a:extLst>
           </p:cNvPr>
@@ -4019,7 +4024,7 @@
           <p:cNvPr id="22" name="">
             <a:extLst xmlns:a="http://schemas.openxmlformats.org/drawingml/2006/main">
               <a:ext uri="{FF2B5EF4-FFF2-40B4-BE49-F238E27FC236}">
-                <a16:creationId xmlns:a16="http://schemas.microsoft.com/office/drawing/2014/main" id="{E36431C4-F264-4677-B778-AEB8AD1F0431}"/>
+                <a16:creationId xmlns:a16="http://schemas.microsoft.com/office/drawing/2014/main" id="{CDCF425C-4AE3-48D3-8D4A-16F0871D86A0}"/>
               </a:ext>
             </a:extLst>
           </p:cNvPr>
@@ -4073,7 +4078,7 @@
     </p:spTree>
     <p:extLst>
       <p:ext uri="{BB962C8B-B14F-4D97-AF65-F5344CB8AC3E}">
-        <p14:creationId xmlns:p14="http://schemas.microsoft.com/office/powerpoint/2010/main" val="1071479596"/>
+        <p14:creationId xmlns:p14="http://schemas.microsoft.com/office/powerpoint/2010/main" val="1358945371"/>
       </p:ext>
     </p:extLst>
   </p:cSld>
@@ -4104,7 +4109,7 @@
           <p:cNvPr id="9" name="">
             <a:extLst xmlns:a="http://schemas.openxmlformats.org/drawingml/2006/main">
               <a:ext uri="{FF2B5EF4-FFF2-40B4-BE49-F238E27FC236}">
-                <a16:creationId xmlns:a16="http://schemas.microsoft.com/office/drawing/2014/main" id="{30A98E8F-1D73-4FF0-92AA-8E9606BBD2BD}"/>
+                <a16:creationId xmlns:a16="http://schemas.microsoft.com/office/drawing/2014/main" id="{6074D982-CBFE-4976-8FEB-E9867B39C794}"/>
               </a:ext>
             </a:extLst>
           </p:cNvPr>
@@ -4160,7 +4165,7 @@
           <p:cNvPr id="2" name="">
             <a:extLst xmlns:a="http://schemas.openxmlformats.org/drawingml/2006/main">
               <a:ext uri="{FF2B5EF4-FFF2-40B4-BE49-F238E27FC236}">
-                <a16:creationId xmlns:a16="http://schemas.microsoft.com/office/drawing/2014/main" id="{E903E680-5672-45D9-8C52-3DE93E24653E}"/>
+                <a16:creationId xmlns:a16="http://schemas.microsoft.com/office/drawing/2014/main" id="{D506B151-BC57-4519-9683-8D4C3F17D4F4}"/>
               </a:ext>
             </a:extLst>
           </p:cNvPr>
@@ -4216,7 +4221,7 @@
           <p:cNvPr id="3" name="">
             <a:extLst xmlns:a="http://schemas.openxmlformats.org/drawingml/2006/main">
               <a:ext uri="{FF2B5EF4-FFF2-40B4-BE49-F238E27FC236}">
-                <a16:creationId xmlns:a16="http://schemas.microsoft.com/office/drawing/2014/main" id="{DBD838F7-D9A2-40A6-B4B3-AE78AC929E4E}"/>
+                <a16:creationId xmlns:a16="http://schemas.microsoft.com/office/drawing/2014/main" id="{FD1BD61F-BA61-4AB5-BA8F-9C690A9C6F5B}"/>
               </a:ext>
             </a:extLst>
           </p:cNvPr>
@@ -4272,7 +4277,7 @@
           <p:cNvPr id="4" name="">
             <a:extLst xmlns:a="http://schemas.openxmlformats.org/drawingml/2006/main">
               <a:ext uri="{FF2B5EF4-FFF2-40B4-BE49-F238E27FC236}">
-                <a16:creationId xmlns:a16="http://schemas.microsoft.com/office/drawing/2014/main" id="{17CAFB13-9DC5-4B5E-BA5C-38DF492B601C}"/>
+                <a16:creationId xmlns:a16="http://schemas.microsoft.com/office/drawing/2014/main" id="{AA1974F6-8965-490B-881D-18088B364754}"/>
               </a:ext>
             </a:extLst>
           </p:cNvPr>
@@ -4328,7 +4333,7 @@
           <p:cNvPr id="5" name="">
             <a:extLst xmlns:a="http://schemas.openxmlformats.org/drawingml/2006/main">
               <a:ext uri="{FF2B5EF4-FFF2-40B4-BE49-F238E27FC236}">
-                <a16:creationId xmlns:a16="http://schemas.microsoft.com/office/drawing/2014/main" id="{C03ECA59-7A87-49B3-A90B-BAB4D680D43C}"/>
+                <a16:creationId xmlns:a16="http://schemas.microsoft.com/office/drawing/2014/main" id="{526E6923-D2F0-4C2E-B04B-60BA7451BC98}"/>
               </a:ext>
             </a:extLst>
           </p:cNvPr>
@@ -4468,7 +4473,7 @@
           <p:cNvPr id="6" name="">
             <a:extLst xmlns:a="http://schemas.openxmlformats.org/drawingml/2006/main">
               <a:ext uri="{FF2B5EF4-FFF2-40B4-BE49-F238E27FC236}">
-                <a16:creationId xmlns:a16="http://schemas.microsoft.com/office/drawing/2014/main" id="{052A18D3-6A3F-4234-8826-4F63BEDAAA95}"/>
+                <a16:creationId xmlns:a16="http://schemas.microsoft.com/office/drawing/2014/main" id="{48DF067E-5C92-4B40-AC0F-32799F1A803B}"/>
               </a:ext>
             </a:extLst>
           </p:cNvPr>
@@ -4505,7 +4510,7 @@
           <p:nvPr/>
         </p:nvPicPr>
         <p:blipFill>
-          <a:blip xmlns:r="http://schemas.openxmlformats.org/officeDocument/2006/relationships" xmlns:a="http://schemas.openxmlformats.org/drawingml/2006/main" r:embed="R6e388cc41f42474e"/>
+          <a:blip xmlns:r="http://schemas.openxmlformats.org/officeDocument/2006/relationships" xmlns:a="http://schemas.openxmlformats.org/drawingml/2006/main" r:embed="R55df0bc18bd3453f"/>
           <a:stretch xmlns:a="http://schemas.openxmlformats.org/drawingml/2006/main"/>
         </p:blipFill>
         <p:spPr>
@@ -4523,7 +4528,7 @@
           <p:cNvPr id="8" name="">
             <a:extLst xmlns:a="http://schemas.openxmlformats.org/drawingml/2006/main">
               <a:ext uri="{FF2B5EF4-FFF2-40B4-BE49-F238E27FC236}">
-                <a16:creationId xmlns:a16="http://schemas.microsoft.com/office/drawing/2014/main" id="{B0150D73-AC6E-4C58-8266-B0C71E999178}"/>
+                <a16:creationId xmlns:a16="http://schemas.microsoft.com/office/drawing/2014/main" id="{23EDF45A-C83F-4105-9A5F-CCBE2EEC5161}"/>
               </a:ext>
             </a:extLst>
           </p:cNvPr>
@@ -4577,7 +4582,7 @@
     </p:spTree>
     <p:extLst>
       <p:ext uri="{BB962C8B-B14F-4D97-AF65-F5344CB8AC3E}">
-        <p14:creationId xmlns:p14="http://schemas.microsoft.com/office/powerpoint/2010/main" val="329357279"/>
+        <p14:creationId xmlns:p14="http://schemas.microsoft.com/office/powerpoint/2010/main" val="803770492"/>
       </p:ext>
     </p:extLst>
   </p:cSld>
@@ -4608,7 +4613,7 @@
           <p:cNvPr id="15" name="">
             <a:extLst xmlns:a="http://schemas.openxmlformats.org/drawingml/2006/main">
               <a:ext uri="{FF2B5EF4-FFF2-40B4-BE49-F238E27FC236}">
-                <a16:creationId xmlns:a16="http://schemas.microsoft.com/office/drawing/2014/main" id="{A38AAC00-5887-4683-B94D-1520BA20DD10}"/>
+                <a16:creationId xmlns:a16="http://schemas.microsoft.com/office/drawing/2014/main" id="{48DC397F-E7BA-4F5C-A114-54A81B269307}"/>
               </a:ext>
             </a:extLst>
           </p:cNvPr>
@@ -4664,7 +4669,7 @@
           <p:cNvPr id="2" name="">
             <a:extLst xmlns:a="http://schemas.openxmlformats.org/drawingml/2006/main">
               <a:ext uri="{FF2B5EF4-FFF2-40B4-BE49-F238E27FC236}">
-                <a16:creationId xmlns:a16="http://schemas.microsoft.com/office/drawing/2014/main" id="{F06FEE02-4B2E-4075-AB76-4AA694A570C3}"/>
+                <a16:creationId xmlns:a16="http://schemas.microsoft.com/office/drawing/2014/main" id="{83A7292E-838A-4270-9B83-6018BC88744D}"/>
               </a:ext>
             </a:extLst>
           </p:cNvPr>
@@ -4720,7 +4725,7 @@
           <p:cNvPr id="3" name="">
             <a:extLst xmlns:a="http://schemas.openxmlformats.org/drawingml/2006/main">
               <a:ext uri="{FF2B5EF4-FFF2-40B4-BE49-F238E27FC236}">
-                <a16:creationId xmlns:a16="http://schemas.microsoft.com/office/drawing/2014/main" id="{6E8B611E-354D-41C1-811B-E313666E9517}"/>
+                <a16:creationId xmlns:a16="http://schemas.microsoft.com/office/drawing/2014/main" id="{B9E3C4BB-5CCA-4A3C-BC4F-DBA8D07CAEB7}"/>
               </a:ext>
             </a:extLst>
           </p:cNvPr>
@@ -4776,7 +4781,7 @@
           <p:cNvPr id="4" name="">
             <a:extLst xmlns:a="http://schemas.openxmlformats.org/drawingml/2006/main">
               <a:ext uri="{FF2B5EF4-FFF2-40B4-BE49-F238E27FC236}">
-                <a16:creationId xmlns:a16="http://schemas.microsoft.com/office/drawing/2014/main" id="{CC01886C-3579-4A59-B2D9-941039623ED3}"/>
+                <a16:creationId xmlns:a16="http://schemas.microsoft.com/office/drawing/2014/main" id="{E4698E0D-D2ED-4522-AD42-A89CA30C16B8}"/>
               </a:ext>
             </a:extLst>
           </p:cNvPr>
@@ -4832,7 +4837,7 @@
           <p:cNvPr id="5" name="">
             <a:extLst xmlns:a="http://schemas.openxmlformats.org/drawingml/2006/main">
               <a:ext uri="{FF2B5EF4-FFF2-40B4-BE49-F238E27FC236}">
-                <a16:creationId xmlns:a16="http://schemas.microsoft.com/office/drawing/2014/main" id="{333240A9-501B-401F-A747-63846292AE18}"/>
+                <a16:creationId xmlns:a16="http://schemas.microsoft.com/office/drawing/2014/main" id="{94480220-614F-4FAE-83BB-90FE683CC41A}"/>
               </a:ext>
             </a:extLst>
           </p:cNvPr>
@@ -4863,7 +4868,7 @@
           <p:cNvPr id="6" name="">
             <a:extLst xmlns:a="http://schemas.openxmlformats.org/drawingml/2006/main">
               <a:ext uri="{FF2B5EF4-FFF2-40B4-BE49-F238E27FC236}">
-                <a16:creationId xmlns:a16="http://schemas.microsoft.com/office/drawing/2014/main" id="{49B7DD5B-FB11-48BC-8551-41A2272204F7}"/>
+                <a16:creationId xmlns:a16="http://schemas.microsoft.com/office/drawing/2014/main" id="{8645D6AD-4E75-4E70-A245-7D7D2A2D242A}"/>
               </a:ext>
             </a:extLst>
           </p:cNvPr>
@@ -4894,7 +4899,7 @@
           <p:cNvPr id="7" name="">
             <a:extLst xmlns:a="http://schemas.openxmlformats.org/drawingml/2006/main">
               <a:ext uri="{FF2B5EF4-FFF2-40B4-BE49-F238E27FC236}">
-                <a16:creationId xmlns:a16="http://schemas.microsoft.com/office/drawing/2014/main" id="{4265D518-5E54-4015-BFD9-9DE087EA0A3A}"/>
+                <a16:creationId xmlns:a16="http://schemas.microsoft.com/office/drawing/2014/main" id="{5C8F6320-394F-4F75-BDD2-CBB78C3EC634}"/>
               </a:ext>
             </a:extLst>
           </p:cNvPr>
@@ -4950,7 +4955,7 @@
           <p:cNvPr id="8" name="">
             <a:extLst xmlns:a="http://schemas.openxmlformats.org/drawingml/2006/main">
               <a:ext uri="{FF2B5EF4-FFF2-40B4-BE49-F238E27FC236}">
-                <a16:creationId xmlns:a16="http://schemas.microsoft.com/office/drawing/2014/main" id="{CF77AC74-09E2-4558-BEEC-DBC874115E26}"/>
+                <a16:creationId xmlns:a16="http://schemas.microsoft.com/office/drawing/2014/main" id="{302C9FAC-4738-46D7-9F88-135AE8C257D8}"/>
               </a:ext>
             </a:extLst>
           </p:cNvPr>
@@ -5006,7 +5011,7 @@
           <p:cNvPr id="9" name="">
             <a:extLst xmlns:a="http://schemas.openxmlformats.org/drawingml/2006/main">
               <a:ext uri="{FF2B5EF4-FFF2-40B4-BE49-F238E27FC236}">
-                <a16:creationId xmlns:a16="http://schemas.microsoft.com/office/drawing/2014/main" id="{05DE8135-1D83-4C5F-BA15-BB48986582D7}"/>
+                <a16:creationId xmlns:a16="http://schemas.microsoft.com/office/drawing/2014/main" id="{1BB916CB-67B3-4012-8593-A0EFAA6B6F0F}"/>
               </a:ext>
             </a:extLst>
           </p:cNvPr>
@@ -5131,7 +5136,7 @@
           <p:cNvPr id="10" name="">
             <a:extLst xmlns:a="http://schemas.openxmlformats.org/drawingml/2006/main">
               <a:ext uri="{FF2B5EF4-FFF2-40B4-BE49-F238E27FC236}">
-                <a16:creationId xmlns:a16="http://schemas.microsoft.com/office/drawing/2014/main" id="{BFACC530-1C7A-4581-B12A-07A91D666F9B}"/>
+                <a16:creationId xmlns:a16="http://schemas.microsoft.com/office/drawing/2014/main" id="{BE13FE0C-7D8E-48EC-888D-014C612FC56B}"/>
               </a:ext>
             </a:extLst>
           </p:cNvPr>
@@ -5187,7 +5192,7 @@
           <p:cNvPr id="11" name="">
             <a:extLst xmlns:a="http://schemas.openxmlformats.org/drawingml/2006/main">
               <a:ext uri="{FF2B5EF4-FFF2-40B4-BE49-F238E27FC236}">
-                <a16:creationId xmlns:a16="http://schemas.microsoft.com/office/drawing/2014/main" id="{10BFB2F4-50D7-4DC2-BEF8-6B0C08325D0E}"/>
+                <a16:creationId xmlns:a16="http://schemas.microsoft.com/office/drawing/2014/main" id="{E2530563-4B85-4115-9EE3-22E538C9723F}"/>
               </a:ext>
             </a:extLst>
           </p:cNvPr>
@@ -5243,7 +5248,7 @@
           <p:cNvPr id="12" name="">
             <a:extLst xmlns:a="http://schemas.openxmlformats.org/drawingml/2006/main">
               <a:ext uri="{FF2B5EF4-FFF2-40B4-BE49-F238E27FC236}">
-                <a16:creationId xmlns:a16="http://schemas.microsoft.com/office/drawing/2014/main" id="{64E0108A-2F94-4556-B6D6-8474BEF1E421}"/>
+                <a16:creationId xmlns:a16="http://schemas.microsoft.com/office/drawing/2014/main" id="{A8C87EA3-37F0-4629-9773-D27BE7C2F92D}"/>
               </a:ext>
             </a:extLst>
           </p:cNvPr>
@@ -5299,7 +5304,7 @@
           <p:cNvPr id="13" name="">
             <a:extLst xmlns:a="http://schemas.openxmlformats.org/drawingml/2006/main">
               <a:ext uri="{FF2B5EF4-FFF2-40B4-BE49-F238E27FC236}">
-                <a16:creationId xmlns:a16="http://schemas.microsoft.com/office/drawing/2014/main" id="{148FB7D5-F004-41E4-9507-BC1F97784461}"/>
+                <a16:creationId xmlns:a16="http://schemas.microsoft.com/office/drawing/2014/main" id="{1002EB1A-B97B-45CA-97E6-E7FECABAD14D}"/>
               </a:ext>
             </a:extLst>
           </p:cNvPr>
@@ -5424,7 +5429,7 @@
           <p:cNvPr id="14" name="">
             <a:extLst xmlns:a="http://schemas.openxmlformats.org/drawingml/2006/main">
               <a:ext uri="{FF2B5EF4-FFF2-40B4-BE49-F238E27FC236}">
-                <a16:creationId xmlns:a16="http://schemas.microsoft.com/office/drawing/2014/main" id="{53BF57C0-729B-4B4E-BEAB-096691F6BFC5}"/>
+                <a16:creationId xmlns:a16="http://schemas.microsoft.com/office/drawing/2014/main" id="{8302D512-5BC0-4904-BE38-95A1E1C0AEE6}"/>
               </a:ext>
             </a:extLst>
           </p:cNvPr>
@@ -5478,7 +5483,7 @@
     </p:spTree>
     <p:extLst>
       <p:ext uri="{BB962C8B-B14F-4D97-AF65-F5344CB8AC3E}">
-        <p14:creationId xmlns:p14="http://schemas.microsoft.com/office/powerpoint/2010/main" val="1177139156"/>
+        <p14:creationId xmlns:p14="http://schemas.microsoft.com/office/powerpoint/2010/main" val="841624218"/>
       </p:ext>
     </p:extLst>
   </p:cSld>
@@ -5509,7 +5514,7 @@
           <p:cNvPr id="20" name="">
             <a:extLst xmlns:a="http://schemas.openxmlformats.org/drawingml/2006/main">
               <a:ext uri="{FF2B5EF4-FFF2-40B4-BE49-F238E27FC236}">
-                <a16:creationId xmlns:a16="http://schemas.microsoft.com/office/drawing/2014/main" id="{E5EAF928-B54E-4470-BE44-7657B9834476}"/>
+                <a16:creationId xmlns:a16="http://schemas.microsoft.com/office/drawing/2014/main" id="{CB8880E1-7990-44F2-A335-5E316D075A1A}"/>
               </a:ext>
             </a:extLst>
           </p:cNvPr>
@@ -5565,7 +5570,7 @@
           <p:cNvPr id="2" name="">
             <a:extLst xmlns:a="http://schemas.openxmlformats.org/drawingml/2006/main">
               <a:ext uri="{FF2B5EF4-FFF2-40B4-BE49-F238E27FC236}">
-                <a16:creationId xmlns:a16="http://schemas.microsoft.com/office/drawing/2014/main" id="{2DE3BB85-7793-4F18-9AAC-89A34F978A86}"/>
+                <a16:creationId xmlns:a16="http://schemas.microsoft.com/office/drawing/2014/main" id="{3FBBEDD1-13A5-468A-A6A0-FD91A1F351D5}"/>
               </a:ext>
             </a:extLst>
           </p:cNvPr>
@@ -5644,7 +5649,7 @@
           <p:cNvPr id="3" name="">
             <a:extLst xmlns:a="http://schemas.openxmlformats.org/drawingml/2006/main">
               <a:ext uri="{FF2B5EF4-FFF2-40B4-BE49-F238E27FC236}">
-                <a16:creationId xmlns:a16="http://schemas.microsoft.com/office/drawing/2014/main" id="{E0F102CA-EDD0-4906-B7F9-7A2D022811B7}"/>
+                <a16:creationId xmlns:a16="http://schemas.microsoft.com/office/drawing/2014/main" id="{F08CE983-BA96-4305-BA4C-6B772D180FB6}"/>
               </a:ext>
             </a:extLst>
           </p:cNvPr>
@@ -5700,7 +5705,7 @@
           <p:cNvPr id="4" name="">
             <a:extLst xmlns:a="http://schemas.openxmlformats.org/drawingml/2006/main">
               <a:ext uri="{FF2B5EF4-FFF2-40B4-BE49-F238E27FC236}">
-                <a16:creationId xmlns:a16="http://schemas.microsoft.com/office/drawing/2014/main" id="{FF5D2D55-40A1-4057-85DF-0AB466296570}"/>
+                <a16:creationId xmlns:a16="http://schemas.microsoft.com/office/drawing/2014/main" id="{F2FEC70B-9AF2-4E72-9481-D4F78138FB78}"/>
               </a:ext>
             </a:extLst>
           </p:cNvPr>
@@ -5731,7 +5736,7 @@
           <p:cNvPr id="5" name="">
             <a:extLst xmlns:a="http://schemas.openxmlformats.org/drawingml/2006/main">
               <a:ext uri="{FF2B5EF4-FFF2-40B4-BE49-F238E27FC236}">
-                <a16:creationId xmlns:a16="http://schemas.microsoft.com/office/drawing/2014/main" id="{FECE4D70-334C-4FE9-8629-D4C7C7C4601F}"/>
+                <a16:creationId xmlns:a16="http://schemas.microsoft.com/office/drawing/2014/main" id="{07C87855-6864-4A85-A473-24710A219280}"/>
               </a:ext>
             </a:extLst>
           </p:cNvPr>
@@ -5787,7 +5792,7 @@
           <p:cNvPr id="6" name="">
             <a:extLst xmlns:a="http://schemas.openxmlformats.org/drawingml/2006/main">
               <a:ext uri="{FF2B5EF4-FFF2-40B4-BE49-F238E27FC236}">
-                <a16:creationId xmlns:a16="http://schemas.microsoft.com/office/drawing/2014/main" id="{7FAC556B-7539-477D-B178-8BB78F72C2B9}"/>
+                <a16:creationId xmlns:a16="http://schemas.microsoft.com/office/drawing/2014/main" id="{FF2F2309-553C-418D-9D56-B3E8F0982FC1}"/>
               </a:ext>
             </a:extLst>
           </p:cNvPr>
@@ -5843,7 +5848,7 @@
           <p:cNvPr id="7" name="">
             <a:extLst xmlns:a="http://schemas.openxmlformats.org/drawingml/2006/main">
               <a:ext uri="{FF2B5EF4-FFF2-40B4-BE49-F238E27FC236}">
-                <a16:creationId xmlns:a16="http://schemas.microsoft.com/office/drawing/2014/main" id="{9893AE07-B6DC-4D9F-A766-6684C416208B}"/>
+                <a16:creationId xmlns:a16="http://schemas.microsoft.com/office/drawing/2014/main" id="{01EBD2C3-F421-4659-81D2-D832C942331F}"/>
               </a:ext>
             </a:extLst>
           </p:cNvPr>
@@ -5899,7 +5904,7 @@
           <p:cNvPr id="8" name="">
             <a:extLst xmlns:a="http://schemas.openxmlformats.org/drawingml/2006/main">
               <a:ext uri="{FF2B5EF4-FFF2-40B4-BE49-F238E27FC236}">
-                <a16:creationId xmlns:a16="http://schemas.microsoft.com/office/drawing/2014/main" id="{451D749D-7617-4882-B8FF-8263B505C303}"/>
+                <a16:creationId xmlns:a16="http://schemas.microsoft.com/office/drawing/2014/main" id="{69E82D89-9DA8-4D0D-B2D4-C4F975B94827}"/>
               </a:ext>
             </a:extLst>
           </p:cNvPr>
@@ -5930,7 +5935,7 @@
           <p:cNvPr id="9" name="">
             <a:extLst xmlns:a="http://schemas.openxmlformats.org/drawingml/2006/main">
               <a:ext uri="{FF2B5EF4-FFF2-40B4-BE49-F238E27FC236}">
-                <a16:creationId xmlns:a16="http://schemas.microsoft.com/office/drawing/2014/main" id="{3498F643-36C8-496C-8DD0-FE4A46C24597}"/>
+                <a16:creationId xmlns:a16="http://schemas.microsoft.com/office/drawing/2014/main" id="{E2AB6086-055D-4C18-9CA5-A6F638484167}"/>
               </a:ext>
             </a:extLst>
           </p:cNvPr>
@@ -5986,7 +5991,7 @@
           <p:cNvPr id="10" name="">
             <a:extLst xmlns:a="http://schemas.openxmlformats.org/drawingml/2006/main">
               <a:ext uri="{FF2B5EF4-FFF2-40B4-BE49-F238E27FC236}">
-                <a16:creationId xmlns:a16="http://schemas.microsoft.com/office/drawing/2014/main" id="{7BE2AAC4-99BB-4C0E-AA45-AB2A33791191}"/>
+                <a16:creationId xmlns:a16="http://schemas.microsoft.com/office/drawing/2014/main" id="{0CEDC0B5-125D-4A3A-A8A4-0E5F3F7C1794}"/>
               </a:ext>
             </a:extLst>
           </p:cNvPr>
@@ -6042,7 +6047,7 @@
           <p:cNvPr id="11" name="">
             <a:extLst xmlns:a="http://schemas.openxmlformats.org/drawingml/2006/main">
               <a:ext uri="{FF2B5EF4-FFF2-40B4-BE49-F238E27FC236}">
-                <a16:creationId xmlns:a16="http://schemas.microsoft.com/office/drawing/2014/main" id="{44343F02-36A8-4E09-8809-3C09E4BEB6DC}"/>
+                <a16:creationId xmlns:a16="http://schemas.microsoft.com/office/drawing/2014/main" id="{9AD3CDAF-5DFB-4E1E-9120-8225DAE22A23}"/>
               </a:ext>
             </a:extLst>
           </p:cNvPr>
@@ -6098,7 +6103,7 @@
           <p:cNvPr id="12" name="">
             <a:extLst xmlns:a="http://schemas.openxmlformats.org/drawingml/2006/main">
               <a:ext uri="{FF2B5EF4-FFF2-40B4-BE49-F238E27FC236}">
-                <a16:creationId xmlns:a16="http://schemas.microsoft.com/office/drawing/2014/main" id="{D05AC38C-9B29-4C26-B11A-1A6634718F68}"/>
+                <a16:creationId xmlns:a16="http://schemas.microsoft.com/office/drawing/2014/main" id="{F841CB8A-C81D-4CA0-B0D7-EA88EA7217AB}"/>
               </a:ext>
             </a:extLst>
           </p:cNvPr>
@@ -6129,7 +6134,7 @@
           <p:cNvPr id="13" name="">
             <a:extLst xmlns:a="http://schemas.openxmlformats.org/drawingml/2006/main">
               <a:ext uri="{FF2B5EF4-FFF2-40B4-BE49-F238E27FC236}">
-                <a16:creationId xmlns:a16="http://schemas.microsoft.com/office/drawing/2014/main" id="{30D0D97B-2025-4F16-8A36-969915E40CDF}"/>
+                <a16:creationId xmlns:a16="http://schemas.microsoft.com/office/drawing/2014/main" id="{A38EEB1E-04B7-4DA5-84B7-4014A6FEF962}"/>
               </a:ext>
             </a:extLst>
           </p:cNvPr>
@@ -6185,7 +6190,7 @@
           <p:cNvPr id="14" name="">
             <a:extLst xmlns:a="http://schemas.openxmlformats.org/drawingml/2006/main">
               <a:ext uri="{FF2B5EF4-FFF2-40B4-BE49-F238E27FC236}">
-                <a16:creationId xmlns:a16="http://schemas.microsoft.com/office/drawing/2014/main" id="{70C01F9B-6913-4452-B03F-D9711D31B7F7}"/>
+                <a16:creationId xmlns:a16="http://schemas.microsoft.com/office/drawing/2014/main" id="{77C1EEA3-6A48-470C-B72D-585A799BC8DD}"/>
               </a:ext>
             </a:extLst>
           </p:cNvPr>
@@ -6241,7 +6246,7 @@
           <p:cNvPr id="15" name="">
             <a:extLst xmlns:a="http://schemas.openxmlformats.org/drawingml/2006/main">
               <a:ext uri="{FF2B5EF4-FFF2-40B4-BE49-F238E27FC236}">
-                <a16:creationId xmlns:a16="http://schemas.microsoft.com/office/drawing/2014/main" id="{72C38233-0D44-4E43-988D-E89FC3060030}"/>
+                <a16:creationId xmlns:a16="http://schemas.microsoft.com/office/drawing/2014/main" id="{364E0808-1FC9-4599-B3E8-C66FB419E812}"/>
               </a:ext>
             </a:extLst>
           </p:cNvPr>
@@ -6297,7 +6302,7 @@
           <p:cNvPr id="16" name="">
             <a:extLst xmlns:a="http://schemas.openxmlformats.org/drawingml/2006/main">
               <a:ext uri="{FF2B5EF4-FFF2-40B4-BE49-F238E27FC236}">
-                <a16:creationId xmlns:a16="http://schemas.microsoft.com/office/drawing/2014/main" id="{10D97E0A-D6AD-4D80-A663-DB0244F21A90}"/>
+                <a16:creationId xmlns:a16="http://schemas.microsoft.com/office/drawing/2014/main" id="{3CFBA7DC-D6D0-46FD-BA0D-0AF68021699D}"/>
               </a:ext>
             </a:extLst>
           </p:cNvPr>
@@ -6353,7 +6358,7 @@
           <p:cNvPr id="17" name="">
             <a:extLst xmlns:a="http://schemas.openxmlformats.org/drawingml/2006/main">
               <a:ext uri="{FF2B5EF4-FFF2-40B4-BE49-F238E27FC236}">
-                <a16:creationId xmlns:a16="http://schemas.microsoft.com/office/drawing/2014/main" id="{7744AF83-5888-45B0-BC43-3E0416BC5C30}"/>
+                <a16:creationId xmlns:a16="http://schemas.microsoft.com/office/drawing/2014/main" id="{BEB73740-14FC-4B2E-8633-50D5346A3819}"/>
               </a:ext>
             </a:extLst>
           </p:cNvPr>
@@ -6409,7 +6414,7 @@
           <p:cNvPr id="18" name="">
             <a:extLst xmlns:a="http://schemas.openxmlformats.org/drawingml/2006/main">
               <a:ext uri="{FF2B5EF4-FFF2-40B4-BE49-F238E27FC236}">
-                <a16:creationId xmlns:a16="http://schemas.microsoft.com/office/drawing/2014/main" id="{DA48AD66-8854-47AE-987E-A7CCEB016B55}"/>
+                <a16:creationId xmlns:a16="http://schemas.microsoft.com/office/drawing/2014/main" id="{2933B625-302E-4642-8373-AECE40866DE2}"/>
               </a:ext>
             </a:extLst>
           </p:cNvPr>
@@ -6469,7 +6474,7 @@
           <p:nvPr/>
         </p:nvPicPr>
         <p:blipFill>
-          <a:blip xmlns:r="http://schemas.openxmlformats.org/officeDocument/2006/relationships" xmlns:a="http://schemas.openxmlformats.org/drawingml/2006/main" r:embed="Rd4f3daaad9e14d66"/>
+          <a:blip xmlns:r="http://schemas.openxmlformats.org/officeDocument/2006/relationships" xmlns:a="http://schemas.openxmlformats.org/drawingml/2006/main" r:embed="Rcc0868150fc84a16"/>
           <a:stretch xmlns:a="http://schemas.openxmlformats.org/drawingml/2006/main"/>
         </p:blipFill>
         <p:spPr>
@@ -6485,7 +6490,7 @@
     </p:spTree>
     <p:extLst>
       <p:ext uri="{BB962C8B-B14F-4D97-AF65-F5344CB8AC3E}">
-        <p14:creationId xmlns:p14="http://schemas.microsoft.com/office/powerpoint/2010/main" val="2033317976"/>
+        <p14:creationId xmlns:p14="http://schemas.microsoft.com/office/powerpoint/2010/main" val="518130950"/>
       </p:ext>
     </p:extLst>
   </p:cSld>

</xml_diff>

<commit_message>
Sunum: v1.1.0 indirme bağlantısı ve EN-TR sözlük metrikleri
Co-Authored-By: Claude Fable 5.1 <noreply@anthropic.com>
</commit_message>
<xml_diff>
--- a/docs/presentation/English-Course-AI-Bilingual.pptx
+++ b/docs/presentation/English-Course-AI-Bilingual.pptx
@@ -2,18 +2,18 @@
 <file path=ppt/presentation.xml><?xml version="1.0" encoding="utf-8"?>
 <p:presentation xmlns:p="http://schemas.openxmlformats.org/presentationml/2006/main">
   <p:sldMasterIdLst>
-    <p:sldMasterId xmlns:r="http://schemas.openxmlformats.org/officeDocument/2006/relationships" id="2147483648" r:id="R7edb7c08ecf94745"/>
+    <p:sldMasterId xmlns:r="http://schemas.openxmlformats.org/officeDocument/2006/relationships" id="2147483648" r:id="R548930dc537148f9"/>
   </p:sldMasterIdLst>
   <p:notesMasterIdLst>
-    <p:notesMasterId xmlns:r="http://schemas.openxmlformats.org/officeDocument/2006/relationships" r:id="Rc90896163ab64c5c"/>
+    <p:notesMasterId xmlns:r="http://schemas.openxmlformats.org/officeDocument/2006/relationships" r:id="Rfe150eeba0664a44"/>
   </p:notesMasterIdLst>
   <p:sldIdLst>
-    <p:sldId xmlns:r="http://schemas.openxmlformats.org/officeDocument/2006/relationships" id="256" r:id="R7bee2c70acd246eb"/>
-    <p:sldId xmlns:r="http://schemas.openxmlformats.org/officeDocument/2006/relationships" id="257" r:id="R5c7ae9bd1f264011"/>
-    <p:sldId xmlns:r="http://schemas.openxmlformats.org/officeDocument/2006/relationships" id="258" r:id="Rc50e2daa5fa84a9a"/>
-    <p:sldId xmlns:r="http://schemas.openxmlformats.org/officeDocument/2006/relationships" id="259" r:id="Rc7b79f9f08494001"/>
-    <p:sldId xmlns:r="http://schemas.openxmlformats.org/officeDocument/2006/relationships" id="260" r:id="R8586d0791d364ea0"/>
-    <p:sldId xmlns:r="http://schemas.openxmlformats.org/officeDocument/2006/relationships" id="261" r:id="Ra722d1ec4eb74f99"/>
+    <p:sldId xmlns:r="http://schemas.openxmlformats.org/officeDocument/2006/relationships" id="256" r:id="R41244f3007e04e89"/>
+    <p:sldId xmlns:r="http://schemas.openxmlformats.org/officeDocument/2006/relationships" id="257" r:id="R5a06de511d894477"/>
+    <p:sldId xmlns:r="http://schemas.openxmlformats.org/officeDocument/2006/relationships" id="258" r:id="R0d9c2e26122d44e3"/>
+    <p:sldId xmlns:r="http://schemas.openxmlformats.org/officeDocument/2006/relationships" id="259" r:id="R275143bebce340e8"/>
+    <p:sldId xmlns:r="http://schemas.openxmlformats.org/officeDocument/2006/relationships" id="260" r:id="R9ecff22207ba4138"/>
+    <p:sldId xmlns:r="http://schemas.openxmlformats.org/officeDocument/2006/relationships" id="261" r:id="Rccef45420e5247e9"/>
   </p:sldIdLst>
   <p:sldSz cx="12192000" cy="6858000"/>
   <p:notesSz cx="6858000" cy="9144000"/>
@@ -917,7 +917,7 @@
           </a:p>
           <a:p xmlns:a="http://schemas.openxmlformats.org/drawingml/2006/main">
             <a:r>
-              <a:t>- GitHub release (private repo): https://github.com/Azizsekerdil/EnglishCourseAI/releases/tag/v1.0.0 (Windows zip + macOS zip)</a:t>
+              <a:t>- GitHub release (private repo): https://github.com/Azizsekerdil/EnglishCourseAI/releases/tag/v1.1.0 (Windows zip + macOS zip)</a:t>
             </a:r>
           </a:p>
           <a:p xmlns:a="http://schemas.openxmlformats.org/drawingml/2006/main">
@@ -990,7 +990,7 @@
   </p:cSld>
   <p:clrMap bg1="lt1" tx1="dk1" bg2="lt2" tx2="dk2" accent1="accent1" accent2="accent2" accent3="accent3" accent4="accent4" accent5="accent5" accent6="accent6" hlink="hlink" folHlink="folHlink"/>
   <p:sldLayoutIdLst>
-    <p:sldLayoutId xmlns:r="http://schemas.openxmlformats.org/officeDocument/2006/relationships" id="2147483649" r:id="Ra9522b1a04184b50"/>
+    <p:sldLayoutId xmlns:r="http://schemas.openxmlformats.org/officeDocument/2006/relationships" id="2147483649" r:id="R26db73c29cdb4d59"/>
   </p:sldLayoutIdLst>
   <p:txStyles>
     <p:titleStyle>
@@ -1541,7 +1541,7 @@
           <p:cNvPr id="8" name="">
             <a:extLst xmlns:a="http://schemas.openxmlformats.org/drawingml/2006/main">
               <a:ext uri="{FF2B5EF4-FFF2-40B4-BE49-F238E27FC236}">
-                <a16:creationId xmlns:a16="http://schemas.microsoft.com/office/drawing/2014/main" id="{F0D6EE19-E3A3-487F-9185-1D16D2BECF55}"/>
+                <a16:creationId xmlns:a16="http://schemas.microsoft.com/office/drawing/2014/main" id="{B96E6E91-D51D-4284-8D1C-3370B110AEBE}"/>
               </a:ext>
             </a:extLst>
           </p:cNvPr>
@@ -1576,7 +1576,7 @@
           <p:nvPr/>
         </p:nvPicPr>
         <p:blipFill>
-          <a:blip xmlns:r="http://schemas.openxmlformats.org/officeDocument/2006/relationships" xmlns:a="http://schemas.openxmlformats.org/drawingml/2006/main" r:embed="Re49337b706d14520"/>
+          <a:blip xmlns:r="http://schemas.openxmlformats.org/officeDocument/2006/relationships" xmlns:a="http://schemas.openxmlformats.org/drawingml/2006/main" r:embed="R4808e0fce77a44c3"/>
           <a:stretch xmlns:a="http://schemas.openxmlformats.org/drawingml/2006/main"/>
         </p:blipFill>
         <p:spPr>
@@ -1594,7 +1594,7 @@
           <p:cNvPr id="3" name="">
             <a:extLst xmlns:a="http://schemas.openxmlformats.org/drawingml/2006/main">
               <a:ext uri="{FF2B5EF4-FFF2-40B4-BE49-F238E27FC236}">
-                <a16:creationId xmlns:a16="http://schemas.microsoft.com/office/drawing/2014/main" id="{0FCF35E6-313C-405C-BB15-091C9670D361}"/>
+                <a16:creationId xmlns:a16="http://schemas.microsoft.com/office/drawing/2014/main" id="{4DB2D8C1-4922-49A5-8A0A-0B4B3A42A51A}"/>
               </a:ext>
             </a:extLst>
           </p:cNvPr>
@@ -1650,7 +1650,7 @@
           <p:cNvPr id="4" name="">
             <a:extLst xmlns:a="http://schemas.openxmlformats.org/drawingml/2006/main">
               <a:ext uri="{FF2B5EF4-FFF2-40B4-BE49-F238E27FC236}">
-                <a16:creationId xmlns:a16="http://schemas.microsoft.com/office/drawing/2014/main" id="{FCD61B4B-BD15-4901-BC06-436816126E9A}"/>
+                <a16:creationId xmlns:a16="http://schemas.microsoft.com/office/drawing/2014/main" id="{7E95482E-8754-469D-8A36-33412282740F}"/>
               </a:ext>
             </a:extLst>
           </p:cNvPr>
@@ -1729,7 +1729,7 @@
           <p:cNvPr id="5" name="">
             <a:extLst xmlns:a="http://schemas.openxmlformats.org/drawingml/2006/main">
               <a:ext uri="{FF2B5EF4-FFF2-40B4-BE49-F238E27FC236}">
-                <a16:creationId xmlns:a16="http://schemas.microsoft.com/office/drawing/2014/main" id="{F57F9DF9-C29F-46E4-800C-E14BCB79643A}"/>
+                <a16:creationId xmlns:a16="http://schemas.microsoft.com/office/drawing/2014/main" id="{AF90C5C1-3BD1-47DB-92E7-E166255E92A8}"/>
               </a:ext>
             </a:extLst>
           </p:cNvPr>
@@ -1760,7 +1760,7 @@
           <p:cNvPr id="6" name="">
             <a:extLst xmlns:a="http://schemas.openxmlformats.org/drawingml/2006/main">
               <a:ext uri="{FF2B5EF4-FFF2-40B4-BE49-F238E27FC236}">
-                <a16:creationId xmlns:a16="http://schemas.microsoft.com/office/drawing/2014/main" id="{480A8198-B97B-4E17-999A-A881552F03F2}"/>
+                <a16:creationId xmlns:a16="http://schemas.microsoft.com/office/drawing/2014/main" id="{6D4BCAC2-3452-46FF-B908-A677E83219C9}"/>
               </a:ext>
             </a:extLst>
           </p:cNvPr>
@@ -1839,7 +1839,7 @@
           <p:cNvPr id="7" name="">
             <a:extLst xmlns:a="http://schemas.openxmlformats.org/drawingml/2006/main">
               <a:ext uri="{FF2B5EF4-FFF2-40B4-BE49-F238E27FC236}">
-                <a16:creationId xmlns:a16="http://schemas.microsoft.com/office/drawing/2014/main" id="{3A4F3CC1-086E-4148-9B26-0D80B1DF0C0E}"/>
+                <a16:creationId xmlns:a16="http://schemas.microsoft.com/office/drawing/2014/main" id="{2134ED90-50A3-4DA6-96B3-D88ACE4D8F99}"/>
               </a:ext>
             </a:extLst>
           </p:cNvPr>
@@ -1885,7 +1885,7 @@
                 <a:ea typeface="Arial"/>
                 <a:cs typeface="Arial"/>
               </a:rPr>
-              <a:t>v1.0.0  •  2026</a:t>
+              <a:t>v1.1.0  •  2026</a:t>
             </a:r>
           </a:p>
         </p:txBody>
@@ -1893,7 +1893,7 @@
     </p:spTree>
     <p:extLst>
       <p:ext uri="{BB962C8B-B14F-4D97-AF65-F5344CB8AC3E}">
-        <p14:creationId xmlns:p14="http://schemas.microsoft.com/office/powerpoint/2010/main" val="1067418838"/>
+        <p14:creationId xmlns:p14="http://schemas.microsoft.com/office/powerpoint/2010/main" val="96276581"/>
       </p:ext>
     </p:extLst>
   </p:cSld>
@@ -1924,7 +1924,7 @@
           <p:cNvPr id="21" name="">
             <a:extLst xmlns:a="http://schemas.openxmlformats.org/drawingml/2006/main">
               <a:ext uri="{FF2B5EF4-FFF2-40B4-BE49-F238E27FC236}">
-                <a16:creationId xmlns:a16="http://schemas.microsoft.com/office/drawing/2014/main" id="{6702CE05-D302-4F70-900C-4D8E276275E3}"/>
+                <a16:creationId xmlns:a16="http://schemas.microsoft.com/office/drawing/2014/main" id="{DBA85FEC-BC17-4DED-A939-E1495AF69B78}"/>
               </a:ext>
             </a:extLst>
           </p:cNvPr>
@@ -1980,7 +1980,7 @@
           <p:cNvPr id="2" name="">
             <a:extLst xmlns:a="http://schemas.openxmlformats.org/drawingml/2006/main">
               <a:ext uri="{FF2B5EF4-FFF2-40B4-BE49-F238E27FC236}">
-                <a16:creationId xmlns:a16="http://schemas.microsoft.com/office/drawing/2014/main" id="{293ECE08-0098-427D-B217-3C032F5D7A78}"/>
+                <a16:creationId xmlns:a16="http://schemas.microsoft.com/office/drawing/2014/main" id="{B5E7CC10-A5E7-4DEF-8E3C-B2A800380BB8}"/>
               </a:ext>
             </a:extLst>
           </p:cNvPr>
@@ -2036,7 +2036,7 @@
           <p:cNvPr id="3" name="">
             <a:extLst xmlns:a="http://schemas.openxmlformats.org/drawingml/2006/main">
               <a:ext uri="{FF2B5EF4-FFF2-40B4-BE49-F238E27FC236}">
-                <a16:creationId xmlns:a16="http://schemas.microsoft.com/office/drawing/2014/main" id="{881D52C1-2A34-4B85-A99F-C2A614772FE5}"/>
+                <a16:creationId xmlns:a16="http://schemas.microsoft.com/office/drawing/2014/main" id="{C10394C5-0FAC-4325-B0A3-87DF80AAED6B}"/>
               </a:ext>
             </a:extLst>
           </p:cNvPr>
@@ -2092,7 +2092,7 @@
           <p:cNvPr id="4" name="">
             <a:extLst xmlns:a="http://schemas.openxmlformats.org/drawingml/2006/main">
               <a:ext uri="{FF2B5EF4-FFF2-40B4-BE49-F238E27FC236}">
-                <a16:creationId xmlns:a16="http://schemas.microsoft.com/office/drawing/2014/main" id="{4BB28EC2-4507-4D6E-B925-1200AF8E2579}"/>
+                <a16:creationId xmlns:a16="http://schemas.microsoft.com/office/drawing/2014/main" id="{4E0DA323-659D-4412-B1C8-7480657584BD}"/>
               </a:ext>
             </a:extLst>
           </p:cNvPr>
@@ -2148,7 +2148,7 @@
           <p:cNvPr id="5" name="">
             <a:extLst xmlns:a="http://schemas.openxmlformats.org/drawingml/2006/main">
               <a:ext uri="{FF2B5EF4-FFF2-40B4-BE49-F238E27FC236}">
-                <a16:creationId xmlns:a16="http://schemas.microsoft.com/office/drawing/2014/main" id="{F6A38E5A-D788-4F14-A03F-6B3BF4466D31}"/>
+                <a16:creationId xmlns:a16="http://schemas.microsoft.com/office/drawing/2014/main" id="{D653539D-783C-46C6-964B-5FC07D52F929}"/>
               </a:ext>
             </a:extLst>
           </p:cNvPr>
@@ -2179,7 +2179,7 @@
           <p:cNvPr id="6" name="">
             <a:extLst xmlns:a="http://schemas.openxmlformats.org/drawingml/2006/main">
               <a:ext uri="{FF2B5EF4-FFF2-40B4-BE49-F238E27FC236}">
-                <a16:creationId xmlns:a16="http://schemas.microsoft.com/office/drawing/2014/main" id="{44D9E31D-F1B8-4611-ABC6-48C11C645A83}"/>
+                <a16:creationId xmlns:a16="http://schemas.microsoft.com/office/drawing/2014/main" id="{B83C87C8-F869-4B32-826A-EC66798CA81C}"/>
               </a:ext>
             </a:extLst>
           </p:cNvPr>
@@ -2235,7 +2235,7 @@
           <p:cNvPr id="7" name="">
             <a:extLst xmlns:a="http://schemas.openxmlformats.org/drawingml/2006/main">
               <a:ext uri="{FF2B5EF4-FFF2-40B4-BE49-F238E27FC236}">
-                <a16:creationId xmlns:a16="http://schemas.microsoft.com/office/drawing/2014/main" id="{E941B783-61FC-4614-BCA0-586F69A05376}"/>
+                <a16:creationId xmlns:a16="http://schemas.microsoft.com/office/drawing/2014/main" id="{FF752DA2-A104-4F2E-AC25-4D9B12C70A86}"/>
               </a:ext>
             </a:extLst>
           </p:cNvPr>
@@ -2291,7 +2291,7 @@
           <p:cNvPr id="8" name="">
             <a:extLst xmlns:a="http://schemas.openxmlformats.org/drawingml/2006/main">
               <a:ext uri="{FF2B5EF4-FFF2-40B4-BE49-F238E27FC236}">
-                <a16:creationId xmlns:a16="http://schemas.microsoft.com/office/drawing/2014/main" id="{BE8264BC-83EF-46B3-BFCD-CDBB35A0C322}"/>
+                <a16:creationId xmlns:a16="http://schemas.microsoft.com/office/drawing/2014/main" id="{1C8AFC00-667D-485D-8878-7CE85AB45E01}"/>
               </a:ext>
             </a:extLst>
           </p:cNvPr>
@@ -2347,7 +2347,7 @@
           <p:cNvPr id="9" name="">
             <a:extLst xmlns:a="http://schemas.openxmlformats.org/drawingml/2006/main">
               <a:ext uri="{FF2B5EF4-FFF2-40B4-BE49-F238E27FC236}">
-                <a16:creationId xmlns:a16="http://schemas.microsoft.com/office/drawing/2014/main" id="{D35A6FEE-EF34-416C-999C-17DEBC87D256}"/>
+                <a16:creationId xmlns:a16="http://schemas.microsoft.com/office/drawing/2014/main" id="{C2ECE541-F376-4F66-9C54-61F40AA3E0CA}"/>
               </a:ext>
             </a:extLst>
           </p:cNvPr>
@@ -2378,7 +2378,7 @@
           <p:cNvPr id="10" name="">
             <a:extLst xmlns:a="http://schemas.openxmlformats.org/drawingml/2006/main">
               <a:ext uri="{FF2B5EF4-FFF2-40B4-BE49-F238E27FC236}">
-                <a16:creationId xmlns:a16="http://schemas.microsoft.com/office/drawing/2014/main" id="{86823042-0A3D-4EF3-AB27-6FEB3A7E42CD}"/>
+                <a16:creationId xmlns:a16="http://schemas.microsoft.com/office/drawing/2014/main" id="{C1E055E9-3CB4-4AC4-8126-0BADFF969B75}"/>
               </a:ext>
             </a:extLst>
           </p:cNvPr>
@@ -2434,7 +2434,7 @@
           <p:cNvPr id="11" name="">
             <a:extLst xmlns:a="http://schemas.openxmlformats.org/drawingml/2006/main">
               <a:ext uri="{FF2B5EF4-FFF2-40B4-BE49-F238E27FC236}">
-                <a16:creationId xmlns:a16="http://schemas.microsoft.com/office/drawing/2014/main" id="{793FDA2A-09F4-42ED-9EC5-7BD86A6C6271}"/>
+                <a16:creationId xmlns:a16="http://schemas.microsoft.com/office/drawing/2014/main" id="{69B2812B-827F-4E93-AE45-FEAC58135154}"/>
               </a:ext>
             </a:extLst>
           </p:cNvPr>
@@ -2490,7 +2490,7 @@
           <p:cNvPr id="12" name="">
             <a:extLst xmlns:a="http://schemas.openxmlformats.org/drawingml/2006/main">
               <a:ext uri="{FF2B5EF4-FFF2-40B4-BE49-F238E27FC236}">
-                <a16:creationId xmlns:a16="http://schemas.microsoft.com/office/drawing/2014/main" id="{4950F57F-88C0-4BE2-930D-EA07C9AB1DAA}"/>
+                <a16:creationId xmlns:a16="http://schemas.microsoft.com/office/drawing/2014/main" id="{9D0802CA-6D7B-4BBF-A0BE-51EA0E8B91D3}"/>
               </a:ext>
             </a:extLst>
           </p:cNvPr>
@@ -2546,7 +2546,7 @@
           <p:cNvPr id="13" name="">
             <a:extLst xmlns:a="http://schemas.openxmlformats.org/drawingml/2006/main">
               <a:ext uri="{FF2B5EF4-FFF2-40B4-BE49-F238E27FC236}">
-                <a16:creationId xmlns:a16="http://schemas.microsoft.com/office/drawing/2014/main" id="{996B4D1D-67B6-496A-B507-74C9CD92535C}"/>
+                <a16:creationId xmlns:a16="http://schemas.microsoft.com/office/drawing/2014/main" id="{CF5340F5-805B-4BDB-BDC7-FCBCDB903BF7}"/>
               </a:ext>
             </a:extLst>
           </p:cNvPr>
@@ -2577,7 +2577,7 @@
           <p:cNvPr id="14" name="">
             <a:extLst xmlns:a="http://schemas.openxmlformats.org/drawingml/2006/main">
               <a:ext uri="{FF2B5EF4-FFF2-40B4-BE49-F238E27FC236}">
-                <a16:creationId xmlns:a16="http://schemas.microsoft.com/office/drawing/2014/main" id="{0B5F49D9-AEA3-48C0-907A-5C3B3B628F61}"/>
+                <a16:creationId xmlns:a16="http://schemas.microsoft.com/office/drawing/2014/main" id="{E5741F84-2010-4395-8571-ABA7BEF29E2F}"/>
               </a:ext>
             </a:extLst>
           </p:cNvPr>
@@ -2633,7 +2633,7 @@
           <p:cNvPr id="15" name="">
             <a:extLst xmlns:a="http://schemas.openxmlformats.org/drawingml/2006/main">
               <a:ext uri="{FF2B5EF4-FFF2-40B4-BE49-F238E27FC236}">
-                <a16:creationId xmlns:a16="http://schemas.microsoft.com/office/drawing/2014/main" id="{B9BEFA16-71EB-4253-B94E-5F33016A0A39}"/>
+                <a16:creationId xmlns:a16="http://schemas.microsoft.com/office/drawing/2014/main" id="{C89F47DA-5222-4FBE-A2EA-C7818F37CCDF}"/>
               </a:ext>
             </a:extLst>
           </p:cNvPr>
@@ -2689,7 +2689,7 @@
           <p:cNvPr id="16" name="">
             <a:extLst xmlns:a="http://schemas.openxmlformats.org/drawingml/2006/main">
               <a:ext uri="{FF2B5EF4-FFF2-40B4-BE49-F238E27FC236}">
-                <a16:creationId xmlns:a16="http://schemas.microsoft.com/office/drawing/2014/main" id="{B6D9EC47-12EB-46C4-AE24-22E49E180AC3}"/>
+                <a16:creationId xmlns:a16="http://schemas.microsoft.com/office/drawing/2014/main" id="{B36AAB39-78B3-4298-822B-5B947D3461D1}"/>
               </a:ext>
             </a:extLst>
           </p:cNvPr>
@@ -2745,7 +2745,7 @@
           <p:cNvPr id="17" name="">
             <a:extLst xmlns:a="http://schemas.openxmlformats.org/drawingml/2006/main">
               <a:ext uri="{FF2B5EF4-FFF2-40B4-BE49-F238E27FC236}">
-                <a16:creationId xmlns:a16="http://schemas.microsoft.com/office/drawing/2014/main" id="{837C0B21-8FEB-404E-94D0-6AEC929A12D0}"/>
+                <a16:creationId xmlns:a16="http://schemas.microsoft.com/office/drawing/2014/main" id="{79042646-0AEC-48D9-BFFC-81D9F6573EFC}"/>
               </a:ext>
             </a:extLst>
           </p:cNvPr>
@@ -2776,7 +2776,7 @@
           <p:cNvPr id="18" name="">
             <a:extLst xmlns:a="http://schemas.openxmlformats.org/drawingml/2006/main">
               <a:ext uri="{FF2B5EF4-FFF2-40B4-BE49-F238E27FC236}">
-                <a16:creationId xmlns:a16="http://schemas.microsoft.com/office/drawing/2014/main" id="{59B1CC7D-FDBF-4620-95DD-9A57D0934517}"/>
+                <a16:creationId xmlns:a16="http://schemas.microsoft.com/office/drawing/2014/main" id="{34C5700E-4424-41DF-BF98-B6A2E78E9B84}"/>
               </a:ext>
             </a:extLst>
           </p:cNvPr>
@@ -2832,7 +2832,7 @@
           <p:cNvPr id="19" name="">
             <a:extLst xmlns:a="http://schemas.openxmlformats.org/drawingml/2006/main">
               <a:ext uri="{FF2B5EF4-FFF2-40B4-BE49-F238E27FC236}">
-                <a16:creationId xmlns:a16="http://schemas.microsoft.com/office/drawing/2014/main" id="{34054248-C267-47FE-A7CE-3161FF24C02F}"/>
+                <a16:creationId xmlns:a16="http://schemas.microsoft.com/office/drawing/2014/main" id="{D4C84EC2-16BB-4E1E-B9B0-22470F0463D1}"/>
               </a:ext>
             </a:extLst>
           </p:cNvPr>
@@ -2888,7 +2888,7 @@
           <p:cNvPr id="20" name="">
             <a:extLst xmlns:a="http://schemas.openxmlformats.org/drawingml/2006/main">
               <a:ext uri="{FF2B5EF4-FFF2-40B4-BE49-F238E27FC236}">
-                <a16:creationId xmlns:a16="http://schemas.microsoft.com/office/drawing/2014/main" id="{3C107357-35F5-46CA-B373-383E7FE2E17A}"/>
+                <a16:creationId xmlns:a16="http://schemas.microsoft.com/office/drawing/2014/main" id="{795CAED8-19E7-4DCA-80C9-E24DB8715377}"/>
               </a:ext>
             </a:extLst>
           </p:cNvPr>
@@ -2942,7 +2942,7 @@
     </p:spTree>
     <p:extLst>
       <p:ext uri="{BB962C8B-B14F-4D97-AF65-F5344CB8AC3E}">
-        <p14:creationId xmlns:p14="http://schemas.microsoft.com/office/powerpoint/2010/main" val="1097892686"/>
+        <p14:creationId xmlns:p14="http://schemas.microsoft.com/office/powerpoint/2010/main" val="141661787"/>
       </p:ext>
     </p:extLst>
   </p:cSld>
@@ -2973,7 +2973,7 @@
           <p:cNvPr id="23" name="">
             <a:extLst xmlns:a="http://schemas.openxmlformats.org/drawingml/2006/main">
               <a:ext uri="{FF2B5EF4-FFF2-40B4-BE49-F238E27FC236}">
-                <a16:creationId xmlns:a16="http://schemas.microsoft.com/office/drawing/2014/main" id="{211645A7-0D33-4648-9107-2990485AE77E}"/>
+                <a16:creationId xmlns:a16="http://schemas.microsoft.com/office/drawing/2014/main" id="{3268245B-E2E5-4401-B55D-E5AF56190959}"/>
               </a:ext>
             </a:extLst>
           </p:cNvPr>
@@ -3029,7 +3029,7 @@
           <p:cNvPr id="2" name="">
             <a:extLst xmlns:a="http://schemas.openxmlformats.org/drawingml/2006/main">
               <a:ext uri="{FF2B5EF4-FFF2-40B4-BE49-F238E27FC236}">
-                <a16:creationId xmlns:a16="http://schemas.microsoft.com/office/drawing/2014/main" id="{35EE677A-F0F8-40C0-9D15-FFA617680BA5}"/>
+                <a16:creationId xmlns:a16="http://schemas.microsoft.com/office/drawing/2014/main" id="{BC2FC91A-75D4-4CA3-80F4-C661FC7F29A3}"/>
               </a:ext>
             </a:extLst>
           </p:cNvPr>
@@ -3085,7 +3085,7 @@
           <p:cNvPr id="3" name="">
             <a:extLst xmlns:a="http://schemas.openxmlformats.org/drawingml/2006/main">
               <a:ext uri="{FF2B5EF4-FFF2-40B4-BE49-F238E27FC236}">
-                <a16:creationId xmlns:a16="http://schemas.microsoft.com/office/drawing/2014/main" id="{755997F4-71DD-4497-A41E-140485CE39C3}"/>
+                <a16:creationId xmlns:a16="http://schemas.microsoft.com/office/drawing/2014/main" id="{F743CA8A-B08D-4961-BD3D-3B0BB900383E}"/>
               </a:ext>
             </a:extLst>
           </p:cNvPr>
@@ -3141,7 +3141,7 @@
           <p:cNvPr id="4" name="">
             <a:extLst xmlns:a="http://schemas.openxmlformats.org/drawingml/2006/main">
               <a:ext uri="{FF2B5EF4-FFF2-40B4-BE49-F238E27FC236}">
-                <a16:creationId xmlns:a16="http://schemas.microsoft.com/office/drawing/2014/main" id="{5841C2C9-B377-44FB-AAC7-A63628AF5D41}"/>
+                <a16:creationId xmlns:a16="http://schemas.microsoft.com/office/drawing/2014/main" id="{D5DE7B33-93DE-4AA9-A170-36CF2BA5F8B9}"/>
               </a:ext>
             </a:extLst>
           </p:cNvPr>
@@ -3197,7 +3197,7 @@
           <p:cNvPr id="5" name="">
             <a:extLst xmlns:a="http://schemas.openxmlformats.org/drawingml/2006/main">
               <a:ext uri="{FF2B5EF4-FFF2-40B4-BE49-F238E27FC236}">
-                <a16:creationId xmlns:a16="http://schemas.microsoft.com/office/drawing/2014/main" id="{AF24F4B6-FFB4-4AE6-AE47-535F4F35943D}"/>
+                <a16:creationId xmlns:a16="http://schemas.microsoft.com/office/drawing/2014/main" id="{72766623-2B21-4F86-A120-AC89445E919D}"/>
               </a:ext>
             </a:extLst>
           </p:cNvPr>
@@ -3228,7 +3228,7 @@
           <p:cNvPr id="6" name="">
             <a:extLst xmlns:a="http://schemas.openxmlformats.org/drawingml/2006/main">
               <a:ext uri="{FF2B5EF4-FFF2-40B4-BE49-F238E27FC236}">
-                <a16:creationId xmlns:a16="http://schemas.microsoft.com/office/drawing/2014/main" id="{540174A5-FDA7-404C-A3E3-A457A12A882C}"/>
+                <a16:creationId xmlns:a16="http://schemas.microsoft.com/office/drawing/2014/main" id="{DDB223B9-5755-4AA4-881C-21C230C21A1C}"/>
               </a:ext>
             </a:extLst>
           </p:cNvPr>
@@ -3284,7 +3284,7 @@
           <p:cNvPr id="7" name="">
             <a:extLst xmlns:a="http://schemas.openxmlformats.org/drawingml/2006/main">
               <a:ext uri="{FF2B5EF4-FFF2-40B4-BE49-F238E27FC236}">
-                <a16:creationId xmlns:a16="http://schemas.microsoft.com/office/drawing/2014/main" id="{8EC065D9-900D-44EF-929E-86AA84710C40}"/>
+                <a16:creationId xmlns:a16="http://schemas.microsoft.com/office/drawing/2014/main" id="{E5EB6C2B-B474-45C0-B366-D98F751E0230}"/>
               </a:ext>
             </a:extLst>
           </p:cNvPr>
@@ -3340,7 +3340,7 @@
           <p:cNvPr id="8" name="">
             <a:extLst xmlns:a="http://schemas.openxmlformats.org/drawingml/2006/main">
               <a:ext uri="{FF2B5EF4-FFF2-40B4-BE49-F238E27FC236}">
-                <a16:creationId xmlns:a16="http://schemas.microsoft.com/office/drawing/2014/main" id="{380A609E-74C4-4665-AA80-8F1E63B9FA1D}"/>
+                <a16:creationId xmlns:a16="http://schemas.microsoft.com/office/drawing/2014/main" id="{5119706A-1AA4-41C5-9FDC-A85A8FDD3FFD}"/>
               </a:ext>
             </a:extLst>
           </p:cNvPr>
@@ -3396,7 +3396,7 @@
           <p:cNvPr id="9" name="">
             <a:extLst xmlns:a="http://schemas.openxmlformats.org/drawingml/2006/main">
               <a:ext uri="{FF2B5EF4-FFF2-40B4-BE49-F238E27FC236}">
-                <a16:creationId xmlns:a16="http://schemas.microsoft.com/office/drawing/2014/main" id="{2457BD8D-693B-4710-92CB-55E0F34D52BF}"/>
+                <a16:creationId xmlns:a16="http://schemas.microsoft.com/office/drawing/2014/main" id="{F00EDBAF-B431-4B15-AA9B-4F9A58719028}"/>
               </a:ext>
             </a:extLst>
           </p:cNvPr>
@@ -3427,7 +3427,7 @@
           <p:cNvPr id="10" name="">
             <a:extLst xmlns:a="http://schemas.openxmlformats.org/drawingml/2006/main">
               <a:ext uri="{FF2B5EF4-FFF2-40B4-BE49-F238E27FC236}">
-                <a16:creationId xmlns:a16="http://schemas.microsoft.com/office/drawing/2014/main" id="{1E8960C4-7F66-4078-A652-4C1393B57AAB}"/>
+                <a16:creationId xmlns:a16="http://schemas.microsoft.com/office/drawing/2014/main" id="{BB49F7AD-45D4-4048-BFDE-9990B9446A57}"/>
               </a:ext>
             </a:extLst>
           </p:cNvPr>
@@ -3483,7 +3483,7 @@
           <p:cNvPr id="11" name="">
             <a:extLst xmlns:a="http://schemas.openxmlformats.org/drawingml/2006/main">
               <a:ext uri="{FF2B5EF4-FFF2-40B4-BE49-F238E27FC236}">
-                <a16:creationId xmlns:a16="http://schemas.microsoft.com/office/drawing/2014/main" id="{7824B72F-90BC-4FFF-BECF-D467EDC86F25}"/>
+                <a16:creationId xmlns:a16="http://schemas.microsoft.com/office/drawing/2014/main" id="{4BA19BF0-E312-4220-B37E-A4F7E58CE2E6}"/>
               </a:ext>
             </a:extLst>
           </p:cNvPr>
@@ -3539,7 +3539,7 @@
           <p:cNvPr id="12" name="">
             <a:extLst xmlns:a="http://schemas.openxmlformats.org/drawingml/2006/main">
               <a:ext uri="{FF2B5EF4-FFF2-40B4-BE49-F238E27FC236}">
-                <a16:creationId xmlns:a16="http://schemas.microsoft.com/office/drawing/2014/main" id="{89527322-F6BD-46D9-933E-3E274475EEA7}"/>
+                <a16:creationId xmlns:a16="http://schemas.microsoft.com/office/drawing/2014/main" id="{BFD0ADBC-FEE5-4BBD-AC77-E4481F495906}"/>
               </a:ext>
             </a:extLst>
           </p:cNvPr>
@@ -3595,7 +3595,7 @@
           <p:cNvPr id="13" name="">
             <a:extLst xmlns:a="http://schemas.openxmlformats.org/drawingml/2006/main">
               <a:ext uri="{FF2B5EF4-FFF2-40B4-BE49-F238E27FC236}">
-                <a16:creationId xmlns:a16="http://schemas.microsoft.com/office/drawing/2014/main" id="{704373A8-3D4A-48C1-BE7C-A3B163F8A9CC}"/>
+                <a16:creationId xmlns:a16="http://schemas.microsoft.com/office/drawing/2014/main" id="{3A4C8906-869A-4218-AAAB-635C7621B49F}"/>
               </a:ext>
             </a:extLst>
           </p:cNvPr>
@@ -3626,7 +3626,7 @@
           <p:cNvPr id="14" name="">
             <a:extLst xmlns:a="http://schemas.openxmlformats.org/drawingml/2006/main">
               <a:ext uri="{FF2B5EF4-FFF2-40B4-BE49-F238E27FC236}">
-                <a16:creationId xmlns:a16="http://schemas.microsoft.com/office/drawing/2014/main" id="{10016126-5952-49D6-ABBE-D21DA067E73A}"/>
+                <a16:creationId xmlns:a16="http://schemas.microsoft.com/office/drawing/2014/main" id="{79D9DB4A-CAAA-4334-9408-6D3072539A7C}"/>
               </a:ext>
             </a:extLst>
           </p:cNvPr>
@@ -3682,7 +3682,7 @@
           <p:cNvPr id="15" name="">
             <a:extLst xmlns:a="http://schemas.openxmlformats.org/drawingml/2006/main">
               <a:ext uri="{FF2B5EF4-FFF2-40B4-BE49-F238E27FC236}">
-                <a16:creationId xmlns:a16="http://schemas.microsoft.com/office/drawing/2014/main" id="{3452C510-EFAC-4667-A1DD-BBBF8CDDB831}"/>
+                <a16:creationId xmlns:a16="http://schemas.microsoft.com/office/drawing/2014/main" id="{F0377A7E-3A62-428E-A5E5-EECBE5967DC2}"/>
               </a:ext>
             </a:extLst>
           </p:cNvPr>
@@ -3738,7 +3738,7 @@
           <p:cNvPr id="16" name="">
             <a:extLst xmlns:a="http://schemas.openxmlformats.org/drawingml/2006/main">
               <a:ext uri="{FF2B5EF4-FFF2-40B4-BE49-F238E27FC236}">
-                <a16:creationId xmlns:a16="http://schemas.microsoft.com/office/drawing/2014/main" id="{0290DDBF-D131-4151-AC31-D7B1664FA935}"/>
+                <a16:creationId xmlns:a16="http://schemas.microsoft.com/office/drawing/2014/main" id="{B2E7F390-9AB9-4E61-A1F4-123D4D2C34AD}"/>
               </a:ext>
             </a:extLst>
           </p:cNvPr>
@@ -3794,7 +3794,7 @@
           <p:cNvPr id="17" name="">
             <a:extLst xmlns:a="http://schemas.openxmlformats.org/drawingml/2006/main">
               <a:ext uri="{FF2B5EF4-FFF2-40B4-BE49-F238E27FC236}">
-                <a16:creationId xmlns:a16="http://schemas.microsoft.com/office/drawing/2014/main" id="{763DA481-9224-4B58-AEE6-1E95FBC11DB2}"/>
+                <a16:creationId xmlns:a16="http://schemas.microsoft.com/office/drawing/2014/main" id="{B6E19225-B130-4B34-9D64-454D538A1B13}"/>
               </a:ext>
             </a:extLst>
           </p:cNvPr>
@@ -3825,7 +3825,7 @@
           <p:cNvPr id="18" name="">
             <a:extLst xmlns:a="http://schemas.openxmlformats.org/drawingml/2006/main">
               <a:ext uri="{FF2B5EF4-FFF2-40B4-BE49-F238E27FC236}">
-                <a16:creationId xmlns:a16="http://schemas.microsoft.com/office/drawing/2014/main" id="{E507FF94-6D00-405C-B3FC-1D849A5A02F8}"/>
+                <a16:creationId xmlns:a16="http://schemas.microsoft.com/office/drawing/2014/main" id="{510667D5-9BA9-42CF-9AE3-7D8B051E0CE4}"/>
               </a:ext>
             </a:extLst>
           </p:cNvPr>
@@ -3881,7 +3881,7 @@
           <p:cNvPr id="19" name="">
             <a:extLst xmlns:a="http://schemas.openxmlformats.org/drawingml/2006/main">
               <a:ext uri="{FF2B5EF4-FFF2-40B4-BE49-F238E27FC236}">
-                <a16:creationId xmlns:a16="http://schemas.microsoft.com/office/drawing/2014/main" id="{E06E4BAC-D736-4796-99C6-427791F864B2}"/>
+                <a16:creationId xmlns:a16="http://schemas.microsoft.com/office/drawing/2014/main" id="{8AD9E00B-8F6B-4C98-8C3C-FAA5339F6995}"/>
               </a:ext>
             </a:extLst>
           </p:cNvPr>
@@ -3937,7 +3937,7 @@
           <p:cNvPr id="20" name="">
             <a:extLst xmlns:a="http://schemas.openxmlformats.org/drawingml/2006/main">
               <a:ext uri="{FF2B5EF4-FFF2-40B4-BE49-F238E27FC236}">
-                <a16:creationId xmlns:a16="http://schemas.microsoft.com/office/drawing/2014/main" id="{C8F51AB6-4BFE-4C03-9E48-B812D303F370}"/>
+                <a16:creationId xmlns:a16="http://schemas.microsoft.com/office/drawing/2014/main" id="{77F787B7-FBD3-4718-A6A0-532C8B9846EC}"/>
               </a:ext>
             </a:extLst>
           </p:cNvPr>
@@ -3993,7 +3993,7 @@
           <p:cNvPr id="21" name="">
             <a:extLst xmlns:a="http://schemas.openxmlformats.org/drawingml/2006/main">
               <a:ext uri="{FF2B5EF4-FFF2-40B4-BE49-F238E27FC236}">
-                <a16:creationId xmlns:a16="http://schemas.microsoft.com/office/drawing/2014/main" id="{C3379F25-583C-44E1-B6BA-DCF4C38B9D12}"/>
+                <a16:creationId xmlns:a16="http://schemas.microsoft.com/office/drawing/2014/main" id="{D72EB848-1E9F-493A-BBD4-FDE9A0943B41}"/>
               </a:ext>
             </a:extLst>
           </p:cNvPr>
@@ -4024,7 +4024,7 @@
           <p:cNvPr id="22" name="">
             <a:extLst xmlns:a="http://schemas.openxmlformats.org/drawingml/2006/main">
               <a:ext uri="{FF2B5EF4-FFF2-40B4-BE49-F238E27FC236}">
-                <a16:creationId xmlns:a16="http://schemas.microsoft.com/office/drawing/2014/main" id="{CDCF425C-4AE3-48D3-8D4A-16F0871D86A0}"/>
+                <a16:creationId xmlns:a16="http://schemas.microsoft.com/office/drawing/2014/main" id="{A96C2B67-B772-44CF-84D9-AEC00FDE51F5}"/>
               </a:ext>
             </a:extLst>
           </p:cNvPr>
@@ -4078,7 +4078,7 @@
     </p:spTree>
     <p:extLst>
       <p:ext uri="{BB962C8B-B14F-4D97-AF65-F5344CB8AC3E}">
-        <p14:creationId xmlns:p14="http://schemas.microsoft.com/office/powerpoint/2010/main" val="1358945371"/>
+        <p14:creationId xmlns:p14="http://schemas.microsoft.com/office/powerpoint/2010/main" val="300750136"/>
       </p:ext>
     </p:extLst>
   </p:cSld>
@@ -4109,7 +4109,7 @@
           <p:cNvPr id="9" name="">
             <a:extLst xmlns:a="http://schemas.openxmlformats.org/drawingml/2006/main">
               <a:ext uri="{FF2B5EF4-FFF2-40B4-BE49-F238E27FC236}">
-                <a16:creationId xmlns:a16="http://schemas.microsoft.com/office/drawing/2014/main" id="{6074D982-CBFE-4976-8FEB-E9867B39C794}"/>
+                <a16:creationId xmlns:a16="http://schemas.microsoft.com/office/drawing/2014/main" id="{88344FE7-3E0B-42F8-B93F-94D2B01B5F3D}"/>
               </a:ext>
             </a:extLst>
           </p:cNvPr>
@@ -4165,7 +4165,7 @@
           <p:cNvPr id="2" name="">
             <a:extLst xmlns:a="http://schemas.openxmlformats.org/drawingml/2006/main">
               <a:ext uri="{FF2B5EF4-FFF2-40B4-BE49-F238E27FC236}">
-                <a16:creationId xmlns:a16="http://schemas.microsoft.com/office/drawing/2014/main" id="{D506B151-BC57-4519-9683-8D4C3F17D4F4}"/>
+                <a16:creationId xmlns:a16="http://schemas.microsoft.com/office/drawing/2014/main" id="{79C10F2D-0A88-4B4B-85A3-4E7075BB5E2E}"/>
               </a:ext>
             </a:extLst>
           </p:cNvPr>
@@ -4221,7 +4221,7 @@
           <p:cNvPr id="3" name="">
             <a:extLst xmlns:a="http://schemas.openxmlformats.org/drawingml/2006/main">
               <a:ext uri="{FF2B5EF4-FFF2-40B4-BE49-F238E27FC236}">
-                <a16:creationId xmlns:a16="http://schemas.microsoft.com/office/drawing/2014/main" id="{FD1BD61F-BA61-4AB5-BA8F-9C690A9C6F5B}"/>
+                <a16:creationId xmlns:a16="http://schemas.microsoft.com/office/drawing/2014/main" id="{F0B06D3F-28B8-4019-B298-1AA0B0AE4F27}"/>
               </a:ext>
             </a:extLst>
           </p:cNvPr>
@@ -4277,7 +4277,7 @@
           <p:cNvPr id="4" name="">
             <a:extLst xmlns:a="http://schemas.openxmlformats.org/drawingml/2006/main">
               <a:ext uri="{FF2B5EF4-FFF2-40B4-BE49-F238E27FC236}">
-                <a16:creationId xmlns:a16="http://schemas.microsoft.com/office/drawing/2014/main" id="{AA1974F6-8965-490B-881D-18088B364754}"/>
+                <a16:creationId xmlns:a16="http://schemas.microsoft.com/office/drawing/2014/main" id="{BE23955B-CDC3-4DBD-932E-B1FD63103A57}"/>
               </a:ext>
             </a:extLst>
           </p:cNvPr>
@@ -4333,7 +4333,7 @@
           <p:cNvPr id="5" name="">
             <a:extLst xmlns:a="http://schemas.openxmlformats.org/drawingml/2006/main">
               <a:ext uri="{FF2B5EF4-FFF2-40B4-BE49-F238E27FC236}">
-                <a16:creationId xmlns:a16="http://schemas.microsoft.com/office/drawing/2014/main" id="{526E6923-D2F0-4C2E-B04B-60BA7451BC98}"/>
+                <a16:creationId xmlns:a16="http://schemas.microsoft.com/office/drawing/2014/main" id="{311EA04E-F220-40F4-963B-727AF6E07F21}"/>
               </a:ext>
             </a:extLst>
           </p:cNvPr>
@@ -4473,7 +4473,7 @@
           <p:cNvPr id="6" name="">
             <a:extLst xmlns:a="http://schemas.openxmlformats.org/drawingml/2006/main">
               <a:ext uri="{FF2B5EF4-FFF2-40B4-BE49-F238E27FC236}">
-                <a16:creationId xmlns:a16="http://schemas.microsoft.com/office/drawing/2014/main" id="{48DF067E-5C92-4B40-AC0F-32799F1A803B}"/>
+                <a16:creationId xmlns:a16="http://schemas.microsoft.com/office/drawing/2014/main" id="{247CCDDD-4FFD-42BB-B877-316805518369}"/>
               </a:ext>
             </a:extLst>
           </p:cNvPr>
@@ -4510,7 +4510,7 @@
           <p:nvPr/>
         </p:nvPicPr>
         <p:blipFill>
-          <a:blip xmlns:r="http://schemas.openxmlformats.org/officeDocument/2006/relationships" xmlns:a="http://schemas.openxmlformats.org/drawingml/2006/main" r:embed="R55df0bc18bd3453f"/>
+          <a:blip xmlns:r="http://schemas.openxmlformats.org/officeDocument/2006/relationships" xmlns:a="http://schemas.openxmlformats.org/drawingml/2006/main" r:embed="Rc002db8069da4f19"/>
           <a:stretch xmlns:a="http://schemas.openxmlformats.org/drawingml/2006/main"/>
         </p:blipFill>
         <p:spPr>
@@ -4528,7 +4528,7 @@
           <p:cNvPr id="8" name="">
             <a:extLst xmlns:a="http://schemas.openxmlformats.org/drawingml/2006/main">
               <a:ext uri="{FF2B5EF4-FFF2-40B4-BE49-F238E27FC236}">
-                <a16:creationId xmlns:a16="http://schemas.microsoft.com/office/drawing/2014/main" id="{23EDF45A-C83F-4105-9A5F-CCBE2EEC5161}"/>
+                <a16:creationId xmlns:a16="http://schemas.microsoft.com/office/drawing/2014/main" id="{009D8AF7-3646-4289-9981-99DBDEE51C6F}"/>
               </a:ext>
             </a:extLst>
           </p:cNvPr>
@@ -4582,7 +4582,7 @@
     </p:spTree>
     <p:extLst>
       <p:ext uri="{BB962C8B-B14F-4D97-AF65-F5344CB8AC3E}">
-        <p14:creationId xmlns:p14="http://schemas.microsoft.com/office/powerpoint/2010/main" val="803770492"/>
+        <p14:creationId xmlns:p14="http://schemas.microsoft.com/office/powerpoint/2010/main" val="2062868421"/>
       </p:ext>
     </p:extLst>
   </p:cSld>
@@ -4613,7 +4613,7 @@
           <p:cNvPr id="15" name="">
             <a:extLst xmlns:a="http://schemas.openxmlformats.org/drawingml/2006/main">
               <a:ext uri="{FF2B5EF4-FFF2-40B4-BE49-F238E27FC236}">
-                <a16:creationId xmlns:a16="http://schemas.microsoft.com/office/drawing/2014/main" id="{48DC397F-E7BA-4F5C-A114-54A81B269307}"/>
+                <a16:creationId xmlns:a16="http://schemas.microsoft.com/office/drawing/2014/main" id="{02F5465E-B753-4584-BDC9-B7D476B4DB83}"/>
               </a:ext>
             </a:extLst>
           </p:cNvPr>
@@ -4669,7 +4669,7 @@
           <p:cNvPr id="2" name="">
             <a:extLst xmlns:a="http://schemas.openxmlformats.org/drawingml/2006/main">
               <a:ext uri="{FF2B5EF4-FFF2-40B4-BE49-F238E27FC236}">
-                <a16:creationId xmlns:a16="http://schemas.microsoft.com/office/drawing/2014/main" id="{83A7292E-838A-4270-9B83-6018BC88744D}"/>
+                <a16:creationId xmlns:a16="http://schemas.microsoft.com/office/drawing/2014/main" id="{19994668-F477-4F44-B572-A875332EC33A}"/>
               </a:ext>
             </a:extLst>
           </p:cNvPr>
@@ -4725,7 +4725,7 @@
           <p:cNvPr id="3" name="">
             <a:extLst xmlns:a="http://schemas.openxmlformats.org/drawingml/2006/main">
               <a:ext uri="{FF2B5EF4-FFF2-40B4-BE49-F238E27FC236}">
-                <a16:creationId xmlns:a16="http://schemas.microsoft.com/office/drawing/2014/main" id="{B9E3C4BB-5CCA-4A3C-BC4F-DBA8D07CAEB7}"/>
+                <a16:creationId xmlns:a16="http://schemas.microsoft.com/office/drawing/2014/main" id="{8DFE3DE8-AF13-4314-9234-AB929F5A03C8}"/>
               </a:ext>
             </a:extLst>
           </p:cNvPr>
@@ -4781,7 +4781,7 @@
           <p:cNvPr id="4" name="">
             <a:extLst xmlns:a="http://schemas.openxmlformats.org/drawingml/2006/main">
               <a:ext uri="{FF2B5EF4-FFF2-40B4-BE49-F238E27FC236}">
-                <a16:creationId xmlns:a16="http://schemas.microsoft.com/office/drawing/2014/main" id="{E4698E0D-D2ED-4522-AD42-A89CA30C16B8}"/>
+                <a16:creationId xmlns:a16="http://schemas.microsoft.com/office/drawing/2014/main" id="{773E6CE7-DCFA-49B4-8178-81E3D0D484B3}"/>
               </a:ext>
             </a:extLst>
           </p:cNvPr>
@@ -4837,7 +4837,7 @@
           <p:cNvPr id="5" name="">
             <a:extLst xmlns:a="http://schemas.openxmlformats.org/drawingml/2006/main">
               <a:ext uri="{FF2B5EF4-FFF2-40B4-BE49-F238E27FC236}">
-                <a16:creationId xmlns:a16="http://schemas.microsoft.com/office/drawing/2014/main" id="{94480220-614F-4FAE-83BB-90FE683CC41A}"/>
+                <a16:creationId xmlns:a16="http://schemas.microsoft.com/office/drawing/2014/main" id="{246E93B1-F73E-4B65-8F04-8D2B5F0041B1}"/>
               </a:ext>
             </a:extLst>
           </p:cNvPr>
@@ -4868,7 +4868,7 @@
           <p:cNvPr id="6" name="">
             <a:extLst xmlns:a="http://schemas.openxmlformats.org/drawingml/2006/main">
               <a:ext uri="{FF2B5EF4-FFF2-40B4-BE49-F238E27FC236}">
-                <a16:creationId xmlns:a16="http://schemas.microsoft.com/office/drawing/2014/main" id="{8645D6AD-4E75-4E70-A245-7D7D2A2D242A}"/>
+                <a16:creationId xmlns:a16="http://schemas.microsoft.com/office/drawing/2014/main" id="{F55F5770-005F-4E0F-BCAC-46478CFBBB3F}"/>
               </a:ext>
             </a:extLst>
           </p:cNvPr>
@@ -4899,7 +4899,7 @@
           <p:cNvPr id="7" name="">
             <a:extLst xmlns:a="http://schemas.openxmlformats.org/drawingml/2006/main">
               <a:ext uri="{FF2B5EF4-FFF2-40B4-BE49-F238E27FC236}">
-                <a16:creationId xmlns:a16="http://schemas.microsoft.com/office/drawing/2014/main" id="{5C8F6320-394F-4F75-BDD2-CBB78C3EC634}"/>
+                <a16:creationId xmlns:a16="http://schemas.microsoft.com/office/drawing/2014/main" id="{EA47AB42-9318-4591-AD2E-A36DD3A77A6A}"/>
               </a:ext>
             </a:extLst>
           </p:cNvPr>
@@ -4955,7 +4955,7 @@
           <p:cNvPr id="8" name="">
             <a:extLst xmlns:a="http://schemas.openxmlformats.org/drawingml/2006/main">
               <a:ext uri="{FF2B5EF4-FFF2-40B4-BE49-F238E27FC236}">
-                <a16:creationId xmlns:a16="http://schemas.microsoft.com/office/drawing/2014/main" id="{302C9FAC-4738-46D7-9F88-135AE8C257D8}"/>
+                <a16:creationId xmlns:a16="http://schemas.microsoft.com/office/drawing/2014/main" id="{84720626-42B9-4C9A-B1B9-D55E6673BEDD}"/>
               </a:ext>
             </a:extLst>
           </p:cNvPr>
@@ -5011,7 +5011,7 @@
           <p:cNvPr id="9" name="">
             <a:extLst xmlns:a="http://schemas.openxmlformats.org/drawingml/2006/main">
               <a:ext uri="{FF2B5EF4-FFF2-40B4-BE49-F238E27FC236}">
-                <a16:creationId xmlns:a16="http://schemas.microsoft.com/office/drawing/2014/main" id="{1BB916CB-67B3-4012-8593-A0EFAA6B6F0F}"/>
+                <a16:creationId xmlns:a16="http://schemas.microsoft.com/office/drawing/2014/main" id="{F31D0390-2226-4820-9E1C-E5EDBAECAECF}"/>
               </a:ext>
             </a:extLst>
           </p:cNvPr>
@@ -5136,7 +5136,7 @@
           <p:cNvPr id="10" name="">
             <a:extLst xmlns:a="http://schemas.openxmlformats.org/drawingml/2006/main">
               <a:ext uri="{FF2B5EF4-FFF2-40B4-BE49-F238E27FC236}">
-                <a16:creationId xmlns:a16="http://schemas.microsoft.com/office/drawing/2014/main" id="{BE13FE0C-7D8E-48EC-888D-014C612FC56B}"/>
+                <a16:creationId xmlns:a16="http://schemas.microsoft.com/office/drawing/2014/main" id="{4BF237A0-A98C-428C-B74F-D832730C907F}"/>
               </a:ext>
             </a:extLst>
           </p:cNvPr>
@@ -5192,7 +5192,7 @@
           <p:cNvPr id="11" name="">
             <a:extLst xmlns:a="http://schemas.openxmlformats.org/drawingml/2006/main">
               <a:ext uri="{FF2B5EF4-FFF2-40B4-BE49-F238E27FC236}">
-                <a16:creationId xmlns:a16="http://schemas.microsoft.com/office/drawing/2014/main" id="{E2530563-4B85-4115-9EE3-22E538C9723F}"/>
+                <a16:creationId xmlns:a16="http://schemas.microsoft.com/office/drawing/2014/main" id="{597DA63A-73D7-407D-83E6-CD8BD73B2124}"/>
               </a:ext>
             </a:extLst>
           </p:cNvPr>
@@ -5248,7 +5248,7 @@
           <p:cNvPr id="12" name="">
             <a:extLst xmlns:a="http://schemas.openxmlformats.org/drawingml/2006/main">
               <a:ext uri="{FF2B5EF4-FFF2-40B4-BE49-F238E27FC236}">
-                <a16:creationId xmlns:a16="http://schemas.microsoft.com/office/drawing/2014/main" id="{A8C87EA3-37F0-4629-9773-D27BE7C2F92D}"/>
+                <a16:creationId xmlns:a16="http://schemas.microsoft.com/office/drawing/2014/main" id="{B1B5CEE8-9B8C-4612-8CA1-884C695242BA}"/>
               </a:ext>
             </a:extLst>
           </p:cNvPr>
@@ -5304,7 +5304,7 @@
           <p:cNvPr id="13" name="">
             <a:extLst xmlns:a="http://schemas.openxmlformats.org/drawingml/2006/main">
               <a:ext uri="{FF2B5EF4-FFF2-40B4-BE49-F238E27FC236}">
-                <a16:creationId xmlns:a16="http://schemas.microsoft.com/office/drawing/2014/main" id="{1002EB1A-B97B-45CA-97E6-E7FECABAD14D}"/>
+                <a16:creationId xmlns:a16="http://schemas.microsoft.com/office/drawing/2014/main" id="{D09E49E0-F525-4A3C-B0D8-CC3F72210599}"/>
               </a:ext>
             </a:extLst>
           </p:cNvPr>
@@ -5429,7 +5429,7 @@
           <p:cNvPr id="14" name="">
             <a:extLst xmlns:a="http://schemas.openxmlformats.org/drawingml/2006/main">
               <a:ext uri="{FF2B5EF4-FFF2-40B4-BE49-F238E27FC236}">
-                <a16:creationId xmlns:a16="http://schemas.microsoft.com/office/drawing/2014/main" id="{8302D512-5BC0-4904-BE38-95A1E1C0AEE6}"/>
+                <a16:creationId xmlns:a16="http://schemas.microsoft.com/office/drawing/2014/main" id="{201F97D9-AA80-4848-96A4-EF9B68541F0F}"/>
               </a:ext>
             </a:extLst>
           </p:cNvPr>
@@ -5483,7 +5483,7 @@
     </p:spTree>
     <p:extLst>
       <p:ext uri="{BB962C8B-B14F-4D97-AF65-F5344CB8AC3E}">
-        <p14:creationId xmlns:p14="http://schemas.microsoft.com/office/powerpoint/2010/main" val="841624218"/>
+        <p14:creationId xmlns:p14="http://schemas.microsoft.com/office/powerpoint/2010/main" val="2110790188"/>
       </p:ext>
     </p:extLst>
   </p:cSld>
@@ -5514,7 +5514,7 @@
           <p:cNvPr id="20" name="">
             <a:extLst xmlns:a="http://schemas.openxmlformats.org/drawingml/2006/main">
               <a:ext uri="{FF2B5EF4-FFF2-40B4-BE49-F238E27FC236}">
-                <a16:creationId xmlns:a16="http://schemas.microsoft.com/office/drawing/2014/main" id="{CB8880E1-7990-44F2-A335-5E316D075A1A}"/>
+                <a16:creationId xmlns:a16="http://schemas.microsoft.com/office/drawing/2014/main" id="{82F6B547-F6F0-42B2-AF23-DD6D624658FA}"/>
               </a:ext>
             </a:extLst>
           </p:cNvPr>
@@ -5570,7 +5570,7 @@
           <p:cNvPr id="2" name="">
             <a:extLst xmlns:a="http://schemas.openxmlformats.org/drawingml/2006/main">
               <a:ext uri="{FF2B5EF4-FFF2-40B4-BE49-F238E27FC236}">
-                <a16:creationId xmlns:a16="http://schemas.microsoft.com/office/drawing/2014/main" id="{3FBBEDD1-13A5-468A-A6A0-FD91A1F351D5}"/>
+                <a16:creationId xmlns:a16="http://schemas.microsoft.com/office/drawing/2014/main" id="{7B3D3B06-7CEE-4FA2-BBB3-B88E0D2E7C32}"/>
               </a:ext>
             </a:extLst>
           </p:cNvPr>
@@ -5649,7 +5649,7 @@
           <p:cNvPr id="3" name="">
             <a:extLst xmlns:a="http://schemas.openxmlformats.org/drawingml/2006/main">
               <a:ext uri="{FF2B5EF4-FFF2-40B4-BE49-F238E27FC236}">
-                <a16:creationId xmlns:a16="http://schemas.microsoft.com/office/drawing/2014/main" id="{F08CE983-BA96-4305-BA4C-6B772D180FB6}"/>
+                <a16:creationId xmlns:a16="http://schemas.microsoft.com/office/drawing/2014/main" id="{3E64C8C0-3A8B-40A1-BB78-65B78646ED12}"/>
               </a:ext>
             </a:extLst>
           </p:cNvPr>
@@ -5705,7 +5705,7 @@
           <p:cNvPr id="4" name="">
             <a:extLst xmlns:a="http://schemas.openxmlformats.org/drawingml/2006/main">
               <a:ext uri="{FF2B5EF4-FFF2-40B4-BE49-F238E27FC236}">
-                <a16:creationId xmlns:a16="http://schemas.microsoft.com/office/drawing/2014/main" id="{F2FEC70B-9AF2-4E72-9481-D4F78138FB78}"/>
+                <a16:creationId xmlns:a16="http://schemas.microsoft.com/office/drawing/2014/main" id="{B8F534A9-DCB4-4129-B826-5EBF84058666}"/>
               </a:ext>
             </a:extLst>
           </p:cNvPr>
@@ -5736,7 +5736,7 @@
           <p:cNvPr id="5" name="">
             <a:extLst xmlns:a="http://schemas.openxmlformats.org/drawingml/2006/main">
               <a:ext uri="{FF2B5EF4-FFF2-40B4-BE49-F238E27FC236}">
-                <a16:creationId xmlns:a16="http://schemas.microsoft.com/office/drawing/2014/main" id="{07C87855-6864-4A85-A473-24710A219280}"/>
+                <a16:creationId xmlns:a16="http://schemas.microsoft.com/office/drawing/2014/main" id="{CD351060-6081-404C-A28E-DB0A824355E2}"/>
               </a:ext>
             </a:extLst>
           </p:cNvPr>
@@ -5792,7 +5792,7 @@
           <p:cNvPr id="6" name="">
             <a:extLst xmlns:a="http://schemas.openxmlformats.org/drawingml/2006/main">
               <a:ext uri="{FF2B5EF4-FFF2-40B4-BE49-F238E27FC236}">
-                <a16:creationId xmlns:a16="http://schemas.microsoft.com/office/drawing/2014/main" id="{FF2F2309-553C-418D-9D56-B3E8F0982FC1}"/>
+                <a16:creationId xmlns:a16="http://schemas.microsoft.com/office/drawing/2014/main" id="{E9C780C9-4C26-4584-B6AD-85F7DF6E9717}"/>
               </a:ext>
             </a:extLst>
           </p:cNvPr>
@@ -5848,7 +5848,7 @@
           <p:cNvPr id="7" name="">
             <a:extLst xmlns:a="http://schemas.openxmlformats.org/drawingml/2006/main">
               <a:ext uri="{FF2B5EF4-FFF2-40B4-BE49-F238E27FC236}">
-                <a16:creationId xmlns:a16="http://schemas.microsoft.com/office/drawing/2014/main" id="{01EBD2C3-F421-4659-81D2-D832C942331F}"/>
+                <a16:creationId xmlns:a16="http://schemas.microsoft.com/office/drawing/2014/main" id="{EF8F6572-CC1A-41CC-B5B2-762028199720}"/>
               </a:ext>
             </a:extLst>
           </p:cNvPr>
@@ -5904,7 +5904,7 @@
           <p:cNvPr id="8" name="">
             <a:extLst xmlns:a="http://schemas.openxmlformats.org/drawingml/2006/main">
               <a:ext uri="{FF2B5EF4-FFF2-40B4-BE49-F238E27FC236}">
-                <a16:creationId xmlns:a16="http://schemas.microsoft.com/office/drawing/2014/main" id="{69E82D89-9DA8-4D0D-B2D4-C4F975B94827}"/>
+                <a16:creationId xmlns:a16="http://schemas.microsoft.com/office/drawing/2014/main" id="{2F7A2158-EAE8-4F8D-9F52-845F7E0C8587}"/>
               </a:ext>
             </a:extLst>
           </p:cNvPr>
@@ -5935,7 +5935,7 @@
           <p:cNvPr id="9" name="">
             <a:extLst xmlns:a="http://schemas.openxmlformats.org/drawingml/2006/main">
               <a:ext uri="{FF2B5EF4-FFF2-40B4-BE49-F238E27FC236}">
-                <a16:creationId xmlns:a16="http://schemas.microsoft.com/office/drawing/2014/main" id="{E2AB6086-055D-4C18-9CA5-A6F638484167}"/>
+                <a16:creationId xmlns:a16="http://schemas.microsoft.com/office/drawing/2014/main" id="{F4E5271B-F84F-4F41-A521-99F50462C65E}"/>
               </a:ext>
             </a:extLst>
           </p:cNvPr>
@@ -5991,7 +5991,7 @@
           <p:cNvPr id="10" name="">
             <a:extLst xmlns:a="http://schemas.openxmlformats.org/drawingml/2006/main">
               <a:ext uri="{FF2B5EF4-FFF2-40B4-BE49-F238E27FC236}">
-                <a16:creationId xmlns:a16="http://schemas.microsoft.com/office/drawing/2014/main" id="{0CEDC0B5-125D-4A3A-A8A4-0E5F3F7C1794}"/>
+                <a16:creationId xmlns:a16="http://schemas.microsoft.com/office/drawing/2014/main" id="{60C7E4C1-F289-4D0B-A35D-6C9A3C6AA25F}"/>
               </a:ext>
             </a:extLst>
           </p:cNvPr>
@@ -6047,7 +6047,7 @@
           <p:cNvPr id="11" name="">
             <a:extLst xmlns:a="http://schemas.openxmlformats.org/drawingml/2006/main">
               <a:ext uri="{FF2B5EF4-FFF2-40B4-BE49-F238E27FC236}">
-                <a16:creationId xmlns:a16="http://schemas.microsoft.com/office/drawing/2014/main" id="{9AD3CDAF-5DFB-4E1E-9120-8225DAE22A23}"/>
+                <a16:creationId xmlns:a16="http://schemas.microsoft.com/office/drawing/2014/main" id="{164265AF-B6CA-454D-9BC3-06FCFB0B3006}"/>
               </a:ext>
             </a:extLst>
           </p:cNvPr>
@@ -6103,7 +6103,7 @@
           <p:cNvPr id="12" name="">
             <a:extLst xmlns:a="http://schemas.openxmlformats.org/drawingml/2006/main">
               <a:ext uri="{FF2B5EF4-FFF2-40B4-BE49-F238E27FC236}">
-                <a16:creationId xmlns:a16="http://schemas.microsoft.com/office/drawing/2014/main" id="{F841CB8A-C81D-4CA0-B0D7-EA88EA7217AB}"/>
+                <a16:creationId xmlns:a16="http://schemas.microsoft.com/office/drawing/2014/main" id="{623228EC-4215-47CB-9383-85E4B53E5E54}"/>
               </a:ext>
             </a:extLst>
           </p:cNvPr>
@@ -6134,7 +6134,7 @@
           <p:cNvPr id="13" name="">
             <a:extLst xmlns:a="http://schemas.openxmlformats.org/drawingml/2006/main">
               <a:ext uri="{FF2B5EF4-FFF2-40B4-BE49-F238E27FC236}">
-                <a16:creationId xmlns:a16="http://schemas.microsoft.com/office/drawing/2014/main" id="{A38EEB1E-04B7-4DA5-84B7-4014A6FEF962}"/>
+                <a16:creationId xmlns:a16="http://schemas.microsoft.com/office/drawing/2014/main" id="{D98A74FA-27E4-4747-BEA0-DF5FF34AF471}"/>
               </a:ext>
             </a:extLst>
           </p:cNvPr>
@@ -6190,7 +6190,7 @@
           <p:cNvPr id="14" name="">
             <a:extLst xmlns:a="http://schemas.openxmlformats.org/drawingml/2006/main">
               <a:ext uri="{FF2B5EF4-FFF2-40B4-BE49-F238E27FC236}">
-                <a16:creationId xmlns:a16="http://schemas.microsoft.com/office/drawing/2014/main" id="{77C1EEA3-6A48-470C-B72D-585A799BC8DD}"/>
+                <a16:creationId xmlns:a16="http://schemas.microsoft.com/office/drawing/2014/main" id="{DF127F88-2E4E-45E3-9A0A-ABCC4AB7D055}"/>
               </a:ext>
             </a:extLst>
           </p:cNvPr>
@@ -6246,7 +6246,7 @@
           <p:cNvPr id="15" name="">
             <a:extLst xmlns:a="http://schemas.openxmlformats.org/drawingml/2006/main">
               <a:ext uri="{FF2B5EF4-FFF2-40B4-BE49-F238E27FC236}">
-                <a16:creationId xmlns:a16="http://schemas.microsoft.com/office/drawing/2014/main" id="{364E0808-1FC9-4599-B3E8-C66FB419E812}"/>
+                <a16:creationId xmlns:a16="http://schemas.microsoft.com/office/drawing/2014/main" id="{DD2A3A0F-DF01-4B13-AB5B-6C7F975092EE}"/>
               </a:ext>
             </a:extLst>
           </p:cNvPr>
@@ -6302,7 +6302,7 @@
           <p:cNvPr id="16" name="">
             <a:extLst xmlns:a="http://schemas.openxmlformats.org/drawingml/2006/main">
               <a:ext uri="{FF2B5EF4-FFF2-40B4-BE49-F238E27FC236}">
-                <a16:creationId xmlns:a16="http://schemas.microsoft.com/office/drawing/2014/main" id="{3CFBA7DC-D6D0-46FD-BA0D-0AF68021699D}"/>
+                <a16:creationId xmlns:a16="http://schemas.microsoft.com/office/drawing/2014/main" id="{92D0A7E5-CE4B-48C7-9D2B-4ECD44ACBB6E}"/>
               </a:ext>
             </a:extLst>
           </p:cNvPr>
@@ -6348,7 +6348,7 @@
                 <a:ea typeface="Arial"/>
                 <a:cs typeface="Arial"/>
               </a:rPr>
-              <a:t>Windows 10/11 (x64) + macOS (Apple Silicon) — İndirme: github.com/Azizsekerdil/EnglishCourseAI/releases (v1.0.0, özel repo)</a:t>
+              <a:t>Windows 10/11 (x64) + macOS (Apple Silicon) — İndirme: github.com/Azizsekerdil/EnglishCourseAI/releases (v1.1.0, özel repo)</a:t>
             </a:r>
           </a:p>
         </p:txBody>
@@ -6358,7 +6358,7 @@
           <p:cNvPr id="17" name="">
             <a:extLst xmlns:a="http://schemas.openxmlformats.org/drawingml/2006/main">
               <a:ext uri="{FF2B5EF4-FFF2-40B4-BE49-F238E27FC236}">
-                <a16:creationId xmlns:a16="http://schemas.microsoft.com/office/drawing/2014/main" id="{BEB73740-14FC-4B2E-8633-50D5346A3819}"/>
+                <a16:creationId xmlns:a16="http://schemas.microsoft.com/office/drawing/2014/main" id="{43552A2A-2CE6-450E-A344-11320EA746A0}"/>
               </a:ext>
             </a:extLst>
           </p:cNvPr>
@@ -6404,7 +6404,7 @@
                 <a:ea typeface="Arial"/>
                 <a:cs typeface="Arial"/>
               </a:rPr>
-              <a:t>Windows 10/11 (x64) &amp; macOS (Apple Silicon) — Download: GitHub Releases (v1.0.0)</a:t>
+              <a:t>Windows 10/11 (x64) &amp; macOS (Apple Silicon) — Download: GitHub Releases (v1.1.0)</a:t>
             </a:r>
           </a:p>
         </p:txBody>
@@ -6414,7 +6414,7 @@
           <p:cNvPr id="18" name="">
             <a:extLst xmlns:a="http://schemas.openxmlformats.org/drawingml/2006/main">
               <a:ext uri="{FF2B5EF4-FFF2-40B4-BE49-F238E27FC236}">
-                <a16:creationId xmlns:a16="http://schemas.microsoft.com/office/drawing/2014/main" id="{2933B625-302E-4642-8373-AECE40866DE2}"/>
+                <a16:creationId xmlns:a16="http://schemas.microsoft.com/office/drawing/2014/main" id="{5E7633B0-5EF0-4DAE-BF9F-B0BA35B4CB1B}"/>
               </a:ext>
             </a:extLst>
           </p:cNvPr>
@@ -6474,7 +6474,7 @@
           <p:nvPr/>
         </p:nvPicPr>
         <p:blipFill>
-          <a:blip xmlns:r="http://schemas.openxmlformats.org/officeDocument/2006/relationships" xmlns:a="http://schemas.openxmlformats.org/drawingml/2006/main" r:embed="Rcc0868150fc84a16"/>
+          <a:blip xmlns:r="http://schemas.openxmlformats.org/officeDocument/2006/relationships" xmlns:a="http://schemas.openxmlformats.org/drawingml/2006/main" r:embed="Rc18fe448337f4ecc"/>
           <a:stretch xmlns:a="http://schemas.openxmlformats.org/drawingml/2006/main"/>
         </p:blipFill>
         <p:spPr>
@@ -6490,7 +6490,7 @@
     </p:spTree>
     <p:extLst>
       <p:ext uri="{BB962C8B-B14F-4D97-AF65-F5344CB8AC3E}">
-        <p14:creationId xmlns:p14="http://schemas.microsoft.com/office/powerpoint/2010/main" val="518130950"/>
+        <p14:creationId xmlns:p14="http://schemas.microsoft.com/office/powerpoint/2010/main" val="1263053208"/>
       </p:ext>
     </p:extLst>
   </p:cSld>

</xml_diff>

<commit_message>
Sunum: v1.1.1 indirme bilgileri
Co-Authored-By: Claude Fable 5.1 <noreply@anthropic.com>
</commit_message>
<xml_diff>
--- a/docs/presentation/English-Course-AI-Bilingual.pptx
+++ b/docs/presentation/English-Course-AI-Bilingual.pptx
@@ -2,18 +2,18 @@
 <file path=ppt/presentation.xml><?xml version="1.0" encoding="utf-8"?>
 <p:presentation xmlns:p="http://schemas.openxmlformats.org/presentationml/2006/main">
   <p:sldMasterIdLst>
-    <p:sldMasterId xmlns:r="http://schemas.openxmlformats.org/officeDocument/2006/relationships" id="2147483648" r:id="R548930dc537148f9"/>
+    <p:sldMasterId xmlns:r="http://schemas.openxmlformats.org/officeDocument/2006/relationships" id="2147483648" r:id="R77159e1bc2894078"/>
   </p:sldMasterIdLst>
   <p:notesMasterIdLst>
-    <p:notesMasterId xmlns:r="http://schemas.openxmlformats.org/officeDocument/2006/relationships" r:id="Rfe150eeba0664a44"/>
+    <p:notesMasterId xmlns:r="http://schemas.openxmlformats.org/officeDocument/2006/relationships" r:id="R9dd210d789d94aef"/>
   </p:notesMasterIdLst>
   <p:sldIdLst>
-    <p:sldId xmlns:r="http://schemas.openxmlformats.org/officeDocument/2006/relationships" id="256" r:id="R41244f3007e04e89"/>
-    <p:sldId xmlns:r="http://schemas.openxmlformats.org/officeDocument/2006/relationships" id="257" r:id="R5a06de511d894477"/>
-    <p:sldId xmlns:r="http://schemas.openxmlformats.org/officeDocument/2006/relationships" id="258" r:id="R0d9c2e26122d44e3"/>
-    <p:sldId xmlns:r="http://schemas.openxmlformats.org/officeDocument/2006/relationships" id="259" r:id="R275143bebce340e8"/>
-    <p:sldId xmlns:r="http://schemas.openxmlformats.org/officeDocument/2006/relationships" id="260" r:id="R9ecff22207ba4138"/>
-    <p:sldId xmlns:r="http://schemas.openxmlformats.org/officeDocument/2006/relationships" id="261" r:id="Rccef45420e5247e9"/>
+    <p:sldId xmlns:r="http://schemas.openxmlformats.org/officeDocument/2006/relationships" id="256" r:id="R2750c50ec3304180"/>
+    <p:sldId xmlns:r="http://schemas.openxmlformats.org/officeDocument/2006/relationships" id="257" r:id="Rbebc51e92b624175"/>
+    <p:sldId xmlns:r="http://schemas.openxmlformats.org/officeDocument/2006/relationships" id="258" r:id="Rb78a35a42bac49c2"/>
+    <p:sldId xmlns:r="http://schemas.openxmlformats.org/officeDocument/2006/relationships" id="259" r:id="Rb77f921f922f4222"/>
+    <p:sldId xmlns:r="http://schemas.openxmlformats.org/officeDocument/2006/relationships" id="260" r:id="Rb30d436c259f4ad0"/>
+    <p:sldId xmlns:r="http://schemas.openxmlformats.org/officeDocument/2006/relationships" id="261" r:id="Rb7e06884224b4371"/>
   </p:sldIdLst>
   <p:sldSz cx="12192000" cy="6858000"/>
   <p:notesSz cx="6858000" cy="9144000"/>
@@ -917,7 +917,7 @@
           </a:p>
           <a:p xmlns:a="http://schemas.openxmlformats.org/drawingml/2006/main">
             <a:r>
-              <a:t>- GitHub release (private repo): https://github.com/Azizsekerdil/EnglishCourseAI/releases/tag/v1.1.0 (Windows zip + macOS zip)</a:t>
+              <a:t>- GitHub release (private repo): https://github.com/Azizsekerdil/EnglishCourseAI/releases/tag/v1.1.1 (Windows zip + macOS zip)</a:t>
             </a:r>
           </a:p>
           <a:p xmlns:a="http://schemas.openxmlformats.org/drawingml/2006/main">
@@ -990,7 +990,7 @@
   </p:cSld>
   <p:clrMap bg1="lt1" tx1="dk1" bg2="lt2" tx2="dk2" accent1="accent1" accent2="accent2" accent3="accent3" accent4="accent4" accent5="accent5" accent6="accent6" hlink="hlink" folHlink="folHlink"/>
   <p:sldLayoutIdLst>
-    <p:sldLayoutId xmlns:r="http://schemas.openxmlformats.org/officeDocument/2006/relationships" id="2147483649" r:id="R26db73c29cdb4d59"/>
+    <p:sldLayoutId xmlns:r="http://schemas.openxmlformats.org/officeDocument/2006/relationships" id="2147483649" r:id="Ra3730480925749c2"/>
   </p:sldLayoutIdLst>
   <p:txStyles>
     <p:titleStyle>
@@ -1541,7 +1541,7 @@
           <p:cNvPr id="8" name="">
             <a:extLst xmlns:a="http://schemas.openxmlformats.org/drawingml/2006/main">
               <a:ext uri="{FF2B5EF4-FFF2-40B4-BE49-F238E27FC236}">
-                <a16:creationId xmlns:a16="http://schemas.microsoft.com/office/drawing/2014/main" id="{B96E6E91-D51D-4284-8D1C-3370B110AEBE}"/>
+                <a16:creationId xmlns:a16="http://schemas.microsoft.com/office/drawing/2014/main" id="{EE221133-9126-4986-8C21-60C98C6369B1}"/>
               </a:ext>
             </a:extLst>
           </p:cNvPr>
@@ -1576,7 +1576,7 @@
           <p:nvPr/>
         </p:nvPicPr>
         <p:blipFill>
-          <a:blip xmlns:r="http://schemas.openxmlformats.org/officeDocument/2006/relationships" xmlns:a="http://schemas.openxmlformats.org/drawingml/2006/main" r:embed="R4808e0fce77a44c3"/>
+          <a:blip xmlns:r="http://schemas.openxmlformats.org/officeDocument/2006/relationships" xmlns:a="http://schemas.openxmlformats.org/drawingml/2006/main" r:embed="R6846adf8825245ee"/>
           <a:stretch xmlns:a="http://schemas.openxmlformats.org/drawingml/2006/main"/>
         </p:blipFill>
         <p:spPr>
@@ -1594,7 +1594,7 @@
           <p:cNvPr id="3" name="">
             <a:extLst xmlns:a="http://schemas.openxmlformats.org/drawingml/2006/main">
               <a:ext uri="{FF2B5EF4-FFF2-40B4-BE49-F238E27FC236}">
-                <a16:creationId xmlns:a16="http://schemas.microsoft.com/office/drawing/2014/main" id="{4DB2D8C1-4922-49A5-8A0A-0B4B3A42A51A}"/>
+                <a16:creationId xmlns:a16="http://schemas.microsoft.com/office/drawing/2014/main" id="{57A09D82-9A85-4189-A298-E4B3F220C8CA}"/>
               </a:ext>
             </a:extLst>
           </p:cNvPr>
@@ -1650,7 +1650,7 @@
           <p:cNvPr id="4" name="">
             <a:extLst xmlns:a="http://schemas.openxmlformats.org/drawingml/2006/main">
               <a:ext uri="{FF2B5EF4-FFF2-40B4-BE49-F238E27FC236}">
-                <a16:creationId xmlns:a16="http://schemas.microsoft.com/office/drawing/2014/main" id="{7E95482E-8754-469D-8A36-33412282740F}"/>
+                <a16:creationId xmlns:a16="http://schemas.microsoft.com/office/drawing/2014/main" id="{3CB73DB1-D61E-4ADD-8658-811C106A1BDC}"/>
               </a:ext>
             </a:extLst>
           </p:cNvPr>
@@ -1729,7 +1729,7 @@
           <p:cNvPr id="5" name="">
             <a:extLst xmlns:a="http://schemas.openxmlformats.org/drawingml/2006/main">
               <a:ext uri="{FF2B5EF4-FFF2-40B4-BE49-F238E27FC236}">
-                <a16:creationId xmlns:a16="http://schemas.microsoft.com/office/drawing/2014/main" id="{AF90C5C1-3BD1-47DB-92E7-E166255E92A8}"/>
+                <a16:creationId xmlns:a16="http://schemas.microsoft.com/office/drawing/2014/main" id="{E3CE69F8-CF1D-4EAD-9883-0B8D7F6D4391}"/>
               </a:ext>
             </a:extLst>
           </p:cNvPr>
@@ -1760,7 +1760,7 @@
           <p:cNvPr id="6" name="">
             <a:extLst xmlns:a="http://schemas.openxmlformats.org/drawingml/2006/main">
               <a:ext uri="{FF2B5EF4-FFF2-40B4-BE49-F238E27FC236}">
-                <a16:creationId xmlns:a16="http://schemas.microsoft.com/office/drawing/2014/main" id="{6D4BCAC2-3452-46FF-B908-A677E83219C9}"/>
+                <a16:creationId xmlns:a16="http://schemas.microsoft.com/office/drawing/2014/main" id="{89E4B472-A8E4-42B0-83FA-B1D7699BCE0A}"/>
               </a:ext>
             </a:extLst>
           </p:cNvPr>
@@ -1839,7 +1839,7 @@
           <p:cNvPr id="7" name="">
             <a:extLst xmlns:a="http://schemas.openxmlformats.org/drawingml/2006/main">
               <a:ext uri="{FF2B5EF4-FFF2-40B4-BE49-F238E27FC236}">
-                <a16:creationId xmlns:a16="http://schemas.microsoft.com/office/drawing/2014/main" id="{2134ED90-50A3-4DA6-96B3-D88ACE4D8F99}"/>
+                <a16:creationId xmlns:a16="http://schemas.microsoft.com/office/drawing/2014/main" id="{40FEBDD2-59EF-45FE-864B-7755B54CDF57}"/>
               </a:ext>
             </a:extLst>
           </p:cNvPr>
@@ -1885,7 +1885,7 @@
                 <a:ea typeface="Arial"/>
                 <a:cs typeface="Arial"/>
               </a:rPr>
-              <a:t>v1.1.0  •  2026</a:t>
+              <a:t>v1.1.1  •  2026</a:t>
             </a:r>
           </a:p>
         </p:txBody>
@@ -1893,7 +1893,7 @@
     </p:spTree>
     <p:extLst>
       <p:ext uri="{BB962C8B-B14F-4D97-AF65-F5344CB8AC3E}">
-        <p14:creationId xmlns:p14="http://schemas.microsoft.com/office/powerpoint/2010/main" val="96276581"/>
+        <p14:creationId xmlns:p14="http://schemas.microsoft.com/office/powerpoint/2010/main" val="1220145292"/>
       </p:ext>
     </p:extLst>
   </p:cSld>
@@ -1924,7 +1924,7 @@
           <p:cNvPr id="21" name="">
             <a:extLst xmlns:a="http://schemas.openxmlformats.org/drawingml/2006/main">
               <a:ext uri="{FF2B5EF4-FFF2-40B4-BE49-F238E27FC236}">
-                <a16:creationId xmlns:a16="http://schemas.microsoft.com/office/drawing/2014/main" id="{DBA85FEC-BC17-4DED-A939-E1495AF69B78}"/>
+                <a16:creationId xmlns:a16="http://schemas.microsoft.com/office/drawing/2014/main" id="{0CFC3CE1-12AE-4B5D-B4CD-F66C91B886A1}"/>
               </a:ext>
             </a:extLst>
           </p:cNvPr>
@@ -1980,7 +1980,7 @@
           <p:cNvPr id="2" name="">
             <a:extLst xmlns:a="http://schemas.openxmlformats.org/drawingml/2006/main">
               <a:ext uri="{FF2B5EF4-FFF2-40B4-BE49-F238E27FC236}">
-                <a16:creationId xmlns:a16="http://schemas.microsoft.com/office/drawing/2014/main" id="{B5E7CC10-A5E7-4DEF-8E3C-B2A800380BB8}"/>
+                <a16:creationId xmlns:a16="http://schemas.microsoft.com/office/drawing/2014/main" id="{470A00B2-BE97-41CA-B1F1-403241351927}"/>
               </a:ext>
             </a:extLst>
           </p:cNvPr>
@@ -2036,7 +2036,7 @@
           <p:cNvPr id="3" name="">
             <a:extLst xmlns:a="http://schemas.openxmlformats.org/drawingml/2006/main">
               <a:ext uri="{FF2B5EF4-FFF2-40B4-BE49-F238E27FC236}">
-                <a16:creationId xmlns:a16="http://schemas.microsoft.com/office/drawing/2014/main" id="{C10394C5-0FAC-4325-B0A3-87DF80AAED6B}"/>
+                <a16:creationId xmlns:a16="http://schemas.microsoft.com/office/drawing/2014/main" id="{2385F7D6-1539-403A-8287-8AA8A407D383}"/>
               </a:ext>
             </a:extLst>
           </p:cNvPr>
@@ -2092,7 +2092,7 @@
           <p:cNvPr id="4" name="">
             <a:extLst xmlns:a="http://schemas.openxmlformats.org/drawingml/2006/main">
               <a:ext uri="{FF2B5EF4-FFF2-40B4-BE49-F238E27FC236}">
-                <a16:creationId xmlns:a16="http://schemas.microsoft.com/office/drawing/2014/main" id="{4E0DA323-659D-4412-B1C8-7480657584BD}"/>
+                <a16:creationId xmlns:a16="http://schemas.microsoft.com/office/drawing/2014/main" id="{C0140CDE-A55D-4498-A1F6-494F520BD3DF}"/>
               </a:ext>
             </a:extLst>
           </p:cNvPr>
@@ -2148,7 +2148,7 @@
           <p:cNvPr id="5" name="">
             <a:extLst xmlns:a="http://schemas.openxmlformats.org/drawingml/2006/main">
               <a:ext uri="{FF2B5EF4-FFF2-40B4-BE49-F238E27FC236}">
-                <a16:creationId xmlns:a16="http://schemas.microsoft.com/office/drawing/2014/main" id="{D653539D-783C-46C6-964B-5FC07D52F929}"/>
+                <a16:creationId xmlns:a16="http://schemas.microsoft.com/office/drawing/2014/main" id="{23A4D4C3-527F-4654-AFC8-90F1CE3BAB6E}"/>
               </a:ext>
             </a:extLst>
           </p:cNvPr>
@@ -2179,7 +2179,7 @@
           <p:cNvPr id="6" name="">
             <a:extLst xmlns:a="http://schemas.openxmlformats.org/drawingml/2006/main">
               <a:ext uri="{FF2B5EF4-FFF2-40B4-BE49-F238E27FC236}">
-                <a16:creationId xmlns:a16="http://schemas.microsoft.com/office/drawing/2014/main" id="{B83C87C8-F869-4B32-826A-EC66798CA81C}"/>
+                <a16:creationId xmlns:a16="http://schemas.microsoft.com/office/drawing/2014/main" id="{840FE7BA-0C68-4813-9F07-C4F8C06D5BF5}"/>
               </a:ext>
             </a:extLst>
           </p:cNvPr>
@@ -2235,7 +2235,7 @@
           <p:cNvPr id="7" name="">
             <a:extLst xmlns:a="http://schemas.openxmlformats.org/drawingml/2006/main">
               <a:ext uri="{FF2B5EF4-FFF2-40B4-BE49-F238E27FC236}">
-                <a16:creationId xmlns:a16="http://schemas.microsoft.com/office/drawing/2014/main" id="{FF752DA2-A104-4F2E-AC25-4D9B12C70A86}"/>
+                <a16:creationId xmlns:a16="http://schemas.microsoft.com/office/drawing/2014/main" id="{23DE6485-5CB1-45F0-B70F-F2E1DAA7F015}"/>
               </a:ext>
             </a:extLst>
           </p:cNvPr>
@@ -2291,7 +2291,7 @@
           <p:cNvPr id="8" name="">
             <a:extLst xmlns:a="http://schemas.openxmlformats.org/drawingml/2006/main">
               <a:ext uri="{FF2B5EF4-FFF2-40B4-BE49-F238E27FC236}">
-                <a16:creationId xmlns:a16="http://schemas.microsoft.com/office/drawing/2014/main" id="{1C8AFC00-667D-485D-8878-7CE85AB45E01}"/>
+                <a16:creationId xmlns:a16="http://schemas.microsoft.com/office/drawing/2014/main" id="{AE28E124-8434-495A-9D1C-5EDC3320DE3F}"/>
               </a:ext>
             </a:extLst>
           </p:cNvPr>
@@ -2347,7 +2347,7 @@
           <p:cNvPr id="9" name="">
             <a:extLst xmlns:a="http://schemas.openxmlformats.org/drawingml/2006/main">
               <a:ext uri="{FF2B5EF4-FFF2-40B4-BE49-F238E27FC236}">
-                <a16:creationId xmlns:a16="http://schemas.microsoft.com/office/drawing/2014/main" id="{C2ECE541-F376-4F66-9C54-61F40AA3E0CA}"/>
+                <a16:creationId xmlns:a16="http://schemas.microsoft.com/office/drawing/2014/main" id="{8B551CEE-2E37-4DD1-A464-A7F404786215}"/>
               </a:ext>
             </a:extLst>
           </p:cNvPr>
@@ -2378,7 +2378,7 @@
           <p:cNvPr id="10" name="">
             <a:extLst xmlns:a="http://schemas.openxmlformats.org/drawingml/2006/main">
               <a:ext uri="{FF2B5EF4-FFF2-40B4-BE49-F238E27FC236}">
-                <a16:creationId xmlns:a16="http://schemas.microsoft.com/office/drawing/2014/main" id="{C1E055E9-3CB4-4AC4-8126-0BADFF969B75}"/>
+                <a16:creationId xmlns:a16="http://schemas.microsoft.com/office/drawing/2014/main" id="{95DD0CD7-B308-4CF3-B7EB-10518C248AF2}"/>
               </a:ext>
             </a:extLst>
           </p:cNvPr>
@@ -2434,7 +2434,7 @@
           <p:cNvPr id="11" name="">
             <a:extLst xmlns:a="http://schemas.openxmlformats.org/drawingml/2006/main">
               <a:ext uri="{FF2B5EF4-FFF2-40B4-BE49-F238E27FC236}">
-                <a16:creationId xmlns:a16="http://schemas.microsoft.com/office/drawing/2014/main" id="{69B2812B-827F-4E93-AE45-FEAC58135154}"/>
+                <a16:creationId xmlns:a16="http://schemas.microsoft.com/office/drawing/2014/main" id="{E8D2DB7C-E72D-4983-89F4-D1D03E3AAA09}"/>
               </a:ext>
             </a:extLst>
           </p:cNvPr>
@@ -2490,7 +2490,7 @@
           <p:cNvPr id="12" name="">
             <a:extLst xmlns:a="http://schemas.openxmlformats.org/drawingml/2006/main">
               <a:ext uri="{FF2B5EF4-FFF2-40B4-BE49-F238E27FC236}">
-                <a16:creationId xmlns:a16="http://schemas.microsoft.com/office/drawing/2014/main" id="{9D0802CA-6D7B-4BBF-A0BE-51EA0E8B91D3}"/>
+                <a16:creationId xmlns:a16="http://schemas.microsoft.com/office/drawing/2014/main" id="{7BE53633-F1C4-411A-902B-E9FF7E5A6185}"/>
               </a:ext>
             </a:extLst>
           </p:cNvPr>
@@ -2546,7 +2546,7 @@
           <p:cNvPr id="13" name="">
             <a:extLst xmlns:a="http://schemas.openxmlformats.org/drawingml/2006/main">
               <a:ext uri="{FF2B5EF4-FFF2-40B4-BE49-F238E27FC236}">
-                <a16:creationId xmlns:a16="http://schemas.microsoft.com/office/drawing/2014/main" id="{CF5340F5-805B-4BDB-BDC7-FCBCDB903BF7}"/>
+                <a16:creationId xmlns:a16="http://schemas.microsoft.com/office/drawing/2014/main" id="{1AF75978-1E78-4DE3-9EC4-1BE6349361E4}"/>
               </a:ext>
             </a:extLst>
           </p:cNvPr>
@@ -2577,7 +2577,7 @@
           <p:cNvPr id="14" name="">
             <a:extLst xmlns:a="http://schemas.openxmlformats.org/drawingml/2006/main">
               <a:ext uri="{FF2B5EF4-FFF2-40B4-BE49-F238E27FC236}">
-                <a16:creationId xmlns:a16="http://schemas.microsoft.com/office/drawing/2014/main" id="{E5741F84-2010-4395-8571-ABA7BEF29E2F}"/>
+                <a16:creationId xmlns:a16="http://schemas.microsoft.com/office/drawing/2014/main" id="{3DA4148D-4ACE-487E-93D7-EF8488523BC9}"/>
               </a:ext>
             </a:extLst>
           </p:cNvPr>
@@ -2633,7 +2633,7 @@
           <p:cNvPr id="15" name="">
             <a:extLst xmlns:a="http://schemas.openxmlformats.org/drawingml/2006/main">
               <a:ext uri="{FF2B5EF4-FFF2-40B4-BE49-F238E27FC236}">
-                <a16:creationId xmlns:a16="http://schemas.microsoft.com/office/drawing/2014/main" id="{C89F47DA-5222-4FBE-A2EA-C7818F37CCDF}"/>
+                <a16:creationId xmlns:a16="http://schemas.microsoft.com/office/drawing/2014/main" id="{C35BEFE0-C598-409F-8F44-B1EAAD9F7608}"/>
               </a:ext>
             </a:extLst>
           </p:cNvPr>
@@ -2689,7 +2689,7 @@
           <p:cNvPr id="16" name="">
             <a:extLst xmlns:a="http://schemas.openxmlformats.org/drawingml/2006/main">
               <a:ext uri="{FF2B5EF4-FFF2-40B4-BE49-F238E27FC236}">
-                <a16:creationId xmlns:a16="http://schemas.microsoft.com/office/drawing/2014/main" id="{B36AAB39-78B3-4298-822B-5B947D3461D1}"/>
+                <a16:creationId xmlns:a16="http://schemas.microsoft.com/office/drawing/2014/main" id="{1560B532-F64A-44BB-8102-7AC15E366FA9}"/>
               </a:ext>
             </a:extLst>
           </p:cNvPr>
@@ -2745,7 +2745,7 @@
           <p:cNvPr id="17" name="">
             <a:extLst xmlns:a="http://schemas.openxmlformats.org/drawingml/2006/main">
               <a:ext uri="{FF2B5EF4-FFF2-40B4-BE49-F238E27FC236}">
-                <a16:creationId xmlns:a16="http://schemas.microsoft.com/office/drawing/2014/main" id="{79042646-0AEC-48D9-BFFC-81D9F6573EFC}"/>
+                <a16:creationId xmlns:a16="http://schemas.microsoft.com/office/drawing/2014/main" id="{E549BC7A-A0F6-4E2D-B86F-399C382B6584}"/>
               </a:ext>
             </a:extLst>
           </p:cNvPr>
@@ -2776,7 +2776,7 @@
           <p:cNvPr id="18" name="">
             <a:extLst xmlns:a="http://schemas.openxmlformats.org/drawingml/2006/main">
               <a:ext uri="{FF2B5EF4-FFF2-40B4-BE49-F238E27FC236}">
-                <a16:creationId xmlns:a16="http://schemas.microsoft.com/office/drawing/2014/main" id="{34C5700E-4424-41DF-BF98-B6A2E78E9B84}"/>
+                <a16:creationId xmlns:a16="http://schemas.microsoft.com/office/drawing/2014/main" id="{6901EB48-6CD8-45EB-9F61-DDC6816BF52B}"/>
               </a:ext>
             </a:extLst>
           </p:cNvPr>
@@ -2832,7 +2832,7 @@
           <p:cNvPr id="19" name="">
             <a:extLst xmlns:a="http://schemas.openxmlformats.org/drawingml/2006/main">
               <a:ext uri="{FF2B5EF4-FFF2-40B4-BE49-F238E27FC236}">
-                <a16:creationId xmlns:a16="http://schemas.microsoft.com/office/drawing/2014/main" id="{D4C84EC2-16BB-4E1E-B9B0-22470F0463D1}"/>
+                <a16:creationId xmlns:a16="http://schemas.microsoft.com/office/drawing/2014/main" id="{C7694AA0-E126-4BF3-8F62-EA22777E82D7}"/>
               </a:ext>
             </a:extLst>
           </p:cNvPr>
@@ -2888,7 +2888,7 @@
           <p:cNvPr id="20" name="">
             <a:extLst xmlns:a="http://schemas.openxmlformats.org/drawingml/2006/main">
               <a:ext uri="{FF2B5EF4-FFF2-40B4-BE49-F238E27FC236}">
-                <a16:creationId xmlns:a16="http://schemas.microsoft.com/office/drawing/2014/main" id="{795CAED8-19E7-4DCA-80C9-E24DB8715377}"/>
+                <a16:creationId xmlns:a16="http://schemas.microsoft.com/office/drawing/2014/main" id="{47DD8099-5B0D-4A80-9788-648235209455}"/>
               </a:ext>
             </a:extLst>
           </p:cNvPr>
@@ -2942,7 +2942,7 @@
     </p:spTree>
     <p:extLst>
       <p:ext uri="{BB962C8B-B14F-4D97-AF65-F5344CB8AC3E}">
-        <p14:creationId xmlns:p14="http://schemas.microsoft.com/office/powerpoint/2010/main" val="141661787"/>
+        <p14:creationId xmlns:p14="http://schemas.microsoft.com/office/powerpoint/2010/main" val="1105694363"/>
       </p:ext>
     </p:extLst>
   </p:cSld>
@@ -2973,7 +2973,7 @@
           <p:cNvPr id="23" name="">
             <a:extLst xmlns:a="http://schemas.openxmlformats.org/drawingml/2006/main">
               <a:ext uri="{FF2B5EF4-FFF2-40B4-BE49-F238E27FC236}">
-                <a16:creationId xmlns:a16="http://schemas.microsoft.com/office/drawing/2014/main" id="{3268245B-E2E5-4401-B55D-E5AF56190959}"/>
+                <a16:creationId xmlns:a16="http://schemas.microsoft.com/office/drawing/2014/main" id="{5D27891D-96BA-4331-96D9-53CF3CC9CBEC}"/>
               </a:ext>
             </a:extLst>
           </p:cNvPr>
@@ -3029,7 +3029,7 @@
           <p:cNvPr id="2" name="">
             <a:extLst xmlns:a="http://schemas.openxmlformats.org/drawingml/2006/main">
               <a:ext uri="{FF2B5EF4-FFF2-40B4-BE49-F238E27FC236}">
-                <a16:creationId xmlns:a16="http://schemas.microsoft.com/office/drawing/2014/main" id="{BC2FC91A-75D4-4CA3-80F4-C661FC7F29A3}"/>
+                <a16:creationId xmlns:a16="http://schemas.microsoft.com/office/drawing/2014/main" id="{484D72C1-36DA-4EDF-B641-782FADC82B9C}"/>
               </a:ext>
             </a:extLst>
           </p:cNvPr>
@@ -3085,7 +3085,7 @@
           <p:cNvPr id="3" name="">
             <a:extLst xmlns:a="http://schemas.openxmlformats.org/drawingml/2006/main">
               <a:ext uri="{FF2B5EF4-FFF2-40B4-BE49-F238E27FC236}">
-                <a16:creationId xmlns:a16="http://schemas.microsoft.com/office/drawing/2014/main" id="{F743CA8A-B08D-4961-BD3D-3B0BB900383E}"/>
+                <a16:creationId xmlns:a16="http://schemas.microsoft.com/office/drawing/2014/main" id="{85ABA2A8-0BFC-4C40-8310-043D16295451}"/>
               </a:ext>
             </a:extLst>
           </p:cNvPr>
@@ -3141,7 +3141,7 @@
           <p:cNvPr id="4" name="">
             <a:extLst xmlns:a="http://schemas.openxmlformats.org/drawingml/2006/main">
               <a:ext uri="{FF2B5EF4-FFF2-40B4-BE49-F238E27FC236}">
-                <a16:creationId xmlns:a16="http://schemas.microsoft.com/office/drawing/2014/main" id="{D5DE7B33-93DE-4AA9-A170-36CF2BA5F8B9}"/>
+                <a16:creationId xmlns:a16="http://schemas.microsoft.com/office/drawing/2014/main" id="{79127A6B-9D9B-4B82-9336-85B76190423C}"/>
               </a:ext>
             </a:extLst>
           </p:cNvPr>
@@ -3197,7 +3197,7 @@
           <p:cNvPr id="5" name="">
             <a:extLst xmlns:a="http://schemas.openxmlformats.org/drawingml/2006/main">
               <a:ext uri="{FF2B5EF4-FFF2-40B4-BE49-F238E27FC236}">
-                <a16:creationId xmlns:a16="http://schemas.microsoft.com/office/drawing/2014/main" id="{72766623-2B21-4F86-A120-AC89445E919D}"/>
+                <a16:creationId xmlns:a16="http://schemas.microsoft.com/office/drawing/2014/main" id="{EF577387-771F-4CD8-9245-E30AA884075E}"/>
               </a:ext>
             </a:extLst>
           </p:cNvPr>
@@ -3228,7 +3228,7 @@
           <p:cNvPr id="6" name="">
             <a:extLst xmlns:a="http://schemas.openxmlformats.org/drawingml/2006/main">
               <a:ext uri="{FF2B5EF4-FFF2-40B4-BE49-F238E27FC236}">
-                <a16:creationId xmlns:a16="http://schemas.microsoft.com/office/drawing/2014/main" id="{DDB223B9-5755-4AA4-881C-21C230C21A1C}"/>
+                <a16:creationId xmlns:a16="http://schemas.microsoft.com/office/drawing/2014/main" id="{07665F78-8053-43AB-BAB2-B234E98CC0F0}"/>
               </a:ext>
             </a:extLst>
           </p:cNvPr>
@@ -3284,7 +3284,7 @@
           <p:cNvPr id="7" name="">
             <a:extLst xmlns:a="http://schemas.openxmlformats.org/drawingml/2006/main">
               <a:ext uri="{FF2B5EF4-FFF2-40B4-BE49-F238E27FC236}">
-                <a16:creationId xmlns:a16="http://schemas.microsoft.com/office/drawing/2014/main" id="{E5EB6C2B-B474-45C0-B366-D98F751E0230}"/>
+                <a16:creationId xmlns:a16="http://schemas.microsoft.com/office/drawing/2014/main" id="{61EA9686-CD72-4C8A-844D-6EDFD3ED2F38}"/>
               </a:ext>
             </a:extLst>
           </p:cNvPr>
@@ -3340,7 +3340,7 @@
           <p:cNvPr id="8" name="">
             <a:extLst xmlns:a="http://schemas.openxmlformats.org/drawingml/2006/main">
               <a:ext uri="{FF2B5EF4-FFF2-40B4-BE49-F238E27FC236}">
-                <a16:creationId xmlns:a16="http://schemas.microsoft.com/office/drawing/2014/main" id="{5119706A-1AA4-41C5-9FDC-A85A8FDD3FFD}"/>
+                <a16:creationId xmlns:a16="http://schemas.microsoft.com/office/drawing/2014/main" id="{149F4B94-DF4B-4FC2-930D-E8ACAF597D74}"/>
               </a:ext>
             </a:extLst>
           </p:cNvPr>
@@ -3396,7 +3396,7 @@
           <p:cNvPr id="9" name="">
             <a:extLst xmlns:a="http://schemas.openxmlformats.org/drawingml/2006/main">
               <a:ext uri="{FF2B5EF4-FFF2-40B4-BE49-F238E27FC236}">
-                <a16:creationId xmlns:a16="http://schemas.microsoft.com/office/drawing/2014/main" id="{F00EDBAF-B431-4B15-AA9B-4F9A58719028}"/>
+                <a16:creationId xmlns:a16="http://schemas.microsoft.com/office/drawing/2014/main" id="{2AB0FB6B-A171-4068-86CC-C075A946571E}"/>
               </a:ext>
             </a:extLst>
           </p:cNvPr>
@@ -3427,7 +3427,7 @@
           <p:cNvPr id="10" name="">
             <a:extLst xmlns:a="http://schemas.openxmlformats.org/drawingml/2006/main">
               <a:ext uri="{FF2B5EF4-FFF2-40B4-BE49-F238E27FC236}">
-                <a16:creationId xmlns:a16="http://schemas.microsoft.com/office/drawing/2014/main" id="{BB49F7AD-45D4-4048-BFDE-9990B9446A57}"/>
+                <a16:creationId xmlns:a16="http://schemas.microsoft.com/office/drawing/2014/main" id="{485A5E9D-CD58-40CC-AD0E-71C7D7707480}"/>
               </a:ext>
             </a:extLst>
           </p:cNvPr>
@@ -3483,7 +3483,7 @@
           <p:cNvPr id="11" name="">
             <a:extLst xmlns:a="http://schemas.openxmlformats.org/drawingml/2006/main">
               <a:ext uri="{FF2B5EF4-FFF2-40B4-BE49-F238E27FC236}">
-                <a16:creationId xmlns:a16="http://schemas.microsoft.com/office/drawing/2014/main" id="{4BA19BF0-E312-4220-B37E-A4F7E58CE2E6}"/>
+                <a16:creationId xmlns:a16="http://schemas.microsoft.com/office/drawing/2014/main" id="{7EBF5549-B0D1-426F-B0D1-4DB734EB62AF}"/>
               </a:ext>
             </a:extLst>
           </p:cNvPr>
@@ -3539,7 +3539,7 @@
           <p:cNvPr id="12" name="">
             <a:extLst xmlns:a="http://schemas.openxmlformats.org/drawingml/2006/main">
               <a:ext uri="{FF2B5EF4-FFF2-40B4-BE49-F238E27FC236}">
-                <a16:creationId xmlns:a16="http://schemas.microsoft.com/office/drawing/2014/main" id="{BFD0ADBC-FEE5-4BBD-AC77-E4481F495906}"/>
+                <a16:creationId xmlns:a16="http://schemas.microsoft.com/office/drawing/2014/main" id="{707277C0-03A0-48A5-BEB3-A5AAA4B22E6E}"/>
               </a:ext>
             </a:extLst>
           </p:cNvPr>
@@ -3595,7 +3595,7 @@
           <p:cNvPr id="13" name="">
             <a:extLst xmlns:a="http://schemas.openxmlformats.org/drawingml/2006/main">
               <a:ext uri="{FF2B5EF4-FFF2-40B4-BE49-F238E27FC236}">
-                <a16:creationId xmlns:a16="http://schemas.microsoft.com/office/drawing/2014/main" id="{3A4C8906-869A-4218-AAAB-635C7621B49F}"/>
+                <a16:creationId xmlns:a16="http://schemas.microsoft.com/office/drawing/2014/main" id="{A91A1EFD-EE86-4C6A-9A3D-B3B6D7D1CDBF}"/>
               </a:ext>
             </a:extLst>
           </p:cNvPr>
@@ -3626,7 +3626,7 @@
           <p:cNvPr id="14" name="">
             <a:extLst xmlns:a="http://schemas.openxmlformats.org/drawingml/2006/main">
               <a:ext uri="{FF2B5EF4-FFF2-40B4-BE49-F238E27FC236}">
-                <a16:creationId xmlns:a16="http://schemas.microsoft.com/office/drawing/2014/main" id="{79D9DB4A-CAAA-4334-9408-6D3072539A7C}"/>
+                <a16:creationId xmlns:a16="http://schemas.microsoft.com/office/drawing/2014/main" id="{9D5A282A-B122-40F0-AB6B-C4401CADA8CD}"/>
               </a:ext>
             </a:extLst>
           </p:cNvPr>
@@ -3682,7 +3682,7 @@
           <p:cNvPr id="15" name="">
             <a:extLst xmlns:a="http://schemas.openxmlformats.org/drawingml/2006/main">
               <a:ext uri="{FF2B5EF4-FFF2-40B4-BE49-F238E27FC236}">
-                <a16:creationId xmlns:a16="http://schemas.microsoft.com/office/drawing/2014/main" id="{F0377A7E-3A62-428E-A5E5-EECBE5967DC2}"/>
+                <a16:creationId xmlns:a16="http://schemas.microsoft.com/office/drawing/2014/main" id="{BFFE5C12-7962-466A-8AA4-3C7865D6CDA4}"/>
               </a:ext>
             </a:extLst>
           </p:cNvPr>
@@ -3738,7 +3738,7 @@
           <p:cNvPr id="16" name="">
             <a:extLst xmlns:a="http://schemas.openxmlformats.org/drawingml/2006/main">
               <a:ext uri="{FF2B5EF4-FFF2-40B4-BE49-F238E27FC236}">
-                <a16:creationId xmlns:a16="http://schemas.microsoft.com/office/drawing/2014/main" id="{B2E7F390-9AB9-4E61-A1F4-123D4D2C34AD}"/>
+                <a16:creationId xmlns:a16="http://schemas.microsoft.com/office/drawing/2014/main" id="{7EFD8116-D0D7-4021-9B29-5D3089589FE2}"/>
               </a:ext>
             </a:extLst>
           </p:cNvPr>
@@ -3794,7 +3794,7 @@
           <p:cNvPr id="17" name="">
             <a:extLst xmlns:a="http://schemas.openxmlformats.org/drawingml/2006/main">
               <a:ext uri="{FF2B5EF4-FFF2-40B4-BE49-F238E27FC236}">
-                <a16:creationId xmlns:a16="http://schemas.microsoft.com/office/drawing/2014/main" id="{B6E19225-B130-4B34-9D64-454D538A1B13}"/>
+                <a16:creationId xmlns:a16="http://schemas.microsoft.com/office/drawing/2014/main" id="{13CE6921-2C37-4F0B-9BCE-BF1E2BD19F15}"/>
               </a:ext>
             </a:extLst>
           </p:cNvPr>
@@ -3825,7 +3825,7 @@
           <p:cNvPr id="18" name="">
             <a:extLst xmlns:a="http://schemas.openxmlformats.org/drawingml/2006/main">
               <a:ext uri="{FF2B5EF4-FFF2-40B4-BE49-F238E27FC236}">
-                <a16:creationId xmlns:a16="http://schemas.microsoft.com/office/drawing/2014/main" id="{510667D5-9BA9-42CF-9AE3-7D8B051E0CE4}"/>
+                <a16:creationId xmlns:a16="http://schemas.microsoft.com/office/drawing/2014/main" id="{D279676F-15AF-4435-A310-9A2E9D87E792}"/>
               </a:ext>
             </a:extLst>
           </p:cNvPr>
@@ -3881,7 +3881,7 @@
           <p:cNvPr id="19" name="">
             <a:extLst xmlns:a="http://schemas.openxmlformats.org/drawingml/2006/main">
               <a:ext uri="{FF2B5EF4-FFF2-40B4-BE49-F238E27FC236}">
-                <a16:creationId xmlns:a16="http://schemas.microsoft.com/office/drawing/2014/main" id="{8AD9E00B-8F6B-4C98-8C3C-FAA5339F6995}"/>
+                <a16:creationId xmlns:a16="http://schemas.microsoft.com/office/drawing/2014/main" id="{63D80FB3-4C54-448B-B5CC-7239C0BD7EF9}"/>
               </a:ext>
             </a:extLst>
           </p:cNvPr>
@@ -3937,7 +3937,7 @@
           <p:cNvPr id="20" name="">
             <a:extLst xmlns:a="http://schemas.openxmlformats.org/drawingml/2006/main">
               <a:ext uri="{FF2B5EF4-FFF2-40B4-BE49-F238E27FC236}">
-                <a16:creationId xmlns:a16="http://schemas.microsoft.com/office/drawing/2014/main" id="{77F787B7-FBD3-4718-A6A0-532C8B9846EC}"/>
+                <a16:creationId xmlns:a16="http://schemas.microsoft.com/office/drawing/2014/main" id="{6D8B190E-9FA0-4C24-8EC2-7FD5564970B3}"/>
               </a:ext>
             </a:extLst>
           </p:cNvPr>
@@ -3993,7 +3993,7 @@
           <p:cNvPr id="21" name="">
             <a:extLst xmlns:a="http://schemas.openxmlformats.org/drawingml/2006/main">
               <a:ext uri="{FF2B5EF4-FFF2-40B4-BE49-F238E27FC236}">
-                <a16:creationId xmlns:a16="http://schemas.microsoft.com/office/drawing/2014/main" id="{D72EB848-1E9F-493A-BBD4-FDE9A0943B41}"/>
+                <a16:creationId xmlns:a16="http://schemas.microsoft.com/office/drawing/2014/main" id="{A416918E-A27C-49CF-B7FA-C1787ECDF0E2}"/>
               </a:ext>
             </a:extLst>
           </p:cNvPr>
@@ -4024,7 +4024,7 @@
           <p:cNvPr id="22" name="">
             <a:extLst xmlns:a="http://schemas.openxmlformats.org/drawingml/2006/main">
               <a:ext uri="{FF2B5EF4-FFF2-40B4-BE49-F238E27FC236}">
-                <a16:creationId xmlns:a16="http://schemas.microsoft.com/office/drawing/2014/main" id="{A96C2B67-B772-44CF-84D9-AEC00FDE51F5}"/>
+                <a16:creationId xmlns:a16="http://schemas.microsoft.com/office/drawing/2014/main" id="{134BC8BC-A9A7-46A8-B531-311A92AFC2D5}"/>
               </a:ext>
             </a:extLst>
           </p:cNvPr>
@@ -4078,7 +4078,7 @@
     </p:spTree>
     <p:extLst>
       <p:ext uri="{BB962C8B-B14F-4D97-AF65-F5344CB8AC3E}">
-        <p14:creationId xmlns:p14="http://schemas.microsoft.com/office/powerpoint/2010/main" val="300750136"/>
+        <p14:creationId xmlns:p14="http://schemas.microsoft.com/office/powerpoint/2010/main" val="1354669235"/>
       </p:ext>
     </p:extLst>
   </p:cSld>
@@ -4109,7 +4109,7 @@
           <p:cNvPr id="9" name="">
             <a:extLst xmlns:a="http://schemas.openxmlformats.org/drawingml/2006/main">
               <a:ext uri="{FF2B5EF4-FFF2-40B4-BE49-F238E27FC236}">
-                <a16:creationId xmlns:a16="http://schemas.microsoft.com/office/drawing/2014/main" id="{88344FE7-3E0B-42F8-B93F-94D2B01B5F3D}"/>
+                <a16:creationId xmlns:a16="http://schemas.microsoft.com/office/drawing/2014/main" id="{DB363743-791E-48E5-BCEE-43349B9E1735}"/>
               </a:ext>
             </a:extLst>
           </p:cNvPr>
@@ -4165,7 +4165,7 @@
           <p:cNvPr id="2" name="">
             <a:extLst xmlns:a="http://schemas.openxmlformats.org/drawingml/2006/main">
               <a:ext uri="{FF2B5EF4-FFF2-40B4-BE49-F238E27FC236}">
-                <a16:creationId xmlns:a16="http://schemas.microsoft.com/office/drawing/2014/main" id="{79C10F2D-0A88-4B4B-85A3-4E7075BB5E2E}"/>
+                <a16:creationId xmlns:a16="http://schemas.microsoft.com/office/drawing/2014/main" id="{535EF648-B44A-427C-A0B6-89CE65B27354}"/>
               </a:ext>
             </a:extLst>
           </p:cNvPr>
@@ -4221,7 +4221,7 @@
           <p:cNvPr id="3" name="">
             <a:extLst xmlns:a="http://schemas.openxmlformats.org/drawingml/2006/main">
               <a:ext uri="{FF2B5EF4-FFF2-40B4-BE49-F238E27FC236}">
-                <a16:creationId xmlns:a16="http://schemas.microsoft.com/office/drawing/2014/main" id="{F0B06D3F-28B8-4019-B298-1AA0B0AE4F27}"/>
+                <a16:creationId xmlns:a16="http://schemas.microsoft.com/office/drawing/2014/main" id="{6B73DB4F-9E3C-4361-A099-5A4ED48C1418}"/>
               </a:ext>
             </a:extLst>
           </p:cNvPr>
@@ -4277,7 +4277,7 @@
           <p:cNvPr id="4" name="">
             <a:extLst xmlns:a="http://schemas.openxmlformats.org/drawingml/2006/main">
               <a:ext uri="{FF2B5EF4-FFF2-40B4-BE49-F238E27FC236}">
-                <a16:creationId xmlns:a16="http://schemas.microsoft.com/office/drawing/2014/main" id="{BE23955B-CDC3-4DBD-932E-B1FD63103A57}"/>
+                <a16:creationId xmlns:a16="http://schemas.microsoft.com/office/drawing/2014/main" id="{DDD7FD7C-8B0A-4896-A514-26AAB00A9FB4}"/>
               </a:ext>
             </a:extLst>
           </p:cNvPr>
@@ -4333,7 +4333,7 @@
           <p:cNvPr id="5" name="">
             <a:extLst xmlns:a="http://schemas.openxmlformats.org/drawingml/2006/main">
               <a:ext uri="{FF2B5EF4-FFF2-40B4-BE49-F238E27FC236}">
-                <a16:creationId xmlns:a16="http://schemas.microsoft.com/office/drawing/2014/main" id="{311EA04E-F220-40F4-963B-727AF6E07F21}"/>
+                <a16:creationId xmlns:a16="http://schemas.microsoft.com/office/drawing/2014/main" id="{15422472-0F1A-42D6-8337-661BB44802CE}"/>
               </a:ext>
             </a:extLst>
           </p:cNvPr>
@@ -4473,7 +4473,7 @@
           <p:cNvPr id="6" name="">
             <a:extLst xmlns:a="http://schemas.openxmlformats.org/drawingml/2006/main">
               <a:ext uri="{FF2B5EF4-FFF2-40B4-BE49-F238E27FC236}">
-                <a16:creationId xmlns:a16="http://schemas.microsoft.com/office/drawing/2014/main" id="{247CCDDD-4FFD-42BB-B877-316805518369}"/>
+                <a16:creationId xmlns:a16="http://schemas.microsoft.com/office/drawing/2014/main" id="{4090CCA2-1E7B-4EDE-8AD3-EBA540B14A60}"/>
               </a:ext>
             </a:extLst>
           </p:cNvPr>
@@ -4510,7 +4510,7 @@
           <p:nvPr/>
         </p:nvPicPr>
         <p:blipFill>
-          <a:blip xmlns:r="http://schemas.openxmlformats.org/officeDocument/2006/relationships" xmlns:a="http://schemas.openxmlformats.org/drawingml/2006/main" r:embed="Rc002db8069da4f19"/>
+          <a:blip xmlns:r="http://schemas.openxmlformats.org/officeDocument/2006/relationships" xmlns:a="http://schemas.openxmlformats.org/drawingml/2006/main" r:embed="R5a34a42ebac0476d"/>
           <a:stretch xmlns:a="http://schemas.openxmlformats.org/drawingml/2006/main"/>
         </p:blipFill>
         <p:spPr>
@@ -4528,7 +4528,7 @@
           <p:cNvPr id="8" name="">
             <a:extLst xmlns:a="http://schemas.openxmlformats.org/drawingml/2006/main">
               <a:ext uri="{FF2B5EF4-FFF2-40B4-BE49-F238E27FC236}">
-                <a16:creationId xmlns:a16="http://schemas.microsoft.com/office/drawing/2014/main" id="{009D8AF7-3646-4289-9981-99DBDEE51C6F}"/>
+                <a16:creationId xmlns:a16="http://schemas.microsoft.com/office/drawing/2014/main" id="{441EACC7-3164-42D0-B797-3E50CE55FACE}"/>
               </a:ext>
             </a:extLst>
           </p:cNvPr>
@@ -4582,7 +4582,7 @@
     </p:spTree>
     <p:extLst>
       <p:ext uri="{BB962C8B-B14F-4D97-AF65-F5344CB8AC3E}">
-        <p14:creationId xmlns:p14="http://schemas.microsoft.com/office/powerpoint/2010/main" val="2062868421"/>
+        <p14:creationId xmlns:p14="http://schemas.microsoft.com/office/powerpoint/2010/main" val="1848537086"/>
       </p:ext>
     </p:extLst>
   </p:cSld>
@@ -4613,7 +4613,7 @@
           <p:cNvPr id="15" name="">
             <a:extLst xmlns:a="http://schemas.openxmlformats.org/drawingml/2006/main">
               <a:ext uri="{FF2B5EF4-FFF2-40B4-BE49-F238E27FC236}">
-                <a16:creationId xmlns:a16="http://schemas.microsoft.com/office/drawing/2014/main" id="{02F5465E-B753-4584-BDC9-B7D476B4DB83}"/>
+                <a16:creationId xmlns:a16="http://schemas.microsoft.com/office/drawing/2014/main" id="{66B79C26-0F85-496C-9A59-CE28AC120372}"/>
               </a:ext>
             </a:extLst>
           </p:cNvPr>
@@ -4669,7 +4669,7 @@
           <p:cNvPr id="2" name="">
             <a:extLst xmlns:a="http://schemas.openxmlformats.org/drawingml/2006/main">
               <a:ext uri="{FF2B5EF4-FFF2-40B4-BE49-F238E27FC236}">
-                <a16:creationId xmlns:a16="http://schemas.microsoft.com/office/drawing/2014/main" id="{19994668-F477-4F44-B572-A875332EC33A}"/>
+                <a16:creationId xmlns:a16="http://schemas.microsoft.com/office/drawing/2014/main" id="{25D01973-E5C5-4524-BAD8-096EFD493DAE}"/>
               </a:ext>
             </a:extLst>
           </p:cNvPr>
@@ -4725,7 +4725,7 @@
           <p:cNvPr id="3" name="">
             <a:extLst xmlns:a="http://schemas.openxmlformats.org/drawingml/2006/main">
               <a:ext uri="{FF2B5EF4-FFF2-40B4-BE49-F238E27FC236}">
-                <a16:creationId xmlns:a16="http://schemas.microsoft.com/office/drawing/2014/main" id="{8DFE3DE8-AF13-4314-9234-AB929F5A03C8}"/>
+                <a16:creationId xmlns:a16="http://schemas.microsoft.com/office/drawing/2014/main" id="{7B185399-0C76-479A-9A7E-26443A54F50D}"/>
               </a:ext>
             </a:extLst>
           </p:cNvPr>
@@ -4781,7 +4781,7 @@
           <p:cNvPr id="4" name="">
             <a:extLst xmlns:a="http://schemas.openxmlformats.org/drawingml/2006/main">
               <a:ext uri="{FF2B5EF4-FFF2-40B4-BE49-F238E27FC236}">
-                <a16:creationId xmlns:a16="http://schemas.microsoft.com/office/drawing/2014/main" id="{773E6CE7-DCFA-49B4-8178-81E3D0D484B3}"/>
+                <a16:creationId xmlns:a16="http://schemas.microsoft.com/office/drawing/2014/main" id="{33F5A637-9564-4866-87CE-557E79EA7BD5}"/>
               </a:ext>
             </a:extLst>
           </p:cNvPr>
@@ -4837,7 +4837,7 @@
           <p:cNvPr id="5" name="">
             <a:extLst xmlns:a="http://schemas.openxmlformats.org/drawingml/2006/main">
               <a:ext uri="{FF2B5EF4-FFF2-40B4-BE49-F238E27FC236}">
-                <a16:creationId xmlns:a16="http://schemas.microsoft.com/office/drawing/2014/main" id="{246E93B1-F73E-4B65-8F04-8D2B5F0041B1}"/>
+                <a16:creationId xmlns:a16="http://schemas.microsoft.com/office/drawing/2014/main" id="{F1EC132B-319F-4EC6-9761-13E4C415E531}"/>
               </a:ext>
             </a:extLst>
           </p:cNvPr>
@@ -4868,7 +4868,7 @@
           <p:cNvPr id="6" name="">
             <a:extLst xmlns:a="http://schemas.openxmlformats.org/drawingml/2006/main">
               <a:ext uri="{FF2B5EF4-FFF2-40B4-BE49-F238E27FC236}">
-                <a16:creationId xmlns:a16="http://schemas.microsoft.com/office/drawing/2014/main" id="{F55F5770-005F-4E0F-BCAC-46478CFBBB3F}"/>
+                <a16:creationId xmlns:a16="http://schemas.microsoft.com/office/drawing/2014/main" id="{E9AFDC7B-4A57-421B-9589-843BE0116232}"/>
               </a:ext>
             </a:extLst>
           </p:cNvPr>
@@ -4899,7 +4899,7 @@
           <p:cNvPr id="7" name="">
             <a:extLst xmlns:a="http://schemas.openxmlformats.org/drawingml/2006/main">
               <a:ext uri="{FF2B5EF4-FFF2-40B4-BE49-F238E27FC236}">
-                <a16:creationId xmlns:a16="http://schemas.microsoft.com/office/drawing/2014/main" id="{EA47AB42-9318-4591-AD2E-A36DD3A77A6A}"/>
+                <a16:creationId xmlns:a16="http://schemas.microsoft.com/office/drawing/2014/main" id="{B496A798-347E-45FE-8E57-4513EFDCD880}"/>
               </a:ext>
             </a:extLst>
           </p:cNvPr>
@@ -4955,7 +4955,7 @@
           <p:cNvPr id="8" name="">
             <a:extLst xmlns:a="http://schemas.openxmlformats.org/drawingml/2006/main">
               <a:ext uri="{FF2B5EF4-FFF2-40B4-BE49-F238E27FC236}">
-                <a16:creationId xmlns:a16="http://schemas.microsoft.com/office/drawing/2014/main" id="{84720626-42B9-4C9A-B1B9-D55E6673BEDD}"/>
+                <a16:creationId xmlns:a16="http://schemas.microsoft.com/office/drawing/2014/main" id="{6FAC58D9-E2DD-4CED-98A8-2752B79B26FF}"/>
               </a:ext>
             </a:extLst>
           </p:cNvPr>
@@ -5011,7 +5011,7 @@
           <p:cNvPr id="9" name="">
             <a:extLst xmlns:a="http://schemas.openxmlformats.org/drawingml/2006/main">
               <a:ext uri="{FF2B5EF4-FFF2-40B4-BE49-F238E27FC236}">
-                <a16:creationId xmlns:a16="http://schemas.microsoft.com/office/drawing/2014/main" id="{F31D0390-2226-4820-9E1C-E5EDBAECAECF}"/>
+                <a16:creationId xmlns:a16="http://schemas.microsoft.com/office/drawing/2014/main" id="{D3B368AD-9084-4DBF-84E2-882035098CF6}"/>
               </a:ext>
             </a:extLst>
           </p:cNvPr>
@@ -5136,7 +5136,7 @@
           <p:cNvPr id="10" name="">
             <a:extLst xmlns:a="http://schemas.openxmlformats.org/drawingml/2006/main">
               <a:ext uri="{FF2B5EF4-FFF2-40B4-BE49-F238E27FC236}">
-                <a16:creationId xmlns:a16="http://schemas.microsoft.com/office/drawing/2014/main" id="{4BF237A0-A98C-428C-B74F-D832730C907F}"/>
+                <a16:creationId xmlns:a16="http://schemas.microsoft.com/office/drawing/2014/main" id="{22DD07E7-5964-4A81-97D9-E36DB5EFAF7B}"/>
               </a:ext>
             </a:extLst>
           </p:cNvPr>
@@ -5192,7 +5192,7 @@
           <p:cNvPr id="11" name="">
             <a:extLst xmlns:a="http://schemas.openxmlformats.org/drawingml/2006/main">
               <a:ext uri="{FF2B5EF4-FFF2-40B4-BE49-F238E27FC236}">
-                <a16:creationId xmlns:a16="http://schemas.microsoft.com/office/drawing/2014/main" id="{597DA63A-73D7-407D-83E6-CD8BD73B2124}"/>
+                <a16:creationId xmlns:a16="http://schemas.microsoft.com/office/drawing/2014/main" id="{E8813E39-B8C9-475C-9465-7B80A3257B84}"/>
               </a:ext>
             </a:extLst>
           </p:cNvPr>
@@ -5248,7 +5248,7 @@
           <p:cNvPr id="12" name="">
             <a:extLst xmlns:a="http://schemas.openxmlformats.org/drawingml/2006/main">
               <a:ext uri="{FF2B5EF4-FFF2-40B4-BE49-F238E27FC236}">
-                <a16:creationId xmlns:a16="http://schemas.microsoft.com/office/drawing/2014/main" id="{B1B5CEE8-9B8C-4612-8CA1-884C695242BA}"/>
+                <a16:creationId xmlns:a16="http://schemas.microsoft.com/office/drawing/2014/main" id="{9609E5C6-D7B7-4CD5-846D-C87283AA09A5}"/>
               </a:ext>
             </a:extLst>
           </p:cNvPr>
@@ -5304,7 +5304,7 @@
           <p:cNvPr id="13" name="">
             <a:extLst xmlns:a="http://schemas.openxmlformats.org/drawingml/2006/main">
               <a:ext uri="{FF2B5EF4-FFF2-40B4-BE49-F238E27FC236}">
-                <a16:creationId xmlns:a16="http://schemas.microsoft.com/office/drawing/2014/main" id="{D09E49E0-F525-4A3C-B0D8-CC3F72210599}"/>
+                <a16:creationId xmlns:a16="http://schemas.microsoft.com/office/drawing/2014/main" id="{13CA46AD-4383-4CF8-AB32-E959F1949CE4}"/>
               </a:ext>
             </a:extLst>
           </p:cNvPr>
@@ -5429,7 +5429,7 @@
           <p:cNvPr id="14" name="">
             <a:extLst xmlns:a="http://schemas.openxmlformats.org/drawingml/2006/main">
               <a:ext uri="{FF2B5EF4-FFF2-40B4-BE49-F238E27FC236}">
-                <a16:creationId xmlns:a16="http://schemas.microsoft.com/office/drawing/2014/main" id="{201F97D9-AA80-4848-96A4-EF9B68541F0F}"/>
+                <a16:creationId xmlns:a16="http://schemas.microsoft.com/office/drawing/2014/main" id="{DC079D9A-7301-4BD9-AC40-F51AC0D603A8}"/>
               </a:ext>
             </a:extLst>
           </p:cNvPr>
@@ -5483,7 +5483,7 @@
     </p:spTree>
     <p:extLst>
       <p:ext uri="{BB962C8B-B14F-4D97-AF65-F5344CB8AC3E}">
-        <p14:creationId xmlns:p14="http://schemas.microsoft.com/office/powerpoint/2010/main" val="2110790188"/>
+        <p14:creationId xmlns:p14="http://schemas.microsoft.com/office/powerpoint/2010/main" val="781505823"/>
       </p:ext>
     </p:extLst>
   </p:cSld>
@@ -5514,7 +5514,7 @@
           <p:cNvPr id="20" name="">
             <a:extLst xmlns:a="http://schemas.openxmlformats.org/drawingml/2006/main">
               <a:ext uri="{FF2B5EF4-FFF2-40B4-BE49-F238E27FC236}">
-                <a16:creationId xmlns:a16="http://schemas.microsoft.com/office/drawing/2014/main" id="{82F6B547-F6F0-42B2-AF23-DD6D624658FA}"/>
+                <a16:creationId xmlns:a16="http://schemas.microsoft.com/office/drawing/2014/main" id="{B457AF5D-9781-47D2-87E1-6C36CF1BFE04}"/>
               </a:ext>
             </a:extLst>
           </p:cNvPr>
@@ -5570,7 +5570,7 @@
           <p:cNvPr id="2" name="">
             <a:extLst xmlns:a="http://schemas.openxmlformats.org/drawingml/2006/main">
               <a:ext uri="{FF2B5EF4-FFF2-40B4-BE49-F238E27FC236}">
-                <a16:creationId xmlns:a16="http://schemas.microsoft.com/office/drawing/2014/main" id="{7B3D3B06-7CEE-4FA2-BBB3-B88E0D2E7C32}"/>
+                <a16:creationId xmlns:a16="http://schemas.microsoft.com/office/drawing/2014/main" id="{F98B2305-8E33-46B0-845F-1C83449C8B83}"/>
               </a:ext>
             </a:extLst>
           </p:cNvPr>
@@ -5649,7 +5649,7 @@
           <p:cNvPr id="3" name="">
             <a:extLst xmlns:a="http://schemas.openxmlformats.org/drawingml/2006/main">
               <a:ext uri="{FF2B5EF4-FFF2-40B4-BE49-F238E27FC236}">
-                <a16:creationId xmlns:a16="http://schemas.microsoft.com/office/drawing/2014/main" id="{3E64C8C0-3A8B-40A1-BB78-65B78646ED12}"/>
+                <a16:creationId xmlns:a16="http://schemas.microsoft.com/office/drawing/2014/main" id="{55476475-0F08-4D2B-AA8F-577BC1CCA9DE}"/>
               </a:ext>
             </a:extLst>
           </p:cNvPr>
@@ -5705,7 +5705,7 @@
           <p:cNvPr id="4" name="">
             <a:extLst xmlns:a="http://schemas.openxmlformats.org/drawingml/2006/main">
               <a:ext uri="{FF2B5EF4-FFF2-40B4-BE49-F238E27FC236}">
-                <a16:creationId xmlns:a16="http://schemas.microsoft.com/office/drawing/2014/main" id="{B8F534A9-DCB4-4129-B826-5EBF84058666}"/>
+                <a16:creationId xmlns:a16="http://schemas.microsoft.com/office/drawing/2014/main" id="{49962578-CC99-4A04-BF71-64A3DB59A109}"/>
               </a:ext>
             </a:extLst>
           </p:cNvPr>
@@ -5736,7 +5736,7 @@
           <p:cNvPr id="5" name="">
             <a:extLst xmlns:a="http://schemas.openxmlformats.org/drawingml/2006/main">
               <a:ext uri="{FF2B5EF4-FFF2-40B4-BE49-F238E27FC236}">
-                <a16:creationId xmlns:a16="http://schemas.microsoft.com/office/drawing/2014/main" id="{CD351060-6081-404C-A28E-DB0A824355E2}"/>
+                <a16:creationId xmlns:a16="http://schemas.microsoft.com/office/drawing/2014/main" id="{BDD0333C-8505-4730-B1FC-ED2CF67A5E8B}"/>
               </a:ext>
             </a:extLst>
           </p:cNvPr>
@@ -5792,7 +5792,7 @@
           <p:cNvPr id="6" name="">
             <a:extLst xmlns:a="http://schemas.openxmlformats.org/drawingml/2006/main">
               <a:ext uri="{FF2B5EF4-FFF2-40B4-BE49-F238E27FC236}">
-                <a16:creationId xmlns:a16="http://schemas.microsoft.com/office/drawing/2014/main" id="{E9C780C9-4C26-4584-B6AD-85F7DF6E9717}"/>
+                <a16:creationId xmlns:a16="http://schemas.microsoft.com/office/drawing/2014/main" id="{C9382BFC-1AAC-40BD-97B0-61BDFABF7672}"/>
               </a:ext>
             </a:extLst>
           </p:cNvPr>
@@ -5848,7 +5848,7 @@
           <p:cNvPr id="7" name="">
             <a:extLst xmlns:a="http://schemas.openxmlformats.org/drawingml/2006/main">
               <a:ext uri="{FF2B5EF4-FFF2-40B4-BE49-F238E27FC236}">
-                <a16:creationId xmlns:a16="http://schemas.microsoft.com/office/drawing/2014/main" id="{EF8F6572-CC1A-41CC-B5B2-762028199720}"/>
+                <a16:creationId xmlns:a16="http://schemas.microsoft.com/office/drawing/2014/main" id="{DA22C462-3906-4834-AEDC-0CF53C39071D}"/>
               </a:ext>
             </a:extLst>
           </p:cNvPr>
@@ -5904,7 +5904,7 @@
           <p:cNvPr id="8" name="">
             <a:extLst xmlns:a="http://schemas.openxmlformats.org/drawingml/2006/main">
               <a:ext uri="{FF2B5EF4-FFF2-40B4-BE49-F238E27FC236}">
-                <a16:creationId xmlns:a16="http://schemas.microsoft.com/office/drawing/2014/main" id="{2F7A2158-EAE8-4F8D-9F52-845F7E0C8587}"/>
+                <a16:creationId xmlns:a16="http://schemas.microsoft.com/office/drawing/2014/main" id="{F3DD16ED-12F8-447B-A58F-978D3A907D91}"/>
               </a:ext>
             </a:extLst>
           </p:cNvPr>
@@ -5935,7 +5935,7 @@
           <p:cNvPr id="9" name="">
             <a:extLst xmlns:a="http://schemas.openxmlformats.org/drawingml/2006/main">
               <a:ext uri="{FF2B5EF4-FFF2-40B4-BE49-F238E27FC236}">
-                <a16:creationId xmlns:a16="http://schemas.microsoft.com/office/drawing/2014/main" id="{F4E5271B-F84F-4F41-A521-99F50462C65E}"/>
+                <a16:creationId xmlns:a16="http://schemas.microsoft.com/office/drawing/2014/main" id="{D8F4136A-E0E6-4996-92C5-C942401DCFA2}"/>
               </a:ext>
             </a:extLst>
           </p:cNvPr>
@@ -5991,7 +5991,7 @@
           <p:cNvPr id="10" name="">
             <a:extLst xmlns:a="http://schemas.openxmlformats.org/drawingml/2006/main">
               <a:ext uri="{FF2B5EF4-FFF2-40B4-BE49-F238E27FC236}">
-                <a16:creationId xmlns:a16="http://schemas.microsoft.com/office/drawing/2014/main" id="{60C7E4C1-F289-4D0B-A35D-6C9A3C6AA25F}"/>
+                <a16:creationId xmlns:a16="http://schemas.microsoft.com/office/drawing/2014/main" id="{96007651-AD24-4582-8925-33C42A993638}"/>
               </a:ext>
             </a:extLst>
           </p:cNvPr>
@@ -6047,7 +6047,7 @@
           <p:cNvPr id="11" name="">
             <a:extLst xmlns:a="http://schemas.openxmlformats.org/drawingml/2006/main">
               <a:ext uri="{FF2B5EF4-FFF2-40B4-BE49-F238E27FC236}">
-                <a16:creationId xmlns:a16="http://schemas.microsoft.com/office/drawing/2014/main" id="{164265AF-B6CA-454D-9BC3-06FCFB0B3006}"/>
+                <a16:creationId xmlns:a16="http://schemas.microsoft.com/office/drawing/2014/main" id="{BE0C072B-B080-4B91-9904-81002B831732}"/>
               </a:ext>
             </a:extLst>
           </p:cNvPr>
@@ -6103,7 +6103,7 @@
           <p:cNvPr id="12" name="">
             <a:extLst xmlns:a="http://schemas.openxmlformats.org/drawingml/2006/main">
               <a:ext uri="{FF2B5EF4-FFF2-40B4-BE49-F238E27FC236}">
-                <a16:creationId xmlns:a16="http://schemas.microsoft.com/office/drawing/2014/main" id="{623228EC-4215-47CB-9383-85E4B53E5E54}"/>
+                <a16:creationId xmlns:a16="http://schemas.microsoft.com/office/drawing/2014/main" id="{BE3FBED3-68BB-413F-9151-B163783C959D}"/>
               </a:ext>
             </a:extLst>
           </p:cNvPr>
@@ -6134,7 +6134,7 @@
           <p:cNvPr id="13" name="">
             <a:extLst xmlns:a="http://schemas.openxmlformats.org/drawingml/2006/main">
               <a:ext uri="{FF2B5EF4-FFF2-40B4-BE49-F238E27FC236}">
-                <a16:creationId xmlns:a16="http://schemas.microsoft.com/office/drawing/2014/main" id="{D98A74FA-27E4-4747-BEA0-DF5FF34AF471}"/>
+                <a16:creationId xmlns:a16="http://schemas.microsoft.com/office/drawing/2014/main" id="{3C29DA53-FD5A-4AB8-946F-39834B1C4288}"/>
               </a:ext>
             </a:extLst>
           </p:cNvPr>
@@ -6190,7 +6190,7 @@
           <p:cNvPr id="14" name="">
             <a:extLst xmlns:a="http://schemas.openxmlformats.org/drawingml/2006/main">
               <a:ext uri="{FF2B5EF4-FFF2-40B4-BE49-F238E27FC236}">
-                <a16:creationId xmlns:a16="http://schemas.microsoft.com/office/drawing/2014/main" id="{DF127F88-2E4E-45E3-9A0A-ABCC4AB7D055}"/>
+                <a16:creationId xmlns:a16="http://schemas.microsoft.com/office/drawing/2014/main" id="{1A07C5F4-C536-4D30-954B-8D1E710600D2}"/>
               </a:ext>
             </a:extLst>
           </p:cNvPr>
@@ -6246,7 +6246,7 @@
           <p:cNvPr id="15" name="">
             <a:extLst xmlns:a="http://schemas.openxmlformats.org/drawingml/2006/main">
               <a:ext uri="{FF2B5EF4-FFF2-40B4-BE49-F238E27FC236}">
-                <a16:creationId xmlns:a16="http://schemas.microsoft.com/office/drawing/2014/main" id="{DD2A3A0F-DF01-4B13-AB5B-6C7F975092EE}"/>
+                <a16:creationId xmlns:a16="http://schemas.microsoft.com/office/drawing/2014/main" id="{F94F69EC-54DB-475E-90CD-3B446E01B166}"/>
               </a:ext>
             </a:extLst>
           </p:cNvPr>
@@ -6302,7 +6302,7 @@
           <p:cNvPr id="16" name="">
             <a:extLst xmlns:a="http://schemas.openxmlformats.org/drawingml/2006/main">
               <a:ext uri="{FF2B5EF4-FFF2-40B4-BE49-F238E27FC236}">
-                <a16:creationId xmlns:a16="http://schemas.microsoft.com/office/drawing/2014/main" id="{92D0A7E5-CE4B-48C7-9D2B-4ECD44ACBB6E}"/>
+                <a16:creationId xmlns:a16="http://schemas.microsoft.com/office/drawing/2014/main" id="{19E9A62E-4A34-488B-8D28-0BA41DD014BC}"/>
               </a:ext>
             </a:extLst>
           </p:cNvPr>
@@ -6348,7 +6348,7 @@
                 <a:ea typeface="Arial"/>
                 <a:cs typeface="Arial"/>
               </a:rPr>
-              <a:t>Windows 10/11 (x64) + macOS (Apple Silicon) — İndirme: github.com/Azizsekerdil/EnglishCourseAI/releases (v1.1.0, özel repo)</a:t>
+              <a:t>Windows 10/11 (x64) + macOS (Apple Silicon) — İndirme: github.com/Azizsekerdil/EnglishCourseAI/releases (v1.1.1, özel repo)</a:t>
             </a:r>
           </a:p>
         </p:txBody>
@@ -6358,7 +6358,7 @@
           <p:cNvPr id="17" name="">
             <a:extLst xmlns:a="http://schemas.openxmlformats.org/drawingml/2006/main">
               <a:ext uri="{FF2B5EF4-FFF2-40B4-BE49-F238E27FC236}">
-                <a16:creationId xmlns:a16="http://schemas.microsoft.com/office/drawing/2014/main" id="{43552A2A-2CE6-450E-A344-11320EA746A0}"/>
+                <a16:creationId xmlns:a16="http://schemas.microsoft.com/office/drawing/2014/main" id="{A74B851B-47E2-4380-A1D9-B43170B3A536}"/>
               </a:ext>
             </a:extLst>
           </p:cNvPr>
@@ -6404,7 +6404,7 @@
                 <a:ea typeface="Arial"/>
                 <a:cs typeface="Arial"/>
               </a:rPr>
-              <a:t>Windows 10/11 (x64) &amp; macOS (Apple Silicon) — Download: GitHub Releases (v1.1.0)</a:t>
+              <a:t>Windows 10/11 (x64) &amp; macOS (Apple Silicon) — Download: GitHub Releases (v1.1.1)</a:t>
             </a:r>
           </a:p>
         </p:txBody>
@@ -6414,7 +6414,7 @@
           <p:cNvPr id="18" name="">
             <a:extLst xmlns:a="http://schemas.openxmlformats.org/drawingml/2006/main">
               <a:ext uri="{FF2B5EF4-FFF2-40B4-BE49-F238E27FC236}">
-                <a16:creationId xmlns:a16="http://schemas.microsoft.com/office/drawing/2014/main" id="{5E7633B0-5EF0-4DAE-BF9F-B0BA35B4CB1B}"/>
+                <a16:creationId xmlns:a16="http://schemas.microsoft.com/office/drawing/2014/main" id="{1B8F0372-CA73-4F9A-AF44-D8E66DE28BE0}"/>
               </a:ext>
             </a:extLst>
           </p:cNvPr>
@@ -6474,7 +6474,7 @@
           <p:nvPr/>
         </p:nvPicPr>
         <p:blipFill>
-          <a:blip xmlns:r="http://schemas.openxmlformats.org/officeDocument/2006/relationships" xmlns:a="http://schemas.openxmlformats.org/drawingml/2006/main" r:embed="Rc18fe448337f4ecc"/>
+          <a:blip xmlns:r="http://schemas.openxmlformats.org/officeDocument/2006/relationships" xmlns:a="http://schemas.openxmlformats.org/drawingml/2006/main" r:embed="R8029e4a0af454c4b"/>
           <a:stretch xmlns:a="http://schemas.openxmlformats.org/drawingml/2006/main"/>
         </p:blipFill>
         <p:spPr>
@@ -6490,7 +6490,7 @@
     </p:spTree>
     <p:extLst>
       <p:ext uri="{BB962C8B-B14F-4D97-AF65-F5344CB8AC3E}">
-        <p14:creationId xmlns:p14="http://schemas.microsoft.com/office/powerpoint/2010/main" val="1263053208"/>
+        <p14:creationId xmlns:p14="http://schemas.microsoft.com/office/powerpoint/2010/main" val="2131603070"/>
       </p:ext>
     </p:extLst>
   </p:cSld>

</xml_diff>

<commit_message>
Sunum: v1.1.2 indirme bilgileri
Co-Authored-By: Claude Fable 5.1 <noreply@anthropic.com>
</commit_message>
<xml_diff>
--- a/docs/presentation/English-Course-AI-Bilingual.pptx
+++ b/docs/presentation/English-Course-AI-Bilingual.pptx
@@ -2,18 +2,18 @@
 <file path=ppt/presentation.xml><?xml version="1.0" encoding="utf-8"?>
 <p:presentation xmlns:p="http://schemas.openxmlformats.org/presentationml/2006/main">
   <p:sldMasterIdLst>
-    <p:sldMasterId xmlns:r="http://schemas.openxmlformats.org/officeDocument/2006/relationships" id="2147483648" r:id="R77159e1bc2894078"/>
+    <p:sldMasterId xmlns:r="http://schemas.openxmlformats.org/officeDocument/2006/relationships" id="2147483648" r:id="Rff84a43849674f59"/>
   </p:sldMasterIdLst>
   <p:notesMasterIdLst>
-    <p:notesMasterId xmlns:r="http://schemas.openxmlformats.org/officeDocument/2006/relationships" r:id="R9dd210d789d94aef"/>
+    <p:notesMasterId xmlns:r="http://schemas.openxmlformats.org/officeDocument/2006/relationships" r:id="Rcd922a04c0104511"/>
   </p:notesMasterIdLst>
   <p:sldIdLst>
-    <p:sldId xmlns:r="http://schemas.openxmlformats.org/officeDocument/2006/relationships" id="256" r:id="R2750c50ec3304180"/>
-    <p:sldId xmlns:r="http://schemas.openxmlformats.org/officeDocument/2006/relationships" id="257" r:id="Rbebc51e92b624175"/>
-    <p:sldId xmlns:r="http://schemas.openxmlformats.org/officeDocument/2006/relationships" id="258" r:id="Rb78a35a42bac49c2"/>
-    <p:sldId xmlns:r="http://schemas.openxmlformats.org/officeDocument/2006/relationships" id="259" r:id="Rb77f921f922f4222"/>
-    <p:sldId xmlns:r="http://schemas.openxmlformats.org/officeDocument/2006/relationships" id="260" r:id="Rb30d436c259f4ad0"/>
-    <p:sldId xmlns:r="http://schemas.openxmlformats.org/officeDocument/2006/relationships" id="261" r:id="Rb7e06884224b4371"/>
+    <p:sldId xmlns:r="http://schemas.openxmlformats.org/officeDocument/2006/relationships" id="256" r:id="R9762de30c6e5480c"/>
+    <p:sldId xmlns:r="http://schemas.openxmlformats.org/officeDocument/2006/relationships" id="257" r:id="R96772dc4df724afc"/>
+    <p:sldId xmlns:r="http://schemas.openxmlformats.org/officeDocument/2006/relationships" id="258" r:id="R86890664d12d46b7"/>
+    <p:sldId xmlns:r="http://schemas.openxmlformats.org/officeDocument/2006/relationships" id="259" r:id="R45b8b57b783f4789"/>
+    <p:sldId xmlns:r="http://schemas.openxmlformats.org/officeDocument/2006/relationships" id="260" r:id="R6dcc3f2a64624ec1"/>
+    <p:sldId xmlns:r="http://schemas.openxmlformats.org/officeDocument/2006/relationships" id="261" r:id="R920feb5a0aeb4b95"/>
   </p:sldIdLst>
   <p:sldSz cx="12192000" cy="6858000"/>
   <p:notesSz cx="6858000" cy="9144000"/>
@@ -917,7 +917,7 @@
           </a:p>
           <a:p xmlns:a="http://schemas.openxmlformats.org/drawingml/2006/main">
             <a:r>
-              <a:t>- GitHub release (private repo): https://github.com/Azizsekerdil/EnglishCourseAI/releases/tag/v1.1.1 (Windows zip + macOS zip)</a:t>
+              <a:t>- GitHub release (private repo): https://github.com/Azizsekerdil/EnglishCourseAI/releases/tag/v1.1.2 (Windows zip + macOS zip)</a:t>
             </a:r>
           </a:p>
           <a:p xmlns:a="http://schemas.openxmlformats.org/drawingml/2006/main">
@@ -990,7 +990,7 @@
   </p:cSld>
   <p:clrMap bg1="lt1" tx1="dk1" bg2="lt2" tx2="dk2" accent1="accent1" accent2="accent2" accent3="accent3" accent4="accent4" accent5="accent5" accent6="accent6" hlink="hlink" folHlink="folHlink"/>
   <p:sldLayoutIdLst>
-    <p:sldLayoutId xmlns:r="http://schemas.openxmlformats.org/officeDocument/2006/relationships" id="2147483649" r:id="Ra3730480925749c2"/>
+    <p:sldLayoutId xmlns:r="http://schemas.openxmlformats.org/officeDocument/2006/relationships" id="2147483649" r:id="Read78d50f41d43e6"/>
   </p:sldLayoutIdLst>
   <p:txStyles>
     <p:titleStyle>
@@ -1541,7 +1541,7 @@
           <p:cNvPr id="8" name="">
             <a:extLst xmlns:a="http://schemas.openxmlformats.org/drawingml/2006/main">
               <a:ext uri="{FF2B5EF4-FFF2-40B4-BE49-F238E27FC236}">
-                <a16:creationId xmlns:a16="http://schemas.microsoft.com/office/drawing/2014/main" id="{EE221133-9126-4986-8C21-60C98C6369B1}"/>
+                <a16:creationId xmlns:a16="http://schemas.microsoft.com/office/drawing/2014/main" id="{353B4117-DF56-4CED-82B4-FA048B7333B5}"/>
               </a:ext>
             </a:extLst>
           </p:cNvPr>
@@ -1576,7 +1576,7 @@
           <p:nvPr/>
         </p:nvPicPr>
         <p:blipFill>
-          <a:blip xmlns:r="http://schemas.openxmlformats.org/officeDocument/2006/relationships" xmlns:a="http://schemas.openxmlformats.org/drawingml/2006/main" r:embed="R6846adf8825245ee"/>
+          <a:blip xmlns:r="http://schemas.openxmlformats.org/officeDocument/2006/relationships" xmlns:a="http://schemas.openxmlformats.org/drawingml/2006/main" r:embed="R821f59b868794dd2"/>
           <a:stretch xmlns:a="http://schemas.openxmlformats.org/drawingml/2006/main"/>
         </p:blipFill>
         <p:spPr>
@@ -1594,7 +1594,7 @@
           <p:cNvPr id="3" name="">
             <a:extLst xmlns:a="http://schemas.openxmlformats.org/drawingml/2006/main">
               <a:ext uri="{FF2B5EF4-FFF2-40B4-BE49-F238E27FC236}">
-                <a16:creationId xmlns:a16="http://schemas.microsoft.com/office/drawing/2014/main" id="{57A09D82-9A85-4189-A298-E4B3F220C8CA}"/>
+                <a16:creationId xmlns:a16="http://schemas.microsoft.com/office/drawing/2014/main" id="{A0CFAB51-87E0-45A3-AC25-8AA439DAD37B}"/>
               </a:ext>
             </a:extLst>
           </p:cNvPr>
@@ -1650,7 +1650,7 @@
           <p:cNvPr id="4" name="">
             <a:extLst xmlns:a="http://schemas.openxmlformats.org/drawingml/2006/main">
               <a:ext uri="{FF2B5EF4-FFF2-40B4-BE49-F238E27FC236}">
-                <a16:creationId xmlns:a16="http://schemas.microsoft.com/office/drawing/2014/main" id="{3CB73DB1-D61E-4ADD-8658-811C106A1BDC}"/>
+                <a16:creationId xmlns:a16="http://schemas.microsoft.com/office/drawing/2014/main" id="{A9B1EED1-9CAE-413D-BB57-A065D5F040EC}"/>
               </a:ext>
             </a:extLst>
           </p:cNvPr>
@@ -1729,7 +1729,7 @@
           <p:cNvPr id="5" name="">
             <a:extLst xmlns:a="http://schemas.openxmlformats.org/drawingml/2006/main">
               <a:ext uri="{FF2B5EF4-FFF2-40B4-BE49-F238E27FC236}">
-                <a16:creationId xmlns:a16="http://schemas.microsoft.com/office/drawing/2014/main" id="{E3CE69F8-CF1D-4EAD-9883-0B8D7F6D4391}"/>
+                <a16:creationId xmlns:a16="http://schemas.microsoft.com/office/drawing/2014/main" id="{EE6D3BB0-7619-4517-AB77-2EB4AD080A7E}"/>
               </a:ext>
             </a:extLst>
           </p:cNvPr>
@@ -1760,7 +1760,7 @@
           <p:cNvPr id="6" name="">
             <a:extLst xmlns:a="http://schemas.openxmlformats.org/drawingml/2006/main">
               <a:ext uri="{FF2B5EF4-FFF2-40B4-BE49-F238E27FC236}">
-                <a16:creationId xmlns:a16="http://schemas.microsoft.com/office/drawing/2014/main" id="{89E4B472-A8E4-42B0-83FA-B1D7699BCE0A}"/>
+                <a16:creationId xmlns:a16="http://schemas.microsoft.com/office/drawing/2014/main" id="{2A3A620D-6A5D-4728-A595-1899F32AAA14}"/>
               </a:ext>
             </a:extLst>
           </p:cNvPr>
@@ -1839,7 +1839,7 @@
           <p:cNvPr id="7" name="">
             <a:extLst xmlns:a="http://schemas.openxmlformats.org/drawingml/2006/main">
               <a:ext uri="{FF2B5EF4-FFF2-40B4-BE49-F238E27FC236}">
-                <a16:creationId xmlns:a16="http://schemas.microsoft.com/office/drawing/2014/main" id="{40FEBDD2-59EF-45FE-864B-7755B54CDF57}"/>
+                <a16:creationId xmlns:a16="http://schemas.microsoft.com/office/drawing/2014/main" id="{617B7B41-E915-449E-91FD-72C6DA44004D}"/>
               </a:ext>
             </a:extLst>
           </p:cNvPr>
@@ -1885,7 +1885,7 @@
                 <a:ea typeface="Arial"/>
                 <a:cs typeface="Arial"/>
               </a:rPr>
-              <a:t>v1.1.1  •  2026</a:t>
+              <a:t>v1.1.2  •  2026</a:t>
             </a:r>
           </a:p>
         </p:txBody>
@@ -1893,7 +1893,7 @@
     </p:spTree>
     <p:extLst>
       <p:ext uri="{BB962C8B-B14F-4D97-AF65-F5344CB8AC3E}">
-        <p14:creationId xmlns:p14="http://schemas.microsoft.com/office/powerpoint/2010/main" val="1220145292"/>
+        <p14:creationId xmlns:p14="http://schemas.microsoft.com/office/powerpoint/2010/main" val="1883453455"/>
       </p:ext>
     </p:extLst>
   </p:cSld>
@@ -1924,7 +1924,7 @@
           <p:cNvPr id="21" name="">
             <a:extLst xmlns:a="http://schemas.openxmlformats.org/drawingml/2006/main">
               <a:ext uri="{FF2B5EF4-FFF2-40B4-BE49-F238E27FC236}">
-                <a16:creationId xmlns:a16="http://schemas.microsoft.com/office/drawing/2014/main" id="{0CFC3CE1-12AE-4B5D-B4CD-F66C91B886A1}"/>
+                <a16:creationId xmlns:a16="http://schemas.microsoft.com/office/drawing/2014/main" id="{5C2D4DFD-036C-4D33-A400-7DF9F21CA1CF}"/>
               </a:ext>
             </a:extLst>
           </p:cNvPr>
@@ -1980,7 +1980,7 @@
           <p:cNvPr id="2" name="">
             <a:extLst xmlns:a="http://schemas.openxmlformats.org/drawingml/2006/main">
               <a:ext uri="{FF2B5EF4-FFF2-40B4-BE49-F238E27FC236}">
-                <a16:creationId xmlns:a16="http://schemas.microsoft.com/office/drawing/2014/main" id="{470A00B2-BE97-41CA-B1F1-403241351927}"/>
+                <a16:creationId xmlns:a16="http://schemas.microsoft.com/office/drawing/2014/main" id="{0D3F1CD4-A547-478E-A025-653FE1C12A68}"/>
               </a:ext>
             </a:extLst>
           </p:cNvPr>
@@ -2036,7 +2036,7 @@
           <p:cNvPr id="3" name="">
             <a:extLst xmlns:a="http://schemas.openxmlformats.org/drawingml/2006/main">
               <a:ext uri="{FF2B5EF4-FFF2-40B4-BE49-F238E27FC236}">
-                <a16:creationId xmlns:a16="http://schemas.microsoft.com/office/drawing/2014/main" id="{2385F7D6-1539-403A-8287-8AA8A407D383}"/>
+                <a16:creationId xmlns:a16="http://schemas.microsoft.com/office/drawing/2014/main" id="{BE89797C-2939-4C0E-A17E-023548455478}"/>
               </a:ext>
             </a:extLst>
           </p:cNvPr>
@@ -2092,7 +2092,7 @@
           <p:cNvPr id="4" name="">
             <a:extLst xmlns:a="http://schemas.openxmlformats.org/drawingml/2006/main">
               <a:ext uri="{FF2B5EF4-FFF2-40B4-BE49-F238E27FC236}">
-                <a16:creationId xmlns:a16="http://schemas.microsoft.com/office/drawing/2014/main" id="{C0140CDE-A55D-4498-A1F6-494F520BD3DF}"/>
+                <a16:creationId xmlns:a16="http://schemas.microsoft.com/office/drawing/2014/main" id="{73B0C979-F687-4356-A144-D11765F59EA6}"/>
               </a:ext>
             </a:extLst>
           </p:cNvPr>
@@ -2148,7 +2148,7 @@
           <p:cNvPr id="5" name="">
             <a:extLst xmlns:a="http://schemas.openxmlformats.org/drawingml/2006/main">
               <a:ext uri="{FF2B5EF4-FFF2-40B4-BE49-F238E27FC236}">
-                <a16:creationId xmlns:a16="http://schemas.microsoft.com/office/drawing/2014/main" id="{23A4D4C3-527F-4654-AFC8-90F1CE3BAB6E}"/>
+                <a16:creationId xmlns:a16="http://schemas.microsoft.com/office/drawing/2014/main" id="{651679F2-3085-48EF-A5A9-5DD2918441F4}"/>
               </a:ext>
             </a:extLst>
           </p:cNvPr>
@@ -2179,7 +2179,7 @@
           <p:cNvPr id="6" name="">
             <a:extLst xmlns:a="http://schemas.openxmlformats.org/drawingml/2006/main">
               <a:ext uri="{FF2B5EF4-FFF2-40B4-BE49-F238E27FC236}">
-                <a16:creationId xmlns:a16="http://schemas.microsoft.com/office/drawing/2014/main" id="{840FE7BA-0C68-4813-9F07-C4F8C06D5BF5}"/>
+                <a16:creationId xmlns:a16="http://schemas.microsoft.com/office/drawing/2014/main" id="{763311C4-F3D9-4905-A768-E74664C318DD}"/>
               </a:ext>
             </a:extLst>
           </p:cNvPr>
@@ -2235,7 +2235,7 @@
           <p:cNvPr id="7" name="">
             <a:extLst xmlns:a="http://schemas.openxmlformats.org/drawingml/2006/main">
               <a:ext uri="{FF2B5EF4-FFF2-40B4-BE49-F238E27FC236}">
-                <a16:creationId xmlns:a16="http://schemas.microsoft.com/office/drawing/2014/main" id="{23DE6485-5CB1-45F0-B70F-F2E1DAA7F015}"/>
+                <a16:creationId xmlns:a16="http://schemas.microsoft.com/office/drawing/2014/main" id="{042134BC-5A3A-4434-BAC2-050E688FCB70}"/>
               </a:ext>
             </a:extLst>
           </p:cNvPr>
@@ -2291,7 +2291,7 @@
           <p:cNvPr id="8" name="">
             <a:extLst xmlns:a="http://schemas.openxmlformats.org/drawingml/2006/main">
               <a:ext uri="{FF2B5EF4-FFF2-40B4-BE49-F238E27FC236}">
-                <a16:creationId xmlns:a16="http://schemas.microsoft.com/office/drawing/2014/main" id="{AE28E124-8434-495A-9D1C-5EDC3320DE3F}"/>
+                <a16:creationId xmlns:a16="http://schemas.microsoft.com/office/drawing/2014/main" id="{6AACC1FA-290D-4C04-B194-EDDCD0EE5C72}"/>
               </a:ext>
             </a:extLst>
           </p:cNvPr>
@@ -2347,7 +2347,7 @@
           <p:cNvPr id="9" name="">
             <a:extLst xmlns:a="http://schemas.openxmlformats.org/drawingml/2006/main">
               <a:ext uri="{FF2B5EF4-FFF2-40B4-BE49-F238E27FC236}">
-                <a16:creationId xmlns:a16="http://schemas.microsoft.com/office/drawing/2014/main" id="{8B551CEE-2E37-4DD1-A464-A7F404786215}"/>
+                <a16:creationId xmlns:a16="http://schemas.microsoft.com/office/drawing/2014/main" id="{4F556DB4-B675-43A2-8409-929C3AAA9193}"/>
               </a:ext>
             </a:extLst>
           </p:cNvPr>
@@ -2378,7 +2378,7 @@
           <p:cNvPr id="10" name="">
             <a:extLst xmlns:a="http://schemas.openxmlformats.org/drawingml/2006/main">
               <a:ext uri="{FF2B5EF4-FFF2-40B4-BE49-F238E27FC236}">
-                <a16:creationId xmlns:a16="http://schemas.microsoft.com/office/drawing/2014/main" id="{95DD0CD7-B308-4CF3-B7EB-10518C248AF2}"/>
+                <a16:creationId xmlns:a16="http://schemas.microsoft.com/office/drawing/2014/main" id="{6070EF02-16DB-415A-8387-17910AEDC470}"/>
               </a:ext>
             </a:extLst>
           </p:cNvPr>
@@ -2434,7 +2434,7 @@
           <p:cNvPr id="11" name="">
             <a:extLst xmlns:a="http://schemas.openxmlformats.org/drawingml/2006/main">
               <a:ext uri="{FF2B5EF4-FFF2-40B4-BE49-F238E27FC236}">
-                <a16:creationId xmlns:a16="http://schemas.microsoft.com/office/drawing/2014/main" id="{E8D2DB7C-E72D-4983-89F4-D1D03E3AAA09}"/>
+                <a16:creationId xmlns:a16="http://schemas.microsoft.com/office/drawing/2014/main" id="{90C966CD-7F36-4931-B189-F47FB4E01675}"/>
               </a:ext>
             </a:extLst>
           </p:cNvPr>
@@ -2490,7 +2490,7 @@
           <p:cNvPr id="12" name="">
             <a:extLst xmlns:a="http://schemas.openxmlformats.org/drawingml/2006/main">
               <a:ext uri="{FF2B5EF4-FFF2-40B4-BE49-F238E27FC236}">
-                <a16:creationId xmlns:a16="http://schemas.microsoft.com/office/drawing/2014/main" id="{7BE53633-F1C4-411A-902B-E9FF7E5A6185}"/>
+                <a16:creationId xmlns:a16="http://schemas.microsoft.com/office/drawing/2014/main" id="{B2461FA2-8AA5-47F3-8AE0-B2105C150158}"/>
               </a:ext>
             </a:extLst>
           </p:cNvPr>
@@ -2546,7 +2546,7 @@
           <p:cNvPr id="13" name="">
             <a:extLst xmlns:a="http://schemas.openxmlformats.org/drawingml/2006/main">
               <a:ext uri="{FF2B5EF4-FFF2-40B4-BE49-F238E27FC236}">
-                <a16:creationId xmlns:a16="http://schemas.microsoft.com/office/drawing/2014/main" id="{1AF75978-1E78-4DE3-9EC4-1BE6349361E4}"/>
+                <a16:creationId xmlns:a16="http://schemas.microsoft.com/office/drawing/2014/main" id="{D0886755-8E05-4E9B-BD30-14E5F2355706}"/>
               </a:ext>
             </a:extLst>
           </p:cNvPr>
@@ -2577,7 +2577,7 @@
           <p:cNvPr id="14" name="">
             <a:extLst xmlns:a="http://schemas.openxmlformats.org/drawingml/2006/main">
               <a:ext uri="{FF2B5EF4-FFF2-40B4-BE49-F238E27FC236}">
-                <a16:creationId xmlns:a16="http://schemas.microsoft.com/office/drawing/2014/main" id="{3DA4148D-4ACE-487E-93D7-EF8488523BC9}"/>
+                <a16:creationId xmlns:a16="http://schemas.microsoft.com/office/drawing/2014/main" id="{954E2D9D-7073-464C-9A91-FA915C9CB1DF}"/>
               </a:ext>
             </a:extLst>
           </p:cNvPr>
@@ -2633,7 +2633,7 @@
           <p:cNvPr id="15" name="">
             <a:extLst xmlns:a="http://schemas.openxmlformats.org/drawingml/2006/main">
               <a:ext uri="{FF2B5EF4-FFF2-40B4-BE49-F238E27FC236}">
-                <a16:creationId xmlns:a16="http://schemas.microsoft.com/office/drawing/2014/main" id="{C35BEFE0-C598-409F-8F44-B1EAAD9F7608}"/>
+                <a16:creationId xmlns:a16="http://schemas.microsoft.com/office/drawing/2014/main" id="{CED3FE09-7BD9-40F2-8D40-DB12BF73FC21}"/>
               </a:ext>
             </a:extLst>
           </p:cNvPr>
@@ -2689,7 +2689,7 @@
           <p:cNvPr id="16" name="">
             <a:extLst xmlns:a="http://schemas.openxmlformats.org/drawingml/2006/main">
               <a:ext uri="{FF2B5EF4-FFF2-40B4-BE49-F238E27FC236}">
-                <a16:creationId xmlns:a16="http://schemas.microsoft.com/office/drawing/2014/main" id="{1560B532-F64A-44BB-8102-7AC15E366FA9}"/>
+                <a16:creationId xmlns:a16="http://schemas.microsoft.com/office/drawing/2014/main" id="{820A04CF-D96C-430E-B988-DFEEB2DFE279}"/>
               </a:ext>
             </a:extLst>
           </p:cNvPr>
@@ -2745,7 +2745,7 @@
           <p:cNvPr id="17" name="">
             <a:extLst xmlns:a="http://schemas.openxmlformats.org/drawingml/2006/main">
               <a:ext uri="{FF2B5EF4-FFF2-40B4-BE49-F238E27FC236}">
-                <a16:creationId xmlns:a16="http://schemas.microsoft.com/office/drawing/2014/main" id="{E549BC7A-A0F6-4E2D-B86F-399C382B6584}"/>
+                <a16:creationId xmlns:a16="http://schemas.microsoft.com/office/drawing/2014/main" id="{67F40C74-AE62-4FCF-ADFC-FABA8CEBA474}"/>
               </a:ext>
             </a:extLst>
           </p:cNvPr>
@@ -2776,7 +2776,7 @@
           <p:cNvPr id="18" name="">
             <a:extLst xmlns:a="http://schemas.openxmlformats.org/drawingml/2006/main">
               <a:ext uri="{FF2B5EF4-FFF2-40B4-BE49-F238E27FC236}">
-                <a16:creationId xmlns:a16="http://schemas.microsoft.com/office/drawing/2014/main" id="{6901EB48-6CD8-45EB-9F61-DDC6816BF52B}"/>
+                <a16:creationId xmlns:a16="http://schemas.microsoft.com/office/drawing/2014/main" id="{DD3525D2-63A9-4413-ADD5-40CCCA3E96C0}"/>
               </a:ext>
             </a:extLst>
           </p:cNvPr>
@@ -2832,7 +2832,7 @@
           <p:cNvPr id="19" name="">
             <a:extLst xmlns:a="http://schemas.openxmlformats.org/drawingml/2006/main">
               <a:ext uri="{FF2B5EF4-FFF2-40B4-BE49-F238E27FC236}">
-                <a16:creationId xmlns:a16="http://schemas.microsoft.com/office/drawing/2014/main" id="{C7694AA0-E126-4BF3-8F62-EA22777E82D7}"/>
+                <a16:creationId xmlns:a16="http://schemas.microsoft.com/office/drawing/2014/main" id="{E9AB6F5C-85CA-46D9-BE13-2A36FFFE7BD7}"/>
               </a:ext>
             </a:extLst>
           </p:cNvPr>
@@ -2888,7 +2888,7 @@
           <p:cNvPr id="20" name="">
             <a:extLst xmlns:a="http://schemas.openxmlformats.org/drawingml/2006/main">
               <a:ext uri="{FF2B5EF4-FFF2-40B4-BE49-F238E27FC236}">
-                <a16:creationId xmlns:a16="http://schemas.microsoft.com/office/drawing/2014/main" id="{47DD8099-5B0D-4A80-9788-648235209455}"/>
+                <a16:creationId xmlns:a16="http://schemas.microsoft.com/office/drawing/2014/main" id="{405CE2DD-8286-42AF-BF8C-8EFEDEB8F8C2}"/>
               </a:ext>
             </a:extLst>
           </p:cNvPr>
@@ -2942,7 +2942,7 @@
     </p:spTree>
     <p:extLst>
       <p:ext uri="{BB962C8B-B14F-4D97-AF65-F5344CB8AC3E}">
-        <p14:creationId xmlns:p14="http://schemas.microsoft.com/office/powerpoint/2010/main" val="1105694363"/>
+        <p14:creationId xmlns:p14="http://schemas.microsoft.com/office/powerpoint/2010/main" val="1278148963"/>
       </p:ext>
     </p:extLst>
   </p:cSld>
@@ -2973,7 +2973,7 @@
           <p:cNvPr id="23" name="">
             <a:extLst xmlns:a="http://schemas.openxmlformats.org/drawingml/2006/main">
               <a:ext uri="{FF2B5EF4-FFF2-40B4-BE49-F238E27FC236}">
-                <a16:creationId xmlns:a16="http://schemas.microsoft.com/office/drawing/2014/main" id="{5D27891D-96BA-4331-96D9-53CF3CC9CBEC}"/>
+                <a16:creationId xmlns:a16="http://schemas.microsoft.com/office/drawing/2014/main" id="{B519A116-A7A0-4A90-9192-BC5380917AF8}"/>
               </a:ext>
             </a:extLst>
           </p:cNvPr>
@@ -3029,7 +3029,7 @@
           <p:cNvPr id="2" name="">
             <a:extLst xmlns:a="http://schemas.openxmlformats.org/drawingml/2006/main">
               <a:ext uri="{FF2B5EF4-FFF2-40B4-BE49-F238E27FC236}">
-                <a16:creationId xmlns:a16="http://schemas.microsoft.com/office/drawing/2014/main" id="{484D72C1-36DA-4EDF-B641-782FADC82B9C}"/>
+                <a16:creationId xmlns:a16="http://schemas.microsoft.com/office/drawing/2014/main" id="{4246E68B-8AA9-44BD-82A3-AD84B410A0AC}"/>
               </a:ext>
             </a:extLst>
           </p:cNvPr>
@@ -3085,7 +3085,7 @@
           <p:cNvPr id="3" name="">
             <a:extLst xmlns:a="http://schemas.openxmlformats.org/drawingml/2006/main">
               <a:ext uri="{FF2B5EF4-FFF2-40B4-BE49-F238E27FC236}">
-                <a16:creationId xmlns:a16="http://schemas.microsoft.com/office/drawing/2014/main" id="{85ABA2A8-0BFC-4C40-8310-043D16295451}"/>
+                <a16:creationId xmlns:a16="http://schemas.microsoft.com/office/drawing/2014/main" id="{F5921A1E-CBD0-4CF1-B1D0-FC1E7639DE44}"/>
               </a:ext>
             </a:extLst>
           </p:cNvPr>
@@ -3141,7 +3141,7 @@
           <p:cNvPr id="4" name="">
             <a:extLst xmlns:a="http://schemas.openxmlformats.org/drawingml/2006/main">
               <a:ext uri="{FF2B5EF4-FFF2-40B4-BE49-F238E27FC236}">
-                <a16:creationId xmlns:a16="http://schemas.microsoft.com/office/drawing/2014/main" id="{79127A6B-9D9B-4B82-9336-85B76190423C}"/>
+                <a16:creationId xmlns:a16="http://schemas.microsoft.com/office/drawing/2014/main" id="{940568D0-E60C-45B4-93C9-4F57E3CB81D0}"/>
               </a:ext>
             </a:extLst>
           </p:cNvPr>
@@ -3197,7 +3197,7 @@
           <p:cNvPr id="5" name="">
             <a:extLst xmlns:a="http://schemas.openxmlformats.org/drawingml/2006/main">
               <a:ext uri="{FF2B5EF4-FFF2-40B4-BE49-F238E27FC236}">
-                <a16:creationId xmlns:a16="http://schemas.microsoft.com/office/drawing/2014/main" id="{EF577387-771F-4CD8-9245-E30AA884075E}"/>
+                <a16:creationId xmlns:a16="http://schemas.microsoft.com/office/drawing/2014/main" id="{70ACF512-82BE-4A72-B064-CB1A28347887}"/>
               </a:ext>
             </a:extLst>
           </p:cNvPr>
@@ -3228,7 +3228,7 @@
           <p:cNvPr id="6" name="">
             <a:extLst xmlns:a="http://schemas.openxmlformats.org/drawingml/2006/main">
               <a:ext uri="{FF2B5EF4-FFF2-40B4-BE49-F238E27FC236}">
-                <a16:creationId xmlns:a16="http://schemas.microsoft.com/office/drawing/2014/main" id="{07665F78-8053-43AB-BAB2-B234E98CC0F0}"/>
+                <a16:creationId xmlns:a16="http://schemas.microsoft.com/office/drawing/2014/main" id="{9548A2FE-424A-49E1-BE11-55D9F09B6CFB}"/>
               </a:ext>
             </a:extLst>
           </p:cNvPr>
@@ -3284,7 +3284,7 @@
           <p:cNvPr id="7" name="">
             <a:extLst xmlns:a="http://schemas.openxmlformats.org/drawingml/2006/main">
               <a:ext uri="{FF2B5EF4-FFF2-40B4-BE49-F238E27FC236}">
-                <a16:creationId xmlns:a16="http://schemas.microsoft.com/office/drawing/2014/main" id="{61EA9686-CD72-4C8A-844D-6EDFD3ED2F38}"/>
+                <a16:creationId xmlns:a16="http://schemas.microsoft.com/office/drawing/2014/main" id="{A86F773B-C1B4-4A19-AE6C-789165C32169}"/>
               </a:ext>
             </a:extLst>
           </p:cNvPr>
@@ -3340,7 +3340,7 @@
           <p:cNvPr id="8" name="">
             <a:extLst xmlns:a="http://schemas.openxmlformats.org/drawingml/2006/main">
               <a:ext uri="{FF2B5EF4-FFF2-40B4-BE49-F238E27FC236}">
-                <a16:creationId xmlns:a16="http://schemas.microsoft.com/office/drawing/2014/main" id="{149F4B94-DF4B-4FC2-930D-E8ACAF597D74}"/>
+                <a16:creationId xmlns:a16="http://schemas.microsoft.com/office/drawing/2014/main" id="{BD2164DE-1238-4055-BD05-9C7C39C9578E}"/>
               </a:ext>
             </a:extLst>
           </p:cNvPr>
@@ -3396,7 +3396,7 @@
           <p:cNvPr id="9" name="">
             <a:extLst xmlns:a="http://schemas.openxmlformats.org/drawingml/2006/main">
               <a:ext uri="{FF2B5EF4-FFF2-40B4-BE49-F238E27FC236}">
-                <a16:creationId xmlns:a16="http://schemas.microsoft.com/office/drawing/2014/main" id="{2AB0FB6B-A171-4068-86CC-C075A946571E}"/>
+                <a16:creationId xmlns:a16="http://schemas.microsoft.com/office/drawing/2014/main" id="{F7B927B1-98CF-4A1B-AC6D-40CBD5FCF3F5}"/>
               </a:ext>
             </a:extLst>
           </p:cNvPr>
@@ -3427,7 +3427,7 @@
           <p:cNvPr id="10" name="">
             <a:extLst xmlns:a="http://schemas.openxmlformats.org/drawingml/2006/main">
               <a:ext uri="{FF2B5EF4-FFF2-40B4-BE49-F238E27FC236}">
-                <a16:creationId xmlns:a16="http://schemas.microsoft.com/office/drawing/2014/main" id="{485A5E9D-CD58-40CC-AD0E-71C7D7707480}"/>
+                <a16:creationId xmlns:a16="http://schemas.microsoft.com/office/drawing/2014/main" id="{D39450EC-DFE0-41FD-A784-BEBCF85CEB23}"/>
               </a:ext>
             </a:extLst>
           </p:cNvPr>
@@ -3483,7 +3483,7 @@
           <p:cNvPr id="11" name="">
             <a:extLst xmlns:a="http://schemas.openxmlformats.org/drawingml/2006/main">
               <a:ext uri="{FF2B5EF4-FFF2-40B4-BE49-F238E27FC236}">
-                <a16:creationId xmlns:a16="http://schemas.microsoft.com/office/drawing/2014/main" id="{7EBF5549-B0D1-426F-B0D1-4DB734EB62AF}"/>
+                <a16:creationId xmlns:a16="http://schemas.microsoft.com/office/drawing/2014/main" id="{61738087-D73A-4670-ABCE-18F2FB835429}"/>
               </a:ext>
             </a:extLst>
           </p:cNvPr>
@@ -3539,7 +3539,7 @@
           <p:cNvPr id="12" name="">
             <a:extLst xmlns:a="http://schemas.openxmlformats.org/drawingml/2006/main">
               <a:ext uri="{FF2B5EF4-FFF2-40B4-BE49-F238E27FC236}">
-                <a16:creationId xmlns:a16="http://schemas.microsoft.com/office/drawing/2014/main" id="{707277C0-03A0-48A5-BEB3-A5AAA4B22E6E}"/>
+                <a16:creationId xmlns:a16="http://schemas.microsoft.com/office/drawing/2014/main" id="{BA732AB3-08A4-4A7C-84A6-9E1A3B2EEB1B}"/>
               </a:ext>
             </a:extLst>
           </p:cNvPr>
@@ -3595,7 +3595,7 @@
           <p:cNvPr id="13" name="">
             <a:extLst xmlns:a="http://schemas.openxmlformats.org/drawingml/2006/main">
               <a:ext uri="{FF2B5EF4-FFF2-40B4-BE49-F238E27FC236}">
-                <a16:creationId xmlns:a16="http://schemas.microsoft.com/office/drawing/2014/main" id="{A91A1EFD-EE86-4C6A-9A3D-B3B6D7D1CDBF}"/>
+                <a16:creationId xmlns:a16="http://schemas.microsoft.com/office/drawing/2014/main" id="{E106359E-602F-47FA-AFD9-69CBBC5BC53F}"/>
               </a:ext>
             </a:extLst>
           </p:cNvPr>
@@ -3626,7 +3626,7 @@
           <p:cNvPr id="14" name="">
             <a:extLst xmlns:a="http://schemas.openxmlformats.org/drawingml/2006/main">
               <a:ext uri="{FF2B5EF4-FFF2-40B4-BE49-F238E27FC236}">
-                <a16:creationId xmlns:a16="http://schemas.microsoft.com/office/drawing/2014/main" id="{9D5A282A-B122-40F0-AB6B-C4401CADA8CD}"/>
+                <a16:creationId xmlns:a16="http://schemas.microsoft.com/office/drawing/2014/main" id="{412A59C3-906A-439C-A727-6AB9E721FA62}"/>
               </a:ext>
             </a:extLst>
           </p:cNvPr>
@@ -3682,7 +3682,7 @@
           <p:cNvPr id="15" name="">
             <a:extLst xmlns:a="http://schemas.openxmlformats.org/drawingml/2006/main">
               <a:ext uri="{FF2B5EF4-FFF2-40B4-BE49-F238E27FC236}">
-                <a16:creationId xmlns:a16="http://schemas.microsoft.com/office/drawing/2014/main" id="{BFFE5C12-7962-466A-8AA4-3C7865D6CDA4}"/>
+                <a16:creationId xmlns:a16="http://schemas.microsoft.com/office/drawing/2014/main" id="{E4C7BAAB-8662-4B58-9F7B-0E2AC70AC707}"/>
               </a:ext>
             </a:extLst>
           </p:cNvPr>
@@ -3738,7 +3738,7 @@
           <p:cNvPr id="16" name="">
             <a:extLst xmlns:a="http://schemas.openxmlformats.org/drawingml/2006/main">
               <a:ext uri="{FF2B5EF4-FFF2-40B4-BE49-F238E27FC236}">
-                <a16:creationId xmlns:a16="http://schemas.microsoft.com/office/drawing/2014/main" id="{7EFD8116-D0D7-4021-9B29-5D3089589FE2}"/>
+                <a16:creationId xmlns:a16="http://schemas.microsoft.com/office/drawing/2014/main" id="{62048A41-F9F5-4A4A-8702-FB2FFFEE77AF}"/>
               </a:ext>
             </a:extLst>
           </p:cNvPr>
@@ -3794,7 +3794,7 @@
           <p:cNvPr id="17" name="">
             <a:extLst xmlns:a="http://schemas.openxmlformats.org/drawingml/2006/main">
               <a:ext uri="{FF2B5EF4-FFF2-40B4-BE49-F238E27FC236}">
-                <a16:creationId xmlns:a16="http://schemas.microsoft.com/office/drawing/2014/main" id="{13CE6921-2C37-4F0B-9BCE-BF1E2BD19F15}"/>
+                <a16:creationId xmlns:a16="http://schemas.microsoft.com/office/drawing/2014/main" id="{35AFD851-6925-4564-B463-A59668CA2EA5}"/>
               </a:ext>
             </a:extLst>
           </p:cNvPr>
@@ -3825,7 +3825,7 @@
           <p:cNvPr id="18" name="">
             <a:extLst xmlns:a="http://schemas.openxmlformats.org/drawingml/2006/main">
               <a:ext uri="{FF2B5EF4-FFF2-40B4-BE49-F238E27FC236}">
-                <a16:creationId xmlns:a16="http://schemas.microsoft.com/office/drawing/2014/main" id="{D279676F-15AF-4435-A310-9A2E9D87E792}"/>
+                <a16:creationId xmlns:a16="http://schemas.microsoft.com/office/drawing/2014/main" id="{D5D00F54-85B7-46E1-A5FB-53081C62E1C3}"/>
               </a:ext>
             </a:extLst>
           </p:cNvPr>
@@ -3881,7 +3881,7 @@
           <p:cNvPr id="19" name="">
             <a:extLst xmlns:a="http://schemas.openxmlformats.org/drawingml/2006/main">
               <a:ext uri="{FF2B5EF4-FFF2-40B4-BE49-F238E27FC236}">
-                <a16:creationId xmlns:a16="http://schemas.microsoft.com/office/drawing/2014/main" id="{63D80FB3-4C54-448B-B5CC-7239C0BD7EF9}"/>
+                <a16:creationId xmlns:a16="http://schemas.microsoft.com/office/drawing/2014/main" id="{6CCAF9E5-A528-4717-A2FC-D5D778A1CEE3}"/>
               </a:ext>
             </a:extLst>
           </p:cNvPr>
@@ -3937,7 +3937,7 @@
           <p:cNvPr id="20" name="">
             <a:extLst xmlns:a="http://schemas.openxmlformats.org/drawingml/2006/main">
               <a:ext uri="{FF2B5EF4-FFF2-40B4-BE49-F238E27FC236}">
-                <a16:creationId xmlns:a16="http://schemas.microsoft.com/office/drawing/2014/main" id="{6D8B190E-9FA0-4C24-8EC2-7FD5564970B3}"/>
+                <a16:creationId xmlns:a16="http://schemas.microsoft.com/office/drawing/2014/main" id="{2450319E-FC67-401D-8F71-37EB3A60C05E}"/>
               </a:ext>
             </a:extLst>
           </p:cNvPr>
@@ -3993,7 +3993,7 @@
           <p:cNvPr id="21" name="">
             <a:extLst xmlns:a="http://schemas.openxmlformats.org/drawingml/2006/main">
               <a:ext uri="{FF2B5EF4-FFF2-40B4-BE49-F238E27FC236}">
-                <a16:creationId xmlns:a16="http://schemas.microsoft.com/office/drawing/2014/main" id="{A416918E-A27C-49CF-B7FA-C1787ECDF0E2}"/>
+                <a16:creationId xmlns:a16="http://schemas.microsoft.com/office/drawing/2014/main" id="{82498086-2941-49CC-8C46-B65E0EFA080C}"/>
               </a:ext>
             </a:extLst>
           </p:cNvPr>
@@ -4024,7 +4024,7 @@
           <p:cNvPr id="22" name="">
             <a:extLst xmlns:a="http://schemas.openxmlformats.org/drawingml/2006/main">
               <a:ext uri="{FF2B5EF4-FFF2-40B4-BE49-F238E27FC236}">
-                <a16:creationId xmlns:a16="http://schemas.microsoft.com/office/drawing/2014/main" id="{134BC8BC-A9A7-46A8-B531-311A92AFC2D5}"/>
+                <a16:creationId xmlns:a16="http://schemas.microsoft.com/office/drawing/2014/main" id="{55DE1320-D9C4-4CF7-BA23-839DA2418EAE}"/>
               </a:ext>
             </a:extLst>
           </p:cNvPr>
@@ -4078,7 +4078,7 @@
     </p:spTree>
     <p:extLst>
       <p:ext uri="{BB962C8B-B14F-4D97-AF65-F5344CB8AC3E}">
-        <p14:creationId xmlns:p14="http://schemas.microsoft.com/office/powerpoint/2010/main" val="1354669235"/>
+        <p14:creationId xmlns:p14="http://schemas.microsoft.com/office/powerpoint/2010/main" val="1617368759"/>
       </p:ext>
     </p:extLst>
   </p:cSld>
@@ -4109,7 +4109,7 @@
           <p:cNvPr id="9" name="">
             <a:extLst xmlns:a="http://schemas.openxmlformats.org/drawingml/2006/main">
               <a:ext uri="{FF2B5EF4-FFF2-40B4-BE49-F238E27FC236}">
-                <a16:creationId xmlns:a16="http://schemas.microsoft.com/office/drawing/2014/main" id="{DB363743-791E-48E5-BCEE-43349B9E1735}"/>
+                <a16:creationId xmlns:a16="http://schemas.microsoft.com/office/drawing/2014/main" id="{494C691F-539E-4151-99B3-5ED2AF2EE076}"/>
               </a:ext>
             </a:extLst>
           </p:cNvPr>
@@ -4165,7 +4165,7 @@
           <p:cNvPr id="2" name="">
             <a:extLst xmlns:a="http://schemas.openxmlformats.org/drawingml/2006/main">
               <a:ext uri="{FF2B5EF4-FFF2-40B4-BE49-F238E27FC236}">
-                <a16:creationId xmlns:a16="http://schemas.microsoft.com/office/drawing/2014/main" id="{535EF648-B44A-427C-A0B6-89CE65B27354}"/>
+                <a16:creationId xmlns:a16="http://schemas.microsoft.com/office/drawing/2014/main" id="{0FF0DFD3-2588-4009-AE26-E260ED2E09E4}"/>
               </a:ext>
             </a:extLst>
           </p:cNvPr>
@@ -4221,7 +4221,7 @@
           <p:cNvPr id="3" name="">
             <a:extLst xmlns:a="http://schemas.openxmlformats.org/drawingml/2006/main">
               <a:ext uri="{FF2B5EF4-FFF2-40B4-BE49-F238E27FC236}">
-                <a16:creationId xmlns:a16="http://schemas.microsoft.com/office/drawing/2014/main" id="{6B73DB4F-9E3C-4361-A099-5A4ED48C1418}"/>
+                <a16:creationId xmlns:a16="http://schemas.microsoft.com/office/drawing/2014/main" id="{E34B8AF5-C734-491C-9589-DE3E1D2352FB}"/>
               </a:ext>
             </a:extLst>
           </p:cNvPr>
@@ -4277,7 +4277,7 @@
           <p:cNvPr id="4" name="">
             <a:extLst xmlns:a="http://schemas.openxmlformats.org/drawingml/2006/main">
               <a:ext uri="{FF2B5EF4-FFF2-40B4-BE49-F238E27FC236}">
-                <a16:creationId xmlns:a16="http://schemas.microsoft.com/office/drawing/2014/main" id="{DDD7FD7C-8B0A-4896-A514-26AAB00A9FB4}"/>
+                <a16:creationId xmlns:a16="http://schemas.microsoft.com/office/drawing/2014/main" id="{ECAAF5FA-706A-4B36-8D6A-DAAE5F4B30EC}"/>
               </a:ext>
             </a:extLst>
           </p:cNvPr>
@@ -4333,7 +4333,7 @@
           <p:cNvPr id="5" name="">
             <a:extLst xmlns:a="http://schemas.openxmlformats.org/drawingml/2006/main">
               <a:ext uri="{FF2B5EF4-FFF2-40B4-BE49-F238E27FC236}">
-                <a16:creationId xmlns:a16="http://schemas.microsoft.com/office/drawing/2014/main" id="{15422472-0F1A-42D6-8337-661BB44802CE}"/>
+                <a16:creationId xmlns:a16="http://schemas.microsoft.com/office/drawing/2014/main" id="{F9D92EBE-78CB-4AE0-9067-45284C1EF3BB}"/>
               </a:ext>
             </a:extLst>
           </p:cNvPr>
@@ -4473,7 +4473,7 @@
           <p:cNvPr id="6" name="">
             <a:extLst xmlns:a="http://schemas.openxmlformats.org/drawingml/2006/main">
               <a:ext uri="{FF2B5EF4-FFF2-40B4-BE49-F238E27FC236}">
-                <a16:creationId xmlns:a16="http://schemas.microsoft.com/office/drawing/2014/main" id="{4090CCA2-1E7B-4EDE-8AD3-EBA540B14A60}"/>
+                <a16:creationId xmlns:a16="http://schemas.microsoft.com/office/drawing/2014/main" id="{805C1DD2-504F-4AE7-A881-714530D3D5FD}"/>
               </a:ext>
             </a:extLst>
           </p:cNvPr>
@@ -4510,7 +4510,7 @@
           <p:nvPr/>
         </p:nvPicPr>
         <p:blipFill>
-          <a:blip xmlns:r="http://schemas.openxmlformats.org/officeDocument/2006/relationships" xmlns:a="http://schemas.openxmlformats.org/drawingml/2006/main" r:embed="R5a34a42ebac0476d"/>
+          <a:blip xmlns:r="http://schemas.openxmlformats.org/officeDocument/2006/relationships" xmlns:a="http://schemas.openxmlformats.org/drawingml/2006/main" r:embed="R8eed80d6d7dd43ec"/>
           <a:stretch xmlns:a="http://schemas.openxmlformats.org/drawingml/2006/main"/>
         </p:blipFill>
         <p:spPr>
@@ -4528,7 +4528,7 @@
           <p:cNvPr id="8" name="">
             <a:extLst xmlns:a="http://schemas.openxmlformats.org/drawingml/2006/main">
               <a:ext uri="{FF2B5EF4-FFF2-40B4-BE49-F238E27FC236}">
-                <a16:creationId xmlns:a16="http://schemas.microsoft.com/office/drawing/2014/main" id="{441EACC7-3164-42D0-B797-3E50CE55FACE}"/>
+                <a16:creationId xmlns:a16="http://schemas.microsoft.com/office/drawing/2014/main" id="{88C81BBB-4073-4279-8336-FAE41F314036}"/>
               </a:ext>
             </a:extLst>
           </p:cNvPr>
@@ -4582,7 +4582,7 @@
     </p:spTree>
     <p:extLst>
       <p:ext uri="{BB962C8B-B14F-4D97-AF65-F5344CB8AC3E}">
-        <p14:creationId xmlns:p14="http://schemas.microsoft.com/office/powerpoint/2010/main" val="1848537086"/>
+        <p14:creationId xmlns:p14="http://schemas.microsoft.com/office/powerpoint/2010/main" val="129126999"/>
       </p:ext>
     </p:extLst>
   </p:cSld>
@@ -4613,7 +4613,7 @@
           <p:cNvPr id="15" name="">
             <a:extLst xmlns:a="http://schemas.openxmlformats.org/drawingml/2006/main">
               <a:ext uri="{FF2B5EF4-FFF2-40B4-BE49-F238E27FC236}">
-                <a16:creationId xmlns:a16="http://schemas.microsoft.com/office/drawing/2014/main" id="{66B79C26-0F85-496C-9A59-CE28AC120372}"/>
+                <a16:creationId xmlns:a16="http://schemas.microsoft.com/office/drawing/2014/main" id="{FEA40A80-22F4-467C-87F9-7672E0788B9C}"/>
               </a:ext>
             </a:extLst>
           </p:cNvPr>
@@ -4669,7 +4669,7 @@
           <p:cNvPr id="2" name="">
             <a:extLst xmlns:a="http://schemas.openxmlformats.org/drawingml/2006/main">
               <a:ext uri="{FF2B5EF4-FFF2-40B4-BE49-F238E27FC236}">
-                <a16:creationId xmlns:a16="http://schemas.microsoft.com/office/drawing/2014/main" id="{25D01973-E5C5-4524-BAD8-096EFD493DAE}"/>
+                <a16:creationId xmlns:a16="http://schemas.microsoft.com/office/drawing/2014/main" id="{E2FE9937-8B9E-493F-B92E-1FA51797B643}"/>
               </a:ext>
             </a:extLst>
           </p:cNvPr>
@@ -4725,7 +4725,7 @@
           <p:cNvPr id="3" name="">
             <a:extLst xmlns:a="http://schemas.openxmlformats.org/drawingml/2006/main">
               <a:ext uri="{FF2B5EF4-FFF2-40B4-BE49-F238E27FC236}">
-                <a16:creationId xmlns:a16="http://schemas.microsoft.com/office/drawing/2014/main" id="{7B185399-0C76-479A-9A7E-26443A54F50D}"/>
+                <a16:creationId xmlns:a16="http://schemas.microsoft.com/office/drawing/2014/main" id="{FF66B10C-E554-4177-989A-E1DCA99E4A8A}"/>
               </a:ext>
             </a:extLst>
           </p:cNvPr>
@@ -4781,7 +4781,7 @@
           <p:cNvPr id="4" name="">
             <a:extLst xmlns:a="http://schemas.openxmlformats.org/drawingml/2006/main">
               <a:ext uri="{FF2B5EF4-FFF2-40B4-BE49-F238E27FC236}">
-                <a16:creationId xmlns:a16="http://schemas.microsoft.com/office/drawing/2014/main" id="{33F5A637-9564-4866-87CE-557E79EA7BD5}"/>
+                <a16:creationId xmlns:a16="http://schemas.microsoft.com/office/drawing/2014/main" id="{DCA56932-0194-4A58-81FD-14E2F6DA281C}"/>
               </a:ext>
             </a:extLst>
           </p:cNvPr>
@@ -4837,7 +4837,7 @@
           <p:cNvPr id="5" name="">
             <a:extLst xmlns:a="http://schemas.openxmlformats.org/drawingml/2006/main">
               <a:ext uri="{FF2B5EF4-FFF2-40B4-BE49-F238E27FC236}">
-                <a16:creationId xmlns:a16="http://schemas.microsoft.com/office/drawing/2014/main" id="{F1EC132B-319F-4EC6-9761-13E4C415E531}"/>
+                <a16:creationId xmlns:a16="http://schemas.microsoft.com/office/drawing/2014/main" id="{D10954E9-61FF-422D-BC8C-312B04EC16E1}"/>
               </a:ext>
             </a:extLst>
           </p:cNvPr>
@@ -4868,7 +4868,7 @@
           <p:cNvPr id="6" name="">
             <a:extLst xmlns:a="http://schemas.openxmlformats.org/drawingml/2006/main">
               <a:ext uri="{FF2B5EF4-FFF2-40B4-BE49-F238E27FC236}">
-                <a16:creationId xmlns:a16="http://schemas.microsoft.com/office/drawing/2014/main" id="{E9AFDC7B-4A57-421B-9589-843BE0116232}"/>
+                <a16:creationId xmlns:a16="http://schemas.microsoft.com/office/drawing/2014/main" id="{D8A24BE0-154F-4EA6-BFED-4419BA552CBA}"/>
               </a:ext>
             </a:extLst>
           </p:cNvPr>
@@ -4899,7 +4899,7 @@
           <p:cNvPr id="7" name="">
             <a:extLst xmlns:a="http://schemas.openxmlformats.org/drawingml/2006/main">
               <a:ext uri="{FF2B5EF4-FFF2-40B4-BE49-F238E27FC236}">
-                <a16:creationId xmlns:a16="http://schemas.microsoft.com/office/drawing/2014/main" id="{B496A798-347E-45FE-8E57-4513EFDCD880}"/>
+                <a16:creationId xmlns:a16="http://schemas.microsoft.com/office/drawing/2014/main" id="{92355CC2-217A-45E6-A3EF-C1711C48FC6A}"/>
               </a:ext>
             </a:extLst>
           </p:cNvPr>
@@ -4955,7 +4955,7 @@
           <p:cNvPr id="8" name="">
             <a:extLst xmlns:a="http://schemas.openxmlformats.org/drawingml/2006/main">
               <a:ext uri="{FF2B5EF4-FFF2-40B4-BE49-F238E27FC236}">
-                <a16:creationId xmlns:a16="http://schemas.microsoft.com/office/drawing/2014/main" id="{6FAC58D9-E2DD-4CED-98A8-2752B79B26FF}"/>
+                <a16:creationId xmlns:a16="http://schemas.microsoft.com/office/drawing/2014/main" id="{15E46925-0CBC-417F-801E-F43A1A7D7728}"/>
               </a:ext>
             </a:extLst>
           </p:cNvPr>
@@ -5011,7 +5011,7 @@
           <p:cNvPr id="9" name="">
             <a:extLst xmlns:a="http://schemas.openxmlformats.org/drawingml/2006/main">
               <a:ext uri="{FF2B5EF4-FFF2-40B4-BE49-F238E27FC236}">
-                <a16:creationId xmlns:a16="http://schemas.microsoft.com/office/drawing/2014/main" id="{D3B368AD-9084-4DBF-84E2-882035098CF6}"/>
+                <a16:creationId xmlns:a16="http://schemas.microsoft.com/office/drawing/2014/main" id="{6C804EF9-2DA0-4EA7-8C55-CD4C2B8AE51E}"/>
               </a:ext>
             </a:extLst>
           </p:cNvPr>
@@ -5136,7 +5136,7 @@
           <p:cNvPr id="10" name="">
             <a:extLst xmlns:a="http://schemas.openxmlformats.org/drawingml/2006/main">
               <a:ext uri="{FF2B5EF4-FFF2-40B4-BE49-F238E27FC236}">
-                <a16:creationId xmlns:a16="http://schemas.microsoft.com/office/drawing/2014/main" id="{22DD07E7-5964-4A81-97D9-E36DB5EFAF7B}"/>
+                <a16:creationId xmlns:a16="http://schemas.microsoft.com/office/drawing/2014/main" id="{F7B84331-3BFC-43B4-8994-354F112989DD}"/>
               </a:ext>
             </a:extLst>
           </p:cNvPr>
@@ -5192,7 +5192,7 @@
           <p:cNvPr id="11" name="">
             <a:extLst xmlns:a="http://schemas.openxmlformats.org/drawingml/2006/main">
               <a:ext uri="{FF2B5EF4-FFF2-40B4-BE49-F238E27FC236}">
-                <a16:creationId xmlns:a16="http://schemas.microsoft.com/office/drawing/2014/main" id="{E8813E39-B8C9-475C-9465-7B80A3257B84}"/>
+                <a16:creationId xmlns:a16="http://schemas.microsoft.com/office/drawing/2014/main" id="{87D70DC2-A4AB-4ED6-8F08-446840043E06}"/>
               </a:ext>
             </a:extLst>
           </p:cNvPr>
@@ -5248,7 +5248,7 @@
           <p:cNvPr id="12" name="">
             <a:extLst xmlns:a="http://schemas.openxmlformats.org/drawingml/2006/main">
               <a:ext uri="{FF2B5EF4-FFF2-40B4-BE49-F238E27FC236}">
-                <a16:creationId xmlns:a16="http://schemas.microsoft.com/office/drawing/2014/main" id="{9609E5C6-D7B7-4CD5-846D-C87283AA09A5}"/>
+                <a16:creationId xmlns:a16="http://schemas.microsoft.com/office/drawing/2014/main" id="{162D2ED4-D1D3-4453-96A5-F96FE7416780}"/>
               </a:ext>
             </a:extLst>
           </p:cNvPr>
@@ -5304,7 +5304,7 @@
           <p:cNvPr id="13" name="">
             <a:extLst xmlns:a="http://schemas.openxmlformats.org/drawingml/2006/main">
               <a:ext uri="{FF2B5EF4-FFF2-40B4-BE49-F238E27FC236}">
-                <a16:creationId xmlns:a16="http://schemas.microsoft.com/office/drawing/2014/main" id="{13CA46AD-4383-4CF8-AB32-E959F1949CE4}"/>
+                <a16:creationId xmlns:a16="http://schemas.microsoft.com/office/drawing/2014/main" id="{15B1C00C-36CF-481D-A3B0-B5A21D36D2A5}"/>
               </a:ext>
             </a:extLst>
           </p:cNvPr>
@@ -5429,7 +5429,7 @@
           <p:cNvPr id="14" name="">
             <a:extLst xmlns:a="http://schemas.openxmlformats.org/drawingml/2006/main">
               <a:ext uri="{FF2B5EF4-FFF2-40B4-BE49-F238E27FC236}">
-                <a16:creationId xmlns:a16="http://schemas.microsoft.com/office/drawing/2014/main" id="{DC079D9A-7301-4BD9-AC40-F51AC0D603A8}"/>
+                <a16:creationId xmlns:a16="http://schemas.microsoft.com/office/drawing/2014/main" id="{EB43DD86-B0B1-426E-8CCE-F9CBD28CBF8F}"/>
               </a:ext>
             </a:extLst>
           </p:cNvPr>
@@ -5483,7 +5483,7 @@
     </p:spTree>
     <p:extLst>
       <p:ext uri="{BB962C8B-B14F-4D97-AF65-F5344CB8AC3E}">
-        <p14:creationId xmlns:p14="http://schemas.microsoft.com/office/powerpoint/2010/main" val="781505823"/>
+        <p14:creationId xmlns:p14="http://schemas.microsoft.com/office/powerpoint/2010/main" val="1992646177"/>
       </p:ext>
     </p:extLst>
   </p:cSld>
@@ -5514,7 +5514,7 @@
           <p:cNvPr id="20" name="">
             <a:extLst xmlns:a="http://schemas.openxmlformats.org/drawingml/2006/main">
               <a:ext uri="{FF2B5EF4-FFF2-40B4-BE49-F238E27FC236}">
-                <a16:creationId xmlns:a16="http://schemas.microsoft.com/office/drawing/2014/main" id="{B457AF5D-9781-47D2-87E1-6C36CF1BFE04}"/>
+                <a16:creationId xmlns:a16="http://schemas.microsoft.com/office/drawing/2014/main" id="{0F72C208-5661-415E-9EA6-FFA2833893CF}"/>
               </a:ext>
             </a:extLst>
           </p:cNvPr>
@@ -5570,7 +5570,7 @@
           <p:cNvPr id="2" name="">
             <a:extLst xmlns:a="http://schemas.openxmlformats.org/drawingml/2006/main">
               <a:ext uri="{FF2B5EF4-FFF2-40B4-BE49-F238E27FC236}">
-                <a16:creationId xmlns:a16="http://schemas.microsoft.com/office/drawing/2014/main" id="{F98B2305-8E33-46B0-845F-1C83449C8B83}"/>
+                <a16:creationId xmlns:a16="http://schemas.microsoft.com/office/drawing/2014/main" id="{1195A01F-1B4B-4307-9753-09901D8D7BA1}"/>
               </a:ext>
             </a:extLst>
           </p:cNvPr>
@@ -5649,7 +5649,7 @@
           <p:cNvPr id="3" name="">
             <a:extLst xmlns:a="http://schemas.openxmlformats.org/drawingml/2006/main">
               <a:ext uri="{FF2B5EF4-FFF2-40B4-BE49-F238E27FC236}">
-                <a16:creationId xmlns:a16="http://schemas.microsoft.com/office/drawing/2014/main" id="{55476475-0F08-4D2B-AA8F-577BC1CCA9DE}"/>
+                <a16:creationId xmlns:a16="http://schemas.microsoft.com/office/drawing/2014/main" id="{9AFB56DD-FA42-4004-B7B6-F1A6BC820B30}"/>
               </a:ext>
             </a:extLst>
           </p:cNvPr>
@@ -5705,7 +5705,7 @@
           <p:cNvPr id="4" name="">
             <a:extLst xmlns:a="http://schemas.openxmlformats.org/drawingml/2006/main">
               <a:ext uri="{FF2B5EF4-FFF2-40B4-BE49-F238E27FC236}">
-                <a16:creationId xmlns:a16="http://schemas.microsoft.com/office/drawing/2014/main" id="{49962578-CC99-4A04-BF71-64A3DB59A109}"/>
+                <a16:creationId xmlns:a16="http://schemas.microsoft.com/office/drawing/2014/main" id="{AFF162B9-5646-4FC1-99CE-D82AAF60D883}"/>
               </a:ext>
             </a:extLst>
           </p:cNvPr>
@@ -5736,7 +5736,7 @@
           <p:cNvPr id="5" name="">
             <a:extLst xmlns:a="http://schemas.openxmlformats.org/drawingml/2006/main">
               <a:ext uri="{FF2B5EF4-FFF2-40B4-BE49-F238E27FC236}">
-                <a16:creationId xmlns:a16="http://schemas.microsoft.com/office/drawing/2014/main" id="{BDD0333C-8505-4730-B1FC-ED2CF67A5E8B}"/>
+                <a16:creationId xmlns:a16="http://schemas.microsoft.com/office/drawing/2014/main" id="{898D4CCF-A668-493E-BA5B-EAEB1D117764}"/>
               </a:ext>
             </a:extLst>
           </p:cNvPr>
@@ -5792,7 +5792,7 @@
           <p:cNvPr id="6" name="">
             <a:extLst xmlns:a="http://schemas.openxmlformats.org/drawingml/2006/main">
               <a:ext uri="{FF2B5EF4-FFF2-40B4-BE49-F238E27FC236}">
-                <a16:creationId xmlns:a16="http://schemas.microsoft.com/office/drawing/2014/main" id="{C9382BFC-1AAC-40BD-97B0-61BDFABF7672}"/>
+                <a16:creationId xmlns:a16="http://schemas.microsoft.com/office/drawing/2014/main" id="{F8873955-90C9-4D1C-A094-5B91710D336F}"/>
               </a:ext>
             </a:extLst>
           </p:cNvPr>
@@ -5848,7 +5848,7 @@
           <p:cNvPr id="7" name="">
             <a:extLst xmlns:a="http://schemas.openxmlformats.org/drawingml/2006/main">
               <a:ext uri="{FF2B5EF4-FFF2-40B4-BE49-F238E27FC236}">
-                <a16:creationId xmlns:a16="http://schemas.microsoft.com/office/drawing/2014/main" id="{DA22C462-3906-4834-AEDC-0CF53C39071D}"/>
+                <a16:creationId xmlns:a16="http://schemas.microsoft.com/office/drawing/2014/main" id="{2199E5DB-E9D0-486D-9BF3-B4298DE991C1}"/>
               </a:ext>
             </a:extLst>
           </p:cNvPr>
@@ -5904,7 +5904,7 @@
           <p:cNvPr id="8" name="">
             <a:extLst xmlns:a="http://schemas.openxmlformats.org/drawingml/2006/main">
               <a:ext uri="{FF2B5EF4-FFF2-40B4-BE49-F238E27FC236}">
-                <a16:creationId xmlns:a16="http://schemas.microsoft.com/office/drawing/2014/main" id="{F3DD16ED-12F8-447B-A58F-978D3A907D91}"/>
+                <a16:creationId xmlns:a16="http://schemas.microsoft.com/office/drawing/2014/main" id="{38D1F920-6D1E-48A5-903D-9B1F1F8D0B67}"/>
               </a:ext>
             </a:extLst>
           </p:cNvPr>
@@ -5935,7 +5935,7 @@
           <p:cNvPr id="9" name="">
             <a:extLst xmlns:a="http://schemas.openxmlformats.org/drawingml/2006/main">
               <a:ext uri="{FF2B5EF4-FFF2-40B4-BE49-F238E27FC236}">
-                <a16:creationId xmlns:a16="http://schemas.microsoft.com/office/drawing/2014/main" id="{D8F4136A-E0E6-4996-92C5-C942401DCFA2}"/>
+                <a16:creationId xmlns:a16="http://schemas.microsoft.com/office/drawing/2014/main" id="{446DE91A-9E01-4BA7-85F8-AFCA1F2BC975}"/>
               </a:ext>
             </a:extLst>
           </p:cNvPr>
@@ -5991,7 +5991,7 @@
           <p:cNvPr id="10" name="">
             <a:extLst xmlns:a="http://schemas.openxmlformats.org/drawingml/2006/main">
               <a:ext uri="{FF2B5EF4-FFF2-40B4-BE49-F238E27FC236}">
-                <a16:creationId xmlns:a16="http://schemas.microsoft.com/office/drawing/2014/main" id="{96007651-AD24-4582-8925-33C42A993638}"/>
+                <a16:creationId xmlns:a16="http://schemas.microsoft.com/office/drawing/2014/main" id="{D3591DB2-A5B6-430D-987D-41BF0266337F}"/>
               </a:ext>
             </a:extLst>
           </p:cNvPr>
@@ -6047,7 +6047,7 @@
           <p:cNvPr id="11" name="">
             <a:extLst xmlns:a="http://schemas.openxmlformats.org/drawingml/2006/main">
               <a:ext uri="{FF2B5EF4-FFF2-40B4-BE49-F238E27FC236}">
-                <a16:creationId xmlns:a16="http://schemas.microsoft.com/office/drawing/2014/main" id="{BE0C072B-B080-4B91-9904-81002B831732}"/>
+                <a16:creationId xmlns:a16="http://schemas.microsoft.com/office/drawing/2014/main" id="{915595B9-3054-4F4E-99C3-04C093281FD1}"/>
               </a:ext>
             </a:extLst>
           </p:cNvPr>
@@ -6103,7 +6103,7 @@
           <p:cNvPr id="12" name="">
             <a:extLst xmlns:a="http://schemas.openxmlformats.org/drawingml/2006/main">
               <a:ext uri="{FF2B5EF4-FFF2-40B4-BE49-F238E27FC236}">
-                <a16:creationId xmlns:a16="http://schemas.microsoft.com/office/drawing/2014/main" id="{BE3FBED3-68BB-413F-9151-B163783C959D}"/>
+                <a16:creationId xmlns:a16="http://schemas.microsoft.com/office/drawing/2014/main" id="{AB312A42-D859-4DF4-AB10-5258A25CC3B4}"/>
               </a:ext>
             </a:extLst>
           </p:cNvPr>
@@ -6134,7 +6134,7 @@
           <p:cNvPr id="13" name="">
             <a:extLst xmlns:a="http://schemas.openxmlformats.org/drawingml/2006/main">
               <a:ext uri="{FF2B5EF4-FFF2-40B4-BE49-F238E27FC236}">
-                <a16:creationId xmlns:a16="http://schemas.microsoft.com/office/drawing/2014/main" id="{3C29DA53-FD5A-4AB8-946F-39834B1C4288}"/>
+                <a16:creationId xmlns:a16="http://schemas.microsoft.com/office/drawing/2014/main" id="{85348310-9230-4BCB-B702-C8897D4E224F}"/>
               </a:ext>
             </a:extLst>
           </p:cNvPr>
@@ -6190,7 +6190,7 @@
           <p:cNvPr id="14" name="">
             <a:extLst xmlns:a="http://schemas.openxmlformats.org/drawingml/2006/main">
               <a:ext uri="{FF2B5EF4-FFF2-40B4-BE49-F238E27FC236}">
-                <a16:creationId xmlns:a16="http://schemas.microsoft.com/office/drawing/2014/main" id="{1A07C5F4-C536-4D30-954B-8D1E710600D2}"/>
+                <a16:creationId xmlns:a16="http://schemas.microsoft.com/office/drawing/2014/main" id="{6138600F-985D-4CDD-B77D-61F90E4B60AE}"/>
               </a:ext>
             </a:extLst>
           </p:cNvPr>
@@ -6246,7 +6246,7 @@
           <p:cNvPr id="15" name="">
             <a:extLst xmlns:a="http://schemas.openxmlformats.org/drawingml/2006/main">
               <a:ext uri="{FF2B5EF4-FFF2-40B4-BE49-F238E27FC236}">
-                <a16:creationId xmlns:a16="http://schemas.microsoft.com/office/drawing/2014/main" id="{F94F69EC-54DB-475E-90CD-3B446E01B166}"/>
+                <a16:creationId xmlns:a16="http://schemas.microsoft.com/office/drawing/2014/main" id="{56FFA554-5394-4869-A87F-9FB41935CC4F}"/>
               </a:ext>
             </a:extLst>
           </p:cNvPr>
@@ -6302,7 +6302,7 @@
           <p:cNvPr id="16" name="">
             <a:extLst xmlns:a="http://schemas.openxmlformats.org/drawingml/2006/main">
               <a:ext uri="{FF2B5EF4-FFF2-40B4-BE49-F238E27FC236}">
-                <a16:creationId xmlns:a16="http://schemas.microsoft.com/office/drawing/2014/main" id="{19E9A62E-4A34-488B-8D28-0BA41DD014BC}"/>
+                <a16:creationId xmlns:a16="http://schemas.microsoft.com/office/drawing/2014/main" id="{5C360CC8-49F3-4A8D-8471-4C140E45EDAF}"/>
               </a:ext>
             </a:extLst>
           </p:cNvPr>
@@ -6348,7 +6348,7 @@
                 <a:ea typeface="Arial"/>
                 <a:cs typeface="Arial"/>
               </a:rPr>
-              <a:t>Windows 10/11 (x64) + macOS (Apple Silicon) — İndirme: github.com/Azizsekerdil/EnglishCourseAI/releases (v1.1.1, özel repo)</a:t>
+              <a:t>Windows 10/11 (x64) + macOS (Apple Silicon) — İndirme: github.com/Azizsekerdil/EnglishCourseAI/releases (v1.1.2, özel repo)</a:t>
             </a:r>
           </a:p>
         </p:txBody>
@@ -6358,7 +6358,7 @@
           <p:cNvPr id="17" name="">
             <a:extLst xmlns:a="http://schemas.openxmlformats.org/drawingml/2006/main">
               <a:ext uri="{FF2B5EF4-FFF2-40B4-BE49-F238E27FC236}">
-                <a16:creationId xmlns:a16="http://schemas.microsoft.com/office/drawing/2014/main" id="{A74B851B-47E2-4380-A1D9-B43170B3A536}"/>
+                <a16:creationId xmlns:a16="http://schemas.microsoft.com/office/drawing/2014/main" id="{983322D9-8DEC-4B46-98E0-2F52A6FF5FBE}"/>
               </a:ext>
             </a:extLst>
           </p:cNvPr>
@@ -6404,7 +6404,7 @@
                 <a:ea typeface="Arial"/>
                 <a:cs typeface="Arial"/>
               </a:rPr>
-              <a:t>Windows 10/11 (x64) &amp; macOS (Apple Silicon) — Download: GitHub Releases (v1.1.1)</a:t>
+              <a:t>Windows 10/11 (x64) &amp; macOS (Apple Silicon) — Download: GitHub Releases (v1.1.2)</a:t>
             </a:r>
           </a:p>
         </p:txBody>
@@ -6414,7 +6414,7 @@
           <p:cNvPr id="18" name="">
             <a:extLst xmlns:a="http://schemas.openxmlformats.org/drawingml/2006/main">
               <a:ext uri="{FF2B5EF4-FFF2-40B4-BE49-F238E27FC236}">
-                <a16:creationId xmlns:a16="http://schemas.microsoft.com/office/drawing/2014/main" id="{1B8F0372-CA73-4F9A-AF44-D8E66DE28BE0}"/>
+                <a16:creationId xmlns:a16="http://schemas.microsoft.com/office/drawing/2014/main" id="{FE3994FD-B5CC-40DD-8D17-07165627DC4D}"/>
               </a:ext>
             </a:extLst>
           </p:cNvPr>
@@ -6474,7 +6474,7 @@
           <p:nvPr/>
         </p:nvPicPr>
         <p:blipFill>
-          <a:blip xmlns:r="http://schemas.openxmlformats.org/officeDocument/2006/relationships" xmlns:a="http://schemas.openxmlformats.org/drawingml/2006/main" r:embed="R8029e4a0af454c4b"/>
+          <a:blip xmlns:r="http://schemas.openxmlformats.org/officeDocument/2006/relationships" xmlns:a="http://schemas.openxmlformats.org/drawingml/2006/main" r:embed="R87f62bcad4ca40d5"/>
           <a:stretch xmlns:a="http://schemas.openxmlformats.org/drawingml/2006/main"/>
         </p:blipFill>
         <p:spPr>
@@ -6490,7 +6490,7 @@
     </p:spTree>
     <p:extLst>
       <p:ext uri="{BB962C8B-B14F-4D97-AF65-F5344CB8AC3E}">
-        <p14:creationId xmlns:p14="http://schemas.microsoft.com/office/powerpoint/2010/main" val="2131603070"/>
+        <p14:creationId xmlns:p14="http://schemas.microsoft.com/office/powerpoint/2010/main" val="1312272765"/>
       </p:ext>
     </p:extLst>
   </p:cSld>

</xml_diff>

<commit_message>
Sunum: v1.2.0 sözlük yön seçimi ve EN-TR bilgileri
Co-Authored-By: Claude Opus 5 <noreply@anthropic.com>
</commit_message>
<xml_diff>
--- a/docs/presentation/English-Course-AI-Bilingual.pptx
+++ b/docs/presentation/English-Course-AI-Bilingual.pptx
@@ -2,18 +2,18 @@
 <file path=ppt/presentation.xml><?xml version="1.0" encoding="utf-8"?>
 <p:presentation xmlns:p="http://schemas.openxmlformats.org/presentationml/2006/main">
   <p:sldMasterIdLst>
-    <p:sldMasterId xmlns:r="http://schemas.openxmlformats.org/officeDocument/2006/relationships" id="2147483648" r:id="Rff84a43849674f59"/>
+    <p:sldMasterId xmlns:r="http://schemas.openxmlformats.org/officeDocument/2006/relationships" id="2147483648" r:id="R8d8fe72f936447d5"/>
   </p:sldMasterIdLst>
   <p:notesMasterIdLst>
-    <p:notesMasterId xmlns:r="http://schemas.openxmlformats.org/officeDocument/2006/relationships" r:id="Rcd922a04c0104511"/>
+    <p:notesMasterId xmlns:r="http://schemas.openxmlformats.org/officeDocument/2006/relationships" r:id="R18be1d07e9b44a0b"/>
   </p:notesMasterIdLst>
   <p:sldIdLst>
-    <p:sldId xmlns:r="http://schemas.openxmlformats.org/officeDocument/2006/relationships" id="256" r:id="R9762de30c6e5480c"/>
-    <p:sldId xmlns:r="http://schemas.openxmlformats.org/officeDocument/2006/relationships" id="257" r:id="R96772dc4df724afc"/>
-    <p:sldId xmlns:r="http://schemas.openxmlformats.org/officeDocument/2006/relationships" id="258" r:id="R86890664d12d46b7"/>
-    <p:sldId xmlns:r="http://schemas.openxmlformats.org/officeDocument/2006/relationships" id="259" r:id="R45b8b57b783f4789"/>
-    <p:sldId xmlns:r="http://schemas.openxmlformats.org/officeDocument/2006/relationships" id="260" r:id="R6dcc3f2a64624ec1"/>
-    <p:sldId xmlns:r="http://schemas.openxmlformats.org/officeDocument/2006/relationships" id="261" r:id="R920feb5a0aeb4b95"/>
+    <p:sldId xmlns:r="http://schemas.openxmlformats.org/officeDocument/2006/relationships" id="256" r:id="R0d46ac6bf2174a6e"/>
+    <p:sldId xmlns:r="http://schemas.openxmlformats.org/officeDocument/2006/relationships" id="257" r:id="R8f756fe2ef2d4d40"/>
+    <p:sldId xmlns:r="http://schemas.openxmlformats.org/officeDocument/2006/relationships" id="258" r:id="Re86c3159511c46d4"/>
+    <p:sldId xmlns:r="http://schemas.openxmlformats.org/officeDocument/2006/relationships" id="259" r:id="R76347e6a2bbd4476"/>
+    <p:sldId xmlns:r="http://schemas.openxmlformats.org/officeDocument/2006/relationships" id="260" r:id="R71dbd64775dc4d8e"/>
+    <p:sldId xmlns:r="http://schemas.openxmlformats.org/officeDocument/2006/relationships" id="261" r:id="Ra12009e8cd984873"/>
   </p:sldIdLst>
   <p:sldSz cx="12192000" cy="6858000"/>
   <p:notesSz cx="6858000" cy="9144000"/>
@@ -917,7 +917,7 @@
           </a:p>
           <a:p xmlns:a="http://schemas.openxmlformats.org/drawingml/2006/main">
             <a:r>
-              <a:t>- GitHub release (private repo): https://github.com/Azizsekerdil/EnglishCourseAI/releases/tag/v1.1.2 (Windows zip + macOS zip)</a:t>
+              <a:t>- GitHub release (private repo): https://github.com/Azizsekerdil/EnglishCourseAI/releases/tag/v1.2.0 (Windows zip + macOS zip)</a:t>
             </a:r>
           </a:p>
           <a:p xmlns:a="http://schemas.openxmlformats.org/drawingml/2006/main">
@@ -990,7 +990,7 @@
   </p:cSld>
   <p:clrMap bg1="lt1" tx1="dk1" bg2="lt2" tx2="dk2" accent1="accent1" accent2="accent2" accent3="accent3" accent4="accent4" accent5="accent5" accent6="accent6" hlink="hlink" folHlink="folHlink"/>
   <p:sldLayoutIdLst>
-    <p:sldLayoutId xmlns:r="http://schemas.openxmlformats.org/officeDocument/2006/relationships" id="2147483649" r:id="Read78d50f41d43e6"/>
+    <p:sldLayoutId xmlns:r="http://schemas.openxmlformats.org/officeDocument/2006/relationships" id="2147483649" r:id="R71a237b368994cdb"/>
   </p:sldLayoutIdLst>
   <p:txStyles>
     <p:titleStyle>
@@ -1541,7 +1541,7 @@
           <p:cNvPr id="8" name="">
             <a:extLst xmlns:a="http://schemas.openxmlformats.org/drawingml/2006/main">
               <a:ext uri="{FF2B5EF4-FFF2-40B4-BE49-F238E27FC236}">
-                <a16:creationId xmlns:a16="http://schemas.microsoft.com/office/drawing/2014/main" id="{353B4117-DF56-4CED-82B4-FA048B7333B5}"/>
+                <a16:creationId xmlns:a16="http://schemas.microsoft.com/office/drawing/2014/main" id="{99DC8C5D-21E7-446F-BEB5-9F67A34FCD89}"/>
               </a:ext>
             </a:extLst>
           </p:cNvPr>
@@ -1576,7 +1576,7 @@
           <p:nvPr/>
         </p:nvPicPr>
         <p:blipFill>
-          <a:blip xmlns:r="http://schemas.openxmlformats.org/officeDocument/2006/relationships" xmlns:a="http://schemas.openxmlformats.org/drawingml/2006/main" r:embed="R821f59b868794dd2"/>
+          <a:blip xmlns:r="http://schemas.openxmlformats.org/officeDocument/2006/relationships" xmlns:a="http://schemas.openxmlformats.org/drawingml/2006/main" r:embed="R51b6db79291a434d"/>
           <a:stretch xmlns:a="http://schemas.openxmlformats.org/drawingml/2006/main"/>
         </p:blipFill>
         <p:spPr>
@@ -1594,7 +1594,7 @@
           <p:cNvPr id="3" name="">
             <a:extLst xmlns:a="http://schemas.openxmlformats.org/drawingml/2006/main">
               <a:ext uri="{FF2B5EF4-FFF2-40B4-BE49-F238E27FC236}">
-                <a16:creationId xmlns:a16="http://schemas.microsoft.com/office/drawing/2014/main" id="{A0CFAB51-87E0-45A3-AC25-8AA439DAD37B}"/>
+                <a16:creationId xmlns:a16="http://schemas.microsoft.com/office/drawing/2014/main" id="{3BB05F6A-0E5B-4A8A-9BB8-391CB0262D05}"/>
               </a:ext>
             </a:extLst>
           </p:cNvPr>
@@ -1650,7 +1650,7 @@
           <p:cNvPr id="4" name="">
             <a:extLst xmlns:a="http://schemas.openxmlformats.org/drawingml/2006/main">
               <a:ext uri="{FF2B5EF4-FFF2-40B4-BE49-F238E27FC236}">
-                <a16:creationId xmlns:a16="http://schemas.microsoft.com/office/drawing/2014/main" id="{A9B1EED1-9CAE-413D-BB57-A065D5F040EC}"/>
+                <a16:creationId xmlns:a16="http://schemas.microsoft.com/office/drawing/2014/main" id="{0DBF37C8-662A-42EE-973F-D433F92FCE61}"/>
               </a:ext>
             </a:extLst>
           </p:cNvPr>
@@ -1729,7 +1729,7 @@
           <p:cNvPr id="5" name="">
             <a:extLst xmlns:a="http://schemas.openxmlformats.org/drawingml/2006/main">
               <a:ext uri="{FF2B5EF4-FFF2-40B4-BE49-F238E27FC236}">
-                <a16:creationId xmlns:a16="http://schemas.microsoft.com/office/drawing/2014/main" id="{EE6D3BB0-7619-4517-AB77-2EB4AD080A7E}"/>
+                <a16:creationId xmlns:a16="http://schemas.microsoft.com/office/drawing/2014/main" id="{64A0CEDD-8F6F-4D0F-841B-80795F610A58}"/>
               </a:ext>
             </a:extLst>
           </p:cNvPr>
@@ -1760,7 +1760,7 @@
           <p:cNvPr id="6" name="">
             <a:extLst xmlns:a="http://schemas.openxmlformats.org/drawingml/2006/main">
               <a:ext uri="{FF2B5EF4-FFF2-40B4-BE49-F238E27FC236}">
-                <a16:creationId xmlns:a16="http://schemas.microsoft.com/office/drawing/2014/main" id="{2A3A620D-6A5D-4728-A595-1899F32AAA14}"/>
+                <a16:creationId xmlns:a16="http://schemas.microsoft.com/office/drawing/2014/main" id="{4C6C2022-31E2-43FD-8C49-F2D8B7219873}"/>
               </a:ext>
             </a:extLst>
           </p:cNvPr>
@@ -1839,7 +1839,7 @@
           <p:cNvPr id="7" name="">
             <a:extLst xmlns:a="http://schemas.openxmlformats.org/drawingml/2006/main">
               <a:ext uri="{FF2B5EF4-FFF2-40B4-BE49-F238E27FC236}">
-                <a16:creationId xmlns:a16="http://schemas.microsoft.com/office/drawing/2014/main" id="{617B7B41-E915-449E-91FD-72C6DA44004D}"/>
+                <a16:creationId xmlns:a16="http://schemas.microsoft.com/office/drawing/2014/main" id="{EBE30B14-8BDE-44F4-A552-589CF294B891}"/>
               </a:ext>
             </a:extLst>
           </p:cNvPr>
@@ -1885,7 +1885,7 @@
                 <a:ea typeface="Arial"/>
                 <a:cs typeface="Arial"/>
               </a:rPr>
-              <a:t>v1.1.2  •  2026</a:t>
+              <a:t>v1.2.0  •  2026</a:t>
             </a:r>
           </a:p>
         </p:txBody>
@@ -1893,7 +1893,7 @@
     </p:spTree>
     <p:extLst>
       <p:ext uri="{BB962C8B-B14F-4D97-AF65-F5344CB8AC3E}">
-        <p14:creationId xmlns:p14="http://schemas.microsoft.com/office/powerpoint/2010/main" val="1883453455"/>
+        <p14:creationId xmlns:p14="http://schemas.microsoft.com/office/powerpoint/2010/main" val="2001073212"/>
       </p:ext>
     </p:extLst>
   </p:cSld>
@@ -1924,7 +1924,7 @@
           <p:cNvPr id="21" name="">
             <a:extLst xmlns:a="http://schemas.openxmlformats.org/drawingml/2006/main">
               <a:ext uri="{FF2B5EF4-FFF2-40B4-BE49-F238E27FC236}">
-                <a16:creationId xmlns:a16="http://schemas.microsoft.com/office/drawing/2014/main" id="{5C2D4DFD-036C-4D33-A400-7DF9F21CA1CF}"/>
+                <a16:creationId xmlns:a16="http://schemas.microsoft.com/office/drawing/2014/main" id="{AB0C4FAA-4705-43F5-B047-EE94E53E034B}"/>
               </a:ext>
             </a:extLst>
           </p:cNvPr>
@@ -1980,7 +1980,7 @@
           <p:cNvPr id="2" name="">
             <a:extLst xmlns:a="http://schemas.openxmlformats.org/drawingml/2006/main">
               <a:ext uri="{FF2B5EF4-FFF2-40B4-BE49-F238E27FC236}">
-                <a16:creationId xmlns:a16="http://schemas.microsoft.com/office/drawing/2014/main" id="{0D3F1CD4-A547-478E-A025-653FE1C12A68}"/>
+                <a16:creationId xmlns:a16="http://schemas.microsoft.com/office/drawing/2014/main" id="{920109E6-A992-49F9-8B4B-E985529540AE}"/>
               </a:ext>
             </a:extLst>
           </p:cNvPr>
@@ -2036,7 +2036,7 @@
           <p:cNvPr id="3" name="">
             <a:extLst xmlns:a="http://schemas.openxmlformats.org/drawingml/2006/main">
               <a:ext uri="{FF2B5EF4-FFF2-40B4-BE49-F238E27FC236}">
-                <a16:creationId xmlns:a16="http://schemas.microsoft.com/office/drawing/2014/main" id="{BE89797C-2939-4C0E-A17E-023548455478}"/>
+                <a16:creationId xmlns:a16="http://schemas.microsoft.com/office/drawing/2014/main" id="{73EBA98A-5B58-4D55-9A3A-7FF73FB07A70}"/>
               </a:ext>
             </a:extLst>
           </p:cNvPr>
@@ -2092,7 +2092,7 @@
           <p:cNvPr id="4" name="">
             <a:extLst xmlns:a="http://schemas.openxmlformats.org/drawingml/2006/main">
               <a:ext uri="{FF2B5EF4-FFF2-40B4-BE49-F238E27FC236}">
-                <a16:creationId xmlns:a16="http://schemas.microsoft.com/office/drawing/2014/main" id="{73B0C979-F687-4356-A144-D11765F59EA6}"/>
+                <a16:creationId xmlns:a16="http://schemas.microsoft.com/office/drawing/2014/main" id="{4B976DE8-C925-4446-969A-A6EB80B81BDB}"/>
               </a:ext>
             </a:extLst>
           </p:cNvPr>
@@ -2148,7 +2148,7 @@
           <p:cNvPr id="5" name="">
             <a:extLst xmlns:a="http://schemas.openxmlformats.org/drawingml/2006/main">
               <a:ext uri="{FF2B5EF4-FFF2-40B4-BE49-F238E27FC236}">
-                <a16:creationId xmlns:a16="http://schemas.microsoft.com/office/drawing/2014/main" id="{651679F2-3085-48EF-A5A9-5DD2918441F4}"/>
+                <a16:creationId xmlns:a16="http://schemas.microsoft.com/office/drawing/2014/main" id="{2258517F-545B-4B65-A21C-028A0F35E5E2}"/>
               </a:ext>
             </a:extLst>
           </p:cNvPr>
@@ -2179,7 +2179,7 @@
           <p:cNvPr id="6" name="">
             <a:extLst xmlns:a="http://schemas.openxmlformats.org/drawingml/2006/main">
               <a:ext uri="{FF2B5EF4-FFF2-40B4-BE49-F238E27FC236}">
-                <a16:creationId xmlns:a16="http://schemas.microsoft.com/office/drawing/2014/main" id="{763311C4-F3D9-4905-A768-E74664C318DD}"/>
+                <a16:creationId xmlns:a16="http://schemas.microsoft.com/office/drawing/2014/main" id="{26C4E4F1-0676-432C-AB13-0E8027279F7E}"/>
               </a:ext>
             </a:extLst>
           </p:cNvPr>
@@ -2235,7 +2235,7 @@
           <p:cNvPr id="7" name="">
             <a:extLst xmlns:a="http://schemas.openxmlformats.org/drawingml/2006/main">
               <a:ext uri="{FF2B5EF4-FFF2-40B4-BE49-F238E27FC236}">
-                <a16:creationId xmlns:a16="http://schemas.microsoft.com/office/drawing/2014/main" id="{042134BC-5A3A-4434-BAC2-050E688FCB70}"/>
+                <a16:creationId xmlns:a16="http://schemas.microsoft.com/office/drawing/2014/main" id="{799F432F-3F4A-4983-97C1-D304C0D1E8F8}"/>
               </a:ext>
             </a:extLst>
           </p:cNvPr>
@@ -2291,7 +2291,7 @@
           <p:cNvPr id="8" name="">
             <a:extLst xmlns:a="http://schemas.openxmlformats.org/drawingml/2006/main">
               <a:ext uri="{FF2B5EF4-FFF2-40B4-BE49-F238E27FC236}">
-                <a16:creationId xmlns:a16="http://schemas.microsoft.com/office/drawing/2014/main" id="{6AACC1FA-290D-4C04-B194-EDDCD0EE5C72}"/>
+                <a16:creationId xmlns:a16="http://schemas.microsoft.com/office/drawing/2014/main" id="{79CC6708-3BD5-48DB-9F72-4C06F79C326F}"/>
               </a:ext>
             </a:extLst>
           </p:cNvPr>
@@ -2337,7 +2337,7 @@
                 <a:ea typeface="Arial"/>
                 <a:cs typeface="Arial"/>
               </a:rPr>
-              <a:t>Aralıklı tekrar, kelime bankası, EN-TR öğrenci sözlüğü ve CEFR sınavları</a:t>
+              <a:t>Aralıklı tekrar, kelime bankası, yön seçimli EN↔TR öğrenci sözlüğü ve CEFR sınavları</a:t>
             </a:r>
           </a:p>
         </p:txBody>
@@ -2347,7 +2347,7 @@
           <p:cNvPr id="9" name="">
             <a:extLst xmlns:a="http://schemas.openxmlformats.org/drawingml/2006/main">
               <a:ext uri="{FF2B5EF4-FFF2-40B4-BE49-F238E27FC236}">
-                <a16:creationId xmlns:a16="http://schemas.microsoft.com/office/drawing/2014/main" id="{4F556DB4-B675-43A2-8409-929C3AAA9193}"/>
+                <a16:creationId xmlns:a16="http://schemas.microsoft.com/office/drawing/2014/main" id="{2B8C0AA5-D3A0-43D7-B7BA-2F9177746AB1}"/>
               </a:ext>
             </a:extLst>
           </p:cNvPr>
@@ -2378,7 +2378,7 @@
           <p:cNvPr id="10" name="">
             <a:extLst xmlns:a="http://schemas.openxmlformats.org/drawingml/2006/main">
               <a:ext uri="{FF2B5EF4-FFF2-40B4-BE49-F238E27FC236}">
-                <a16:creationId xmlns:a16="http://schemas.microsoft.com/office/drawing/2014/main" id="{6070EF02-16DB-415A-8387-17910AEDC470}"/>
+                <a16:creationId xmlns:a16="http://schemas.microsoft.com/office/drawing/2014/main" id="{FB528785-42DB-4AA5-98DB-A82503F444F6}"/>
               </a:ext>
             </a:extLst>
           </p:cNvPr>
@@ -2434,7 +2434,7 @@
           <p:cNvPr id="11" name="">
             <a:extLst xmlns:a="http://schemas.openxmlformats.org/drawingml/2006/main">
               <a:ext uri="{FF2B5EF4-FFF2-40B4-BE49-F238E27FC236}">
-                <a16:creationId xmlns:a16="http://schemas.microsoft.com/office/drawing/2014/main" id="{90C966CD-7F36-4931-B189-F47FB4E01675}"/>
+                <a16:creationId xmlns:a16="http://schemas.microsoft.com/office/drawing/2014/main" id="{850E84EA-C4A5-4543-BACF-100F702E88E0}"/>
               </a:ext>
             </a:extLst>
           </p:cNvPr>
@@ -2490,7 +2490,7 @@
           <p:cNvPr id="12" name="">
             <a:extLst xmlns:a="http://schemas.openxmlformats.org/drawingml/2006/main">
               <a:ext uri="{FF2B5EF4-FFF2-40B4-BE49-F238E27FC236}">
-                <a16:creationId xmlns:a16="http://schemas.microsoft.com/office/drawing/2014/main" id="{B2461FA2-8AA5-47F3-8AE0-B2105C150158}"/>
+                <a16:creationId xmlns:a16="http://schemas.microsoft.com/office/drawing/2014/main" id="{6AEF1FFB-FD62-406D-A63A-FD5918484847}"/>
               </a:ext>
             </a:extLst>
           </p:cNvPr>
@@ -2546,7 +2546,7 @@
           <p:cNvPr id="13" name="">
             <a:extLst xmlns:a="http://schemas.openxmlformats.org/drawingml/2006/main">
               <a:ext uri="{FF2B5EF4-FFF2-40B4-BE49-F238E27FC236}">
-                <a16:creationId xmlns:a16="http://schemas.microsoft.com/office/drawing/2014/main" id="{D0886755-8E05-4E9B-BD30-14E5F2355706}"/>
+                <a16:creationId xmlns:a16="http://schemas.microsoft.com/office/drawing/2014/main" id="{72693063-A8DB-42B3-BC24-022B2B0EC66C}"/>
               </a:ext>
             </a:extLst>
           </p:cNvPr>
@@ -2577,7 +2577,7 @@
           <p:cNvPr id="14" name="">
             <a:extLst xmlns:a="http://schemas.openxmlformats.org/drawingml/2006/main">
               <a:ext uri="{FF2B5EF4-FFF2-40B4-BE49-F238E27FC236}">
-                <a16:creationId xmlns:a16="http://schemas.microsoft.com/office/drawing/2014/main" id="{954E2D9D-7073-464C-9A91-FA915C9CB1DF}"/>
+                <a16:creationId xmlns:a16="http://schemas.microsoft.com/office/drawing/2014/main" id="{BDAC83BC-E19A-4E0E-9FA9-95E82B44E588}"/>
               </a:ext>
             </a:extLst>
           </p:cNvPr>
@@ -2633,7 +2633,7 @@
           <p:cNvPr id="15" name="">
             <a:extLst xmlns:a="http://schemas.openxmlformats.org/drawingml/2006/main">
               <a:ext uri="{FF2B5EF4-FFF2-40B4-BE49-F238E27FC236}">
-                <a16:creationId xmlns:a16="http://schemas.microsoft.com/office/drawing/2014/main" id="{CED3FE09-7BD9-40F2-8D40-DB12BF73FC21}"/>
+                <a16:creationId xmlns:a16="http://schemas.microsoft.com/office/drawing/2014/main" id="{77D1D702-DA9A-4173-AE3B-F5B7C8657ECE}"/>
               </a:ext>
             </a:extLst>
           </p:cNvPr>
@@ -2689,7 +2689,7 @@
           <p:cNvPr id="16" name="">
             <a:extLst xmlns:a="http://schemas.openxmlformats.org/drawingml/2006/main">
               <a:ext uri="{FF2B5EF4-FFF2-40B4-BE49-F238E27FC236}">
-                <a16:creationId xmlns:a16="http://schemas.microsoft.com/office/drawing/2014/main" id="{820A04CF-D96C-430E-B988-DFEEB2DFE279}"/>
+                <a16:creationId xmlns:a16="http://schemas.microsoft.com/office/drawing/2014/main" id="{5D8F13FE-2EBE-492E-ADD0-A3D2D6B275DC}"/>
               </a:ext>
             </a:extLst>
           </p:cNvPr>
@@ -2745,7 +2745,7 @@
           <p:cNvPr id="17" name="">
             <a:extLst xmlns:a="http://schemas.openxmlformats.org/drawingml/2006/main">
               <a:ext uri="{FF2B5EF4-FFF2-40B4-BE49-F238E27FC236}">
-                <a16:creationId xmlns:a16="http://schemas.microsoft.com/office/drawing/2014/main" id="{67F40C74-AE62-4FCF-ADFC-FABA8CEBA474}"/>
+                <a16:creationId xmlns:a16="http://schemas.microsoft.com/office/drawing/2014/main" id="{5266516F-68EC-43E2-BBCA-542875BFCF74}"/>
               </a:ext>
             </a:extLst>
           </p:cNvPr>
@@ -2776,7 +2776,7 @@
           <p:cNvPr id="18" name="">
             <a:extLst xmlns:a="http://schemas.openxmlformats.org/drawingml/2006/main">
               <a:ext uri="{FF2B5EF4-FFF2-40B4-BE49-F238E27FC236}">
-                <a16:creationId xmlns:a16="http://schemas.microsoft.com/office/drawing/2014/main" id="{DD3525D2-63A9-4413-ADD5-40CCCA3E96C0}"/>
+                <a16:creationId xmlns:a16="http://schemas.microsoft.com/office/drawing/2014/main" id="{C2335960-598F-4951-9333-6DE126E39FD6}"/>
               </a:ext>
             </a:extLst>
           </p:cNvPr>
@@ -2832,7 +2832,7 @@
           <p:cNvPr id="19" name="">
             <a:extLst xmlns:a="http://schemas.openxmlformats.org/drawingml/2006/main">
               <a:ext uri="{FF2B5EF4-FFF2-40B4-BE49-F238E27FC236}">
-                <a16:creationId xmlns:a16="http://schemas.microsoft.com/office/drawing/2014/main" id="{E9AB6F5C-85CA-46D9-BE13-2A36FFFE7BD7}"/>
+                <a16:creationId xmlns:a16="http://schemas.microsoft.com/office/drawing/2014/main" id="{33307CC5-1DD3-41DF-96DD-C233B4696C6F}"/>
               </a:ext>
             </a:extLst>
           </p:cNvPr>
@@ -2888,7 +2888,7 @@
           <p:cNvPr id="20" name="">
             <a:extLst xmlns:a="http://schemas.openxmlformats.org/drawingml/2006/main">
               <a:ext uri="{FF2B5EF4-FFF2-40B4-BE49-F238E27FC236}">
-                <a16:creationId xmlns:a16="http://schemas.microsoft.com/office/drawing/2014/main" id="{405CE2DD-8286-42AF-BF8C-8EFEDEB8F8C2}"/>
+                <a16:creationId xmlns:a16="http://schemas.microsoft.com/office/drawing/2014/main" id="{BFBACD80-7B97-4BA6-9391-B5A36757DF11}"/>
               </a:ext>
             </a:extLst>
           </p:cNvPr>
@@ -2942,7 +2942,7 @@
     </p:spTree>
     <p:extLst>
       <p:ext uri="{BB962C8B-B14F-4D97-AF65-F5344CB8AC3E}">
-        <p14:creationId xmlns:p14="http://schemas.microsoft.com/office/powerpoint/2010/main" val="1278148963"/>
+        <p14:creationId xmlns:p14="http://schemas.microsoft.com/office/powerpoint/2010/main" val="318485728"/>
       </p:ext>
     </p:extLst>
   </p:cSld>
@@ -2973,7 +2973,7 @@
           <p:cNvPr id="23" name="">
             <a:extLst xmlns:a="http://schemas.openxmlformats.org/drawingml/2006/main">
               <a:ext uri="{FF2B5EF4-FFF2-40B4-BE49-F238E27FC236}">
-                <a16:creationId xmlns:a16="http://schemas.microsoft.com/office/drawing/2014/main" id="{B519A116-A7A0-4A90-9192-BC5380917AF8}"/>
+                <a16:creationId xmlns:a16="http://schemas.microsoft.com/office/drawing/2014/main" id="{6AE75E76-EA70-4430-9326-2F062A323F5C}"/>
               </a:ext>
             </a:extLst>
           </p:cNvPr>
@@ -3029,7 +3029,7 @@
           <p:cNvPr id="2" name="">
             <a:extLst xmlns:a="http://schemas.openxmlformats.org/drawingml/2006/main">
               <a:ext uri="{FF2B5EF4-FFF2-40B4-BE49-F238E27FC236}">
-                <a16:creationId xmlns:a16="http://schemas.microsoft.com/office/drawing/2014/main" id="{4246E68B-8AA9-44BD-82A3-AD84B410A0AC}"/>
+                <a16:creationId xmlns:a16="http://schemas.microsoft.com/office/drawing/2014/main" id="{34ED261C-0FFA-4477-ACCB-8553DF3D9488}"/>
               </a:ext>
             </a:extLst>
           </p:cNvPr>
@@ -3085,7 +3085,7 @@
           <p:cNvPr id="3" name="">
             <a:extLst xmlns:a="http://schemas.openxmlformats.org/drawingml/2006/main">
               <a:ext uri="{FF2B5EF4-FFF2-40B4-BE49-F238E27FC236}">
-                <a16:creationId xmlns:a16="http://schemas.microsoft.com/office/drawing/2014/main" id="{F5921A1E-CBD0-4CF1-B1D0-FC1E7639DE44}"/>
+                <a16:creationId xmlns:a16="http://schemas.microsoft.com/office/drawing/2014/main" id="{7F70C719-DBA8-4657-971D-F43414CE2DFB}"/>
               </a:ext>
             </a:extLst>
           </p:cNvPr>
@@ -3141,7 +3141,7 @@
           <p:cNvPr id="4" name="">
             <a:extLst xmlns:a="http://schemas.openxmlformats.org/drawingml/2006/main">
               <a:ext uri="{FF2B5EF4-FFF2-40B4-BE49-F238E27FC236}">
-                <a16:creationId xmlns:a16="http://schemas.microsoft.com/office/drawing/2014/main" id="{940568D0-E60C-45B4-93C9-4F57E3CB81D0}"/>
+                <a16:creationId xmlns:a16="http://schemas.microsoft.com/office/drawing/2014/main" id="{09E128EC-41C1-4318-83E6-4EBAE38543DE}"/>
               </a:ext>
             </a:extLst>
           </p:cNvPr>
@@ -3197,7 +3197,7 @@
           <p:cNvPr id="5" name="">
             <a:extLst xmlns:a="http://schemas.openxmlformats.org/drawingml/2006/main">
               <a:ext uri="{FF2B5EF4-FFF2-40B4-BE49-F238E27FC236}">
-                <a16:creationId xmlns:a16="http://schemas.microsoft.com/office/drawing/2014/main" id="{70ACF512-82BE-4A72-B064-CB1A28347887}"/>
+                <a16:creationId xmlns:a16="http://schemas.microsoft.com/office/drawing/2014/main" id="{0F2B070B-E18E-4D59-8C9E-E5FE1150ECE3}"/>
               </a:ext>
             </a:extLst>
           </p:cNvPr>
@@ -3228,7 +3228,7 @@
           <p:cNvPr id="6" name="">
             <a:extLst xmlns:a="http://schemas.openxmlformats.org/drawingml/2006/main">
               <a:ext uri="{FF2B5EF4-FFF2-40B4-BE49-F238E27FC236}">
-                <a16:creationId xmlns:a16="http://schemas.microsoft.com/office/drawing/2014/main" id="{9548A2FE-424A-49E1-BE11-55D9F09B6CFB}"/>
+                <a16:creationId xmlns:a16="http://schemas.microsoft.com/office/drawing/2014/main" id="{094954D8-17F8-48BF-BE5D-0E5BEA042585}"/>
               </a:ext>
             </a:extLst>
           </p:cNvPr>
@@ -3284,7 +3284,7 @@
           <p:cNvPr id="7" name="">
             <a:extLst xmlns:a="http://schemas.openxmlformats.org/drawingml/2006/main">
               <a:ext uri="{FF2B5EF4-FFF2-40B4-BE49-F238E27FC236}">
-                <a16:creationId xmlns:a16="http://schemas.microsoft.com/office/drawing/2014/main" id="{A86F773B-C1B4-4A19-AE6C-789165C32169}"/>
+                <a16:creationId xmlns:a16="http://schemas.microsoft.com/office/drawing/2014/main" id="{B291BDF0-4D88-4D48-A88A-36B51717A92D}"/>
               </a:ext>
             </a:extLst>
           </p:cNvPr>
@@ -3340,7 +3340,7 @@
           <p:cNvPr id="8" name="">
             <a:extLst xmlns:a="http://schemas.openxmlformats.org/drawingml/2006/main">
               <a:ext uri="{FF2B5EF4-FFF2-40B4-BE49-F238E27FC236}">
-                <a16:creationId xmlns:a16="http://schemas.microsoft.com/office/drawing/2014/main" id="{BD2164DE-1238-4055-BD05-9C7C39C9578E}"/>
+                <a16:creationId xmlns:a16="http://schemas.microsoft.com/office/drawing/2014/main" id="{51D04C6B-3784-46D0-97A3-D6B1C56E4037}"/>
               </a:ext>
             </a:extLst>
           </p:cNvPr>
@@ -3396,7 +3396,7 @@
           <p:cNvPr id="9" name="">
             <a:extLst xmlns:a="http://schemas.openxmlformats.org/drawingml/2006/main">
               <a:ext uri="{FF2B5EF4-FFF2-40B4-BE49-F238E27FC236}">
-                <a16:creationId xmlns:a16="http://schemas.microsoft.com/office/drawing/2014/main" id="{F7B927B1-98CF-4A1B-AC6D-40CBD5FCF3F5}"/>
+                <a16:creationId xmlns:a16="http://schemas.microsoft.com/office/drawing/2014/main" id="{AF42C9D4-E162-454E-A41D-B5148AF62B18}"/>
               </a:ext>
             </a:extLst>
           </p:cNvPr>
@@ -3427,7 +3427,7 @@
           <p:cNvPr id="10" name="">
             <a:extLst xmlns:a="http://schemas.openxmlformats.org/drawingml/2006/main">
               <a:ext uri="{FF2B5EF4-FFF2-40B4-BE49-F238E27FC236}">
-                <a16:creationId xmlns:a16="http://schemas.microsoft.com/office/drawing/2014/main" id="{D39450EC-DFE0-41FD-A784-BEBCF85CEB23}"/>
+                <a16:creationId xmlns:a16="http://schemas.microsoft.com/office/drawing/2014/main" id="{C28E28FA-2A48-45C7-8751-9AA2132FB180}"/>
               </a:ext>
             </a:extLst>
           </p:cNvPr>
@@ -3483,7 +3483,7 @@
           <p:cNvPr id="11" name="">
             <a:extLst xmlns:a="http://schemas.openxmlformats.org/drawingml/2006/main">
               <a:ext uri="{FF2B5EF4-FFF2-40B4-BE49-F238E27FC236}">
-                <a16:creationId xmlns:a16="http://schemas.microsoft.com/office/drawing/2014/main" id="{61738087-D73A-4670-ABCE-18F2FB835429}"/>
+                <a16:creationId xmlns:a16="http://schemas.microsoft.com/office/drawing/2014/main" id="{3C9DB5FA-B0EB-4F8A-B836-5120C3C21EBB}"/>
               </a:ext>
             </a:extLst>
           </p:cNvPr>
@@ -3539,7 +3539,7 @@
           <p:cNvPr id="12" name="">
             <a:extLst xmlns:a="http://schemas.openxmlformats.org/drawingml/2006/main">
               <a:ext uri="{FF2B5EF4-FFF2-40B4-BE49-F238E27FC236}">
-                <a16:creationId xmlns:a16="http://schemas.microsoft.com/office/drawing/2014/main" id="{BA732AB3-08A4-4A7C-84A6-9E1A3B2EEB1B}"/>
+                <a16:creationId xmlns:a16="http://schemas.microsoft.com/office/drawing/2014/main" id="{27B31572-7D1B-4225-8680-5593E9E72C9E}"/>
               </a:ext>
             </a:extLst>
           </p:cNvPr>
@@ -3595,7 +3595,7 @@
           <p:cNvPr id="13" name="">
             <a:extLst xmlns:a="http://schemas.openxmlformats.org/drawingml/2006/main">
               <a:ext uri="{FF2B5EF4-FFF2-40B4-BE49-F238E27FC236}">
-                <a16:creationId xmlns:a16="http://schemas.microsoft.com/office/drawing/2014/main" id="{E106359E-602F-47FA-AFD9-69CBBC5BC53F}"/>
+                <a16:creationId xmlns:a16="http://schemas.microsoft.com/office/drawing/2014/main" id="{AECDC81B-CB27-473B-86AE-D7452137E9A5}"/>
               </a:ext>
             </a:extLst>
           </p:cNvPr>
@@ -3626,7 +3626,7 @@
           <p:cNvPr id="14" name="">
             <a:extLst xmlns:a="http://schemas.openxmlformats.org/drawingml/2006/main">
               <a:ext uri="{FF2B5EF4-FFF2-40B4-BE49-F238E27FC236}">
-                <a16:creationId xmlns:a16="http://schemas.microsoft.com/office/drawing/2014/main" id="{412A59C3-906A-439C-A727-6AB9E721FA62}"/>
+                <a16:creationId xmlns:a16="http://schemas.microsoft.com/office/drawing/2014/main" id="{A0C6030E-BCC8-46AE-BEC1-0F62F446E3EB}"/>
               </a:ext>
             </a:extLst>
           </p:cNvPr>
@@ -3682,7 +3682,7 @@
           <p:cNvPr id="15" name="">
             <a:extLst xmlns:a="http://schemas.openxmlformats.org/drawingml/2006/main">
               <a:ext uri="{FF2B5EF4-FFF2-40B4-BE49-F238E27FC236}">
-                <a16:creationId xmlns:a16="http://schemas.microsoft.com/office/drawing/2014/main" id="{E4C7BAAB-8662-4B58-9F7B-0E2AC70AC707}"/>
+                <a16:creationId xmlns:a16="http://schemas.microsoft.com/office/drawing/2014/main" id="{A4C4D527-B34D-4100-B652-F5495D76111B}"/>
               </a:ext>
             </a:extLst>
           </p:cNvPr>
@@ -3738,7 +3738,7 @@
           <p:cNvPr id="16" name="">
             <a:extLst xmlns:a="http://schemas.openxmlformats.org/drawingml/2006/main">
               <a:ext uri="{FF2B5EF4-FFF2-40B4-BE49-F238E27FC236}">
-                <a16:creationId xmlns:a16="http://schemas.microsoft.com/office/drawing/2014/main" id="{62048A41-F9F5-4A4A-8702-FB2FFFEE77AF}"/>
+                <a16:creationId xmlns:a16="http://schemas.microsoft.com/office/drawing/2014/main" id="{B9B3E8A3-4486-48C1-B121-9FDF64B8D4BC}"/>
               </a:ext>
             </a:extLst>
           </p:cNvPr>
@@ -3794,7 +3794,7 @@
           <p:cNvPr id="17" name="">
             <a:extLst xmlns:a="http://schemas.openxmlformats.org/drawingml/2006/main">
               <a:ext uri="{FF2B5EF4-FFF2-40B4-BE49-F238E27FC236}">
-                <a16:creationId xmlns:a16="http://schemas.microsoft.com/office/drawing/2014/main" id="{35AFD851-6925-4564-B463-A59668CA2EA5}"/>
+                <a16:creationId xmlns:a16="http://schemas.microsoft.com/office/drawing/2014/main" id="{3AC75207-C74C-41DC-B538-A277113718D4}"/>
               </a:ext>
             </a:extLst>
           </p:cNvPr>
@@ -3825,7 +3825,7 @@
           <p:cNvPr id="18" name="">
             <a:extLst xmlns:a="http://schemas.openxmlformats.org/drawingml/2006/main">
               <a:ext uri="{FF2B5EF4-FFF2-40B4-BE49-F238E27FC236}">
-                <a16:creationId xmlns:a16="http://schemas.microsoft.com/office/drawing/2014/main" id="{D5D00F54-85B7-46E1-A5FB-53081C62E1C3}"/>
+                <a16:creationId xmlns:a16="http://schemas.microsoft.com/office/drawing/2014/main" id="{C1A3F6D8-13E8-4018-8C39-23BA6D214A46}"/>
               </a:ext>
             </a:extLst>
           </p:cNvPr>
@@ -3881,7 +3881,7 @@
           <p:cNvPr id="19" name="">
             <a:extLst xmlns:a="http://schemas.openxmlformats.org/drawingml/2006/main">
               <a:ext uri="{FF2B5EF4-FFF2-40B4-BE49-F238E27FC236}">
-                <a16:creationId xmlns:a16="http://schemas.microsoft.com/office/drawing/2014/main" id="{6CCAF9E5-A528-4717-A2FC-D5D778A1CEE3}"/>
+                <a16:creationId xmlns:a16="http://schemas.microsoft.com/office/drawing/2014/main" id="{5041DBA6-7842-4A5F-87EB-CF10C3F6AF0F}"/>
               </a:ext>
             </a:extLst>
           </p:cNvPr>
@@ -3937,7 +3937,7 @@
           <p:cNvPr id="20" name="">
             <a:extLst xmlns:a="http://schemas.openxmlformats.org/drawingml/2006/main">
               <a:ext uri="{FF2B5EF4-FFF2-40B4-BE49-F238E27FC236}">
-                <a16:creationId xmlns:a16="http://schemas.microsoft.com/office/drawing/2014/main" id="{2450319E-FC67-401D-8F71-37EB3A60C05E}"/>
+                <a16:creationId xmlns:a16="http://schemas.microsoft.com/office/drawing/2014/main" id="{2CB7B3FB-5198-4FE2-8B41-FCD8E487B8DF}"/>
               </a:ext>
             </a:extLst>
           </p:cNvPr>
@@ -3993,7 +3993,7 @@
           <p:cNvPr id="21" name="">
             <a:extLst xmlns:a="http://schemas.openxmlformats.org/drawingml/2006/main">
               <a:ext uri="{FF2B5EF4-FFF2-40B4-BE49-F238E27FC236}">
-                <a16:creationId xmlns:a16="http://schemas.microsoft.com/office/drawing/2014/main" id="{82498086-2941-49CC-8C46-B65E0EFA080C}"/>
+                <a16:creationId xmlns:a16="http://schemas.microsoft.com/office/drawing/2014/main" id="{B6539F44-396E-40AA-B382-3661B5FE4722}"/>
               </a:ext>
             </a:extLst>
           </p:cNvPr>
@@ -4024,7 +4024,7 @@
           <p:cNvPr id="22" name="">
             <a:extLst xmlns:a="http://schemas.openxmlformats.org/drawingml/2006/main">
               <a:ext uri="{FF2B5EF4-FFF2-40B4-BE49-F238E27FC236}">
-                <a16:creationId xmlns:a16="http://schemas.microsoft.com/office/drawing/2014/main" id="{55DE1320-D9C4-4CF7-BA23-839DA2418EAE}"/>
+                <a16:creationId xmlns:a16="http://schemas.microsoft.com/office/drawing/2014/main" id="{DCF9F738-49CB-4612-B484-50C4A8B3CB8D}"/>
               </a:ext>
             </a:extLst>
           </p:cNvPr>
@@ -4078,7 +4078,7 @@
     </p:spTree>
     <p:extLst>
       <p:ext uri="{BB962C8B-B14F-4D97-AF65-F5344CB8AC3E}">
-        <p14:creationId xmlns:p14="http://schemas.microsoft.com/office/powerpoint/2010/main" val="1617368759"/>
+        <p14:creationId xmlns:p14="http://schemas.microsoft.com/office/powerpoint/2010/main" val="1343664234"/>
       </p:ext>
     </p:extLst>
   </p:cSld>
@@ -4109,7 +4109,7 @@
           <p:cNvPr id="9" name="">
             <a:extLst xmlns:a="http://schemas.openxmlformats.org/drawingml/2006/main">
               <a:ext uri="{FF2B5EF4-FFF2-40B4-BE49-F238E27FC236}">
-                <a16:creationId xmlns:a16="http://schemas.microsoft.com/office/drawing/2014/main" id="{494C691F-539E-4151-99B3-5ED2AF2EE076}"/>
+                <a16:creationId xmlns:a16="http://schemas.microsoft.com/office/drawing/2014/main" id="{19875A20-B6A2-4EE4-9FCC-2984B7C2D534}"/>
               </a:ext>
             </a:extLst>
           </p:cNvPr>
@@ -4165,7 +4165,7 @@
           <p:cNvPr id="2" name="">
             <a:extLst xmlns:a="http://schemas.openxmlformats.org/drawingml/2006/main">
               <a:ext uri="{FF2B5EF4-FFF2-40B4-BE49-F238E27FC236}">
-                <a16:creationId xmlns:a16="http://schemas.microsoft.com/office/drawing/2014/main" id="{0FF0DFD3-2588-4009-AE26-E260ED2E09E4}"/>
+                <a16:creationId xmlns:a16="http://schemas.microsoft.com/office/drawing/2014/main" id="{45EB703B-D360-48D0-ACC7-F71C2B40BA48}"/>
               </a:ext>
             </a:extLst>
           </p:cNvPr>
@@ -4221,7 +4221,7 @@
           <p:cNvPr id="3" name="">
             <a:extLst xmlns:a="http://schemas.openxmlformats.org/drawingml/2006/main">
               <a:ext uri="{FF2B5EF4-FFF2-40B4-BE49-F238E27FC236}">
-                <a16:creationId xmlns:a16="http://schemas.microsoft.com/office/drawing/2014/main" id="{E34B8AF5-C734-491C-9589-DE3E1D2352FB}"/>
+                <a16:creationId xmlns:a16="http://schemas.microsoft.com/office/drawing/2014/main" id="{F2D47587-E2DC-4811-98A9-D2A9A9619B1F}"/>
               </a:ext>
             </a:extLst>
           </p:cNvPr>
@@ -4277,7 +4277,7 @@
           <p:cNvPr id="4" name="">
             <a:extLst xmlns:a="http://schemas.openxmlformats.org/drawingml/2006/main">
               <a:ext uri="{FF2B5EF4-FFF2-40B4-BE49-F238E27FC236}">
-                <a16:creationId xmlns:a16="http://schemas.microsoft.com/office/drawing/2014/main" id="{ECAAF5FA-706A-4B36-8D6A-DAAE5F4B30EC}"/>
+                <a16:creationId xmlns:a16="http://schemas.microsoft.com/office/drawing/2014/main" id="{7014D7D4-6C85-40A0-8EC4-F4C1A3BA1D66}"/>
               </a:ext>
             </a:extLst>
           </p:cNvPr>
@@ -4333,7 +4333,7 @@
           <p:cNvPr id="5" name="">
             <a:extLst xmlns:a="http://schemas.openxmlformats.org/drawingml/2006/main">
               <a:ext uri="{FF2B5EF4-FFF2-40B4-BE49-F238E27FC236}">
-                <a16:creationId xmlns:a16="http://schemas.microsoft.com/office/drawing/2014/main" id="{F9D92EBE-78CB-4AE0-9067-45284C1EF3BB}"/>
+                <a16:creationId xmlns:a16="http://schemas.microsoft.com/office/drawing/2014/main" id="{5432E8F7-19E4-4C8B-AE0F-1CD7A46D1B27}"/>
               </a:ext>
             </a:extLst>
           </p:cNvPr>
@@ -4473,7 +4473,7 @@
           <p:cNvPr id="6" name="">
             <a:extLst xmlns:a="http://schemas.openxmlformats.org/drawingml/2006/main">
               <a:ext uri="{FF2B5EF4-FFF2-40B4-BE49-F238E27FC236}">
-                <a16:creationId xmlns:a16="http://schemas.microsoft.com/office/drawing/2014/main" id="{805C1DD2-504F-4AE7-A881-714530D3D5FD}"/>
+                <a16:creationId xmlns:a16="http://schemas.microsoft.com/office/drawing/2014/main" id="{22D1A868-6BEC-460E-A1E0-4C8FC501DA18}"/>
               </a:ext>
             </a:extLst>
           </p:cNvPr>
@@ -4510,7 +4510,7 @@
           <p:nvPr/>
         </p:nvPicPr>
         <p:blipFill>
-          <a:blip xmlns:r="http://schemas.openxmlformats.org/officeDocument/2006/relationships" xmlns:a="http://schemas.openxmlformats.org/drawingml/2006/main" r:embed="R8eed80d6d7dd43ec"/>
+          <a:blip xmlns:r="http://schemas.openxmlformats.org/officeDocument/2006/relationships" xmlns:a="http://schemas.openxmlformats.org/drawingml/2006/main" r:embed="R9dcd7b1a6f0e4874"/>
           <a:stretch xmlns:a="http://schemas.openxmlformats.org/drawingml/2006/main"/>
         </p:blipFill>
         <p:spPr>
@@ -4528,7 +4528,7 @@
           <p:cNvPr id="8" name="">
             <a:extLst xmlns:a="http://schemas.openxmlformats.org/drawingml/2006/main">
               <a:ext uri="{FF2B5EF4-FFF2-40B4-BE49-F238E27FC236}">
-                <a16:creationId xmlns:a16="http://schemas.microsoft.com/office/drawing/2014/main" id="{88C81BBB-4073-4279-8336-FAE41F314036}"/>
+                <a16:creationId xmlns:a16="http://schemas.microsoft.com/office/drawing/2014/main" id="{8BD97425-5B98-4985-AE78-B2FA90E8B77D}"/>
               </a:ext>
             </a:extLst>
           </p:cNvPr>
@@ -4582,7 +4582,7 @@
     </p:spTree>
     <p:extLst>
       <p:ext uri="{BB962C8B-B14F-4D97-AF65-F5344CB8AC3E}">
-        <p14:creationId xmlns:p14="http://schemas.microsoft.com/office/powerpoint/2010/main" val="129126999"/>
+        <p14:creationId xmlns:p14="http://schemas.microsoft.com/office/powerpoint/2010/main" val="2120667256"/>
       </p:ext>
     </p:extLst>
   </p:cSld>
@@ -4613,7 +4613,7 @@
           <p:cNvPr id="15" name="">
             <a:extLst xmlns:a="http://schemas.openxmlformats.org/drawingml/2006/main">
               <a:ext uri="{FF2B5EF4-FFF2-40B4-BE49-F238E27FC236}">
-                <a16:creationId xmlns:a16="http://schemas.microsoft.com/office/drawing/2014/main" id="{FEA40A80-22F4-467C-87F9-7672E0788B9C}"/>
+                <a16:creationId xmlns:a16="http://schemas.microsoft.com/office/drawing/2014/main" id="{46E6FB26-D5D5-4A46-AB1E-DC4ABDADC5B1}"/>
               </a:ext>
             </a:extLst>
           </p:cNvPr>
@@ -4669,7 +4669,7 @@
           <p:cNvPr id="2" name="">
             <a:extLst xmlns:a="http://schemas.openxmlformats.org/drawingml/2006/main">
               <a:ext uri="{FF2B5EF4-FFF2-40B4-BE49-F238E27FC236}">
-                <a16:creationId xmlns:a16="http://schemas.microsoft.com/office/drawing/2014/main" id="{E2FE9937-8B9E-493F-B92E-1FA51797B643}"/>
+                <a16:creationId xmlns:a16="http://schemas.microsoft.com/office/drawing/2014/main" id="{90F4955D-3D9B-4F32-9693-247110F73A1A}"/>
               </a:ext>
             </a:extLst>
           </p:cNvPr>
@@ -4725,7 +4725,7 @@
           <p:cNvPr id="3" name="">
             <a:extLst xmlns:a="http://schemas.openxmlformats.org/drawingml/2006/main">
               <a:ext uri="{FF2B5EF4-FFF2-40B4-BE49-F238E27FC236}">
-                <a16:creationId xmlns:a16="http://schemas.microsoft.com/office/drawing/2014/main" id="{FF66B10C-E554-4177-989A-E1DCA99E4A8A}"/>
+                <a16:creationId xmlns:a16="http://schemas.microsoft.com/office/drawing/2014/main" id="{34732E50-87AA-4965-B623-C344BB9CAC49}"/>
               </a:ext>
             </a:extLst>
           </p:cNvPr>
@@ -4781,7 +4781,7 @@
           <p:cNvPr id="4" name="">
             <a:extLst xmlns:a="http://schemas.openxmlformats.org/drawingml/2006/main">
               <a:ext uri="{FF2B5EF4-FFF2-40B4-BE49-F238E27FC236}">
-                <a16:creationId xmlns:a16="http://schemas.microsoft.com/office/drawing/2014/main" id="{DCA56932-0194-4A58-81FD-14E2F6DA281C}"/>
+                <a16:creationId xmlns:a16="http://schemas.microsoft.com/office/drawing/2014/main" id="{09B4E3C8-0728-4493-BFBA-2127BE028924}"/>
               </a:ext>
             </a:extLst>
           </p:cNvPr>
@@ -4837,7 +4837,7 @@
           <p:cNvPr id="5" name="">
             <a:extLst xmlns:a="http://schemas.openxmlformats.org/drawingml/2006/main">
               <a:ext uri="{FF2B5EF4-FFF2-40B4-BE49-F238E27FC236}">
-                <a16:creationId xmlns:a16="http://schemas.microsoft.com/office/drawing/2014/main" id="{D10954E9-61FF-422D-BC8C-312B04EC16E1}"/>
+                <a16:creationId xmlns:a16="http://schemas.microsoft.com/office/drawing/2014/main" id="{848783C5-ED1C-4A8B-A702-0C42436655C4}"/>
               </a:ext>
             </a:extLst>
           </p:cNvPr>
@@ -4868,7 +4868,7 @@
           <p:cNvPr id="6" name="">
             <a:extLst xmlns:a="http://schemas.openxmlformats.org/drawingml/2006/main">
               <a:ext uri="{FF2B5EF4-FFF2-40B4-BE49-F238E27FC236}">
-                <a16:creationId xmlns:a16="http://schemas.microsoft.com/office/drawing/2014/main" id="{D8A24BE0-154F-4EA6-BFED-4419BA552CBA}"/>
+                <a16:creationId xmlns:a16="http://schemas.microsoft.com/office/drawing/2014/main" id="{95560C70-5F44-4242-AE54-DB978639DB9C}"/>
               </a:ext>
             </a:extLst>
           </p:cNvPr>
@@ -4899,7 +4899,7 @@
           <p:cNvPr id="7" name="">
             <a:extLst xmlns:a="http://schemas.openxmlformats.org/drawingml/2006/main">
               <a:ext uri="{FF2B5EF4-FFF2-40B4-BE49-F238E27FC236}">
-                <a16:creationId xmlns:a16="http://schemas.microsoft.com/office/drawing/2014/main" id="{92355CC2-217A-45E6-A3EF-C1711C48FC6A}"/>
+                <a16:creationId xmlns:a16="http://schemas.microsoft.com/office/drawing/2014/main" id="{D2E6A23D-2D90-43B4-81AB-79072E9AE3B4}"/>
               </a:ext>
             </a:extLst>
           </p:cNvPr>
@@ -4955,7 +4955,7 @@
           <p:cNvPr id="8" name="">
             <a:extLst xmlns:a="http://schemas.openxmlformats.org/drawingml/2006/main">
               <a:ext uri="{FF2B5EF4-FFF2-40B4-BE49-F238E27FC236}">
-                <a16:creationId xmlns:a16="http://schemas.microsoft.com/office/drawing/2014/main" id="{15E46925-0CBC-417F-801E-F43A1A7D7728}"/>
+                <a16:creationId xmlns:a16="http://schemas.microsoft.com/office/drawing/2014/main" id="{C4F426FF-3DA3-4366-8AB0-9CE767F5866B}"/>
               </a:ext>
             </a:extLst>
           </p:cNvPr>
@@ -5011,7 +5011,7 @@
           <p:cNvPr id="9" name="">
             <a:extLst xmlns:a="http://schemas.openxmlformats.org/drawingml/2006/main">
               <a:ext uri="{FF2B5EF4-FFF2-40B4-BE49-F238E27FC236}">
-                <a16:creationId xmlns:a16="http://schemas.microsoft.com/office/drawing/2014/main" id="{6C804EF9-2DA0-4EA7-8C55-CD4C2B8AE51E}"/>
+                <a16:creationId xmlns:a16="http://schemas.microsoft.com/office/drawing/2014/main" id="{D46F290F-82B9-4479-9CE8-E81401AB9A85}"/>
               </a:ext>
             </a:extLst>
           </p:cNvPr>
@@ -5136,7 +5136,7 @@
           <p:cNvPr id="10" name="">
             <a:extLst xmlns:a="http://schemas.openxmlformats.org/drawingml/2006/main">
               <a:ext uri="{FF2B5EF4-FFF2-40B4-BE49-F238E27FC236}">
-                <a16:creationId xmlns:a16="http://schemas.microsoft.com/office/drawing/2014/main" id="{F7B84331-3BFC-43B4-8994-354F112989DD}"/>
+                <a16:creationId xmlns:a16="http://schemas.microsoft.com/office/drawing/2014/main" id="{583777D4-9C91-4234-83D4-367769A2124A}"/>
               </a:ext>
             </a:extLst>
           </p:cNvPr>
@@ -5192,7 +5192,7 @@
           <p:cNvPr id="11" name="">
             <a:extLst xmlns:a="http://schemas.openxmlformats.org/drawingml/2006/main">
               <a:ext uri="{FF2B5EF4-FFF2-40B4-BE49-F238E27FC236}">
-                <a16:creationId xmlns:a16="http://schemas.microsoft.com/office/drawing/2014/main" id="{87D70DC2-A4AB-4ED6-8F08-446840043E06}"/>
+                <a16:creationId xmlns:a16="http://schemas.microsoft.com/office/drawing/2014/main" id="{3349EB32-EB0B-4BBF-808C-4E291489A313}"/>
               </a:ext>
             </a:extLst>
           </p:cNvPr>
@@ -5248,7 +5248,7 @@
           <p:cNvPr id="12" name="">
             <a:extLst xmlns:a="http://schemas.openxmlformats.org/drawingml/2006/main">
               <a:ext uri="{FF2B5EF4-FFF2-40B4-BE49-F238E27FC236}">
-                <a16:creationId xmlns:a16="http://schemas.microsoft.com/office/drawing/2014/main" id="{162D2ED4-D1D3-4453-96A5-F96FE7416780}"/>
+                <a16:creationId xmlns:a16="http://schemas.microsoft.com/office/drawing/2014/main" id="{01D8D650-839A-4156-B8AB-6B6DB4CE7C17}"/>
               </a:ext>
             </a:extLst>
           </p:cNvPr>
@@ -5304,7 +5304,7 @@
           <p:cNvPr id="13" name="">
             <a:extLst xmlns:a="http://schemas.openxmlformats.org/drawingml/2006/main">
               <a:ext uri="{FF2B5EF4-FFF2-40B4-BE49-F238E27FC236}">
-                <a16:creationId xmlns:a16="http://schemas.microsoft.com/office/drawing/2014/main" id="{15B1C00C-36CF-481D-A3B0-B5A21D36D2A5}"/>
+                <a16:creationId xmlns:a16="http://schemas.microsoft.com/office/drawing/2014/main" id="{D50AF19E-3655-4E69-AE4A-CB6088228F4C}"/>
               </a:ext>
             </a:extLst>
           </p:cNvPr>
@@ -5429,7 +5429,7 @@
           <p:cNvPr id="14" name="">
             <a:extLst xmlns:a="http://schemas.openxmlformats.org/drawingml/2006/main">
               <a:ext uri="{FF2B5EF4-FFF2-40B4-BE49-F238E27FC236}">
-                <a16:creationId xmlns:a16="http://schemas.microsoft.com/office/drawing/2014/main" id="{EB43DD86-B0B1-426E-8CCE-F9CBD28CBF8F}"/>
+                <a16:creationId xmlns:a16="http://schemas.microsoft.com/office/drawing/2014/main" id="{E0694DFD-2867-4B53-BC33-49E2D4E238DB}"/>
               </a:ext>
             </a:extLst>
           </p:cNvPr>
@@ -5483,7 +5483,7 @@
     </p:spTree>
     <p:extLst>
       <p:ext uri="{BB962C8B-B14F-4D97-AF65-F5344CB8AC3E}">
-        <p14:creationId xmlns:p14="http://schemas.microsoft.com/office/powerpoint/2010/main" val="1992646177"/>
+        <p14:creationId xmlns:p14="http://schemas.microsoft.com/office/powerpoint/2010/main" val="1900238781"/>
       </p:ext>
     </p:extLst>
   </p:cSld>
@@ -5514,7 +5514,7 @@
           <p:cNvPr id="20" name="">
             <a:extLst xmlns:a="http://schemas.openxmlformats.org/drawingml/2006/main">
               <a:ext uri="{FF2B5EF4-FFF2-40B4-BE49-F238E27FC236}">
-                <a16:creationId xmlns:a16="http://schemas.microsoft.com/office/drawing/2014/main" id="{0F72C208-5661-415E-9EA6-FFA2833893CF}"/>
+                <a16:creationId xmlns:a16="http://schemas.microsoft.com/office/drawing/2014/main" id="{539E290F-A1E1-4AB9-A2C3-06A91CFB6866}"/>
               </a:ext>
             </a:extLst>
           </p:cNvPr>
@@ -5570,7 +5570,7 @@
           <p:cNvPr id="2" name="">
             <a:extLst xmlns:a="http://schemas.openxmlformats.org/drawingml/2006/main">
               <a:ext uri="{FF2B5EF4-FFF2-40B4-BE49-F238E27FC236}">
-                <a16:creationId xmlns:a16="http://schemas.microsoft.com/office/drawing/2014/main" id="{1195A01F-1B4B-4307-9753-09901D8D7BA1}"/>
+                <a16:creationId xmlns:a16="http://schemas.microsoft.com/office/drawing/2014/main" id="{2F1B2F78-6850-4364-A77C-F9793AF0FD74}"/>
               </a:ext>
             </a:extLst>
           </p:cNvPr>
@@ -5649,7 +5649,7 @@
           <p:cNvPr id="3" name="">
             <a:extLst xmlns:a="http://schemas.openxmlformats.org/drawingml/2006/main">
               <a:ext uri="{FF2B5EF4-FFF2-40B4-BE49-F238E27FC236}">
-                <a16:creationId xmlns:a16="http://schemas.microsoft.com/office/drawing/2014/main" id="{9AFB56DD-FA42-4004-B7B6-F1A6BC820B30}"/>
+                <a16:creationId xmlns:a16="http://schemas.microsoft.com/office/drawing/2014/main" id="{EF6F50E4-61C9-4158-B9BE-EBB676CA8B99}"/>
               </a:ext>
             </a:extLst>
           </p:cNvPr>
@@ -5705,7 +5705,7 @@
           <p:cNvPr id="4" name="">
             <a:extLst xmlns:a="http://schemas.openxmlformats.org/drawingml/2006/main">
               <a:ext uri="{FF2B5EF4-FFF2-40B4-BE49-F238E27FC236}">
-                <a16:creationId xmlns:a16="http://schemas.microsoft.com/office/drawing/2014/main" id="{AFF162B9-5646-4FC1-99CE-D82AAF60D883}"/>
+                <a16:creationId xmlns:a16="http://schemas.microsoft.com/office/drawing/2014/main" id="{BB7CE477-B088-4542-99DD-2D234D0FA3C0}"/>
               </a:ext>
             </a:extLst>
           </p:cNvPr>
@@ -5736,7 +5736,7 @@
           <p:cNvPr id="5" name="">
             <a:extLst xmlns:a="http://schemas.openxmlformats.org/drawingml/2006/main">
               <a:ext uri="{FF2B5EF4-FFF2-40B4-BE49-F238E27FC236}">
-                <a16:creationId xmlns:a16="http://schemas.microsoft.com/office/drawing/2014/main" id="{898D4CCF-A668-493E-BA5B-EAEB1D117764}"/>
+                <a16:creationId xmlns:a16="http://schemas.microsoft.com/office/drawing/2014/main" id="{F949F413-BD61-47DB-A472-294A2629D568}"/>
               </a:ext>
             </a:extLst>
           </p:cNvPr>
@@ -5792,7 +5792,7 @@
           <p:cNvPr id="6" name="">
             <a:extLst xmlns:a="http://schemas.openxmlformats.org/drawingml/2006/main">
               <a:ext uri="{FF2B5EF4-FFF2-40B4-BE49-F238E27FC236}">
-                <a16:creationId xmlns:a16="http://schemas.microsoft.com/office/drawing/2014/main" id="{F8873955-90C9-4D1C-A094-5B91710D336F}"/>
+                <a16:creationId xmlns:a16="http://schemas.microsoft.com/office/drawing/2014/main" id="{74366F38-5D5B-4D18-847D-36C3BA2BE6E7}"/>
               </a:ext>
             </a:extLst>
           </p:cNvPr>
@@ -5848,7 +5848,7 @@
           <p:cNvPr id="7" name="">
             <a:extLst xmlns:a="http://schemas.openxmlformats.org/drawingml/2006/main">
               <a:ext uri="{FF2B5EF4-FFF2-40B4-BE49-F238E27FC236}">
-                <a16:creationId xmlns:a16="http://schemas.microsoft.com/office/drawing/2014/main" id="{2199E5DB-E9D0-486D-9BF3-B4298DE991C1}"/>
+                <a16:creationId xmlns:a16="http://schemas.microsoft.com/office/drawing/2014/main" id="{96CC4E90-F8CD-44D5-A5A2-2A7270977159}"/>
               </a:ext>
             </a:extLst>
           </p:cNvPr>
@@ -5904,7 +5904,7 @@
           <p:cNvPr id="8" name="">
             <a:extLst xmlns:a="http://schemas.openxmlformats.org/drawingml/2006/main">
               <a:ext uri="{FF2B5EF4-FFF2-40B4-BE49-F238E27FC236}">
-                <a16:creationId xmlns:a16="http://schemas.microsoft.com/office/drawing/2014/main" id="{38D1F920-6D1E-48A5-903D-9B1F1F8D0B67}"/>
+                <a16:creationId xmlns:a16="http://schemas.microsoft.com/office/drawing/2014/main" id="{D4F6D0B5-919C-4A96-95F2-0725AECEA78B}"/>
               </a:ext>
             </a:extLst>
           </p:cNvPr>
@@ -5935,7 +5935,7 @@
           <p:cNvPr id="9" name="">
             <a:extLst xmlns:a="http://schemas.openxmlformats.org/drawingml/2006/main">
               <a:ext uri="{FF2B5EF4-FFF2-40B4-BE49-F238E27FC236}">
-                <a16:creationId xmlns:a16="http://schemas.microsoft.com/office/drawing/2014/main" id="{446DE91A-9E01-4BA7-85F8-AFCA1F2BC975}"/>
+                <a16:creationId xmlns:a16="http://schemas.microsoft.com/office/drawing/2014/main" id="{F8950D2D-8E2B-4B44-9AC5-D6829F949654}"/>
               </a:ext>
             </a:extLst>
           </p:cNvPr>
@@ -5991,7 +5991,7 @@
           <p:cNvPr id="10" name="">
             <a:extLst xmlns:a="http://schemas.openxmlformats.org/drawingml/2006/main">
               <a:ext uri="{FF2B5EF4-FFF2-40B4-BE49-F238E27FC236}">
-                <a16:creationId xmlns:a16="http://schemas.microsoft.com/office/drawing/2014/main" id="{D3591DB2-A5B6-430D-987D-41BF0266337F}"/>
+                <a16:creationId xmlns:a16="http://schemas.microsoft.com/office/drawing/2014/main" id="{FA8ABCD7-31D6-412A-ABB7-0DD0A007EED8}"/>
               </a:ext>
             </a:extLst>
           </p:cNvPr>
@@ -6047,7 +6047,7 @@
           <p:cNvPr id="11" name="">
             <a:extLst xmlns:a="http://schemas.openxmlformats.org/drawingml/2006/main">
               <a:ext uri="{FF2B5EF4-FFF2-40B4-BE49-F238E27FC236}">
-                <a16:creationId xmlns:a16="http://schemas.microsoft.com/office/drawing/2014/main" id="{915595B9-3054-4F4E-99C3-04C093281FD1}"/>
+                <a16:creationId xmlns:a16="http://schemas.microsoft.com/office/drawing/2014/main" id="{121BA430-7B4B-4ED3-895B-FBEE1EA820B7}"/>
               </a:ext>
             </a:extLst>
           </p:cNvPr>
@@ -6103,7 +6103,7 @@
           <p:cNvPr id="12" name="">
             <a:extLst xmlns:a="http://schemas.openxmlformats.org/drawingml/2006/main">
               <a:ext uri="{FF2B5EF4-FFF2-40B4-BE49-F238E27FC236}">
-                <a16:creationId xmlns:a16="http://schemas.microsoft.com/office/drawing/2014/main" id="{AB312A42-D859-4DF4-AB10-5258A25CC3B4}"/>
+                <a16:creationId xmlns:a16="http://schemas.microsoft.com/office/drawing/2014/main" id="{A89DCC27-7C73-4AF0-9CFA-D37666AB284D}"/>
               </a:ext>
             </a:extLst>
           </p:cNvPr>
@@ -6134,7 +6134,7 @@
           <p:cNvPr id="13" name="">
             <a:extLst xmlns:a="http://schemas.openxmlformats.org/drawingml/2006/main">
               <a:ext uri="{FF2B5EF4-FFF2-40B4-BE49-F238E27FC236}">
-                <a16:creationId xmlns:a16="http://schemas.microsoft.com/office/drawing/2014/main" id="{85348310-9230-4BCB-B702-C8897D4E224F}"/>
+                <a16:creationId xmlns:a16="http://schemas.microsoft.com/office/drawing/2014/main" id="{C6DA940C-950E-4652-9962-CBE43BAD1858}"/>
               </a:ext>
             </a:extLst>
           </p:cNvPr>
@@ -6190,7 +6190,7 @@
           <p:cNvPr id="14" name="">
             <a:extLst xmlns:a="http://schemas.openxmlformats.org/drawingml/2006/main">
               <a:ext uri="{FF2B5EF4-FFF2-40B4-BE49-F238E27FC236}">
-                <a16:creationId xmlns:a16="http://schemas.microsoft.com/office/drawing/2014/main" id="{6138600F-985D-4CDD-B77D-61F90E4B60AE}"/>
+                <a16:creationId xmlns:a16="http://schemas.microsoft.com/office/drawing/2014/main" id="{21727B1A-5E0A-4B29-B115-38E63801BE0C}"/>
               </a:ext>
             </a:extLst>
           </p:cNvPr>
@@ -6246,7 +6246,7 @@
           <p:cNvPr id="15" name="">
             <a:extLst xmlns:a="http://schemas.openxmlformats.org/drawingml/2006/main">
               <a:ext uri="{FF2B5EF4-FFF2-40B4-BE49-F238E27FC236}">
-                <a16:creationId xmlns:a16="http://schemas.microsoft.com/office/drawing/2014/main" id="{56FFA554-5394-4869-A87F-9FB41935CC4F}"/>
+                <a16:creationId xmlns:a16="http://schemas.microsoft.com/office/drawing/2014/main" id="{324C258D-BC9E-429B-A5BA-5E4C1FD434FD}"/>
               </a:ext>
             </a:extLst>
           </p:cNvPr>
@@ -6302,7 +6302,7 @@
           <p:cNvPr id="16" name="">
             <a:extLst xmlns:a="http://schemas.openxmlformats.org/drawingml/2006/main">
               <a:ext uri="{FF2B5EF4-FFF2-40B4-BE49-F238E27FC236}">
-                <a16:creationId xmlns:a16="http://schemas.microsoft.com/office/drawing/2014/main" id="{5C360CC8-49F3-4A8D-8471-4C140E45EDAF}"/>
+                <a16:creationId xmlns:a16="http://schemas.microsoft.com/office/drawing/2014/main" id="{DB1BA47E-1B8F-4959-979F-C206699BC595}"/>
               </a:ext>
             </a:extLst>
           </p:cNvPr>
@@ -6348,7 +6348,7 @@
                 <a:ea typeface="Arial"/>
                 <a:cs typeface="Arial"/>
               </a:rPr>
-              <a:t>Windows 10/11 (x64) + macOS (Apple Silicon) — İndirme: github.com/Azizsekerdil/EnglishCourseAI/releases (v1.1.2, özel repo)</a:t>
+              <a:t>Windows 10/11 (x64) + macOS (Apple Silicon) — İndirme: github.com/Azizsekerdil/EnglishCourseAI/releases (v1.2.0, özel repo)</a:t>
             </a:r>
           </a:p>
         </p:txBody>
@@ -6358,7 +6358,7 @@
           <p:cNvPr id="17" name="">
             <a:extLst xmlns:a="http://schemas.openxmlformats.org/drawingml/2006/main">
               <a:ext uri="{FF2B5EF4-FFF2-40B4-BE49-F238E27FC236}">
-                <a16:creationId xmlns:a16="http://schemas.microsoft.com/office/drawing/2014/main" id="{983322D9-8DEC-4B46-98E0-2F52A6FF5FBE}"/>
+                <a16:creationId xmlns:a16="http://schemas.microsoft.com/office/drawing/2014/main" id="{FD9AECD7-BC28-4F00-B04C-4235D817A693}"/>
               </a:ext>
             </a:extLst>
           </p:cNvPr>
@@ -6404,7 +6404,7 @@
                 <a:ea typeface="Arial"/>
                 <a:cs typeface="Arial"/>
               </a:rPr>
-              <a:t>Windows 10/11 (x64) &amp; macOS (Apple Silicon) — Download: GitHub Releases (v1.1.2)</a:t>
+              <a:t>Windows 10/11 (x64) &amp; macOS (Apple Silicon) — Download: GitHub Releases (v1.2.0)</a:t>
             </a:r>
           </a:p>
         </p:txBody>
@@ -6414,7 +6414,7 @@
           <p:cNvPr id="18" name="">
             <a:extLst xmlns:a="http://schemas.openxmlformats.org/drawingml/2006/main">
               <a:ext uri="{FF2B5EF4-FFF2-40B4-BE49-F238E27FC236}">
-                <a16:creationId xmlns:a16="http://schemas.microsoft.com/office/drawing/2014/main" id="{FE3994FD-B5CC-40DD-8D17-07165627DC4D}"/>
+                <a16:creationId xmlns:a16="http://schemas.microsoft.com/office/drawing/2014/main" id="{6616ADC4-701F-49E3-BE6C-DFC946E29372}"/>
               </a:ext>
             </a:extLst>
           </p:cNvPr>
@@ -6474,7 +6474,7 @@
           <p:nvPr/>
         </p:nvPicPr>
         <p:blipFill>
-          <a:blip xmlns:r="http://schemas.openxmlformats.org/officeDocument/2006/relationships" xmlns:a="http://schemas.openxmlformats.org/drawingml/2006/main" r:embed="R87f62bcad4ca40d5"/>
+          <a:blip xmlns:r="http://schemas.openxmlformats.org/officeDocument/2006/relationships" xmlns:a="http://schemas.openxmlformats.org/drawingml/2006/main" r:embed="Rd69c623c06e44ef6"/>
           <a:stretch xmlns:a="http://schemas.openxmlformats.org/drawingml/2006/main"/>
         </p:blipFill>
         <p:spPr>
@@ -6490,7 +6490,7 @@
     </p:spTree>
     <p:extLst>
       <p:ext uri="{BB962C8B-B14F-4D97-AF65-F5344CB8AC3E}">
-        <p14:creationId xmlns:p14="http://schemas.microsoft.com/office/powerpoint/2010/main" val="1312272765"/>
+        <p14:creationId xmlns:p14="http://schemas.microsoft.com/office/powerpoint/2010/main" val="1631260123"/>
       </p:ext>
     </p:extLst>
   </p:cSld>

</xml_diff>

<commit_message>
Sunum: v1.2.1 indirme bilgileri ve güncel test sayıları
Co-Authored-By: Claude Opus 5 <noreply@anthropic.com>
</commit_message>
<xml_diff>
--- a/docs/presentation/English-Course-AI-Bilingual.pptx
+++ b/docs/presentation/English-Course-AI-Bilingual.pptx
@@ -2,18 +2,18 @@
 <file path=ppt/presentation.xml><?xml version="1.0" encoding="utf-8"?>
 <p:presentation xmlns:p="http://schemas.openxmlformats.org/presentationml/2006/main">
   <p:sldMasterIdLst>
-    <p:sldMasterId xmlns:r="http://schemas.openxmlformats.org/officeDocument/2006/relationships" id="2147483648" r:id="R8d8fe72f936447d5"/>
+    <p:sldMasterId xmlns:r="http://schemas.openxmlformats.org/officeDocument/2006/relationships" id="2147483648" r:id="Rbf97a788f1934050"/>
   </p:sldMasterIdLst>
   <p:notesMasterIdLst>
-    <p:notesMasterId xmlns:r="http://schemas.openxmlformats.org/officeDocument/2006/relationships" r:id="R18be1d07e9b44a0b"/>
+    <p:notesMasterId xmlns:r="http://schemas.openxmlformats.org/officeDocument/2006/relationships" r:id="Rb4a246b63bb3407f"/>
   </p:notesMasterIdLst>
   <p:sldIdLst>
-    <p:sldId xmlns:r="http://schemas.openxmlformats.org/officeDocument/2006/relationships" id="256" r:id="R0d46ac6bf2174a6e"/>
-    <p:sldId xmlns:r="http://schemas.openxmlformats.org/officeDocument/2006/relationships" id="257" r:id="R8f756fe2ef2d4d40"/>
-    <p:sldId xmlns:r="http://schemas.openxmlformats.org/officeDocument/2006/relationships" id="258" r:id="Re86c3159511c46d4"/>
-    <p:sldId xmlns:r="http://schemas.openxmlformats.org/officeDocument/2006/relationships" id="259" r:id="R76347e6a2bbd4476"/>
-    <p:sldId xmlns:r="http://schemas.openxmlformats.org/officeDocument/2006/relationships" id="260" r:id="R71dbd64775dc4d8e"/>
-    <p:sldId xmlns:r="http://schemas.openxmlformats.org/officeDocument/2006/relationships" id="261" r:id="Ra12009e8cd984873"/>
+    <p:sldId xmlns:r="http://schemas.openxmlformats.org/officeDocument/2006/relationships" id="256" r:id="R943c728fe72b4619"/>
+    <p:sldId xmlns:r="http://schemas.openxmlformats.org/officeDocument/2006/relationships" id="257" r:id="Rede9425787244119"/>
+    <p:sldId xmlns:r="http://schemas.openxmlformats.org/officeDocument/2006/relationships" id="258" r:id="Rf3914741f8e74da5"/>
+    <p:sldId xmlns:r="http://schemas.openxmlformats.org/officeDocument/2006/relationships" id="259" r:id="R136728bc2cfe4182"/>
+    <p:sldId xmlns:r="http://schemas.openxmlformats.org/officeDocument/2006/relationships" id="260" r:id="R7735dd6b11c74ab7"/>
+    <p:sldId xmlns:r="http://schemas.openxmlformats.org/officeDocument/2006/relationships" id="261" r:id="R7d6d675d2f5d433f"/>
   </p:sldIdLst>
   <p:sldSz cx="12192000" cy="6858000"/>
   <p:notesSz cx="6858000" cy="9144000"/>
@@ -917,7 +917,7 @@
           </a:p>
           <a:p xmlns:a="http://schemas.openxmlformats.org/drawingml/2006/main">
             <a:r>
-              <a:t>- GitHub release (private repo): https://github.com/Azizsekerdil/EnglishCourseAI/releases/tag/v1.2.0 (Windows zip + macOS zip)</a:t>
+              <a:t>- GitHub release (private repo): https://github.com/Azizsekerdil/EnglishCourseAI/releases/tag/v1.2.1 (Windows zip + macOS zip)</a:t>
             </a:r>
           </a:p>
           <a:p xmlns:a="http://schemas.openxmlformats.org/drawingml/2006/main">
@@ -990,7 +990,7 @@
   </p:cSld>
   <p:clrMap bg1="lt1" tx1="dk1" bg2="lt2" tx2="dk2" accent1="accent1" accent2="accent2" accent3="accent3" accent4="accent4" accent5="accent5" accent6="accent6" hlink="hlink" folHlink="folHlink"/>
   <p:sldLayoutIdLst>
-    <p:sldLayoutId xmlns:r="http://schemas.openxmlformats.org/officeDocument/2006/relationships" id="2147483649" r:id="R71a237b368994cdb"/>
+    <p:sldLayoutId xmlns:r="http://schemas.openxmlformats.org/officeDocument/2006/relationships" id="2147483649" r:id="R72c9815521bf4343"/>
   </p:sldLayoutIdLst>
   <p:txStyles>
     <p:titleStyle>
@@ -1541,7 +1541,7 @@
           <p:cNvPr id="8" name="">
             <a:extLst xmlns:a="http://schemas.openxmlformats.org/drawingml/2006/main">
               <a:ext uri="{FF2B5EF4-FFF2-40B4-BE49-F238E27FC236}">
-                <a16:creationId xmlns:a16="http://schemas.microsoft.com/office/drawing/2014/main" id="{99DC8C5D-21E7-446F-BEB5-9F67A34FCD89}"/>
+                <a16:creationId xmlns:a16="http://schemas.microsoft.com/office/drawing/2014/main" id="{AB6D9E4F-6A6A-455B-A98A-65D4B7261C53}"/>
               </a:ext>
             </a:extLst>
           </p:cNvPr>
@@ -1576,7 +1576,7 @@
           <p:nvPr/>
         </p:nvPicPr>
         <p:blipFill>
-          <a:blip xmlns:r="http://schemas.openxmlformats.org/officeDocument/2006/relationships" xmlns:a="http://schemas.openxmlformats.org/drawingml/2006/main" r:embed="R51b6db79291a434d"/>
+          <a:blip xmlns:r="http://schemas.openxmlformats.org/officeDocument/2006/relationships" xmlns:a="http://schemas.openxmlformats.org/drawingml/2006/main" r:embed="R5ccd1820d2494fb5"/>
           <a:stretch xmlns:a="http://schemas.openxmlformats.org/drawingml/2006/main"/>
         </p:blipFill>
         <p:spPr>
@@ -1594,7 +1594,7 @@
           <p:cNvPr id="3" name="">
             <a:extLst xmlns:a="http://schemas.openxmlformats.org/drawingml/2006/main">
               <a:ext uri="{FF2B5EF4-FFF2-40B4-BE49-F238E27FC236}">
-                <a16:creationId xmlns:a16="http://schemas.microsoft.com/office/drawing/2014/main" id="{3BB05F6A-0E5B-4A8A-9BB8-391CB0262D05}"/>
+                <a16:creationId xmlns:a16="http://schemas.microsoft.com/office/drawing/2014/main" id="{DB33CD84-5755-4E9E-98ED-8F911180C7EE}"/>
               </a:ext>
             </a:extLst>
           </p:cNvPr>
@@ -1650,7 +1650,7 @@
           <p:cNvPr id="4" name="">
             <a:extLst xmlns:a="http://schemas.openxmlformats.org/drawingml/2006/main">
               <a:ext uri="{FF2B5EF4-FFF2-40B4-BE49-F238E27FC236}">
-                <a16:creationId xmlns:a16="http://schemas.microsoft.com/office/drawing/2014/main" id="{0DBF37C8-662A-42EE-973F-D433F92FCE61}"/>
+                <a16:creationId xmlns:a16="http://schemas.microsoft.com/office/drawing/2014/main" id="{98F7E67D-35C6-4637-A132-41DDEB6FA77B}"/>
               </a:ext>
             </a:extLst>
           </p:cNvPr>
@@ -1729,7 +1729,7 @@
           <p:cNvPr id="5" name="">
             <a:extLst xmlns:a="http://schemas.openxmlformats.org/drawingml/2006/main">
               <a:ext uri="{FF2B5EF4-FFF2-40B4-BE49-F238E27FC236}">
-                <a16:creationId xmlns:a16="http://schemas.microsoft.com/office/drawing/2014/main" id="{64A0CEDD-8F6F-4D0F-841B-80795F610A58}"/>
+                <a16:creationId xmlns:a16="http://schemas.microsoft.com/office/drawing/2014/main" id="{470611BA-376C-457F-8DE1-459B879DCA15}"/>
               </a:ext>
             </a:extLst>
           </p:cNvPr>
@@ -1760,7 +1760,7 @@
           <p:cNvPr id="6" name="">
             <a:extLst xmlns:a="http://schemas.openxmlformats.org/drawingml/2006/main">
               <a:ext uri="{FF2B5EF4-FFF2-40B4-BE49-F238E27FC236}">
-                <a16:creationId xmlns:a16="http://schemas.microsoft.com/office/drawing/2014/main" id="{4C6C2022-31E2-43FD-8C49-F2D8B7219873}"/>
+                <a16:creationId xmlns:a16="http://schemas.microsoft.com/office/drawing/2014/main" id="{2A5361FD-26F5-4CBC-8821-262FDC904D12}"/>
               </a:ext>
             </a:extLst>
           </p:cNvPr>
@@ -1839,7 +1839,7 @@
           <p:cNvPr id="7" name="">
             <a:extLst xmlns:a="http://schemas.openxmlformats.org/drawingml/2006/main">
               <a:ext uri="{FF2B5EF4-FFF2-40B4-BE49-F238E27FC236}">
-                <a16:creationId xmlns:a16="http://schemas.microsoft.com/office/drawing/2014/main" id="{EBE30B14-8BDE-44F4-A552-589CF294B891}"/>
+                <a16:creationId xmlns:a16="http://schemas.microsoft.com/office/drawing/2014/main" id="{B2369F18-6EC5-4E6A-BD56-6DED3091CDF6}"/>
               </a:ext>
             </a:extLst>
           </p:cNvPr>
@@ -1885,7 +1885,7 @@
                 <a:ea typeface="Arial"/>
                 <a:cs typeface="Arial"/>
               </a:rPr>
-              <a:t>v1.2.0  •  2026</a:t>
+              <a:t>v1.2.1  •  2026</a:t>
             </a:r>
           </a:p>
         </p:txBody>
@@ -1893,7 +1893,7 @@
     </p:spTree>
     <p:extLst>
       <p:ext uri="{BB962C8B-B14F-4D97-AF65-F5344CB8AC3E}">
-        <p14:creationId xmlns:p14="http://schemas.microsoft.com/office/powerpoint/2010/main" val="2001073212"/>
+        <p14:creationId xmlns:p14="http://schemas.microsoft.com/office/powerpoint/2010/main" val="2006506580"/>
       </p:ext>
     </p:extLst>
   </p:cSld>
@@ -1924,7 +1924,7 @@
           <p:cNvPr id="21" name="">
             <a:extLst xmlns:a="http://schemas.openxmlformats.org/drawingml/2006/main">
               <a:ext uri="{FF2B5EF4-FFF2-40B4-BE49-F238E27FC236}">
-                <a16:creationId xmlns:a16="http://schemas.microsoft.com/office/drawing/2014/main" id="{AB0C4FAA-4705-43F5-B047-EE94E53E034B}"/>
+                <a16:creationId xmlns:a16="http://schemas.microsoft.com/office/drawing/2014/main" id="{8B386BE9-E847-453F-B048-2DF41C9549C4}"/>
               </a:ext>
             </a:extLst>
           </p:cNvPr>
@@ -1980,7 +1980,7 @@
           <p:cNvPr id="2" name="">
             <a:extLst xmlns:a="http://schemas.openxmlformats.org/drawingml/2006/main">
               <a:ext uri="{FF2B5EF4-FFF2-40B4-BE49-F238E27FC236}">
-                <a16:creationId xmlns:a16="http://schemas.microsoft.com/office/drawing/2014/main" id="{920109E6-A992-49F9-8B4B-E985529540AE}"/>
+                <a16:creationId xmlns:a16="http://schemas.microsoft.com/office/drawing/2014/main" id="{55CB5858-6729-4832-858E-4D8C630999FC}"/>
               </a:ext>
             </a:extLst>
           </p:cNvPr>
@@ -2036,7 +2036,7 @@
           <p:cNvPr id="3" name="">
             <a:extLst xmlns:a="http://schemas.openxmlformats.org/drawingml/2006/main">
               <a:ext uri="{FF2B5EF4-FFF2-40B4-BE49-F238E27FC236}">
-                <a16:creationId xmlns:a16="http://schemas.microsoft.com/office/drawing/2014/main" id="{73EBA98A-5B58-4D55-9A3A-7FF73FB07A70}"/>
+                <a16:creationId xmlns:a16="http://schemas.microsoft.com/office/drawing/2014/main" id="{E62C9210-30E9-418A-8694-F1A2AEE4F307}"/>
               </a:ext>
             </a:extLst>
           </p:cNvPr>
@@ -2092,7 +2092,7 @@
           <p:cNvPr id="4" name="">
             <a:extLst xmlns:a="http://schemas.openxmlformats.org/drawingml/2006/main">
               <a:ext uri="{FF2B5EF4-FFF2-40B4-BE49-F238E27FC236}">
-                <a16:creationId xmlns:a16="http://schemas.microsoft.com/office/drawing/2014/main" id="{4B976DE8-C925-4446-969A-A6EB80B81BDB}"/>
+                <a16:creationId xmlns:a16="http://schemas.microsoft.com/office/drawing/2014/main" id="{E28C32EF-C62D-4349-8BDC-9045DF58A13A}"/>
               </a:ext>
             </a:extLst>
           </p:cNvPr>
@@ -2148,7 +2148,7 @@
           <p:cNvPr id="5" name="">
             <a:extLst xmlns:a="http://schemas.openxmlformats.org/drawingml/2006/main">
               <a:ext uri="{FF2B5EF4-FFF2-40B4-BE49-F238E27FC236}">
-                <a16:creationId xmlns:a16="http://schemas.microsoft.com/office/drawing/2014/main" id="{2258517F-545B-4B65-A21C-028A0F35E5E2}"/>
+                <a16:creationId xmlns:a16="http://schemas.microsoft.com/office/drawing/2014/main" id="{918AB2B7-BD3C-48DE-8C02-86CD1C0A9271}"/>
               </a:ext>
             </a:extLst>
           </p:cNvPr>
@@ -2179,7 +2179,7 @@
           <p:cNvPr id="6" name="">
             <a:extLst xmlns:a="http://schemas.openxmlformats.org/drawingml/2006/main">
               <a:ext uri="{FF2B5EF4-FFF2-40B4-BE49-F238E27FC236}">
-                <a16:creationId xmlns:a16="http://schemas.microsoft.com/office/drawing/2014/main" id="{26C4E4F1-0676-432C-AB13-0E8027279F7E}"/>
+                <a16:creationId xmlns:a16="http://schemas.microsoft.com/office/drawing/2014/main" id="{7C93DE75-64C1-4EE0-8E3B-88CB9AC5504E}"/>
               </a:ext>
             </a:extLst>
           </p:cNvPr>
@@ -2235,7 +2235,7 @@
           <p:cNvPr id="7" name="">
             <a:extLst xmlns:a="http://schemas.openxmlformats.org/drawingml/2006/main">
               <a:ext uri="{FF2B5EF4-FFF2-40B4-BE49-F238E27FC236}">
-                <a16:creationId xmlns:a16="http://schemas.microsoft.com/office/drawing/2014/main" id="{799F432F-3F4A-4983-97C1-D304C0D1E8F8}"/>
+                <a16:creationId xmlns:a16="http://schemas.microsoft.com/office/drawing/2014/main" id="{B979C984-734C-4C20-9FBA-D9E0867E4F2B}"/>
               </a:ext>
             </a:extLst>
           </p:cNvPr>
@@ -2291,7 +2291,7 @@
           <p:cNvPr id="8" name="">
             <a:extLst xmlns:a="http://schemas.openxmlformats.org/drawingml/2006/main">
               <a:ext uri="{FF2B5EF4-FFF2-40B4-BE49-F238E27FC236}">
-                <a16:creationId xmlns:a16="http://schemas.microsoft.com/office/drawing/2014/main" id="{79CC6708-3BD5-48DB-9F72-4C06F79C326F}"/>
+                <a16:creationId xmlns:a16="http://schemas.microsoft.com/office/drawing/2014/main" id="{734FB06A-9E9A-4F30-A4CD-D2D5DB2BCB64}"/>
               </a:ext>
             </a:extLst>
           </p:cNvPr>
@@ -2347,7 +2347,7 @@
           <p:cNvPr id="9" name="">
             <a:extLst xmlns:a="http://schemas.openxmlformats.org/drawingml/2006/main">
               <a:ext uri="{FF2B5EF4-FFF2-40B4-BE49-F238E27FC236}">
-                <a16:creationId xmlns:a16="http://schemas.microsoft.com/office/drawing/2014/main" id="{2B8C0AA5-D3A0-43D7-B7BA-2F9177746AB1}"/>
+                <a16:creationId xmlns:a16="http://schemas.microsoft.com/office/drawing/2014/main" id="{7E1804EE-65DB-41C9-B9AC-A11D1FAE3E8A}"/>
               </a:ext>
             </a:extLst>
           </p:cNvPr>
@@ -2378,7 +2378,7 @@
           <p:cNvPr id="10" name="">
             <a:extLst xmlns:a="http://schemas.openxmlformats.org/drawingml/2006/main">
               <a:ext uri="{FF2B5EF4-FFF2-40B4-BE49-F238E27FC236}">
-                <a16:creationId xmlns:a16="http://schemas.microsoft.com/office/drawing/2014/main" id="{FB528785-42DB-4AA5-98DB-A82503F444F6}"/>
+                <a16:creationId xmlns:a16="http://schemas.microsoft.com/office/drawing/2014/main" id="{23DE9910-A885-4520-B02F-C94D2D450C49}"/>
               </a:ext>
             </a:extLst>
           </p:cNvPr>
@@ -2434,7 +2434,7 @@
           <p:cNvPr id="11" name="">
             <a:extLst xmlns:a="http://schemas.openxmlformats.org/drawingml/2006/main">
               <a:ext uri="{FF2B5EF4-FFF2-40B4-BE49-F238E27FC236}">
-                <a16:creationId xmlns:a16="http://schemas.microsoft.com/office/drawing/2014/main" id="{850E84EA-C4A5-4543-BACF-100F702E88E0}"/>
+                <a16:creationId xmlns:a16="http://schemas.microsoft.com/office/drawing/2014/main" id="{575027DB-B2EA-4B1B-BC3D-539825234693}"/>
               </a:ext>
             </a:extLst>
           </p:cNvPr>
@@ -2490,7 +2490,7 @@
           <p:cNvPr id="12" name="">
             <a:extLst xmlns:a="http://schemas.openxmlformats.org/drawingml/2006/main">
               <a:ext uri="{FF2B5EF4-FFF2-40B4-BE49-F238E27FC236}">
-                <a16:creationId xmlns:a16="http://schemas.microsoft.com/office/drawing/2014/main" id="{6AEF1FFB-FD62-406D-A63A-FD5918484847}"/>
+                <a16:creationId xmlns:a16="http://schemas.microsoft.com/office/drawing/2014/main" id="{F786E57F-CB41-46C4-9CD7-DCBF55F63EAC}"/>
               </a:ext>
             </a:extLst>
           </p:cNvPr>
@@ -2546,7 +2546,7 @@
           <p:cNvPr id="13" name="">
             <a:extLst xmlns:a="http://schemas.openxmlformats.org/drawingml/2006/main">
               <a:ext uri="{FF2B5EF4-FFF2-40B4-BE49-F238E27FC236}">
-                <a16:creationId xmlns:a16="http://schemas.microsoft.com/office/drawing/2014/main" id="{72693063-A8DB-42B3-BC24-022B2B0EC66C}"/>
+                <a16:creationId xmlns:a16="http://schemas.microsoft.com/office/drawing/2014/main" id="{C03897BC-6153-46B9-A1AC-83FA1B384DA0}"/>
               </a:ext>
             </a:extLst>
           </p:cNvPr>
@@ -2577,7 +2577,7 @@
           <p:cNvPr id="14" name="">
             <a:extLst xmlns:a="http://schemas.openxmlformats.org/drawingml/2006/main">
               <a:ext uri="{FF2B5EF4-FFF2-40B4-BE49-F238E27FC236}">
-                <a16:creationId xmlns:a16="http://schemas.microsoft.com/office/drawing/2014/main" id="{BDAC83BC-E19A-4E0E-9FA9-95E82B44E588}"/>
+                <a16:creationId xmlns:a16="http://schemas.microsoft.com/office/drawing/2014/main" id="{60AFCAAD-422B-4EF7-A6AE-6C0949EB93BA}"/>
               </a:ext>
             </a:extLst>
           </p:cNvPr>
@@ -2633,7 +2633,7 @@
           <p:cNvPr id="15" name="">
             <a:extLst xmlns:a="http://schemas.openxmlformats.org/drawingml/2006/main">
               <a:ext uri="{FF2B5EF4-FFF2-40B4-BE49-F238E27FC236}">
-                <a16:creationId xmlns:a16="http://schemas.microsoft.com/office/drawing/2014/main" id="{77D1D702-DA9A-4173-AE3B-F5B7C8657ECE}"/>
+                <a16:creationId xmlns:a16="http://schemas.microsoft.com/office/drawing/2014/main" id="{9E090EF4-EF45-4E39-BC84-4305F394384C}"/>
               </a:ext>
             </a:extLst>
           </p:cNvPr>
@@ -2689,7 +2689,7 @@
           <p:cNvPr id="16" name="">
             <a:extLst xmlns:a="http://schemas.openxmlformats.org/drawingml/2006/main">
               <a:ext uri="{FF2B5EF4-FFF2-40B4-BE49-F238E27FC236}">
-                <a16:creationId xmlns:a16="http://schemas.microsoft.com/office/drawing/2014/main" id="{5D8F13FE-2EBE-492E-ADD0-A3D2D6B275DC}"/>
+                <a16:creationId xmlns:a16="http://schemas.microsoft.com/office/drawing/2014/main" id="{195BEA0F-4D64-46D6-9ADC-AF442CCD7852}"/>
               </a:ext>
             </a:extLst>
           </p:cNvPr>
@@ -2745,7 +2745,7 @@
           <p:cNvPr id="17" name="">
             <a:extLst xmlns:a="http://schemas.openxmlformats.org/drawingml/2006/main">
               <a:ext uri="{FF2B5EF4-FFF2-40B4-BE49-F238E27FC236}">
-                <a16:creationId xmlns:a16="http://schemas.microsoft.com/office/drawing/2014/main" id="{5266516F-68EC-43E2-BBCA-542875BFCF74}"/>
+                <a16:creationId xmlns:a16="http://schemas.microsoft.com/office/drawing/2014/main" id="{BE014128-F1F8-4FCB-B941-1A49C75B144C}"/>
               </a:ext>
             </a:extLst>
           </p:cNvPr>
@@ -2776,7 +2776,7 @@
           <p:cNvPr id="18" name="">
             <a:extLst xmlns:a="http://schemas.openxmlformats.org/drawingml/2006/main">
               <a:ext uri="{FF2B5EF4-FFF2-40B4-BE49-F238E27FC236}">
-                <a16:creationId xmlns:a16="http://schemas.microsoft.com/office/drawing/2014/main" id="{C2335960-598F-4951-9333-6DE126E39FD6}"/>
+                <a16:creationId xmlns:a16="http://schemas.microsoft.com/office/drawing/2014/main" id="{918FB66F-AF91-44EE-8243-7F2ED15C282D}"/>
               </a:ext>
             </a:extLst>
           </p:cNvPr>
@@ -2832,7 +2832,7 @@
           <p:cNvPr id="19" name="">
             <a:extLst xmlns:a="http://schemas.openxmlformats.org/drawingml/2006/main">
               <a:ext uri="{FF2B5EF4-FFF2-40B4-BE49-F238E27FC236}">
-                <a16:creationId xmlns:a16="http://schemas.microsoft.com/office/drawing/2014/main" id="{33307CC5-1DD3-41DF-96DD-C233B4696C6F}"/>
+                <a16:creationId xmlns:a16="http://schemas.microsoft.com/office/drawing/2014/main" id="{BC556B7E-8558-4B5A-8225-A9230371D70E}"/>
               </a:ext>
             </a:extLst>
           </p:cNvPr>
@@ -2888,7 +2888,7 @@
           <p:cNvPr id="20" name="">
             <a:extLst xmlns:a="http://schemas.openxmlformats.org/drawingml/2006/main">
               <a:ext uri="{FF2B5EF4-FFF2-40B4-BE49-F238E27FC236}">
-                <a16:creationId xmlns:a16="http://schemas.microsoft.com/office/drawing/2014/main" id="{BFBACD80-7B97-4BA6-9391-B5A36757DF11}"/>
+                <a16:creationId xmlns:a16="http://schemas.microsoft.com/office/drawing/2014/main" id="{313AB116-B139-498D-8F94-D397BDA88C1D}"/>
               </a:ext>
             </a:extLst>
           </p:cNvPr>
@@ -2942,7 +2942,7 @@
     </p:spTree>
     <p:extLst>
       <p:ext uri="{BB962C8B-B14F-4D97-AF65-F5344CB8AC3E}">
-        <p14:creationId xmlns:p14="http://schemas.microsoft.com/office/powerpoint/2010/main" val="318485728"/>
+        <p14:creationId xmlns:p14="http://schemas.microsoft.com/office/powerpoint/2010/main" val="910836135"/>
       </p:ext>
     </p:extLst>
   </p:cSld>
@@ -2973,7 +2973,7 @@
           <p:cNvPr id="23" name="">
             <a:extLst xmlns:a="http://schemas.openxmlformats.org/drawingml/2006/main">
               <a:ext uri="{FF2B5EF4-FFF2-40B4-BE49-F238E27FC236}">
-                <a16:creationId xmlns:a16="http://schemas.microsoft.com/office/drawing/2014/main" id="{6AE75E76-EA70-4430-9326-2F062A323F5C}"/>
+                <a16:creationId xmlns:a16="http://schemas.microsoft.com/office/drawing/2014/main" id="{BD349338-ED39-42DF-99A6-2498420654F0}"/>
               </a:ext>
             </a:extLst>
           </p:cNvPr>
@@ -3029,7 +3029,7 @@
           <p:cNvPr id="2" name="">
             <a:extLst xmlns:a="http://schemas.openxmlformats.org/drawingml/2006/main">
               <a:ext uri="{FF2B5EF4-FFF2-40B4-BE49-F238E27FC236}">
-                <a16:creationId xmlns:a16="http://schemas.microsoft.com/office/drawing/2014/main" id="{34ED261C-0FFA-4477-ACCB-8553DF3D9488}"/>
+                <a16:creationId xmlns:a16="http://schemas.microsoft.com/office/drawing/2014/main" id="{DAE1AA51-9EE4-46B4-8EFD-ECAD06BA5E41}"/>
               </a:ext>
             </a:extLst>
           </p:cNvPr>
@@ -3085,7 +3085,7 @@
           <p:cNvPr id="3" name="">
             <a:extLst xmlns:a="http://schemas.openxmlformats.org/drawingml/2006/main">
               <a:ext uri="{FF2B5EF4-FFF2-40B4-BE49-F238E27FC236}">
-                <a16:creationId xmlns:a16="http://schemas.microsoft.com/office/drawing/2014/main" id="{7F70C719-DBA8-4657-971D-F43414CE2DFB}"/>
+                <a16:creationId xmlns:a16="http://schemas.microsoft.com/office/drawing/2014/main" id="{96C0BC09-4406-416F-A85A-D9F209ED4D90}"/>
               </a:ext>
             </a:extLst>
           </p:cNvPr>
@@ -3141,7 +3141,7 @@
           <p:cNvPr id="4" name="">
             <a:extLst xmlns:a="http://schemas.openxmlformats.org/drawingml/2006/main">
               <a:ext uri="{FF2B5EF4-FFF2-40B4-BE49-F238E27FC236}">
-                <a16:creationId xmlns:a16="http://schemas.microsoft.com/office/drawing/2014/main" id="{09E128EC-41C1-4318-83E6-4EBAE38543DE}"/>
+                <a16:creationId xmlns:a16="http://schemas.microsoft.com/office/drawing/2014/main" id="{9175E832-06EF-4577-99F4-880AEACA61AF}"/>
               </a:ext>
             </a:extLst>
           </p:cNvPr>
@@ -3197,7 +3197,7 @@
           <p:cNvPr id="5" name="">
             <a:extLst xmlns:a="http://schemas.openxmlformats.org/drawingml/2006/main">
               <a:ext uri="{FF2B5EF4-FFF2-40B4-BE49-F238E27FC236}">
-                <a16:creationId xmlns:a16="http://schemas.microsoft.com/office/drawing/2014/main" id="{0F2B070B-E18E-4D59-8C9E-E5FE1150ECE3}"/>
+                <a16:creationId xmlns:a16="http://schemas.microsoft.com/office/drawing/2014/main" id="{8EAECEEF-467A-476C-A40E-7B2A49CF4CDB}"/>
               </a:ext>
             </a:extLst>
           </p:cNvPr>
@@ -3228,7 +3228,7 @@
           <p:cNvPr id="6" name="">
             <a:extLst xmlns:a="http://schemas.openxmlformats.org/drawingml/2006/main">
               <a:ext uri="{FF2B5EF4-FFF2-40B4-BE49-F238E27FC236}">
-                <a16:creationId xmlns:a16="http://schemas.microsoft.com/office/drawing/2014/main" id="{094954D8-17F8-48BF-BE5D-0E5BEA042585}"/>
+                <a16:creationId xmlns:a16="http://schemas.microsoft.com/office/drawing/2014/main" id="{66550FD7-106D-437B-86E7-FEA2818D2169}"/>
               </a:ext>
             </a:extLst>
           </p:cNvPr>
@@ -3284,7 +3284,7 @@
           <p:cNvPr id="7" name="">
             <a:extLst xmlns:a="http://schemas.openxmlformats.org/drawingml/2006/main">
               <a:ext uri="{FF2B5EF4-FFF2-40B4-BE49-F238E27FC236}">
-                <a16:creationId xmlns:a16="http://schemas.microsoft.com/office/drawing/2014/main" id="{B291BDF0-4D88-4D48-A88A-36B51717A92D}"/>
+                <a16:creationId xmlns:a16="http://schemas.microsoft.com/office/drawing/2014/main" id="{0DAB1DEF-499D-4AD4-A14F-0C7485CC4ECE}"/>
               </a:ext>
             </a:extLst>
           </p:cNvPr>
@@ -3340,7 +3340,7 @@
           <p:cNvPr id="8" name="">
             <a:extLst xmlns:a="http://schemas.openxmlformats.org/drawingml/2006/main">
               <a:ext uri="{FF2B5EF4-FFF2-40B4-BE49-F238E27FC236}">
-                <a16:creationId xmlns:a16="http://schemas.microsoft.com/office/drawing/2014/main" id="{51D04C6B-3784-46D0-97A3-D6B1C56E4037}"/>
+                <a16:creationId xmlns:a16="http://schemas.microsoft.com/office/drawing/2014/main" id="{710E19C2-2AD1-4AC6-94DC-1BBF023057F2}"/>
               </a:ext>
             </a:extLst>
           </p:cNvPr>
@@ -3396,7 +3396,7 @@
           <p:cNvPr id="9" name="">
             <a:extLst xmlns:a="http://schemas.openxmlformats.org/drawingml/2006/main">
               <a:ext uri="{FF2B5EF4-FFF2-40B4-BE49-F238E27FC236}">
-                <a16:creationId xmlns:a16="http://schemas.microsoft.com/office/drawing/2014/main" id="{AF42C9D4-E162-454E-A41D-B5148AF62B18}"/>
+                <a16:creationId xmlns:a16="http://schemas.microsoft.com/office/drawing/2014/main" id="{880617F6-AB8E-4CD1-86A1-FCF1D4DE42F6}"/>
               </a:ext>
             </a:extLst>
           </p:cNvPr>
@@ -3427,7 +3427,7 @@
           <p:cNvPr id="10" name="">
             <a:extLst xmlns:a="http://schemas.openxmlformats.org/drawingml/2006/main">
               <a:ext uri="{FF2B5EF4-FFF2-40B4-BE49-F238E27FC236}">
-                <a16:creationId xmlns:a16="http://schemas.microsoft.com/office/drawing/2014/main" id="{C28E28FA-2A48-45C7-8751-9AA2132FB180}"/>
+                <a16:creationId xmlns:a16="http://schemas.microsoft.com/office/drawing/2014/main" id="{D98DF582-788A-401F-84AC-80D58854F660}"/>
               </a:ext>
             </a:extLst>
           </p:cNvPr>
@@ -3483,7 +3483,7 @@
           <p:cNvPr id="11" name="">
             <a:extLst xmlns:a="http://schemas.openxmlformats.org/drawingml/2006/main">
               <a:ext uri="{FF2B5EF4-FFF2-40B4-BE49-F238E27FC236}">
-                <a16:creationId xmlns:a16="http://schemas.microsoft.com/office/drawing/2014/main" id="{3C9DB5FA-B0EB-4F8A-B836-5120C3C21EBB}"/>
+                <a16:creationId xmlns:a16="http://schemas.microsoft.com/office/drawing/2014/main" id="{DDF179E9-289D-46DB-83C3-05277A02D4B4}"/>
               </a:ext>
             </a:extLst>
           </p:cNvPr>
@@ -3539,7 +3539,7 @@
           <p:cNvPr id="12" name="">
             <a:extLst xmlns:a="http://schemas.openxmlformats.org/drawingml/2006/main">
               <a:ext uri="{FF2B5EF4-FFF2-40B4-BE49-F238E27FC236}">
-                <a16:creationId xmlns:a16="http://schemas.microsoft.com/office/drawing/2014/main" id="{27B31572-7D1B-4225-8680-5593E9E72C9E}"/>
+                <a16:creationId xmlns:a16="http://schemas.microsoft.com/office/drawing/2014/main" id="{33715E14-BA2D-4863-ADFD-11EE87EA03B5}"/>
               </a:ext>
             </a:extLst>
           </p:cNvPr>
@@ -3595,7 +3595,7 @@
           <p:cNvPr id="13" name="">
             <a:extLst xmlns:a="http://schemas.openxmlformats.org/drawingml/2006/main">
               <a:ext uri="{FF2B5EF4-FFF2-40B4-BE49-F238E27FC236}">
-                <a16:creationId xmlns:a16="http://schemas.microsoft.com/office/drawing/2014/main" id="{AECDC81B-CB27-473B-86AE-D7452137E9A5}"/>
+                <a16:creationId xmlns:a16="http://schemas.microsoft.com/office/drawing/2014/main" id="{D7724E58-509D-45BC-8C38-314FF5CA0685}"/>
               </a:ext>
             </a:extLst>
           </p:cNvPr>
@@ -3626,7 +3626,7 @@
           <p:cNvPr id="14" name="">
             <a:extLst xmlns:a="http://schemas.openxmlformats.org/drawingml/2006/main">
               <a:ext uri="{FF2B5EF4-FFF2-40B4-BE49-F238E27FC236}">
-                <a16:creationId xmlns:a16="http://schemas.microsoft.com/office/drawing/2014/main" id="{A0C6030E-BCC8-46AE-BEC1-0F62F446E3EB}"/>
+                <a16:creationId xmlns:a16="http://schemas.microsoft.com/office/drawing/2014/main" id="{85AD96E4-4939-4C94-B4C7-CB47A3756BC9}"/>
               </a:ext>
             </a:extLst>
           </p:cNvPr>
@@ -3682,7 +3682,7 @@
           <p:cNvPr id="15" name="">
             <a:extLst xmlns:a="http://schemas.openxmlformats.org/drawingml/2006/main">
               <a:ext uri="{FF2B5EF4-FFF2-40B4-BE49-F238E27FC236}">
-                <a16:creationId xmlns:a16="http://schemas.microsoft.com/office/drawing/2014/main" id="{A4C4D527-B34D-4100-B652-F5495D76111B}"/>
+                <a16:creationId xmlns:a16="http://schemas.microsoft.com/office/drawing/2014/main" id="{6AD42633-026C-46B5-BDBE-DFED8BA77D2E}"/>
               </a:ext>
             </a:extLst>
           </p:cNvPr>
@@ -3738,7 +3738,7 @@
           <p:cNvPr id="16" name="">
             <a:extLst xmlns:a="http://schemas.openxmlformats.org/drawingml/2006/main">
               <a:ext uri="{FF2B5EF4-FFF2-40B4-BE49-F238E27FC236}">
-                <a16:creationId xmlns:a16="http://schemas.microsoft.com/office/drawing/2014/main" id="{B9B3E8A3-4486-48C1-B121-9FDF64B8D4BC}"/>
+                <a16:creationId xmlns:a16="http://schemas.microsoft.com/office/drawing/2014/main" id="{8ACAB495-A13C-4CB4-912E-E42AA393E8CA}"/>
               </a:ext>
             </a:extLst>
           </p:cNvPr>
@@ -3794,7 +3794,7 @@
           <p:cNvPr id="17" name="">
             <a:extLst xmlns:a="http://schemas.openxmlformats.org/drawingml/2006/main">
               <a:ext uri="{FF2B5EF4-FFF2-40B4-BE49-F238E27FC236}">
-                <a16:creationId xmlns:a16="http://schemas.microsoft.com/office/drawing/2014/main" id="{3AC75207-C74C-41DC-B538-A277113718D4}"/>
+                <a16:creationId xmlns:a16="http://schemas.microsoft.com/office/drawing/2014/main" id="{195D146F-ED3B-4D96-9149-AB6EFE6ABA55}"/>
               </a:ext>
             </a:extLst>
           </p:cNvPr>
@@ -3825,7 +3825,7 @@
           <p:cNvPr id="18" name="">
             <a:extLst xmlns:a="http://schemas.openxmlformats.org/drawingml/2006/main">
               <a:ext uri="{FF2B5EF4-FFF2-40B4-BE49-F238E27FC236}">
-                <a16:creationId xmlns:a16="http://schemas.microsoft.com/office/drawing/2014/main" id="{C1A3F6D8-13E8-4018-8C39-23BA6D214A46}"/>
+                <a16:creationId xmlns:a16="http://schemas.microsoft.com/office/drawing/2014/main" id="{28895316-D729-4E15-9C83-5766F83A2C59}"/>
               </a:ext>
             </a:extLst>
           </p:cNvPr>
@@ -3881,7 +3881,7 @@
           <p:cNvPr id="19" name="">
             <a:extLst xmlns:a="http://schemas.openxmlformats.org/drawingml/2006/main">
               <a:ext uri="{FF2B5EF4-FFF2-40B4-BE49-F238E27FC236}">
-                <a16:creationId xmlns:a16="http://schemas.microsoft.com/office/drawing/2014/main" id="{5041DBA6-7842-4A5F-87EB-CF10C3F6AF0F}"/>
+                <a16:creationId xmlns:a16="http://schemas.microsoft.com/office/drawing/2014/main" id="{9E55AD71-AE87-42CF-8685-95642BEFC186}"/>
               </a:ext>
             </a:extLst>
           </p:cNvPr>
@@ -3937,7 +3937,7 @@
           <p:cNvPr id="20" name="">
             <a:extLst xmlns:a="http://schemas.openxmlformats.org/drawingml/2006/main">
               <a:ext uri="{FF2B5EF4-FFF2-40B4-BE49-F238E27FC236}">
-                <a16:creationId xmlns:a16="http://schemas.microsoft.com/office/drawing/2014/main" id="{2CB7B3FB-5198-4FE2-8B41-FCD8E487B8DF}"/>
+                <a16:creationId xmlns:a16="http://schemas.microsoft.com/office/drawing/2014/main" id="{D25CBE83-2384-4F8C-972E-55A1B4A1C00F}"/>
               </a:ext>
             </a:extLst>
           </p:cNvPr>
@@ -3993,7 +3993,7 @@
           <p:cNvPr id="21" name="">
             <a:extLst xmlns:a="http://schemas.openxmlformats.org/drawingml/2006/main">
               <a:ext uri="{FF2B5EF4-FFF2-40B4-BE49-F238E27FC236}">
-                <a16:creationId xmlns:a16="http://schemas.microsoft.com/office/drawing/2014/main" id="{B6539F44-396E-40AA-B382-3661B5FE4722}"/>
+                <a16:creationId xmlns:a16="http://schemas.microsoft.com/office/drawing/2014/main" id="{153B8A1E-C5AB-472E-93A2-802544B72468}"/>
               </a:ext>
             </a:extLst>
           </p:cNvPr>
@@ -4024,7 +4024,7 @@
           <p:cNvPr id="22" name="">
             <a:extLst xmlns:a="http://schemas.openxmlformats.org/drawingml/2006/main">
               <a:ext uri="{FF2B5EF4-FFF2-40B4-BE49-F238E27FC236}">
-                <a16:creationId xmlns:a16="http://schemas.microsoft.com/office/drawing/2014/main" id="{DCF9F738-49CB-4612-B484-50C4A8B3CB8D}"/>
+                <a16:creationId xmlns:a16="http://schemas.microsoft.com/office/drawing/2014/main" id="{A8BE608A-E70C-447E-8ACB-C965D62E7E7C}"/>
               </a:ext>
             </a:extLst>
           </p:cNvPr>
@@ -4078,7 +4078,7 @@
     </p:spTree>
     <p:extLst>
       <p:ext uri="{BB962C8B-B14F-4D97-AF65-F5344CB8AC3E}">
-        <p14:creationId xmlns:p14="http://schemas.microsoft.com/office/powerpoint/2010/main" val="1343664234"/>
+        <p14:creationId xmlns:p14="http://schemas.microsoft.com/office/powerpoint/2010/main" val="274168482"/>
       </p:ext>
     </p:extLst>
   </p:cSld>
@@ -4109,7 +4109,7 @@
           <p:cNvPr id="9" name="">
             <a:extLst xmlns:a="http://schemas.openxmlformats.org/drawingml/2006/main">
               <a:ext uri="{FF2B5EF4-FFF2-40B4-BE49-F238E27FC236}">
-                <a16:creationId xmlns:a16="http://schemas.microsoft.com/office/drawing/2014/main" id="{19875A20-B6A2-4EE4-9FCC-2984B7C2D534}"/>
+                <a16:creationId xmlns:a16="http://schemas.microsoft.com/office/drawing/2014/main" id="{74D4C853-9345-4C90-A396-9DEC84D29DB6}"/>
               </a:ext>
             </a:extLst>
           </p:cNvPr>
@@ -4165,7 +4165,7 @@
           <p:cNvPr id="2" name="">
             <a:extLst xmlns:a="http://schemas.openxmlformats.org/drawingml/2006/main">
               <a:ext uri="{FF2B5EF4-FFF2-40B4-BE49-F238E27FC236}">
-                <a16:creationId xmlns:a16="http://schemas.microsoft.com/office/drawing/2014/main" id="{45EB703B-D360-48D0-ACC7-F71C2B40BA48}"/>
+                <a16:creationId xmlns:a16="http://schemas.microsoft.com/office/drawing/2014/main" id="{165E37EE-73F5-4E22-B79F-92BBCC5905ED}"/>
               </a:ext>
             </a:extLst>
           </p:cNvPr>
@@ -4221,7 +4221,7 @@
           <p:cNvPr id="3" name="">
             <a:extLst xmlns:a="http://schemas.openxmlformats.org/drawingml/2006/main">
               <a:ext uri="{FF2B5EF4-FFF2-40B4-BE49-F238E27FC236}">
-                <a16:creationId xmlns:a16="http://schemas.microsoft.com/office/drawing/2014/main" id="{F2D47587-E2DC-4811-98A9-D2A9A9619B1F}"/>
+                <a16:creationId xmlns:a16="http://schemas.microsoft.com/office/drawing/2014/main" id="{18ACC60F-850B-494B-A81C-5E4572E1D8A6}"/>
               </a:ext>
             </a:extLst>
           </p:cNvPr>
@@ -4277,7 +4277,7 @@
           <p:cNvPr id="4" name="">
             <a:extLst xmlns:a="http://schemas.openxmlformats.org/drawingml/2006/main">
               <a:ext uri="{FF2B5EF4-FFF2-40B4-BE49-F238E27FC236}">
-                <a16:creationId xmlns:a16="http://schemas.microsoft.com/office/drawing/2014/main" id="{7014D7D4-6C85-40A0-8EC4-F4C1A3BA1D66}"/>
+                <a16:creationId xmlns:a16="http://schemas.microsoft.com/office/drawing/2014/main" id="{86E85564-2C62-4F0A-8941-7573006D99DD}"/>
               </a:ext>
             </a:extLst>
           </p:cNvPr>
@@ -4333,7 +4333,7 @@
           <p:cNvPr id="5" name="">
             <a:extLst xmlns:a="http://schemas.openxmlformats.org/drawingml/2006/main">
               <a:ext uri="{FF2B5EF4-FFF2-40B4-BE49-F238E27FC236}">
-                <a16:creationId xmlns:a16="http://schemas.microsoft.com/office/drawing/2014/main" id="{5432E8F7-19E4-4C8B-AE0F-1CD7A46D1B27}"/>
+                <a16:creationId xmlns:a16="http://schemas.microsoft.com/office/drawing/2014/main" id="{5A5A6AD9-9915-44AB-ACB9-9B639E152394}"/>
               </a:ext>
             </a:extLst>
           </p:cNvPr>
@@ -4473,7 +4473,7 @@
           <p:cNvPr id="6" name="">
             <a:extLst xmlns:a="http://schemas.openxmlformats.org/drawingml/2006/main">
               <a:ext uri="{FF2B5EF4-FFF2-40B4-BE49-F238E27FC236}">
-                <a16:creationId xmlns:a16="http://schemas.microsoft.com/office/drawing/2014/main" id="{22D1A868-6BEC-460E-A1E0-4C8FC501DA18}"/>
+                <a16:creationId xmlns:a16="http://schemas.microsoft.com/office/drawing/2014/main" id="{0C3CB1AF-D796-4390-B9B0-84DB400AED6B}"/>
               </a:ext>
             </a:extLst>
           </p:cNvPr>
@@ -4510,7 +4510,7 @@
           <p:nvPr/>
         </p:nvPicPr>
         <p:blipFill>
-          <a:blip xmlns:r="http://schemas.openxmlformats.org/officeDocument/2006/relationships" xmlns:a="http://schemas.openxmlformats.org/drawingml/2006/main" r:embed="R9dcd7b1a6f0e4874"/>
+          <a:blip xmlns:r="http://schemas.openxmlformats.org/officeDocument/2006/relationships" xmlns:a="http://schemas.openxmlformats.org/drawingml/2006/main" r:embed="R728f3513c5974f48"/>
           <a:stretch xmlns:a="http://schemas.openxmlformats.org/drawingml/2006/main"/>
         </p:blipFill>
         <p:spPr>
@@ -4528,7 +4528,7 @@
           <p:cNvPr id="8" name="">
             <a:extLst xmlns:a="http://schemas.openxmlformats.org/drawingml/2006/main">
               <a:ext uri="{FF2B5EF4-FFF2-40B4-BE49-F238E27FC236}">
-                <a16:creationId xmlns:a16="http://schemas.microsoft.com/office/drawing/2014/main" id="{8BD97425-5B98-4985-AE78-B2FA90E8B77D}"/>
+                <a16:creationId xmlns:a16="http://schemas.microsoft.com/office/drawing/2014/main" id="{8D5957A3-45C2-41CC-91F7-06AAADA6728B}"/>
               </a:ext>
             </a:extLst>
           </p:cNvPr>
@@ -4582,7 +4582,7 @@
     </p:spTree>
     <p:extLst>
       <p:ext uri="{BB962C8B-B14F-4D97-AF65-F5344CB8AC3E}">
-        <p14:creationId xmlns:p14="http://schemas.microsoft.com/office/powerpoint/2010/main" val="2120667256"/>
+        <p14:creationId xmlns:p14="http://schemas.microsoft.com/office/powerpoint/2010/main" val="425413502"/>
       </p:ext>
     </p:extLst>
   </p:cSld>
@@ -4613,7 +4613,7 @@
           <p:cNvPr id="15" name="">
             <a:extLst xmlns:a="http://schemas.openxmlformats.org/drawingml/2006/main">
               <a:ext uri="{FF2B5EF4-FFF2-40B4-BE49-F238E27FC236}">
-                <a16:creationId xmlns:a16="http://schemas.microsoft.com/office/drawing/2014/main" id="{46E6FB26-D5D5-4A46-AB1E-DC4ABDADC5B1}"/>
+                <a16:creationId xmlns:a16="http://schemas.microsoft.com/office/drawing/2014/main" id="{F8AA6F61-E0B7-42AB-8640-2AD1620AB639}"/>
               </a:ext>
             </a:extLst>
           </p:cNvPr>
@@ -4669,7 +4669,7 @@
           <p:cNvPr id="2" name="">
             <a:extLst xmlns:a="http://schemas.openxmlformats.org/drawingml/2006/main">
               <a:ext uri="{FF2B5EF4-FFF2-40B4-BE49-F238E27FC236}">
-                <a16:creationId xmlns:a16="http://schemas.microsoft.com/office/drawing/2014/main" id="{90F4955D-3D9B-4F32-9693-247110F73A1A}"/>
+                <a16:creationId xmlns:a16="http://schemas.microsoft.com/office/drawing/2014/main" id="{2DA0F7FB-0F3E-44E0-AE4B-D529EAD7F351}"/>
               </a:ext>
             </a:extLst>
           </p:cNvPr>
@@ -4725,7 +4725,7 @@
           <p:cNvPr id="3" name="">
             <a:extLst xmlns:a="http://schemas.openxmlformats.org/drawingml/2006/main">
               <a:ext uri="{FF2B5EF4-FFF2-40B4-BE49-F238E27FC236}">
-                <a16:creationId xmlns:a16="http://schemas.microsoft.com/office/drawing/2014/main" id="{34732E50-87AA-4965-B623-C344BB9CAC49}"/>
+                <a16:creationId xmlns:a16="http://schemas.microsoft.com/office/drawing/2014/main" id="{BC92CFB7-3AE8-4718-9824-5869F2A3F148}"/>
               </a:ext>
             </a:extLst>
           </p:cNvPr>
@@ -4781,7 +4781,7 @@
           <p:cNvPr id="4" name="">
             <a:extLst xmlns:a="http://schemas.openxmlformats.org/drawingml/2006/main">
               <a:ext uri="{FF2B5EF4-FFF2-40B4-BE49-F238E27FC236}">
-                <a16:creationId xmlns:a16="http://schemas.microsoft.com/office/drawing/2014/main" id="{09B4E3C8-0728-4493-BFBA-2127BE028924}"/>
+                <a16:creationId xmlns:a16="http://schemas.microsoft.com/office/drawing/2014/main" id="{84AEA6DF-0B03-4856-A740-AF6010535ED9}"/>
               </a:ext>
             </a:extLst>
           </p:cNvPr>
@@ -4837,7 +4837,7 @@
           <p:cNvPr id="5" name="">
             <a:extLst xmlns:a="http://schemas.openxmlformats.org/drawingml/2006/main">
               <a:ext uri="{FF2B5EF4-FFF2-40B4-BE49-F238E27FC236}">
-                <a16:creationId xmlns:a16="http://schemas.microsoft.com/office/drawing/2014/main" id="{848783C5-ED1C-4A8B-A702-0C42436655C4}"/>
+                <a16:creationId xmlns:a16="http://schemas.microsoft.com/office/drawing/2014/main" id="{2909D0E9-2DBB-42A2-BF62-1052E391E47C}"/>
               </a:ext>
             </a:extLst>
           </p:cNvPr>
@@ -4868,7 +4868,7 @@
           <p:cNvPr id="6" name="">
             <a:extLst xmlns:a="http://schemas.openxmlformats.org/drawingml/2006/main">
               <a:ext uri="{FF2B5EF4-FFF2-40B4-BE49-F238E27FC236}">
-                <a16:creationId xmlns:a16="http://schemas.microsoft.com/office/drawing/2014/main" id="{95560C70-5F44-4242-AE54-DB978639DB9C}"/>
+                <a16:creationId xmlns:a16="http://schemas.microsoft.com/office/drawing/2014/main" id="{BC2E6CC8-F537-4E45-B2DC-2C46BE0F47D2}"/>
               </a:ext>
             </a:extLst>
           </p:cNvPr>
@@ -4899,7 +4899,7 @@
           <p:cNvPr id="7" name="">
             <a:extLst xmlns:a="http://schemas.openxmlformats.org/drawingml/2006/main">
               <a:ext uri="{FF2B5EF4-FFF2-40B4-BE49-F238E27FC236}">
-                <a16:creationId xmlns:a16="http://schemas.microsoft.com/office/drawing/2014/main" id="{D2E6A23D-2D90-43B4-81AB-79072E9AE3B4}"/>
+                <a16:creationId xmlns:a16="http://schemas.microsoft.com/office/drawing/2014/main" id="{295583CA-5A1F-4C3A-8317-BE6A953414D1}"/>
               </a:ext>
             </a:extLst>
           </p:cNvPr>
@@ -4955,7 +4955,7 @@
           <p:cNvPr id="8" name="">
             <a:extLst xmlns:a="http://schemas.openxmlformats.org/drawingml/2006/main">
               <a:ext uri="{FF2B5EF4-FFF2-40B4-BE49-F238E27FC236}">
-                <a16:creationId xmlns:a16="http://schemas.microsoft.com/office/drawing/2014/main" id="{C4F426FF-3DA3-4366-8AB0-9CE767F5866B}"/>
+                <a16:creationId xmlns:a16="http://schemas.microsoft.com/office/drawing/2014/main" id="{B291F339-BF8B-4E99-A54D-DC9EF0062524}"/>
               </a:ext>
             </a:extLst>
           </p:cNvPr>
@@ -5011,7 +5011,7 @@
           <p:cNvPr id="9" name="">
             <a:extLst xmlns:a="http://schemas.openxmlformats.org/drawingml/2006/main">
               <a:ext uri="{FF2B5EF4-FFF2-40B4-BE49-F238E27FC236}">
-                <a16:creationId xmlns:a16="http://schemas.microsoft.com/office/drawing/2014/main" id="{D46F290F-82B9-4479-9CE8-E81401AB9A85}"/>
+                <a16:creationId xmlns:a16="http://schemas.microsoft.com/office/drawing/2014/main" id="{3BE7DBBD-6C19-47DA-AA0C-377B10E90939}"/>
               </a:ext>
             </a:extLst>
           </p:cNvPr>
@@ -5136,7 +5136,7 @@
           <p:cNvPr id="10" name="">
             <a:extLst xmlns:a="http://schemas.openxmlformats.org/drawingml/2006/main">
               <a:ext uri="{FF2B5EF4-FFF2-40B4-BE49-F238E27FC236}">
-                <a16:creationId xmlns:a16="http://schemas.microsoft.com/office/drawing/2014/main" id="{583777D4-9C91-4234-83D4-367769A2124A}"/>
+                <a16:creationId xmlns:a16="http://schemas.microsoft.com/office/drawing/2014/main" id="{B1698B81-9B04-4A2D-A62C-DC7ADCB214AB}"/>
               </a:ext>
             </a:extLst>
           </p:cNvPr>
@@ -5192,7 +5192,7 @@
           <p:cNvPr id="11" name="">
             <a:extLst xmlns:a="http://schemas.openxmlformats.org/drawingml/2006/main">
               <a:ext uri="{FF2B5EF4-FFF2-40B4-BE49-F238E27FC236}">
-                <a16:creationId xmlns:a16="http://schemas.microsoft.com/office/drawing/2014/main" id="{3349EB32-EB0B-4BBF-808C-4E291489A313}"/>
+                <a16:creationId xmlns:a16="http://schemas.microsoft.com/office/drawing/2014/main" id="{BA61081D-45BC-40D6-A241-BAA2620A829F}"/>
               </a:ext>
             </a:extLst>
           </p:cNvPr>
@@ -5248,7 +5248,7 @@
           <p:cNvPr id="12" name="">
             <a:extLst xmlns:a="http://schemas.openxmlformats.org/drawingml/2006/main">
               <a:ext uri="{FF2B5EF4-FFF2-40B4-BE49-F238E27FC236}">
-                <a16:creationId xmlns:a16="http://schemas.microsoft.com/office/drawing/2014/main" id="{01D8D650-839A-4156-B8AB-6B6DB4CE7C17}"/>
+                <a16:creationId xmlns:a16="http://schemas.microsoft.com/office/drawing/2014/main" id="{0BA9DA8B-460C-4B9F-AC21-D7EE94DA68B3}"/>
               </a:ext>
             </a:extLst>
           </p:cNvPr>
@@ -5304,7 +5304,7 @@
           <p:cNvPr id="13" name="">
             <a:extLst xmlns:a="http://schemas.openxmlformats.org/drawingml/2006/main">
               <a:ext uri="{FF2B5EF4-FFF2-40B4-BE49-F238E27FC236}">
-                <a16:creationId xmlns:a16="http://schemas.microsoft.com/office/drawing/2014/main" id="{D50AF19E-3655-4E69-AE4A-CB6088228F4C}"/>
+                <a16:creationId xmlns:a16="http://schemas.microsoft.com/office/drawing/2014/main" id="{9E73D831-5BE7-4454-B7C6-BAF2A5982EC2}"/>
               </a:ext>
             </a:extLst>
           </p:cNvPr>
@@ -5429,7 +5429,7 @@
           <p:cNvPr id="14" name="">
             <a:extLst xmlns:a="http://schemas.openxmlformats.org/drawingml/2006/main">
               <a:ext uri="{FF2B5EF4-FFF2-40B4-BE49-F238E27FC236}">
-                <a16:creationId xmlns:a16="http://schemas.microsoft.com/office/drawing/2014/main" id="{E0694DFD-2867-4B53-BC33-49E2D4E238DB}"/>
+                <a16:creationId xmlns:a16="http://schemas.microsoft.com/office/drawing/2014/main" id="{1F57F0E3-E494-4E00-9739-0F08CD8A3821}"/>
               </a:ext>
             </a:extLst>
           </p:cNvPr>
@@ -5483,7 +5483,7 @@
     </p:spTree>
     <p:extLst>
       <p:ext uri="{BB962C8B-B14F-4D97-AF65-F5344CB8AC3E}">
-        <p14:creationId xmlns:p14="http://schemas.microsoft.com/office/powerpoint/2010/main" val="1900238781"/>
+        <p14:creationId xmlns:p14="http://schemas.microsoft.com/office/powerpoint/2010/main" val="1268649860"/>
       </p:ext>
     </p:extLst>
   </p:cSld>
@@ -5514,7 +5514,7 @@
           <p:cNvPr id="20" name="">
             <a:extLst xmlns:a="http://schemas.openxmlformats.org/drawingml/2006/main">
               <a:ext uri="{FF2B5EF4-FFF2-40B4-BE49-F238E27FC236}">
-                <a16:creationId xmlns:a16="http://schemas.microsoft.com/office/drawing/2014/main" id="{539E290F-A1E1-4AB9-A2C3-06A91CFB6866}"/>
+                <a16:creationId xmlns:a16="http://schemas.microsoft.com/office/drawing/2014/main" id="{F7C4B55A-8B89-4F16-BAEB-C637A1BDF557}"/>
               </a:ext>
             </a:extLst>
           </p:cNvPr>
@@ -5570,7 +5570,7 @@
           <p:cNvPr id="2" name="">
             <a:extLst xmlns:a="http://schemas.openxmlformats.org/drawingml/2006/main">
               <a:ext uri="{FF2B5EF4-FFF2-40B4-BE49-F238E27FC236}">
-                <a16:creationId xmlns:a16="http://schemas.microsoft.com/office/drawing/2014/main" id="{2F1B2F78-6850-4364-A77C-F9793AF0FD74}"/>
+                <a16:creationId xmlns:a16="http://schemas.microsoft.com/office/drawing/2014/main" id="{DFB3EAB5-560B-498C-B309-5D980B371262}"/>
               </a:ext>
             </a:extLst>
           </p:cNvPr>
@@ -5649,7 +5649,7 @@
           <p:cNvPr id="3" name="">
             <a:extLst xmlns:a="http://schemas.openxmlformats.org/drawingml/2006/main">
               <a:ext uri="{FF2B5EF4-FFF2-40B4-BE49-F238E27FC236}">
-                <a16:creationId xmlns:a16="http://schemas.microsoft.com/office/drawing/2014/main" id="{EF6F50E4-61C9-4158-B9BE-EBB676CA8B99}"/>
+                <a16:creationId xmlns:a16="http://schemas.microsoft.com/office/drawing/2014/main" id="{6A944540-B970-4F0B-996A-2EF185529CFE}"/>
               </a:ext>
             </a:extLst>
           </p:cNvPr>
@@ -5705,7 +5705,7 @@
           <p:cNvPr id="4" name="">
             <a:extLst xmlns:a="http://schemas.openxmlformats.org/drawingml/2006/main">
               <a:ext uri="{FF2B5EF4-FFF2-40B4-BE49-F238E27FC236}">
-                <a16:creationId xmlns:a16="http://schemas.microsoft.com/office/drawing/2014/main" id="{BB7CE477-B088-4542-99DD-2D234D0FA3C0}"/>
+                <a16:creationId xmlns:a16="http://schemas.microsoft.com/office/drawing/2014/main" id="{B138FBC6-E2AF-4412-A66D-90497F2C8038}"/>
               </a:ext>
             </a:extLst>
           </p:cNvPr>
@@ -5736,7 +5736,7 @@
           <p:cNvPr id="5" name="">
             <a:extLst xmlns:a="http://schemas.openxmlformats.org/drawingml/2006/main">
               <a:ext uri="{FF2B5EF4-FFF2-40B4-BE49-F238E27FC236}">
-                <a16:creationId xmlns:a16="http://schemas.microsoft.com/office/drawing/2014/main" id="{F949F413-BD61-47DB-A472-294A2629D568}"/>
+                <a16:creationId xmlns:a16="http://schemas.microsoft.com/office/drawing/2014/main" id="{0BC0B4A0-0CF9-49D0-AE88-9B7C85D85899}"/>
               </a:ext>
             </a:extLst>
           </p:cNvPr>
@@ -5792,7 +5792,7 @@
           <p:cNvPr id="6" name="">
             <a:extLst xmlns:a="http://schemas.openxmlformats.org/drawingml/2006/main">
               <a:ext uri="{FF2B5EF4-FFF2-40B4-BE49-F238E27FC236}">
-                <a16:creationId xmlns:a16="http://schemas.microsoft.com/office/drawing/2014/main" id="{74366F38-5D5B-4D18-847D-36C3BA2BE6E7}"/>
+                <a16:creationId xmlns:a16="http://schemas.microsoft.com/office/drawing/2014/main" id="{41572A19-F94B-449D-809E-0B57D819DEDD}"/>
               </a:ext>
             </a:extLst>
           </p:cNvPr>
@@ -5848,7 +5848,7 @@
           <p:cNvPr id="7" name="">
             <a:extLst xmlns:a="http://schemas.openxmlformats.org/drawingml/2006/main">
               <a:ext uri="{FF2B5EF4-FFF2-40B4-BE49-F238E27FC236}">
-                <a16:creationId xmlns:a16="http://schemas.microsoft.com/office/drawing/2014/main" id="{96CC4E90-F8CD-44D5-A5A2-2A7270977159}"/>
+                <a16:creationId xmlns:a16="http://schemas.microsoft.com/office/drawing/2014/main" id="{DC73FDF0-9015-4C9D-9B91-3FAA72018026}"/>
               </a:ext>
             </a:extLst>
           </p:cNvPr>
@@ -5904,7 +5904,7 @@
           <p:cNvPr id="8" name="">
             <a:extLst xmlns:a="http://schemas.openxmlformats.org/drawingml/2006/main">
               <a:ext uri="{FF2B5EF4-FFF2-40B4-BE49-F238E27FC236}">
-                <a16:creationId xmlns:a16="http://schemas.microsoft.com/office/drawing/2014/main" id="{D4F6D0B5-919C-4A96-95F2-0725AECEA78B}"/>
+                <a16:creationId xmlns:a16="http://schemas.microsoft.com/office/drawing/2014/main" id="{06BA2BF7-E1C5-4FF0-BEF3-693243E58291}"/>
               </a:ext>
             </a:extLst>
           </p:cNvPr>
@@ -5935,7 +5935,7 @@
           <p:cNvPr id="9" name="">
             <a:extLst xmlns:a="http://schemas.openxmlformats.org/drawingml/2006/main">
               <a:ext uri="{FF2B5EF4-FFF2-40B4-BE49-F238E27FC236}">
-                <a16:creationId xmlns:a16="http://schemas.microsoft.com/office/drawing/2014/main" id="{F8950D2D-8E2B-4B44-9AC5-D6829F949654}"/>
+                <a16:creationId xmlns:a16="http://schemas.microsoft.com/office/drawing/2014/main" id="{BADD67C7-2C9C-4DF8-A1DE-8B3DB57C2D90}"/>
               </a:ext>
             </a:extLst>
           </p:cNvPr>
@@ -5991,7 +5991,7 @@
           <p:cNvPr id="10" name="">
             <a:extLst xmlns:a="http://schemas.openxmlformats.org/drawingml/2006/main">
               <a:ext uri="{FF2B5EF4-FFF2-40B4-BE49-F238E27FC236}">
-                <a16:creationId xmlns:a16="http://schemas.microsoft.com/office/drawing/2014/main" id="{FA8ABCD7-31D6-412A-ABB7-0DD0A007EED8}"/>
+                <a16:creationId xmlns:a16="http://schemas.microsoft.com/office/drawing/2014/main" id="{02358F1B-A2F1-452D-AA21-0042FE9573B9}"/>
               </a:ext>
             </a:extLst>
           </p:cNvPr>
@@ -6047,7 +6047,7 @@
           <p:cNvPr id="11" name="">
             <a:extLst xmlns:a="http://schemas.openxmlformats.org/drawingml/2006/main">
               <a:ext uri="{FF2B5EF4-FFF2-40B4-BE49-F238E27FC236}">
-                <a16:creationId xmlns:a16="http://schemas.microsoft.com/office/drawing/2014/main" id="{121BA430-7B4B-4ED3-895B-FBEE1EA820B7}"/>
+                <a16:creationId xmlns:a16="http://schemas.microsoft.com/office/drawing/2014/main" id="{DBF16789-E44D-4A0C-9ED8-2300531E026D}"/>
               </a:ext>
             </a:extLst>
           </p:cNvPr>
@@ -6103,7 +6103,7 @@
           <p:cNvPr id="12" name="">
             <a:extLst xmlns:a="http://schemas.openxmlformats.org/drawingml/2006/main">
               <a:ext uri="{FF2B5EF4-FFF2-40B4-BE49-F238E27FC236}">
-                <a16:creationId xmlns:a16="http://schemas.microsoft.com/office/drawing/2014/main" id="{A89DCC27-7C73-4AF0-9CFA-D37666AB284D}"/>
+                <a16:creationId xmlns:a16="http://schemas.microsoft.com/office/drawing/2014/main" id="{F15DD2A4-EC78-48D0-8216-D512C38D3CE1}"/>
               </a:ext>
             </a:extLst>
           </p:cNvPr>
@@ -6134,7 +6134,7 @@
           <p:cNvPr id="13" name="">
             <a:extLst xmlns:a="http://schemas.openxmlformats.org/drawingml/2006/main">
               <a:ext uri="{FF2B5EF4-FFF2-40B4-BE49-F238E27FC236}">
-                <a16:creationId xmlns:a16="http://schemas.microsoft.com/office/drawing/2014/main" id="{C6DA940C-950E-4652-9962-CBE43BAD1858}"/>
+                <a16:creationId xmlns:a16="http://schemas.microsoft.com/office/drawing/2014/main" id="{2449209D-38C4-49FE-BE9C-50DFF2F5A40E}"/>
               </a:ext>
             </a:extLst>
           </p:cNvPr>
@@ -6190,7 +6190,7 @@
           <p:cNvPr id="14" name="">
             <a:extLst xmlns:a="http://schemas.openxmlformats.org/drawingml/2006/main">
               <a:ext uri="{FF2B5EF4-FFF2-40B4-BE49-F238E27FC236}">
-                <a16:creationId xmlns:a16="http://schemas.microsoft.com/office/drawing/2014/main" id="{21727B1A-5E0A-4B29-B115-38E63801BE0C}"/>
+                <a16:creationId xmlns:a16="http://schemas.microsoft.com/office/drawing/2014/main" id="{2F7FE346-0E6C-4B33-9515-0E05C5033293}"/>
               </a:ext>
             </a:extLst>
           </p:cNvPr>
@@ -6246,7 +6246,7 @@
           <p:cNvPr id="15" name="">
             <a:extLst xmlns:a="http://schemas.openxmlformats.org/drawingml/2006/main">
               <a:ext uri="{FF2B5EF4-FFF2-40B4-BE49-F238E27FC236}">
-                <a16:creationId xmlns:a16="http://schemas.microsoft.com/office/drawing/2014/main" id="{324C258D-BC9E-429B-A5BA-5E4C1FD434FD}"/>
+                <a16:creationId xmlns:a16="http://schemas.microsoft.com/office/drawing/2014/main" id="{9A8F6A79-A7CB-47F9-B883-89CAD1363266}"/>
               </a:ext>
             </a:extLst>
           </p:cNvPr>
@@ -6302,7 +6302,7 @@
           <p:cNvPr id="16" name="">
             <a:extLst xmlns:a="http://schemas.openxmlformats.org/drawingml/2006/main">
               <a:ext uri="{FF2B5EF4-FFF2-40B4-BE49-F238E27FC236}">
-                <a16:creationId xmlns:a16="http://schemas.microsoft.com/office/drawing/2014/main" id="{DB1BA47E-1B8F-4959-979F-C206699BC595}"/>
+                <a16:creationId xmlns:a16="http://schemas.microsoft.com/office/drawing/2014/main" id="{212C315A-C07D-492B-824E-18891355FB0A}"/>
               </a:ext>
             </a:extLst>
           </p:cNvPr>
@@ -6348,7 +6348,7 @@
                 <a:ea typeface="Arial"/>
                 <a:cs typeface="Arial"/>
               </a:rPr>
-              <a:t>Windows 10/11 (x64) + macOS (Apple Silicon) — İndirme: github.com/Azizsekerdil/EnglishCourseAI/releases (v1.2.0, özel repo)</a:t>
+              <a:t>Windows 10/11 (x64) + macOS (Apple Silicon) — İndirme: github.com/Azizsekerdil/EnglishCourseAI/releases (v1.2.1, özel repo)</a:t>
             </a:r>
           </a:p>
         </p:txBody>
@@ -6358,7 +6358,7 @@
           <p:cNvPr id="17" name="">
             <a:extLst xmlns:a="http://schemas.openxmlformats.org/drawingml/2006/main">
               <a:ext uri="{FF2B5EF4-FFF2-40B4-BE49-F238E27FC236}">
-                <a16:creationId xmlns:a16="http://schemas.microsoft.com/office/drawing/2014/main" id="{FD9AECD7-BC28-4F00-B04C-4235D817A693}"/>
+                <a16:creationId xmlns:a16="http://schemas.microsoft.com/office/drawing/2014/main" id="{3CC9335A-B6EF-4299-89AF-71D574145FDD}"/>
               </a:ext>
             </a:extLst>
           </p:cNvPr>
@@ -6404,7 +6404,7 @@
                 <a:ea typeface="Arial"/>
                 <a:cs typeface="Arial"/>
               </a:rPr>
-              <a:t>Windows 10/11 (x64) &amp; macOS (Apple Silicon) — Download: GitHub Releases (v1.2.0)</a:t>
+              <a:t>Windows 10/11 (x64) &amp; macOS (Apple Silicon) — Download: GitHub Releases (v1.2.1)</a:t>
             </a:r>
           </a:p>
         </p:txBody>
@@ -6414,7 +6414,7 @@
           <p:cNvPr id="18" name="">
             <a:extLst xmlns:a="http://schemas.openxmlformats.org/drawingml/2006/main">
               <a:ext uri="{FF2B5EF4-FFF2-40B4-BE49-F238E27FC236}">
-                <a16:creationId xmlns:a16="http://schemas.microsoft.com/office/drawing/2014/main" id="{6616ADC4-701F-49E3-BE6C-DFC946E29372}"/>
+                <a16:creationId xmlns:a16="http://schemas.microsoft.com/office/drawing/2014/main" id="{D5D7ED3C-791A-4481-BBE2-9122A6F2CE2A}"/>
               </a:ext>
             </a:extLst>
           </p:cNvPr>
@@ -6474,7 +6474,7 @@
           <p:nvPr/>
         </p:nvPicPr>
         <p:blipFill>
-          <a:blip xmlns:r="http://schemas.openxmlformats.org/officeDocument/2006/relationships" xmlns:a="http://schemas.openxmlformats.org/drawingml/2006/main" r:embed="Rd69c623c06e44ef6"/>
+          <a:blip xmlns:r="http://schemas.openxmlformats.org/officeDocument/2006/relationships" xmlns:a="http://schemas.openxmlformats.org/drawingml/2006/main" r:embed="R2146c9e9e21240d2"/>
           <a:stretch xmlns:a="http://schemas.openxmlformats.org/drawingml/2006/main"/>
         </p:blipFill>
         <p:spPr>
@@ -6490,7 +6490,7 @@
     </p:spTree>
     <p:extLst>
       <p:ext uri="{BB962C8B-B14F-4D97-AF65-F5344CB8AC3E}">
-        <p14:creationId xmlns:p14="http://schemas.microsoft.com/office/powerpoint/2010/main" val="1631260123"/>
+        <p14:creationId xmlns:p14="http://schemas.microsoft.com/office/powerpoint/2010/main" val="1135392546"/>
       </p:ext>
     </p:extLst>
   </p:cSld>

</xml_diff>